<commit_message>
Sjöskolan v40: figures in all three decks and new Växelströmslabbet
- Add 43 figures to the week-40 decks: one per exercise slide plus selected
  theory slides. v40_01 exercise 2 now shows the curve it refers to. Each
  figure has alt text; the sought quantity is marked with '?'.
- New sjoskolan/vaxelstromslabbet/: interactive AC lab with three tabs
  (sinus, impedans, effekt), 12 predict-then-check exercises using numbers
  different from the hand-in exercises, and 16 model tests.
- Link the lab from the week-40 page and the course index.
- Keep the figure generator in sjoskolan/verktyg/figurer/ for later weeks.

Co-Authored-By: Claude Opus 5.5 <noreply@anthropic.com>
Claude-Session: https://claude.ai/code/session_011V9KjBb53XrDm23Dw58SH3
</commit_message>
<xml_diff>
--- a/sjoskolan/vecka-40/aktuell/v40_01_Sinusformad_vaxelspanning_elev.pptx
+++ b/sjoskolan/vecka-40/aktuell/v40_01_Sinusformad_vaxelspanning_elev.pptx
@@ -4946,7 +4946,7 @@
         <p:spPr>
           <a:xfrm xmlns:a="http://schemas.openxmlformats.org/drawingml/2006/main">
             <a:off x="762000" y="2533650"/>
-            <a:ext cx="7620000" cy="2286000"/>
+            <a:ext cx="3886200" cy="2606040"/>
           </a:xfrm>
           <a:prstGeom xmlns:a="http://schemas.openxmlformats.org/drawingml/2006/main" prst="rect">
             <a:avLst/>
@@ -5103,6 +5103,30 @@
           </a:p>
         </p:txBody>
       </p:sp>
+      <p:pic xmlns:a="http://schemas.openxmlformats.org/drawingml/2006/main" xmlns:r="http://schemas.openxmlformats.org/officeDocument/2006/relationships">
+        <p:nvPicPr>
+          <p:cNvPr id="9" name="Figur: Sinus vid 50 Hz där perioden T är okänd" descr="Sinus vid 50 Hz där perioden T är okänd"/>
+          <p:cNvPicPr>
+            <a:picLocks noChangeAspect="1"/>
+          </p:cNvPicPr>
+          <p:nvPr/>
+        </p:nvPicPr>
+        <p:blipFill>
+          <a:blip r:embed="rId3"/>
+          <a:stretch>
+            <a:fillRect/>
+          </a:stretch>
+        </p:blipFill>
+        <p:spPr>
+          <a:xfrm>
+            <a:off x="4846320" y="2331720"/>
+            <a:ext cx="3931920" cy="2740984"/>
+          </a:xfrm>
+          <a:prstGeom prst="rect">
+            <a:avLst/>
+          </a:prstGeom>
+        </p:spPr>
+      </p:pic>
     </p:spTree>
     <p:extLst>
       <p:ext uri="{BB962C8B-B14F-4D97-AF65-F5344CB8AC3E}">
@@ -5670,7 +5694,7 @@
         <p:spPr>
           <a:xfrm xmlns:a="http://schemas.openxmlformats.org/drawingml/2006/main">
             <a:off x="762000" y="2533650"/>
-            <a:ext cx="7620000" cy="2286000"/>
+            <a:ext cx="3886200" cy="2606040"/>
           </a:xfrm>
           <a:prstGeom xmlns:a="http://schemas.openxmlformats.org/drawingml/2006/main" prst="rect">
             <a:avLst/>
@@ -5827,6 +5851,30 @@
           </a:p>
         </p:txBody>
       </p:sp>
+      <p:pic xmlns:a="http://schemas.openxmlformats.org/drawingml/2006/main" xmlns:r="http://schemas.openxmlformats.org/officeDocument/2006/relationships">
+        <p:nvPicPr>
+          <p:cNvPr id="9" name="Figur: Sinuskurva som upprepar sig var 4,0 ms, " descr="Sinuskurva som upprepar sig var 4,0 ms, tidsaxel 0 till 8 ms"/>
+          <p:cNvPicPr>
+            <a:picLocks noChangeAspect="1"/>
+          </p:cNvPicPr>
+          <p:nvPr/>
+        </p:nvPicPr>
+        <p:blipFill>
+          <a:blip r:embed="rId3"/>
+          <a:stretch>
+            <a:fillRect/>
+          </a:stretch>
+        </p:blipFill>
+        <p:spPr>
+          <a:xfrm>
+            <a:off x="4846320" y="2331720"/>
+            <a:ext cx="3931920" cy="2740984"/>
+          </a:xfrm>
+          <a:prstGeom prst="rect">
+            <a:avLst/>
+          </a:prstGeom>
+        </p:spPr>
+      </p:pic>
     </p:spTree>
     <p:extLst>
       <p:ext uri="{BB962C8B-B14F-4D97-AF65-F5344CB8AC3E}">
@@ -6394,7 +6442,7 @@
         <p:spPr>
           <a:xfrm xmlns:a="http://schemas.openxmlformats.org/drawingml/2006/main">
             <a:off x="762000" y="2533650"/>
-            <a:ext cx="7620000" cy="2286000"/>
+            <a:ext cx="3886200" cy="2606040"/>
           </a:xfrm>
           <a:prstGeom xmlns:a="http://schemas.openxmlformats.org/drawingml/2006/main" prst="rect">
             <a:avLst/>
@@ -6551,6 +6599,30 @@
           </a:p>
         </p:txBody>
       </p:sp>
+      <p:pic xmlns:a="http://schemas.openxmlformats.org/drawingml/2006/main" xmlns:r="http://schemas.openxmlformats.org/officeDocument/2006/relationships">
+        <p:nvPicPr>
+          <p:cNvPr id="9" name="Figur: Sinus med effektivvärdet 12,0 V markerat" descr="Sinus med effektivvärdet 12,0 V markerat och okänt toppvärde"/>
+          <p:cNvPicPr>
+            <a:picLocks noChangeAspect="1"/>
+          </p:cNvPicPr>
+          <p:nvPr/>
+        </p:nvPicPr>
+        <p:blipFill>
+          <a:blip r:embed="rId3"/>
+          <a:stretch>
+            <a:fillRect/>
+          </a:stretch>
+        </p:blipFill>
+        <p:spPr>
+          <a:xfrm>
+            <a:off x="4846320" y="2331720"/>
+            <a:ext cx="3931920" cy="2740984"/>
+          </a:xfrm>
+          <a:prstGeom prst="rect">
+            <a:avLst/>
+          </a:prstGeom>
+        </p:spPr>
+      </p:pic>
     </p:spTree>
     <p:extLst>
       <p:ext uri="{BB962C8B-B14F-4D97-AF65-F5344CB8AC3E}">
@@ -7118,7 +7190,7 @@
         <p:spPr>
           <a:xfrm xmlns:a="http://schemas.openxmlformats.org/drawingml/2006/main">
             <a:off x="762000" y="2533650"/>
-            <a:ext cx="7620000" cy="2286000"/>
+            <a:ext cx="3886200" cy="2606040"/>
           </a:xfrm>
           <a:prstGeom xmlns:a="http://schemas.openxmlformats.org/drawingml/2006/main" prst="rect">
             <a:avLst/>
@@ -7275,6 +7347,30 @@
           </a:p>
         </p:txBody>
       </p:sp>
+      <p:pic xmlns:a="http://schemas.openxmlformats.org/drawingml/2006/main" xmlns:r="http://schemas.openxmlformats.org/officeDocument/2006/relationships">
+        <p:nvPicPr>
+          <p:cNvPr id="9" name="Figur: Sinus med toppvärdet 34,0 V och okänt ef" descr="Sinus med toppvärdet 34,0 V och okänt effektivvärde"/>
+          <p:cNvPicPr>
+            <a:picLocks noChangeAspect="1"/>
+          </p:cNvPicPr>
+          <p:nvPr/>
+        </p:nvPicPr>
+        <p:blipFill>
+          <a:blip r:embed="rId3"/>
+          <a:stretch>
+            <a:fillRect/>
+          </a:stretch>
+        </p:blipFill>
+        <p:spPr>
+          <a:xfrm>
+            <a:off x="4846320" y="2331720"/>
+            <a:ext cx="3931920" cy="2740984"/>
+          </a:xfrm>
+          <a:prstGeom prst="rect">
+            <a:avLst/>
+          </a:prstGeom>
+        </p:spPr>
+      </p:pic>
     </p:spTree>
     <p:extLst>
       <p:ext uri="{BB962C8B-B14F-4D97-AF65-F5344CB8AC3E}">
@@ -7865,7 +7961,7 @@
         <p:spPr>
           <a:xfrm xmlns:a="http://schemas.openxmlformats.org/drawingml/2006/main">
             <a:off x="762000" y="2533650"/>
-            <a:ext cx="7620000" cy="2286000"/>
+            <a:ext cx="3886200" cy="2606040"/>
           </a:xfrm>
           <a:prstGeom xmlns:a="http://schemas.openxmlformats.org/drawingml/2006/main" prst="rect">
             <a:avLst/>
@@ -8022,6 +8118,30 @@
           </a:p>
         </p:txBody>
       </p:sp>
+      <p:pic xmlns:a="http://schemas.openxmlformats.org/drawingml/2006/main" xmlns:r="http://schemas.openxmlformats.org/officeDocument/2006/relationships">
+        <p:nvPicPr>
+          <p:cNvPr id="9" name="Figur: Oscilloskopbild där sinusen är 20,0 V to" descr="Oscilloskopbild där sinusen är 20,0 V topp till topp"/>
+          <p:cNvPicPr>
+            <a:picLocks noChangeAspect="1"/>
+          </p:cNvPicPr>
+          <p:nvPr/>
+        </p:nvPicPr>
+        <p:blipFill>
+          <a:blip r:embed="rId3"/>
+          <a:stretch>
+            <a:fillRect/>
+          </a:stretch>
+        </p:blipFill>
+        <p:spPr>
+          <a:xfrm>
+            <a:off x="4846320" y="2331720"/>
+            <a:ext cx="3931920" cy="2740984"/>
+          </a:xfrm>
+          <a:prstGeom prst="rect">
+            <a:avLst/>
+          </a:prstGeom>
+        </p:spPr>
+      </p:pic>
     </p:spTree>
     <p:extLst>
       <p:ext uri="{BB962C8B-B14F-4D97-AF65-F5344CB8AC3E}">
@@ -8887,7 +9007,7 @@
         <p:spPr>
           <a:xfrm xmlns:a="http://schemas.openxmlformats.org/drawingml/2006/main">
             <a:off x="762000" y="1619250"/>
-            <a:ext cx="7620000" cy="1466850"/>
+            <a:ext cx="3977639" cy="1466850"/>
           </a:xfrm>
           <a:prstGeom xmlns:a="http://schemas.openxmlformats.org/drawingml/2006/main" prst="rect">
             <a:avLst/>
@@ -8915,7 +9035,7 @@
               </a:defRPr>
             </a:pPr>
             <a:r>
-              <a:rPr sz="2400" b="0">
+              <a:rPr sz="2200" b="0">
                 <a:solidFill>
                   <a:srgbClr val="111111"/>
                 </a:solidFill>
@@ -8939,7 +9059,7 @@
               </a:defRPr>
             </a:pPr>
             <a:r>
-              <a:rPr sz="2400" b="0">
+              <a:rPr sz="2200" b="0">
                 <a:solidFill>
                   <a:srgbClr val="111111"/>
                 </a:solidFill>
@@ -8969,7 +9089,7 @@
         <p:spPr>
           <a:xfrm xmlns:a="http://schemas.openxmlformats.org/drawingml/2006/main">
             <a:off x="762000" y="3200400"/>
-            <a:ext cx="7620000" cy="838200"/>
+            <a:ext cx="3977639" cy="838200"/>
           </a:xfrm>
           <a:prstGeom xmlns:a="http://schemas.openxmlformats.org/drawingml/2006/main" prst="rect">
             <a:avLst/>
@@ -8997,7 +9117,7 @@
               </a:defRPr>
             </a:pPr>
             <a:r>
-              <a:rPr sz="2925" b="1">
+              <a:rPr sz="2650" b="1">
                 <a:solidFill>
                   <a:srgbClr val="064F91"/>
                 </a:solidFill>
@@ -9027,7 +9147,7 @@
         <p:spPr>
           <a:xfrm xmlns:a="http://schemas.openxmlformats.org/drawingml/2006/main">
             <a:off x="762000" y="4429125"/>
-            <a:ext cx="7620000" cy="1352550"/>
+            <a:ext cx="3977639" cy="1352550"/>
           </a:xfrm>
           <a:prstGeom xmlns:a="http://schemas.openxmlformats.org/drawingml/2006/main" prst="rect">
             <a:avLst/>
@@ -9055,7 +9175,7 @@
               </a:defRPr>
             </a:pPr>
             <a:r>
-              <a:rPr sz="2250" b="0">
+              <a:rPr sz="2100" b="0">
                 <a:solidFill>
                   <a:srgbClr val="111111"/>
                 </a:solidFill>
@@ -9079,7 +9199,7 @@
               </a:defRPr>
             </a:pPr>
             <a:r>
-              <a:rPr sz="2250" b="0">
+              <a:rPr sz="2100" b="0">
                 <a:solidFill>
                   <a:srgbClr val="111111"/>
                 </a:solidFill>
@@ -9150,6 +9270,30 @@
           </a:p>
         </p:txBody>
       </p:sp>
+      <p:pic xmlns:a="http://schemas.openxmlformats.org/drawingml/2006/main" xmlns:r="http://schemas.openxmlformats.org/officeDocument/2006/relationships">
+        <p:nvPicPr>
+          <p:cNvPr id="9" name="Figur: Sinus där positiv och negativ halvperiod" descr="Sinus där positiv och negativ halvperiod har lika stora ytor, medelvärdet blir noll"/>
+          <p:cNvPicPr>
+            <a:picLocks noChangeAspect="1"/>
+          </p:cNvPicPr>
+          <p:nvPr/>
+        </p:nvPicPr>
+        <p:blipFill>
+          <a:blip r:embed="rId3"/>
+          <a:stretch>
+            <a:fillRect/>
+          </a:stretch>
+        </p:blipFill>
+        <p:spPr>
+          <a:xfrm>
+            <a:off x="4892040" y="1645920"/>
+            <a:ext cx="3886200" cy="3071293"/>
+          </a:xfrm>
+          <a:prstGeom prst="rect">
+            <a:avLst/>
+          </a:prstGeom>
+        </p:spPr>
+      </p:pic>
     </p:spTree>
     <p:extLst>
       <p:ext uri="{BB962C8B-B14F-4D97-AF65-F5344CB8AC3E}">
@@ -9271,7 +9415,7 @@
         <p:spPr>
           <a:xfrm xmlns:a="http://schemas.openxmlformats.org/drawingml/2006/main">
             <a:off x="762000" y="1619250"/>
-            <a:ext cx="7620000" cy="1466850"/>
+            <a:ext cx="3977639" cy="1466850"/>
           </a:xfrm>
           <a:prstGeom xmlns:a="http://schemas.openxmlformats.org/drawingml/2006/main" prst="rect">
             <a:avLst/>
@@ -9299,7 +9443,7 @@
               </a:defRPr>
             </a:pPr>
             <a:r>
-              <a:rPr sz="2400" b="0">
+              <a:rPr sz="2350" b="0">
                 <a:solidFill>
                   <a:srgbClr val="111111"/>
                 </a:solidFill>
@@ -9323,7 +9467,7 @@
               </a:defRPr>
             </a:pPr>
             <a:r>
-              <a:rPr sz="2400" b="0">
+              <a:rPr sz="2350" b="0">
                 <a:solidFill>
                   <a:srgbClr val="111111"/>
                 </a:solidFill>
@@ -9353,7 +9497,7 @@
         <p:spPr>
           <a:xfrm xmlns:a="http://schemas.openxmlformats.org/drawingml/2006/main">
             <a:off x="762000" y="3200400"/>
-            <a:ext cx="7620000" cy="838200"/>
+            <a:ext cx="3977639" cy="838200"/>
           </a:xfrm>
           <a:prstGeom xmlns:a="http://schemas.openxmlformats.org/drawingml/2006/main" prst="rect">
             <a:avLst/>
@@ -9411,7 +9555,7 @@
         <p:spPr>
           <a:xfrm xmlns:a="http://schemas.openxmlformats.org/drawingml/2006/main">
             <a:off x="762000" y="4429125"/>
-            <a:ext cx="7620000" cy="1352550"/>
+            <a:ext cx="3977639" cy="1352550"/>
           </a:xfrm>
           <a:prstGeom xmlns:a="http://schemas.openxmlformats.org/drawingml/2006/main" prst="rect">
             <a:avLst/>
@@ -9439,7 +9583,7 @@
               </a:defRPr>
             </a:pPr>
             <a:r>
-              <a:rPr sz="2250" b="0">
+              <a:rPr sz="2100" b="0">
                 <a:solidFill>
                   <a:srgbClr val="111111"/>
                 </a:solidFill>
@@ -9463,7 +9607,7 @@
               </a:defRPr>
             </a:pPr>
             <a:r>
-              <a:rPr sz="2250" b="0">
+              <a:rPr sz="2100" b="0">
                 <a:solidFill>
                   <a:srgbClr val="111111"/>
                 </a:solidFill>
@@ -9534,6 +9678,30 @@
           </a:p>
         </p:txBody>
       </p:sp>
+      <p:pic xmlns:a="http://schemas.openxmlformats.org/drawingml/2006/main" xmlns:r="http://schemas.openxmlformats.org/officeDocument/2006/relationships">
+        <p:nvPicPr>
+          <p:cNvPr id="9" name="Figur: Två sinusspänningar vid 50 Hz förskjutna" descr="Två sinusspänningar vid 50 Hz förskjutna 5 ms, vilket motsvarar 90 grader"/>
+          <p:cNvPicPr>
+            <a:picLocks noChangeAspect="1"/>
+          </p:cNvPicPr>
+          <p:nvPr/>
+        </p:nvPicPr>
+        <p:blipFill>
+          <a:blip r:embed="rId3"/>
+          <a:stretch>
+            <a:fillRect/>
+          </a:stretch>
+        </p:blipFill>
+        <p:spPr>
+          <a:xfrm>
+            <a:off x="4892040" y="1645920"/>
+            <a:ext cx="3886200" cy="3071293"/>
+          </a:xfrm>
+          <a:prstGeom prst="rect">
+            <a:avLst/>
+          </a:prstGeom>
+        </p:spPr>
+      </p:pic>
     </p:spTree>
     <p:extLst>
       <p:ext uri="{BB962C8B-B14F-4D97-AF65-F5344CB8AC3E}">
@@ -9655,7 +9823,7 @@
         <p:spPr>
           <a:xfrm xmlns:a="http://schemas.openxmlformats.org/drawingml/2006/main">
             <a:off x="762000" y="1619250"/>
-            <a:ext cx="7620000" cy="1466850"/>
+            <a:ext cx="3977639" cy="1466850"/>
           </a:xfrm>
           <a:prstGeom xmlns:a="http://schemas.openxmlformats.org/drawingml/2006/main" prst="rect">
             <a:avLst/>
@@ -9683,7 +9851,7 @@
               </a:defRPr>
             </a:pPr>
             <a:r>
-              <a:rPr sz="2400" b="0">
+              <a:rPr sz="2250" b="0">
                 <a:solidFill>
                   <a:srgbClr val="111111"/>
                 </a:solidFill>
@@ -9707,7 +9875,7 @@
               </a:defRPr>
             </a:pPr>
             <a:r>
-              <a:rPr sz="2400" b="0">
+              <a:rPr sz="2250" b="0">
                 <a:solidFill>
                   <a:srgbClr val="111111"/>
                 </a:solidFill>
@@ -9737,7 +9905,7 @@
         <p:spPr>
           <a:xfrm xmlns:a="http://schemas.openxmlformats.org/drawingml/2006/main">
             <a:off x="762000" y="3200400"/>
-            <a:ext cx="7620000" cy="838200"/>
+            <a:ext cx="3977639" cy="838200"/>
           </a:xfrm>
           <a:prstGeom xmlns:a="http://schemas.openxmlformats.org/drawingml/2006/main" prst="rect">
             <a:avLst/>
@@ -9795,7 +9963,7 @@
         <p:spPr>
           <a:xfrm xmlns:a="http://schemas.openxmlformats.org/drawingml/2006/main">
             <a:off x="762000" y="4429125"/>
-            <a:ext cx="7620000" cy="1352550"/>
+            <a:ext cx="3977639" cy="1352550"/>
           </a:xfrm>
           <a:prstGeom xmlns:a="http://schemas.openxmlformats.org/drawingml/2006/main" prst="rect">
             <a:avLst/>
@@ -9823,7 +9991,7 @@
               </a:defRPr>
             </a:pPr>
             <a:r>
-              <a:rPr sz="2250" b="0">
+              <a:rPr sz="2100" b="0">
                 <a:solidFill>
                   <a:srgbClr val="111111"/>
                 </a:solidFill>
@@ -9847,7 +10015,7 @@
               </a:defRPr>
             </a:pPr>
             <a:r>
-              <a:rPr sz="2250" b="0">
+              <a:rPr sz="2100" b="0">
                 <a:solidFill>
                   <a:srgbClr val="111111"/>
                 </a:solidFill>
@@ -9918,6 +10086,30 @@
           </a:p>
         </p:txBody>
       </p:sp>
+      <p:pic xmlns:a="http://schemas.openxmlformats.org/drawingml/2006/main" xmlns:r="http://schemas.openxmlformats.org/officeDocument/2006/relationships">
+        <p:nvPicPr>
+          <p:cNvPr id="9" name="Figur: Sinus och fyrkantvåg med samma toppvärde" descr="Sinus och fyrkantvåg med samma toppvärde"/>
+          <p:cNvPicPr>
+            <a:picLocks noChangeAspect="1"/>
+          </p:cNvPicPr>
+          <p:nvPr/>
+        </p:nvPicPr>
+        <p:blipFill>
+          <a:blip r:embed="rId3"/>
+          <a:stretch>
+            <a:fillRect/>
+          </a:stretch>
+        </p:blipFill>
+        <p:spPr>
+          <a:xfrm>
+            <a:off x="4892040" y="1645920"/>
+            <a:ext cx="3886200" cy="3071293"/>
+          </a:xfrm>
+          <a:prstGeom prst="rect">
+            <a:avLst/>
+          </a:prstGeom>
+        </p:spPr>
+      </p:pic>
     </p:spTree>
     <p:extLst>
       <p:ext uri="{BB962C8B-B14F-4D97-AF65-F5344CB8AC3E}">
@@ -10919,7 +11111,7 @@
         <p:spPr>
           <a:xfrm xmlns:a="http://schemas.openxmlformats.org/drawingml/2006/main">
             <a:off x="762000" y="2533650"/>
-            <a:ext cx="7620000" cy="2286000"/>
+            <a:ext cx="3886200" cy="2606040"/>
           </a:xfrm>
           <a:prstGeom xmlns:a="http://schemas.openxmlformats.org/drawingml/2006/main" prst="rect">
             <a:avLst/>
@@ -11076,6 +11268,30 @@
           </a:p>
         </p:txBody>
       </p:sp>
+      <p:pic xmlns:a="http://schemas.openxmlformats.org/drawingml/2006/main" xmlns:r="http://schemas.openxmlformats.org/officeDocument/2006/relationships">
+        <p:nvPicPr>
+          <p:cNvPr id="9" name="Figur: Sinus med toppvärde 17,0 V vid 50 Hz, pu" descr="Sinus med toppvärde 17,0 V vid 50 Hz, punkten t = 5 ms markerad"/>
+          <p:cNvPicPr>
+            <a:picLocks noChangeAspect="1"/>
+          </p:cNvPicPr>
+          <p:nvPr/>
+        </p:nvPicPr>
+        <p:blipFill>
+          <a:blip r:embed="rId3"/>
+          <a:stretch>
+            <a:fillRect/>
+          </a:stretch>
+        </p:blipFill>
+        <p:spPr>
+          <a:xfrm>
+            <a:off x="4846320" y="2331720"/>
+            <a:ext cx="3931920" cy="2740984"/>
+          </a:xfrm>
+          <a:prstGeom prst="rect">
+            <a:avLst/>
+          </a:prstGeom>
+        </p:spPr>
+      </p:pic>
     </p:spTree>
     <p:extLst>
       <p:ext uri="{BB962C8B-B14F-4D97-AF65-F5344CB8AC3E}">
@@ -11643,7 +11859,7 @@
         <p:spPr>
           <a:xfrm xmlns:a="http://schemas.openxmlformats.org/drawingml/2006/main">
             <a:off x="762000" y="2533650"/>
-            <a:ext cx="7620000" cy="2286000"/>
+            <a:ext cx="3886200" cy="2606040"/>
           </a:xfrm>
           <a:prstGeom xmlns:a="http://schemas.openxmlformats.org/drawingml/2006/main" prst="rect">
             <a:avLst/>
@@ -11800,6 +12016,30 @@
           </a:p>
         </p:txBody>
       </p:sp>
+      <p:pic xmlns:a="http://schemas.openxmlformats.org/drawingml/2006/main" xmlns:r="http://schemas.openxmlformats.org/officeDocument/2006/relationships">
+        <p:nvPicPr>
+          <p:cNvPr id="9" name="Figur: Sinus med toppvärde 17,0 V vid 50 Hz, pu" descr="Sinus med toppvärde 17,0 V vid 50 Hz, punkten t = 15 ms markerad"/>
+          <p:cNvPicPr>
+            <a:picLocks noChangeAspect="1"/>
+          </p:cNvPicPr>
+          <p:nvPr/>
+        </p:nvPicPr>
+        <p:blipFill>
+          <a:blip r:embed="rId3"/>
+          <a:stretch>
+            <a:fillRect/>
+          </a:stretch>
+        </p:blipFill>
+        <p:spPr>
+          <a:xfrm>
+            <a:off x="4846320" y="2331720"/>
+            <a:ext cx="3931920" cy="2740984"/>
+          </a:xfrm>
+          <a:prstGeom prst="rect">
+            <a:avLst/>
+          </a:prstGeom>
+        </p:spPr>
+      </p:pic>
     </p:spTree>
     <p:extLst>
       <p:ext uri="{BB962C8B-B14F-4D97-AF65-F5344CB8AC3E}">
@@ -12881,7 +13121,7 @@
         <p:spPr>
           <a:xfrm xmlns:a="http://schemas.openxmlformats.org/drawingml/2006/main">
             <a:off x="762000" y="2533650"/>
-            <a:ext cx="7620000" cy="2286000"/>
+            <a:ext cx="3886200" cy="2606040"/>
           </a:xfrm>
           <a:prstGeom xmlns:a="http://schemas.openxmlformats.org/drawingml/2006/main" prst="rect">
             <a:avLst/>
@@ -13038,6 +13278,30 @@
           </a:p>
         </p:txBody>
       </p:sp>
+      <p:pic xmlns:a="http://schemas.openxmlformats.org/drawingml/2006/main" xmlns:r="http://schemas.openxmlformats.org/officeDocument/2006/relationships">
+        <p:nvPicPr>
+          <p:cNvPr id="9" name="Figur: Två sinusspänningar vid 50 Hz förskjutna" descr="Två sinusspänningar vid 50 Hz förskjutna 2,0 ms"/>
+          <p:cNvPicPr>
+            <a:picLocks noChangeAspect="1"/>
+          </p:cNvPicPr>
+          <p:nvPr/>
+        </p:nvPicPr>
+        <p:blipFill>
+          <a:blip r:embed="rId3"/>
+          <a:stretch>
+            <a:fillRect/>
+          </a:stretch>
+        </p:blipFill>
+        <p:spPr>
+          <a:xfrm>
+            <a:off x="4846320" y="2331720"/>
+            <a:ext cx="3931920" cy="2740984"/>
+          </a:xfrm>
+          <a:prstGeom prst="rect">
+            <a:avLst/>
+          </a:prstGeom>
+        </p:spPr>
+      </p:pic>
     </p:spTree>
     <p:extLst>
       <p:ext uri="{BB962C8B-B14F-4D97-AF65-F5344CB8AC3E}">
@@ -13605,7 +13869,7 @@
         <p:spPr>
           <a:xfrm xmlns:a="http://schemas.openxmlformats.org/drawingml/2006/main">
             <a:off x="762000" y="2533650"/>
-            <a:ext cx="7620000" cy="2286000"/>
+            <a:ext cx="3886200" cy="2606040"/>
           </a:xfrm>
           <a:prstGeom xmlns:a="http://schemas.openxmlformats.org/drawingml/2006/main" prst="rect">
             <a:avLst/>
@@ -13762,6 +14026,30 @@
           </a:p>
         </p:txBody>
       </p:sp>
+      <p:pic xmlns:a="http://schemas.openxmlformats.org/drawingml/2006/main" xmlns:r="http://schemas.openxmlformats.org/officeDocument/2006/relationships">
+        <p:nvPicPr>
+          <p:cNvPr id="9" name="Figur: Krets med växelspänningskälla 12,0 V RMS" descr="Krets med växelspänningskälla 12,0 V RMS och resistor 24 ohm"/>
+          <p:cNvPicPr>
+            <a:picLocks noChangeAspect="1"/>
+          </p:cNvPicPr>
+          <p:nvPr/>
+        </p:nvPicPr>
+        <p:blipFill>
+          <a:blip r:embed="rId3"/>
+          <a:stretch>
+            <a:fillRect/>
+          </a:stretch>
+        </p:blipFill>
+        <p:spPr>
+          <a:xfrm>
+            <a:off x="4846320" y="2331720"/>
+            <a:ext cx="3931920" cy="2740984"/>
+          </a:xfrm>
+          <a:prstGeom prst="rect">
+            <a:avLst/>
+          </a:prstGeom>
+        </p:spPr>
+      </p:pic>
     </p:spTree>
     <p:extLst>
       <p:ext uri="{BB962C8B-B14F-4D97-AF65-F5344CB8AC3E}">
@@ -14352,7 +14640,7 @@
         <p:spPr>
           <a:xfrm xmlns:a="http://schemas.openxmlformats.org/drawingml/2006/main">
             <a:off x="762000" y="2533650"/>
-            <a:ext cx="7620000" cy="2286000"/>
+            <a:ext cx="3886200" cy="2606040"/>
           </a:xfrm>
           <a:prstGeom xmlns:a="http://schemas.openxmlformats.org/drawingml/2006/main" prst="rect">
             <a:avLst/>
@@ -14509,6 +14797,30 @@
           </a:p>
         </p:txBody>
       </p:sp>
+      <p:pic xmlns:a="http://schemas.openxmlformats.org/drawingml/2006/main" xmlns:r="http://schemas.openxmlformats.org/officeDocument/2006/relationships">
+        <p:nvPicPr>
+          <p:cNvPr id="9" name="Figur: Signal A är en sinus och signal B en fyr" descr="Signal A är en sinus och signal B en fyrkantvåg, båda mellan plus och minus 12 V"/>
+          <p:cNvPicPr>
+            <a:picLocks noChangeAspect="1"/>
+          </p:cNvPicPr>
+          <p:nvPr/>
+        </p:nvPicPr>
+        <p:blipFill>
+          <a:blip r:embed="rId3"/>
+          <a:stretch>
+            <a:fillRect/>
+          </a:stretch>
+        </p:blipFill>
+        <p:spPr>
+          <a:xfrm>
+            <a:off x="4846320" y="2331720"/>
+            <a:ext cx="3931920" cy="2740984"/>
+          </a:xfrm>
+          <a:prstGeom prst="rect">
+            <a:avLst/>
+          </a:prstGeom>
+        </p:spPr>
+      </p:pic>
     </p:spTree>
     <p:extLst>
       <p:ext uri="{BB962C8B-B14F-4D97-AF65-F5344CB8AC3E}">
@@ -16582,7 +16894,7 @@
         <p:spPr>
           <a:xfrm xmlns:a="http://schemas.openxmlformats.org/drawingml/2006/main">
             <a:off x="762000" y="1619250"/>
-            <a:ext cx="7620000" cy="1466850"/>
+            <a:ext cx="3977639" cy="1466850"/>
           </a:xfrm>
           <a:prstGeom xmlns:a="http://schemas.openxmlformats.org/drawingml/2006/main" prst="rect">
             <a:avLst/>
@@ -16610,7 +16922,7 @@
               </a:defRPr>
             </a:pPr>
             <a:r>
-              <a:rPr sz="2400" b="0">
+              <a:rPr sz="2350" b="0">
                 <a:solidFill>
                   <a:srgbClr val="111111"/>
                 </a:solidFill>
@@ -16634,7 +16946,7 @@
               </a:defRPr>
             </a:pPr>
             <a:r>
-              <a:rPr sz="2400" b="0">
+              <a:rPr sz="2350" b="0">
                 <a:solidFill>
                   <a:srgbClr val="111111"/>
                 </a:solidFill>
@@ -16664,7 +16976,7 @@
         <p:spPr>
           <a:xfrm xmlns:a="http://schemas.openxmlformats.org/drawingml/2006/main">
             <a:off x="762000" y="3200400"/>
-            <a:ext cx="7620000" cy="838200"/>
+            <a:ext cx="3977639" cy="838200"/>
           </a:xfrm>
           <a:prstGeom xmlns:a="http://schemas.openxmlformats.org/drawingml/2006/main" prst="rect">
             <a:avLst/>
@@ -16722,7 +17034,7 @@
         <p:spPr>
           <a:xfrm xmlns:a="http://schemas.openxmlformats.org/drawingml/2006/main">
             <a:off x="762000" y="4429125"/>
-            <a:ext cx="7620000" cy="1352550"/>
+            <a:ext cx="3977639" cy="1352550"/>
           </a:xfrm>
           <a:prstGeom xmlns:a="http://schemas.openxmlformats.org/drawingml/2006/main" prst="rect">
             <a:avLst/>
@@ -16845,6 +17157,30 @@
           </a:p>
         </p:txBody>
       </p:sp>
+      <p:pic xmlns:a="http://schemas.openxmlformats.org/drawingml/2006/main" xmlns:r="http://schemas.openxmlformats.org/officeDocument/2006/relationships">
+        <p:nvPicPr>
+          <p:cNvPr id="9" name="Figur: Sinus vid 50 Hz med perioden T = 20 ms m" descr="Sinus vid 50 Hz med perioden T = 20 ms markerad mellan två toppar"/>
+          <p:cNvPicPr>
+            <a:picLocks noChangeAspect="1"/>
+          </p:cNvPicPr>
+          <p:nvPr/>
+        </p:nvPicPr>
+        <p:blipFill>
+          <a:blip r:embed="rId3"/>
+          <a:stretch>
+            <a:fillRect/>
+          </a:stretch>
+        </p:blipFill>
+        <p:spPr>
+          <a:xfrm>
+            <a:off x="4892040" y="1645920"/>
+            <a:ext cx="3886200" cy="2709112"/>
+          </a:xfrm>
+          <a:prstGeom prst="rect">
+            <a:avLst/>
+          </a:prstGeom>
+        </p:spPr>
+      </p:pic>
     </p:spTree>
     <p:extLst>
       <p:ext uri="{BB962C8B-B14F-4D97-AF65-F5344CB8AC3E}">
@@ -16966,7 +17302,7 @@
         <p:spPr>
           <a:xfrm xmlns:a="http://schemas.openxmlformats.org/drawingml/2006/main">
             <a:off x="762000" y="1619250"/>
-            <a:ext cx="7620000" cy="1466850"/>
+            <a:ext cx="3977639" cy="1466850"/>
           </a:xfrm>
           <a:prstGeom xmlns:a="http://schemas.openxmlformats.org/drawingml/2006/main" prst="rect">
             <a:avLst/>
@@ -16994,7 +17330,7 @@
               </a:defRPr>
             </a:pPr>
             <a:r>
-              <a:rPr sz="2400" b="0">
+              <a:rPr sz="2350" b="0">
                 <a:solidFill>
                   <a:srgbClr val="111111"/>
                 </a:solidFill>
@@ -17018,7 +17354,7 @@
               </a:defRPr>
             </a:pPr>
             <a:r>
-              <a:rPr sz="2400" b="0">
+              <a:rPr sz="2350" b="0">
                 <a:solidFill>
                   <a:srgbClr val="111111"/>
                 </a:solidFill>
@@ -17048,7 +17384,7 @@
         <p:spPr>
           <a:xfrm xmlns:a="http://schemas.openxmlformats.org/drawingml/2006/main">
             <a:off x="762000" y="3200400"/>
-            <a:ext cx="7620000" cy="838200"/>
+            <a:ext cx="3977639" cy="838200"/>
           </a:xfrm>
           <a:prstGeom xmlns:a="http://schemas.openxmlformats.org/drawingml/2006/main" prst="rect">
             <a:avLst/>
@@ -17106,7 +17442,7 @@
         <p:spPr>
           <a:xfrm xmlns:a="http://schemas.openxmlformats.org/drawingml/2006/main">
             <a:off x="762000" y="4429125"/>
-            <a:ext cx="7620000" cy="1352550"/>
+            <a:ext cx="3977639" cy="1352550"/>
           </a:xfrm>
           <a:prstGeom xmlns:a="http://schemas.openxmlformats.org/drawingml/2006/main" prst="rect">
             <a:avLst/>
@@ -17134,7 +17470,7 @@
               </a:defRPr>
             </a:pPr>
             <a:r>
-              <a:rPr sz="2250" b="0">
+              <a:rPr sz="2100" b="0">
                 <a:solidFill>
                   <a:srgbClr val="111111"/>
                 </a:solidFill>
@@ -17158,7 +17494,7 @@
               </a:defRPr>
             </a:pPr>
             <a:r>
-              <a:rPr sz="2250" b="0">
+              <a:rPr sz="2100" b="0">
                 <a:solidFill>
                   <a:srgbClr val="111111"/>
                 </a:solidFill>
@@ -17229,6 +17565,30 @@
           </a:p>
         </p:txBody>
       </p:sp>
+      <p:pic xmlns:a="http://schemas.openxmlformats.org/drawingml/2006/main" xmlns:r="http://schemas.openxmlformats.org/officeDocument/2006/relationships">
+        <p:nvPicPr>
+          <p:cNvPr id="9" name="Figur: Sinus med toppvärde cirka 325 V och effe" descr="Sinus med toppvärde cirka 325 V och effektivvärdet 230 V som streckad linje"/>
+          <p:cNvPicPr>
+            <a:picLocks noChangeAspect="1"/>
+          </p:cNvPicPr>
+          <p:nvPr/>
+        </p:nvPicPr>
+        <p:blipFill>
+          <a:blip r:embed="rId3"/>
+          <a:stretch>
+            <a:fillRect/>
+          </a:stretch>
+        </p:blipFill>
+        <p:spPr>
+          <a:xfrm>
+            <a:off x="4892040" y="1645920"/>
+            <a:ext cx="3886200" cy="3071293"/>
+          </a:xfrm>
+          <a:prstGeom prst="rect">
+            <a:avLst/>
+          </a:prstGeom>
+        </p:spPr>
+      </p:pic>
     </p:spTree>
     <p:extLst>
       <p:ext uri="{BB962C8B-B14F-4D97-AF65-F5344CB8AC3E}">

</xml_diff>

<commit_message>
Sjöskolan vecka 40: alla förkortningar förklarade
Gemensam ordlista (innehall/beteckningar.json) med 44 förkortningar, storheter och enheter. Den ger en sida med
alla beteckningar för veckan, en ruta per avsnitt i genomgången, en ruta i varje lektionsartikel, i övningssidans
kapitel och i Växelströmslabbet. Genomgångens text förklarar förkortningarna första gången (RMS, AC, DC, true RMS,
RAD/DEG, RL, PF, var, f0 …) och index skrivs nedsänkta (X_L, U_R, U_pp). Övningsposter, bok, presentationer, PDF
och bildspel följer. Impedans- och effekttriangeln i genomgången ritades inte alls (variabelfel i visuals.mjs):
rättat. CI stoppar oförklarade förkortningar på vecka 40:s elevsidor.

Co-Authored-By: Claude Opus 5.5 <noreply@anthropic.com>
Claude-Session: https://claude.ai/code/session_011V9KjBb53XrDm23Dw58SH3
</commit_message>
<xml_diff>
--- a/sjoskolan/vecka-40/aktuell/v40_01_Sinusformad_vaxelspanning_elev.pptx
+++ b/sjoskolan/vecka-40/aktuell/v40_01_Sinusformad_vaxelspanning_elev.pptx
@@ -11350,12 +11350,7 @@
                 <a:ea typeface="Calibri"/>
                 <a:cs typeface="Calibri"/>
               </a:rPr>
-              <a:t>Momentanvärdet u(t) gäller en bestämd tidpunkt.</a:t>
-            </a:r>
-          </a:p>
-          <a:p xmlns:a="http://schemas.openxmlformats.org/drawingml/2006/main">
-            <a:r>
-              <a:t/>
+              <a:t>Momentanvärdet u(t) är spänningen vid en bestämd tidpunkt t. Liten bokstav u betyder ett värde som ändras med tiden.</a:t>
             </a:r>
           </a:p>
           <a:p xmlns:a="http://schemas.openxmlformats.org/drawingml/2006/main">
@@ -11369,6 +11364,18 @@
                 <a:cs typeface="Calibri"/>
               </a:defRPr>
             </a:pPr>
+          </a:p>
+          <a:p xmlns:a="http://schemas.openxmlformats.org/drawingml/2006/main">
+            <a:pPr>
+              <a:defRPr sz="2100" b="0">
+                <a:solidFill>
+                  <a:srgbClr val="172F43"/>
+                </a:solidFill>
+                <a:latin typeface="Calibri"/>
+                <a:ea typeface="Calibri"/>
+                <a:cs typeface="Calibri"/>
+              </a:defRPr>
+            </a:pPr>
             <a:r>
               <a:rPr sz="2100" b="0">
                 <a:solidFill>
@@ -11382,11 +11389,6 @@
             </a:r>
           </a:p>
           <a:p xmlns:a="http://schemas.openxmlformats.org/drawingml/2006/main">
-            <a:r>
-              <a:t/>
-            </a:r>
-          </a:p>
-          <a:p xmlns:a="http://schemas.openxmlformats.org/drawingml/2006/main">
             <a:pPr>
               <a:defRPr sz="2100" b="0">
                 <a:solidFill>
@@ -11397,22 +11399,6 @@
                 <a:cs typeface="Calibri"/>
               </a:defRPr>
             </a:pPr>
-            <a:r>
-              <a:rPr sz="2100" b="0">
-                <a:solidFill>
-                  <a:srgbClr val="172F43"/>
-                </a:solidFill>
-                <a:latin typeface="Calibri"/>
-                <a:ea typeface="Calibri"/>
-                <a:cs typeface="Calibri"/>
-              </a:rPr>
-              <a:t>û = 10√2 ≈ 14,14 V. Vinkeln 2πft ≈ 0,9425 rad.</a:t>
-            </a:r>
-          </a:p>
-          <a:p xmlns:a="http://schemas.openxmlformats.org/drawingml/2006/main">
-            <a:r>
-              <a:t/>
-            </a:r>
           </a:p>
           <a:p xmlns:a="http://schemas.openxmlformats.org/drawingml/2006/main">
             <a:pPr>
@@ -11434,7 +11420,42 @@
                 <a:ea typeface="Calibri"/>
                 <a:cs typeface="Calibri"/>
               </a:rPr>
-              <a:t>u = 14,14 · sin(0,9425) ≈ 11,44 V. Räknaren ska stå i RAD.</a:t>
+              <a:t>û = 10√2 ≈ 14,14 V. Vinkeln 2πft ≈ 0,9425 rad (radianer; 2π radianer är ett helt varv, 360°).</a:t>
+            </a:r>
+          </a:p>
+          <a:p xmlns:a="http://schemas.openxmlformats.org/drawingml/2006/main">
+            <a:pPr>
+              <a:defRPr sz="2100" b="0">
+                <a:solidFill>
+                  <a:srgbClr val="172F43"/>
+                </a:solidFill>
+                <a:latin typeface="Calibri"/>
+                <a:ea typeface="Calibri"/>
+                <a:cs typeface="Calibri"/>
+              </a:defRPr>
+            </a:pPr>
+          </a:p>
+          <a:p xmlns:a="http://schemas.openxmlformats.org/drawingml/2006/main">
+            <a:pPr>
+              <a:defRPr sz="2100" b="0">
+                <a:solidFill>
+                  <a:srgbClr val="172F43"/>
+                </a:solidFill>
+                <a:latin typeface="Calibri"/>
+                <a:ea typeface="Calibri"/>
+                <a:cs typeface="Calibri"/>
+              </a:defRPr>
+            </a:pPr>
+            <a:r>
+              <a:rPr sz="2100" b="0">
+                <a:solidFill>
+                  <a:srgbClr val="172F43"/>
+                </a:solidFill>
+                <a:latin typeface="Calibri"/>
+                <a:ea typeface="Calibri"/>
+                <a:cs typeface="Calibri"/>
+              </a:rPr>
+              <a:t>u = 14,14 · sin(0,9425) ≈ 11,44 V. Räknaren ska stå i RAD (radianer), inte DEG (grader).</a:t>
             </a:r>
           </a:p>
         </p:txBody>
@@ -11765,12 +11786,7 @@
                 <a:ea typeface="Calibri"/>
                 <a:cs typeface="Calibri"/>
               </a:rPr>
-              <a:t>En hel period motsvarar 360°.</a:t>
-            </a:r>
-          </a:p>
-          <a:p xmlns:a="http://schemas.openxmlformats.org/drawingml/2006/main">
-            <a:r>
-              <a:t/>
+              <a:t>En hel period motsvarar 360°. Fasvinkeln φ (fi) anger hur långt två kurvor är förskjutna, och Δt (delta t) är tidsskillnaden mellan dem.</a:t>
             </a:r>
           </a:p>
           <a:p xmlns:a="http://schemas.openxmlformats.org/drawingml/2006/main">
@@ -11784,6 +11800,18 @@
                 <a:cs typeface="Calibri"/>
               </a:defRPr>
             </a:pPr>
+          </a:p>
+          <a:p xmlns:a="http://schemas.openxmlformats.org/drawingml/2006/main">
+            <a:pPr>
+              <a:defRPr sz="2100" b="0">
+                <a:solidFill>
+                  <a:srgbClr val="172F43"/>
+                </a:solidFill>
+                <a:latin typeface="Calibri"/>
+                <a:ea typeface="Calibri"/>
+                <a:cs typeface="Calibri"/>
+              </a:defRPr>
+            </a:pPr>
             <a:r>
               <a:rPr sz="2100" b="0">
                 <a:solidFill>
@@ -11797,9 +11825,16 @@
             </a:r>
           </a:p>
           <a:p xmlns:a="http://schemas.openxmlformats.org/drawingml/2006/main">
-            <a:r>
-              <a:t/>
-            </a:r>
+            <a:pPr>
+              <a:defRPr sz="2100" b="0">
+                <a:solidFill>
+                  <a:srgbClr val="172F43"/>
+                </a:solidFill>
+                <a:latin typeface="Calibri"/>
+                <a:ea typeface="Calibri"/>
+                <a:cs typeface="Calibri"/>
+              </a:defRPr>
+            </a:pPr>
           </a:p>
           <a:p xmlns:a="http://schemas.openxmlformats.org/drawingml/2006/main">
             <a:pPr>
@@ -12152,12 +12187,7 @@
                 <a:ea typeface="Calibri"/>
                 <a:cs typeface="Calibri"/>
               </a:rPr>
-              <a:t>Vid likriktning speglas den negativa halvperioden uppåt. Medelvärdet av |u| blir positivt.</a:t>
-            </a:r>
-          </a:p>
-          <a:p xmlns:a="http://schemas.openxmlformats.org/drawingml/2006/main">
-            <a:r>
-              <a:t/>
+              <a:t>Vid likriktning speglas den negativa halvperioden uppåt. |u| betyder spänningen utan tecken (beloppet), så medelvärdet av |u| blir positivt.</a:t>
             </a:r>
           </a:p>
           <a:p xmlns:a="http://schemas.openxmlformats.org/drawingml/2006/main">
@@ -12171,6 +12201,18 @@
                 <a:cs typeface="Calibri"/>
               </a:defRPr>
             </a:pPr>
+          </a:p>
+          <a:p xmlns:a="http://schemas.openxmlformats.org/drawingml/2006/main">
+            <a:pPr>
+              <a:defRPr sz="2100" b="0">
+                <a:solidFill>
+                  <a:srgbClr val="172F43"/>
+                </a:solidFill>
+                <a:latin typeface="Calibri"/>
+                <a:ea typeface="Calibri"/>
+                <a:cs typeface="Calibri"/>
+              </a:defRPr>
+            </a:pPr>
             <a:r>
               <a:rPr sz="2100" b="0">
                 <a:solidFill>
@@ -12184,9 +12226,16 @@
             </a:r>
           </a:p>
           <a:p xmlns:a="http://schemas.openxmlformats.org/drawingml/2006/main">
-            <a:r>
-              <a:t/>
-            </a:r>
+            <a:pPr>
+              <a:defRPr sz="2100" b="0">
+                <a:solidFill>
+                  <a:srgbClr val="172F43"/>
+                </a:solidFill>
+                <a:latin typeface="Calibri"/>
+                <a:ea typeface="Calibri"/>
+                <a:cs typeface="Calibri"/>
+              </a:defRPr>
+            </a:pPr>
           </a:p>
           <a:p xmlns:a="http://schemas.openxmlformats.org/drawingml/2006/main">
             <a:pPr>
@@ -12881,12 +12930,7 @@
                 <a:ea typeface="Calibri"/>
                 <a:cs typeface="Calibri"/>
               </a:rPr>
-              <a:t>Alla tre signalerna har 12,00 V RMS och inget DC-innehåll.</a:t>
-            </a:r>
-          </a:p>
-          <a:p xmlns:a="http://schemas.openxmlformats.org/drawingml/2006/main">
-            <a:r>
-              <a:t/>
+              <a:t>Alla tre signalerna har effektivvärdet 12,00 V och ingen likspänningsdel (DC-innehåll).</a:t>
             </a:r>
           </a:p>
           <a:p xmlns:a="http://schemas.openxmlformats.org/drawingml/2006/main">
@@ -12900,6 +12944,18 @@
                 <a:cs typeface="Calibri"/>
               </a:defRPr>
             </a:pPr>
+          </a:p>
+          <a:p xmlns:a="http://schemas.openxmlformats.org/drawingml/2006/main">
+            <a:pPr>
+              <a:defRPr sz="1650" b="0">
+                <a:solidFill>
+                  <a:srgbClr val="172F43"/>
+                </a:solidFill>
+                <a:latin typeface="Calibri"/>
+                <a:ea typeface="Calibri"/>
+                <a:cs typeface="Calibri"/>
+              </a:defRPr>
+            </a:pPr>
             <a:r>
               <a:rPr sz="1650" b="0">
                 <a:solidFill>
@@ -12913,11 +12969,6 @@
             </a:r>
           </a:p>
           <a:p xmlns:a="http://schemas.openxmlformats.org/drawingml/2006/main">
-            <a:r>
-              <a:t/>
-            </a:r>
-          </a:p>
-          <a:p xmlns:a="http://schemas.openxmlformats.org/drawingml/2006/main">
             <a:pPr>
               <a:defRPr sz="1650" b="0">
                 <a:solidFill>
@@ -12928,6 +12979,18 @@
                 <a:cs typeface="Calibri"/>
               </a:defRPr>
             </a:pPr>
+          </a:p>
+          <a:p xmlns:a="http://schemas.openxmlformats.org/drawingml/2006/main">
+            <a:pPr>
+              <a:defRPr sz="1650" b="0">
+                <a:solidFill>
+                  <a:srgbClr val="172F43"/>
+                </a:solidFill>
+                <a:latin typeface="Calibri"/>
+                <a:ea typeface="Calibri"/>
+                <a:cs typeface="Calibri"/>
+              </a:defRPr>
+            </a:pPr>
             <a:r>
               <a:rPr sz="1650" b="0">
                 <a:solidFill>
@@ -12941,9 +13004,16 @@
             </a:r>
           </a:p>
           <a:p xmlns:a="http://schemas.openxmlformats.org/drawingml/2006/main">
-            <a:r>
-              <a:t/>
-            </a:r>
+            <a:pPr>
+              <a:defRPr sz="1650" b="0">
+                <a:solidFill>
+                  <a:srgbClr val="172F43"/>
+                </a:solidFill>
+                <a:latin typeface="Calibri"/>
+                <a:ea typeface="Calibri"/>
+                <a:cs typeface="Calibri"/>
+              </a:defRPr>
+            </a:pPr>
           </a:p>
           <a:p xmlns:a="http://schemas.openxmlformats.org/drawingml/2006/main">
             <a:pPr>
@@ -13601,11 +13671,6 @@
             </a:r>
           </a:p>
           <a:p xmlns:a="http://schemas.openxmlformats.org/drawingml/2006/main">
-            <a:r>
-              <a:t/>
-            </a:r>
-          </a:p>
-          <a:p xmlns:a="http://schemas.openxmlformats.org/drawingml/2006/main">
             <a:pPr>
               <a:defRPr sz="2100" b="0">
                 <a:solidFill>
@@ -13616,6 +13681,18 @@
                 <a:cs typeface="Calibri"/>
               </a:defRPr>
             </a:pPr>
+          </a:p>
+          <a:p xmlns:a="http://schemas.openxmlformats.org/drawingml/2006/main">
+            <a:pPr>
+              <a:defRPr sz="2100" b="0">
+                <a:solidFill>
+                  <a:srgbClr val="172F43"/>
+                </a:solidFill>
+                <a:latin typeface="Calibri"/>
+                <a:ea typeface="Calibri"/>
+                <a:cs typeface="Calibri"/>
+              </a:defRPr>
+            </a:pPr>
             <a:r>
               <a:rPr sz="2100" b="0">
                 <a:solidFill>
@@ -13625,13 +13702,20 @@
                 <a:ea typeface="Calibri"/>
                 <a:cs typeface="Calibri"/>
               </a:rPr>
-              <a:t>Förklara med egna ord skillnaden mellan RMS, topp och vanligt medelvärde.</a:t>
-            </a:r>
-          </a:p>
-          <a:p xmlns:a="http://schemas.openxmlformats.org/drawingml/2006/main">
-            <a:r>
-              <a:t/>
-            </a:r>
+              <a:t>Förklara med egna ord skillnaden mellan effektivvärde (RMS), toppvärde och vanligt medelvärde.</a:t>
+            </a:r>
+          </a:p>
+          <a:p xmlns:a="http://schemas.openxmlformats.org/drawingml/2006/main">
+            <a:pPr>
+              <a:defRPr sz="2100" b="0">
+                <a:solidFill>
+                  <a:srgbClr val="172F43"/>
+                </a:solidFill>
+                <a:latin typeface="Calibri"/>
+                <a:ea typeface="Calibri"/>
+                <a:cs typeface="Calibri"/>
+              </a:defRPr>
+            </a:pPr>
           </a:p>
           <a:p xmlns:a="http://schemas.openxmlformats.org/drawingml/2006/main">
             <a:pPr>
@@ -13931,11 +14015,6 @@
             </a:r>
           </a:p>
           <a:p xmlns:a="http://schemas.openxmlformats.org/drawingml/2006/main">
-            <a:r>
-              <a:t/>
-            </a:r>
-          </a:p>
-          <a:p xmlns:a="http://schemas.openxmlformats.org/drawingml/2006/main">
             <a:pPr>
               <a:defRPr sz="2100" b="0">
                 <a:solidFill>
@@ -13946,6 +14025,18 @@
                 <a:cs typeface="Calibri"/>
               </a:defRPr>
             </a:pPr>
+          </a:p>
+          <a:p xmlns:a="http://schemas.openxmlformats.org/drawingml/2006/main">
+            <a:pPr>
+              <a:defRPr sz="2100" b="0">
+                <a:solidFill>
+                  <a:srgbClr val="172F43"/>
+                </a:solidFill>
+                <a:latin typeface="Calibri"/>
+                <a:ea typeface="Calibri"/>
+                <a:cs typeface="Calibri"/>
+              </a:defRPr>
+            </a:pPr>
             <a:r>
               <a:rPr sz="2100" b="0">
                 <a:solidFill>
@@ -13959,11 +14050,6 @@
             </a:r>
           </a:p>
           <a:p xmlns:a="http://schemas.openxmlformats.org/drawingml/2006/main">
-            <a:r>
-              <a:t/>
-            </a:r>
-          </a:p>
-          <a:p xmlns:a="http://schemas.openxmlformats.org/drawingml/2006/main">
             <a:pPr>
               <a:defRPr sz="2100" b="0">
                 <a:solidFill>
@@ -13974,6 +14060,18 @@
                 <a:cs typeface="Calibri"/>
               </a:defRPr>
             </a:pPr>
+          </a:p>
+          <a:p xmlns:a="http://schemas.openxmlformats.org/drawingml/2006/main">
+            <a:pPr>
+              <a:defRPr sz="2100" b="0">
+                <a:solidFill>
+                  <a:srgbClr val="172F43"/>
+                </a:solidFill>
+                <a:latin typeface="Calibri"/>
+                <a:ea typeface="Calibri"/>
+                <a:cs typeface="Calibri"/>
+              </a:defRPr>
+            </a:pPr>
             <a:r>
               <a:rPr sz="2100" b="0">
                 <a:solidFill>
@@ -13983,7 +14081,7 @@
                 <a:ea typeface="Calibri"/>
                 <a:cs typeface="Calibri"/>
               </a:rPr>
-              <a:t>Basdelen använder sinus, 12,00 V RMS och 50 Hz. Station B är ett senare, utökat försök.</a:t>
+              <a:t>Basdelen använder en sinusspänning med effektivvärdet 12,00 V (skrivs 12,00 V RMS) och frekvensen 50 hertz (Hz). Station B är ett senare, utökat försök.</a:t>
             </a:r>
           </a:p>
         </p:txBody>
@@ -14680,11 +14778,6 @@
             </a:r>
           </a:p>
           <a:p xmlns:a="http://schemas.openxmlformats.org/drawingml/2006/main">
-            <a:r>
-              <a:t/>
-            </a:r>
-          </a:p>
-          <a:p xmlns:a="http://schemas.openxmlformats.org/drawingml/2006/main">
             <a:pPr>
               <a:defRPr sz="1650" b="0">
                 <a:solidFill>
@@ -14695,6 +14788,18 @@
                 <a:cs typeface="Calibri"/>
               </a:defRPr>
             </a:pPr>
+          </a:p>
+          <a:p xmlns:a="http://schemas.openxmlformats.org/drawingml/2006/main">
+            <a:pPr>
+              <a:defRPr sz="1650" b="0">
+                <a:solidFill>
+                  <a:srgbClr val="172F43"/>
+                </a:solidFill>
+                <a:latin typeface="Calibri"/>
+                <a:ea typeface="Calibri"/>
+                <a:cs typeface="Calibri"/>
+              </a:defRPr>
+            </a:pPr>
             <a:r>
               <a:rPr sz="1650" b="0">
                 <a:solidFill>
@@ -14704,13 +14809,20 @@
                 <a:ea typeface="Calibri"/>
                 <a:cs typeface="Calibri"/>
               </a:rPr>
-              <a:t>Vid 50 Hz: T = 1/50 = 0,020 s = 20,00 ms.</a:t>
-            </a:r>
-          </a:p>
-          <a:p xmlns:a="http://schemas.openxmlformats.org/drawingml/2006/main">
-            <a:r>
-              <a:t/>
-            </a:r>
+              <a:t>Periodtiden T är tiden för en hel period. Vid 50 Hz: T = 1/50 = 0,020 s = 20,00 ms (millisekunder, tusendels sekunder).</a:t>
+            </a:r>
+          </a:p>
+          <a:p xmlns:a="http://schemas.openxmlformats.org/drawingml/2006/main">
+            <a:pPr>
+              <a:defRPr sz="1650" b="0">
+                <a:solidFill>
+                  <a:srgbClr val="172F43"/>
+                </a:solidFill>
+                <a:latin typeface="Calibri"/>
+                <a:ea typeface="Calibri"/>
+                <a:cs typeface="Calibri"/>
+              </a:defRPr>
+            </a:pPr>
           </a:p>
           <a:p xmlns:a="http://schemas.openxmlformats.org/drawingml/2006/main">
             <a:pPr>
@@ -15136,12 +15248,7 @@
                 <a:ea typeface="Calibri"/>
                 <a:cs typeface="Calibri"/>
               </a:rPr>
-              <a:t>Toppvärdet û mäts från noll till den positiva toppen.</a:t>
-            </a:r>
-          </a:p>
-          <a:p xmlns:a="http://schemas.openxmlformats.org/drawingml/2006/main">
-            <a:r>
-              <a:t/>
+              <a:t>Toppvärdet û (läses u-topp, u med hatt) mäts från noll till den positiva toppen.</a:t>
             </a:r>
           </a:p>
           <a:p xmlns:a="http://schemas.openxmlformats.org/drawingml/2006/main">
@@ -15155,22 +15262,6 @@
                 <a:cs typeface="Calibri"/>
               </a:defRPr>
             </a:pPr>
-            <a:r>
-              <a:rPr sz="1650" b="0">
-                <a:solidFill>
-                  <a:srgbClr val="172F43"/>
-                </a:solidFill>
-                <a:latin typeface="Calibri"/>
-                <a:ea typeface="Calibri"/>
-                <a:cs typeface="Calibri"/>
-              </a:rPr>
-              <a:t>Topp till topp, Upp, går från negativ topp till positiv topp.</a:t>
-            </a:r>
-          </a:p>
-          <a:p xmlns:a="http://schemas.openxmlformats.org/drawingml/2006/main">
-            <a:r>
-              <a:t/>
-            </a:r>
           </a:p>
           <a:p xmlns:a="http://schemas.openxmlformats.org/drawingml/2006/main">
             <a:pPr>
@@ -15192,7 +15283,86 @@
                 <a:ea typeface="Calibri"/>
                 <a:cs typeface="Calibri"/>
               </a:rPr>
-              <a:t>För vår sinus: û ≈ 16,97 V och Upp ≈ 33,94 V.</a:t>
+              <a:t>Topp till topp, U</a:t>
+            </a:r>
+            <a:r>
+              <a:rPr sz="1650" b="0" baseline="-25000">
+                <a:solidFill>
+                  <a:srgbClr val="172F43"/>
+                </a:solidFill>
+                <a:latin typeface="Calibri"/>
+                <a:ea typeface="Calibri"/>
+                <a:cs typeface="Calibri"/>
+              </a:rPr>
+              <a:t>pp</a:t>
+            </a:r>
+            <a:r>
+              <a:rPr sz="1650" b="0">
+                <a:solidFill>
+                  <a:srgbClr val="172F43"/>
+                </a:solidFill>
+                <a:latin typeface="Calibri"/>
+                <a:ea typeface="Calibri"/>
+                <a:cs typeface="Calibri"/>
+              </a:rPr>
+              <a:t> (pp: peak to peak), går från negativ topp till positiv topp.</a:t>
+            </a:r>
+          </a:p>
+          <a:p xmlns:a="http://schemas.openxmlformats.org/drawingml/2006/main">
+            <a:pPr>
+              <a:defRPr sz="1650" b="0">
+                <a:solidFill>
+                  <a:srgbClr val="172F43"/>
+                </a:solidFill>
+                <a:latin typeface="Calibri"/>
+                <a:ea typeface="Calibri"/>
+                <a:cs typeface="Calibri"/>
+              </a:defRPr>
+            </a:pPr>
+          </a:p>
+          <a:p xmlns:a="http://schemas.openxmlformats.org/drawingml/2006/main">
+            <a:pPr>
+              <a:defRPr sz="1650" b="0">
+                <a:solidFill>
+                  <a:srgbClr val="172F43"/>
+                </a:solidFill>
+                <a:latin typeface="Calibri"/>
+                <a:ea typeface="Calibri"/>
+                <a:cs typeface="Calibri"/>
+              </a:defRPr>
+            </a:pPr>
+            <a:r>
+              <a:rPr sz="1650" b="0">
+                <a:solidFill>
+                  <a:srgbClr val="172F43"/>
+                </a:solidFill>
+                <a:latin typeface="Calibri"/>
+                <a:ea typeface="Calibri"/>
+                <a:cs typeface="Calibri"/>
+              </a:rPr>
+              <a:t>För vår sinus: û ≈ 16,97 V och U</a:t>
+            </a:r>
+            <a:r>
+              <a:rPr sz="1650" b="0" baseline="-25000">
+                <a:solidFill>
+                  <a:srgbClr val="172F43"/>
+                </a:solidFill>
+                <a:latin typeface="Calibri"/>
+                <a:ea typeface="Calibri"/>
+                <a:cs typeface="Calibri"/>
+              </a:rPr>
+              <a:t>pp</a:t>
+            </a:r>
+            <a:r>
+              <a:rPr sz="1650" b="0">
+                <a:solidFill>
+                  <a:srgbClr val="172F43"/>
+                </a:solidFill>
+                <a:latin typeface="Calibri"/>
+                <a:ea typeface="Calibri"/>
+                <a:cs typeface="Calibri"/>
+              </a:rPr>
+              <a:t> ≈ 33,94 V.</a:t>
             </a:r>
           </a:p>
         </p:txBody>
@@ -15249,7 +15419,29 @@
                 <a:ea typeface="Calibri"/>
                 <a:cs typeface="Calibri"/>
               </a:rPr>
-              <a:t>Upp = 2 · û</a:t>
+              <a:t>U</a:t>
+            </a:r>
+            <a:r>
+              <a:rPr sz="1725" b="1" baseline="-25000">
+                <a:solidFill>
+                  <a:srgbClr val="064F91"/>
+                </a:solidFill>
+                <a:latin typeface="Calibri"/>
+                <a:ea typeface="Calibri"/>
+                <a:cs typeface="Calibri"/>
+              </a:rPr>
+              <a:t>pp</a:t>
+            </a:r>
+            <a:r>
+              <a:rPr sz="1725" b="1">
+                <a:solidFill>
+                  <a:srgbClr val="064F91"/>
+                </a:solidFill>
+                <a:latin typeface="Calibri"/>
+                <a:ea typeface="Calibri"/>
+                <a:cs typeface="Calibri"/>
+              </a:rPr>
+              <a:t> = 2 · û</a:t>
             </a:r>
           </a:p>
         </p:txBody>
@@ -15751,12 +15943,7 @@
                 <a:ea typeface="Calibri"/>
                 <a:cs typeface="Calibri"/>
               </a:rPr>
-              <a:t>12,00 V RMS över en resistor ger samma medeleffekt som 12,00 V likspänning över samma resistor.</a:t>
-            </a:r>
-          </a:p>
-          <a:p xmlns:a="http://schemas.openxmlformats.org/drawingml/2006/main">
-            <a:r>
-              <a:t/>
+              <a:t>Effektivvärdet 12,00 V över en resistor ger samma medeleffekt (värme) som 12,00 V likspänning (DC) över samma resistor.</a:t>
             </a:r>
           </a:p>
           <a:p xmlns:a="http://schemas.openxmlformats.org/drawingml/2006/main">
@@ -15770,6 +15957,18 @@
                 <a:cs typeface="Calibri"/>
               </a:defRPr>
             </a:pPr>
+          </a:p>
+          <a:p xmlns:a="http://schemas.openxmlformats.org/drawingml/2006/main">
+            <a:pPr>
+              <a:defRPr sz="1650" b="0">
+                <a:solidFill>
+                  <a:srgbClr val="172F43"/>
+                </a:solidFill>
+                <a:latin typeface="Calibri"/>
+                <a:ea typeface="Calibri"/>
+                <a:cs typeface="Calibri"/>
+              </a:defRPr>
+            </a:pPr>
             <a:r>
               <a:rPr sz="1650" b="0">
                 <a:solidFill>
@@ -15779,13 +15978,20 @@
                 <a:ea typeface="Calibri"/>
                 <a:cs typeface="Calibri"/>
               </a:rPr>
-              <a:t>RMS kallas effektivvärde. Multimetern i AC-läge visar här 12,00 V.</a:t>
-            </a:r>
-          </a:p>
-          <a:p xmlns:a="http://schemas.openxmlformats.org/drawingml/2006/main">
-            <a:r>
-              <a:t/>
-            </a:r>
+              <a:t>Effektivvärdet förkortas RMS (root mean square, engelska för kvadratiskt medelvärde). U utan index betyder alltid effektivvärdet. Multimetern i växelspänningsläget (AC eller V~) visar här 12,00 V.</a:t>
+            </a:r>
+          </a:p>
+          <a:p xmlns:a="http://schemas.openxmlformats.org/drawingml/2006/main">
+            <a:pPr>
+              <a:defRPr sz="1650" b="0">
+                <a:solidFill>
+                  <a:srgbClr val="172F43"/>
+                </a:solidFill>
+                <a:latin typeface="Calibri"/>
+                <a:ea typeface="Calibri"/>
+                <a:cs typeface="Calibri"/>
+              </a:defRPr>
+            </a:pPr>
           </a:p>
           <a:p xmlns:a="http://schemas.openxmlformats.org/drawingml/2006/main">
             <a:pPr>
@@ -16728,11 +16934,6 @@
             </a:r>
           </a:p>
           <a:p xmlns:a="http://schemas.openxmlformats.org/drawingml/2006/main">
-            <a:r>
-              <a:t/>
-            </a:r>
-          </a:p>
-          <a:p xmlns:a="http://schemas.openxmlformats.org/drawingml/2006/main">
             <a:pPr>
               <a:defRPr sz="1650" b="0">
                 <a:solidFill>
@@ -16743,6 +16944,18 @@
                 <a:cs typeface="Calibri"/>
               </a:defRPr>
             </a:pPr>
+          </a:p>
+          <a:p xmlns:a="http://schemas.openxmlformats.org/drawingml/2006/main">
+            <a:pPr>
+              <a:defRPr sz="1650" b="0">
+                <a:solidFill>
+                  <a:srgbClr val="172F43"/>
+                </a:solidFill>
+                <a:latin typeface="Calibri"/>
+                <a:ea typeface="Calibri"/>
+                <a:cs typeface="Calibri"/>
+              </a:defRPr>
+            </a:pPr>
             <a:r>
               <a:rPr sz="1650" b="0">
                 <a:solidFill>
@@ -16752,13 +16965,20 @@
                 <a:ea typeface="Calibri"/>
                 <a:cs typeface="Calibri"/>
               </a:rPr>
-              <a:t>Förutsäg visningen. Läs sedan av både true RMS-mätaren och den sinuskalibrerade mätaren.</a:t>
-            </a:r>
-          </a:p>
-          <a:p xmlns:a="http://schemas.openxmlformats.org/drawingml/2006/main">
-            <a:r>
-              <a:t/>
-            </a:r>
+              <a:t>Förutsäg visningen. Läs sedan av både true RMS-mätaren (räknar ut det verkliga effektivvärdet för alla kurvformer) och den sinuskalibrerade mätaren (visar rätt bara för ren sinus).</a:t>
+            </a:r>
+          </a:p>
+          <a:p xmlns:a="http://schemas.openxmlformats.org/drawingml/2006/main">
+            <a:pPr>
+              <a:defRPr sz="1650" b="0">
+                <a:solidFill>
+                  <a:srgbClr val="172F43"/>
+                </a:solidFill>
+                <a:latin typeface="Calibri"/>
+                <a:ea typeface="Calibri"/>
+                <a:cs typeface="Calibri"/>
+              </a:defRPr>
+            </a:pPr>
           </a:p>
           <a:p xmlns:a="http://schemas.openxmlformats.org/drawingml/2006/main">
             <a:pPr>

</xml_diff>

<commit_message>
Sjöskolan v40: genomgång och stegfilmer utan labbens svar, svensk text utan ljud
Genomgången (lektioner.mjs), figurerna (visuals.mjs), lektionsartiklarna,
presentationerna v40_01–03 med PDF och bildspel räknade exakt labbens
uppgifter. Nu lärs metoden ut med hemmets och fartygets värden: 440 V/60 Hz,
fläktmotor 50 Ω/382 mH (X_{L} 120 Ω, Z 130 Ω), pumpmotor 1 380 W. Diagrammen
i presentationerna är omritade (kurva 60 Hz, skalriktig impedanstriangel).

Stegfilmerna har svensk text och egen klocka; den engelska rösten,
film-manus.mjs och narrate-short.py är borttagna. Ändringsloggen har regel 22.

Co-Authored-By: Claude Opus 5.5 <noreply@anthropic.com>
Claude-Session: https://claude.ai/code/session_011V9KjBb53XrDm23Dw58SH3
</commit_message>
<xml_diff>
--- a/sjoskolan/vecka-40/aktuell/v40_01_Sinusformad_vaxelspanning_elev.pptx
+++ b/sjoskolan/vecka-40/aktuell/v40_01_Sinusformad_vaxelspanning_elev.pptx
@@ -1020,7 +1020,7 @@
           <a:lstStyle xmlns:a="http://schemas.openxmlformats.org/drawingml/2006/main"/>
           <a:p xmlns:a="http://schemas.openxmlformats.org/drawingml/2006/main">
             <a:r>
-              <a:t>Här hålls RMS konstant. Vid jämförelse med samma toppvärde blir RMS i stället olika. True RMS visar 12,00 V för alla tre i idealmodellen. Verkliga instrument har frekvens-, bandbredds- och crestfaktorgränser.</a:t>
+              <a:t>Här hålls RMS konstant. Vid jämförelse med samma toppvärde blir RMS i stället olika. True RMS visar 10,00 V för alla tre i idealmodellen. Verkliga instrument har frekvens-, bandbredds- och crestfaktorgränser.</a:t>
             </a:r>
           </a:p>
           <a:p xmlns:a="http://schemas.openxmlformats.org/drawingml/2006/main">
@@ -1480,7 +1480,7 @@
           <a:lstStyle xmlns:a="http://schemas.openxmlformats.org/drawingml/2006/main"/>
           <a:p xmlns:a="http://schemas.openxmlformats.org/drawingml/2006/main">
             <a:r>
-              <a:t>Låt eleven peka på två stigande nollpassager innan formeln används. Vanligt fel: 0,020 s skrivs som 0,020 ms.</a:t>
+              <a:t>Låt eleven peka på två stigande nollpassager innan formeln används. Vanligt fel: 0,0167 s skrivs som 0,0167 ms.</a:t>
             </a:r>
           </a:p>
           <a:p xmlns:a="http://schemas.openxmlformats.org/drawingml/2006/main">
@@ -1690,7 +1690,7 @@
           <a:lstStyle xmlns:a="http://schemas.openxmlformats.org/drawingml/2006/main"/>
           <a:p xmlns:a="http://schemas.openxmlformats.org/drawingml/2006/main">
             <a:r>
-              <a:t>Förklara betydelsen innan förkortningen root mean square. Samma resistor 24 Ω ger P = 12²/24 = 6 W i båda fallen.</a:t>
+              <a:t>Förklara betydelsen innan förkortningen root mean square. Ett element på 23 Ω ger P = 230²/23 = 2 300 W med 230 V RMS och med 230 V DC.</a:t>
             </a:r>
           </a:p>
           <a:p xmlns:a="http://schemas.openxmlformats.org/drawingml/2006/main">
@@ -1780,7 +1780,7 @@
           <a:lstStyle xmlns:a="http://schemas.openxmlformats.org/drawingml/2006/main"/>
           <a:p xmlns:a="http://schemas.openxmlformats.org/drawingml/2006/main">
             <a:r>
-              <a:t>Exemplet har samma metod men ett annat spänningsvärde än elevens grundkälla.</a:t>
+              <a:t>Exemplet har samma metod men andra värden än labbens källa, så att eleven själv räknar fram labbens svar.</a:t>
             </a:r>
           </a:p>
           <a:p xmlns:a="http://schemas.openxmlformats.org/drawingml/2006/main">
@@ -5374,7 +5374,15 @@
           <c:idx val="0"/>
           <c:order val="0"/>
           <c:tx>
-            <c:v>Spänning (V)</c:v>
+            <c:strRef>
+              <c:f>Sheet1!$B$1</c:f>
+              <c:strCache>
+                <c:ptCount val="1"/>
+                <c:pt idx="0">
+                  <c:v>u</c:v>
+                </c:pt>
+              </c:strCache>
+            </c:strRef>
           </c:tx>
           <c:spPr>
             <a:ln xmlns:a="http://schemas.openxmlformats.org/drawingml/2006/main" w="23813">
@@ -5388,12 +5396,12 @@
           </c:marker>
           <c:xVal>
             <c:numRef>
-              <c:f>'Chart Data'!$A$2:$A$162</c:f>
+              <c:f>Sheet1!$A$2:$A$162</c:f>
               <c:numCache>
                 <c:formatCode>General</c:formatCode>
                 <c:ptCount val="161"/>
                 <c:pt idx="0">
-                  <c:v>0</c:v>
+                  <c:v>0.0</c:v>
                 </c:pt>
                 <c:pt idx="1">
                   <c:v>0.25</c:v>
@@ -5405,7 +5413,7 @@
                   <c:v>0.75</c:v>
                 </c:pt>
                 <c:pt idx="4">
-                  <c:v>1</c:v>
+                  <c:v>1.0</c:v>
                 </c:pt>
                 <c:pt idx="5">
                   <c:v>1.25</c:v>
@@ -5417,7 +5425,7 @@
                   <c:v>1.75</c:v>
                 </c:pt>
                 <c:pt idx="8">
-                  <c:v>2</c:v>
+                  <c:v>2.0</c:v>
                 </c:pt>
                 <c:pt idx="9">
                   <c:v>2.25</c:v>
@@ -5429,7 +5437,7 @@
                   <c:v>2.75</c:v>
                 </c:pt>
                 <c:pt idx="12">
-                  <c:v>3</c:v>
+                  <c:v>3.0</c:v>
                 </c:pt>
                 <c:pt idx="13">
                   <c:v>3.25</c:v>
@@ -5441,7 +5449,7 @@
                   <c:v>3.75</c:v>
                 </c:pt>
                 <c:pt idx="16">
-                  <c:v>4</c:v>
+                  <c:v>4.0</c:v>
                 </c:pt>
                 <c:pt idx="17">
                   <c:v>4.25</c:v>
@@ -5453,7 +5461,7 @@
                   <c:v>4.75</c:v>
                 </c:pt>
                 <c:pt idx="20">
-                  <c:v>5</c:v>
+                  <c:v>5.0</c:v>
                 </c:pt>
                 <c:pt idx="21">
                   <c:v>5.25</c:v>
@@ -5465,7 +5473,7 @@
                   <c:v>5.75</c:v>
                 </c:pt>
                 <c:pt idx="24">
-                  <c:v>6</c:v>
+                  <c:v>6.0</c:v>
                 </c:pt>
                 <c:pt idx="25">
                   <c:v>6.25</c:v>
@@ -5477,7 +5485,7 @@
                   <c:v>6.75</c:v>
                 </c:pt>
                 <c:pt idx="28">
-                  <c:v>7</c:v>
+                  <c:v>7.0</c:v>
                 </c:pt>
                 <c:pt idx="29">
                   <c:v>7.25</c:v>
@@ -5489,7 +5497,7 @@
                   <c:v>7.75</c:v>
                 </c:pt>
                 <c:pt idx="32">
-                  <c:v>8</c:v>
+                  <c:v>8.0</c:v>
                 </c:pt>
                 <c:pt idx="33">
                   <c:v>8.25</c:v>
@@ -5501,7 +5509,7 @@
                   <c:v>8.75</c:v>
                 </c:pt>
                 <c:pt idx="36">
-                  <c:v>9</c:v>
+                  <c:v>9.0</c:v>
                 </c:pt>
                 <c:pt idx="37">
                   <c:v>9.25</c:v>
@@ -5513,7 +5521,7 @@
                   <c:v>9.75</c:v>
                 </c:pt>
                 <c:pt idx="40">
-                  <c:v>10</c:v>
+                  <c:v>10.0</c:v>
                 </c:pt>
                 <c:pt idx="41">
                   <c:v>10.25</c:v>
@@ -5525,7 +5533,7 @@
                   <c:v>10.75</c:v>
                 </c:pt>
                 <c:pt idx="44">
-                  <c:v>11</c:v>
+                  <c:v>11.0</c:v>
                 </c:pt>
                 <c:pt idx="45">
                   <c:v>11.25</c:v>
@@ -5537,7 +5545,7 @@
                   <c:v>11.75</c:v>
                 </c:pt>
                 <c:pt idx="48">
-                  <c:v>12</c:v>
+                  <c:v>12.0</c:v>
                 </c:pt>
                 <c:pt idx="49">
                   <c:v>12.25</c:v>
@@ -5549,7 +5557,7 @@
                   <c:v>12.75</c:v>
                 </c:pt>
                 <c:pt idx="52">
-                  <c:v>13</c:v>
+                  <c:v>13.0</c:v>
                 </c:pt>
                 <c:pt idx="53">
                   <c:v>13.25</c:v>
@@ -5561,7 +5569,7 @@
                   <c:v>13.75</c:v>
                 </c:pt>
                 <c:pt idx="56">
-                  <c:v>14</c:v>
+                  <c:v>14.0</c:v>
                 </c:pt>
                 <c:pt idx="57">
                   <c:v>14.25</c:v>
@@ -5573,7 +5581,7 @@
                   <c:v>14.75</c:v>
                 </c:pt>
                 <c:pt idx="60">
-                  <c:v>15</c:v>
+                  <c:v>15.0</c:v>
                 </c:pt>
                 <c:pt idx="61">
                   <c:v>15.25</c:v>
@@ -5585,7 +5593,7 @@
                   <c:v>15.75</c:v>
                 </c:pt>
                 <c:pt idx="64">
-                  <c:v>16</c:v>
+                  <c:v>16.0</c:v>
                 </c:pt>
                 <c:pt idx="65">
                   <c:v>16.25</c:v>
@@ -5597,7 +5605,7 @@
                   <c:v>16.75</c:v>
                 </c:pt>
                 <c:pt idx="68">
-                  <c:v>17</c:v>
+                  <c:v>17.0</c:v>
                 </c:pt>
                 <c:pt idx="69">
                   <c:v>17.25</c:v>
@@ -5609,7 +5617,7 @@
                   <c:v>17.75</c:v>
                 </c:pt>
                 <c:pt idx="72">
-                  <c:v>18</c:v>
+                  <c:v>18.0</c:v>
                 </c:pt>
                 <c:pt idx="73">
                   <c:v>18.25</c:v>
@@ -5621,7 +5629,7 @@
                   <c:v>18.75</c:v>
                 </c:pt>
                 <c:pt idx="76">
-                  <c:v>19</c:v>
+                  <c:v>19.0</c:v>
                 </c:pt>
                 <c:pt idx="77">
                   <c:v>19.25</c:v>
@@ -5633,7 +5641,7 @@
                   <c:v>19.75</c:v>
                 </c:pt>
                 <c:pt idx="80">
-                  <c:v>20</c:v>
+                  <c:v>20.0</c:v>
                 </c:pt>
                 <c:pt idx="81">
                   <c:v>20.25</c:v>
@@ -5645,7 +5653,7 @@
                   <c:v>20.75</c:v>
                 </c:pt>
                 <c:pt idx="84">
-                  <c:v>21</c:v>
+                  <c:v>21.0</c:v>
                 </c:pt>
                 <c:pt idx="85">
                   <c:v>21.25</c:v>
@@ -5657,7 +5665,7 @@
                   <c:v>21.75</c:v>
                 </c:pt>
                 <c:pt idx="88">
-                  <c:v>22</c:v>
+                  <c:v>22.0</c:v>
                 </c:pt>
                 <c:pt idx="89">
                   <c:v>22.25</c:v>
@@ -5669,7 +5677,7 @@
                   <c:v>22.75</c:v>
                 </c:pt>
                 <c:pt idx="92">
-                  <c:v>23</c:v>
+                  <c:v>23.0</c:v>
                 </c:pt>
                 <c:pt idx="93">
                   <c:v>23.25</c:v>
@@ -5681,7 +5689,7 @@
                   <c:v>23.75</c:v>
                 </c:pt>
                 <c:pt idx="96">
-                  <c:v>24</c:v>
+                  <c:v>24.0</c:v>
                 </c:pt>
                 <c:pt idx="97">
                   <c:v>24.25</c:v>
@@ -5693,7 +5701,7 @@
                   <c:v>24.75</c:v>
                 </c:pt>
                 <c:pt idx="100">
-                  <c:v>25</c:v>
+                  <c:v>25.0</c:v>
                 </c:pt>
                 <c:pt idx="101">
                   <c:v>25.25</c:v>
@@ -5705,7 +5713,7 @@
                   <c:v>25.75</c:v>
                 </c:pt>
                 <c:pt idx="104">
-                  <c:v>26</c:v>
+                  <c:v>26.0</c:v>
                 </c:pt>
                 <c:pt idx="105">
                   <c:v>26.25</c:v>
@@ -5717,7 +5725,7 @@
                   <c:v>26.75</c:v>
                 </c:pt>
                 <c:pt idx="108">
-                  <c:v>27</c:v>
+                  <c:v>27.0</c:v>
                 </c:pt>
                 <c:pt idx="109">
                   <c:v>27.25</c:v>
@@ -5729,7 +5737,7 @@
                   <c:v>27.75</c:v>
                 </c:pt>
                 <c:pt idx="112">
-                  <c:v>28</c:v>
+                  <c:v>28.0</c:v>
                 </c:pt>
                 <c:pt idx="113">
                   <c:v>28.25</c:v>
@@ -5741,7 +5749,7 @@
                   <c:v>28.75</c:v>
                 </c:pt>
                 <c:pt idx="116">
-                  <c:v>29</c:v>
+                  <c:v>29.0</c:v>
                 </c:pt>
                 <c:pt idx="117">
                   <c:v>29.25</c:v>
@@ -5753,7 +5761,7 @@
                   <c:v>29.75</c:v>
                 </c:pt>
                 <c:pt idx="120">
-                  <c:v>30</c:v>
+                  <c:v>30.0</c:v>
                 </c:pt>
                 <c:pt idx="121">
                   <c:v>30.25</c:v>
@@ -5765,7 +5773,7 @@
                   <c:v>30.75</c:v>
                 </c:pt>
                 <c:pt idx="124">
-                  <c:v>31</c:v>
+                  <c:v>31.0</c:v>
                 </c:pt>
                 <c:pt idx="125">
                   <c:v>31.25</c:v>
@@ -5777,7 +5785,7 @@
                   <c:v>31.75</c:v>
                 </c:pt>
                 <c:pt idx="128">
-                  <c:v>32</c:v>
+                  <c:v>32.0</c:v>
                 </c:pt>
                 <c:pt idx="129">
                   <c:v>32.25</c:v>
@@ -5789,7 +5797,7 @@
                   <c:v>32.75</c:v>
                 </c:pt>
                 <c:pt idx="132">
-                  <c:v>33</c:v>
+                  <c:v>33.0</c:v>
                 </c:pt>
                 <c:pt idx="133">
                   <c:v>33.25</c:v>
@@ -5801,7 +5809,7 @@
                   <c:v>33.75</c:v>
                 </c:pt>
                 <c:pt idx="136">
-                  <c:v>34</c:v>
+                  <c:v>34.0</c:v>
                 </c:pt>
                 <c:pt idx="137">
                   <c:v>34.25</c:v>
@@ -5813,7 +5821,7 @@
                   <c:v>34.75</c:v>
                 </c:pt>
                 <c:pt idx="140">
-                  <c:v>35</c:v>
+                  <c:v>35.0</c:v>
                 </c:pt>
                 <c:pt idx="141">
                   <c:v>35.25</c:v>
@@ -5825,7 +5833,7 @@
                   <c:v>35.75</c:v>
                 </c:pt>
                 <c:pt idx="144">
-                  <c:v>36</c:v>
+                  <c:v>36.0</c:v>
                 </c:pt>
                 <c:pt idx="145">
                   <c:v>36.25</c:v>
@@ -5837,7 +5845,7 @@
                   <c:v>36.75</c:v>
                 </c:pt>
                 <c:pt idx="148">
-                  <c:v>37</c:v>
+                  <c:v>37.0</c:v>
                 </c:pt>
                 <c:pt idx="149">
                   <c:v>37.25</c:v>
@@ -5849,7 +5857,7 @@
                   <c:v>37.75</c:v>
                 </c:pt>
                 <c:pt idx="152">
-                  <c:v>38</c:v>
+                  <c:v>38.0</c:v>
                 </c:pt>
                 <c:pt idx="153">
                   <c:v>38.25</c:v>
@@ -5861,7 +5869,7 @@
                   <c:v>38.75</c:v>
                 </c:pt>
                 <c:pt idx="156">
-                  <c:v>39</c:v>
+                  <c:v>39.0</c:v>
                 </c:pt>
                 <c:pt idx="157">
                   <c:v>39.25</c:v>
@@ -5873,499 +5881,499 @@
                   <c:v>39.75</c:v>
                 </c:pt>
                 <c:pt idx="160">
-                  <c:v>40</c:v>
+                  <c:v>40.0</c:v>
                 </c:pt>
               </c:numCache>
             </c:numRef>
           </c:xVal>
           <c:yVal>
             <c:numRef>
-              <c:f>'Chart Data'!$B$2:$B$162</c:f>
+              <c:f>Sheet1!$B$2:$B$162</c:f>
               <c:numCache>
                 <c:formatCode>General</c:formatCode>
                 <c:ptCount val="161"/>
                 <c:pt idx="0">
-                  <c:v>0</c:v>
+                  <c:v>0.0</c:v>
                 </c:pt>
                 <c:pt idx="1">
-                  <c:v>1.33149501</c:v>
+                  <c:v>58.54</c:v>
                 </c:pt>
                 <c:pt idx="2">
-                  <c:v>2.6547809</c:v>
+                  <c:v>116.55</c:v>
                 </c:pt>
                 <c:pt idx="3">
-                  <c:v>3.9616992</c:v>
+                  <c:v>173.53</c:v>
                 </c:pt>
                 <c:pt idx="4">
-                  <c:v>5.24419229</c:v>
+                  <c:v>228.97</c:v>
                 </c:pt>
                 <c:pt idx="5">
-                  <c:v>6.4943532</c:v>
+                  <c:v>282.38</c:v>
                 </c:pt>
                 <c:pt idx="6">
-                  <c:v>7.70447426</c:v>
+                  <c:v>333.28</c:v>
                 </c:pt>
                 <c:pt idx="7">
-                  <c:v>8.86709468</c:v>
+                  <c:v>381.23</c:v>
                 </c:pt>
                 <c:pt idx="8">
-                  <c:v>9.97504651</c:v>
+                  <c:v>425.79</c:v>
                 </c:pt>
                 <c:pt idx="9">
-                  <c:v>11.02149886</c:v>
+                  <c:v>466.57</c:v>
                 </c:pt>
                 <c:pt idx="10">
-                  <c:v>12</c:v>
+                  <c:v>503.21</c:v>
                 </c:pt>
                 <c:pt idx="11">
-                  <c:v>12.90451715</c:v>
+                  <c:v>535.38</c:v>
                 </c:pt>
                 <c:pt idx="12">
-                  <c:v>13.72947367</c:v>
+                  <c:v>562.8</c:v>
                 </c:pt>
                 <c:pt idx="13">
-                  <c:v>14.46978341</c:v>
+                  <c:v>585.23</c:v>
                 </c:pt>
                 <c:pt idx="14">
-                  <c:v>15.12088213</c:v>
+                  <c:v>602.46</c:v>
                 </c:pt>
                 <c:pt idx="15">
-                  <c:v>15.67875558</c:v>
+                  <c:v>614.34</c:v>
                 </c:pt>
                 <c:pt idx="16">
-                  <c:v>16.13996429</c:v>
+                  <c:v>620.77</c:v>
                 </c:pt>
                 <c:pt idx="17">
-                  <c:v>16.50166475</c:v>
+                  <c:v>621.69</c:v>
                 </c:pt>
                 <c:pt idx="18">
-                  <c:v>16.76162696</c:v>
+                  <c:v>617.1</c:v>
                 </c:pt>
                 <c:pt idx="19">
-                  <c:v>16.91824817</c:v>
+                  <c:v>607.02</c:v>
                 </c:pt>
                 <c:pt idx="20">
-                  <c:v>16.97056275</c:v>
+                  <c:v>591.56</c:v>
                 </c:pt>
                 <c:pt idx="21">
-                  <c:v>16.91824817</c:v>
+                  <c:v>570.84</c:v>
                 </c:pt>
                 <c:pt idx="22">
-                  <c:v>16.76162696</c:v>
+                  <c:v>545.06</c:v>
                 </c:pt>
                 <c:pt idx="23">
-                  <c:v>16.50166475</c:v>
+                  <c:v>514.44</c:v>
                 </c:pt>
                 <c:pt idx="24">
-                  <c:v>16.13996429</c:v>
+                  <c:v>479.26</c:v>
                 </c:pt>
                 <c:pt idx="25">
-                  <c:v>15.67875558</c:v>
+                  <c:v>439.82</c:v>
                 </c:pt>
                 <c:pt idx="26">
-                  <c:v>15.12088213</c:v>
+                  <c:v>396.48</c:v>
                 </c:pt>
                 <c:pt idx="27">
-                  <c:v>14.46978341</c:v>
+                  <c:v>349.62</c:v>
                 </c:pt>
                 <c:pt idx="28">
-                  <c:v>13.72947367</c:v>
+                  <c:v>299.65</c:v>
                 </c:pt>
                 <c:pt idx="29">
-                  <c:v>12.90451715</c:v>
+                  <c:v>247.03</c:v>
                 </c:pt>
                 <c:pt idx="30">
-                  <c:v>12</c:v>
+                  <c:v>192.21</c:v>
                 </c:pt>
                 <c:pt idx="31">
-                  <c:v>11.02149886</c:v>
+                  <c:v>135.69</c:v>
                 </c:pt>
                 <c:pt idx="32">
-                  <c:v>9.97504651</c:v>
+                  <c:v>77.96</c:v>
                 </c:pt>
                 <c:pt idx="33">
-                  <c:v>8.86709468</c:v>
+                  <c:v>19.54</c:v>
                 </c:pt>
                 <c:pt idx="34">
-                  <c:v>7.70447426</c:v>
+                  <c:v>-39.06</c:v>
                 </c:pt>
                 <c:pt idx="35">
-                  <c:v>6.4943532</c:v>
+                  <c:v>-97.3</c:v>
                 </c:pt>
                 <c:pt idx="36">
-                  <c:v>5.24419229</c:v>
+                  <c:v>-154.69</c:v>
                 </c:pt>
                 <c:pt idx="37">
-                  <c:v>3.9616992</c:v>
+                  <c:v>-210.69</c:v>
                 </c:pt>
                 <c:pt idx="38">
-                  <c:v>2.6547809</c:v>
+                  <c:v>-264.83</c:v>
                 </c:pt>
                 <c:pt idx="39">
-                  <c:v>1.33149501</c:v>
+                  <c:v>-316.62</c:v>
                 </c:pt>
                 <c:pt idx="40">
-                  <c:v>0</c:v>
+                  <c:v>-365.6</c:v>
                 </c:pt>
                 <c:pt idx="41">
-                  <c:v>-1.33149501</c:v>
+                  <c:v>-411.34</c:v>
                 </c:pt>
                 <c:pt idx="42">
-                  <c:v>-2.6547809</c:v>
+                  <c:v>-453.42</c:v>
                 </c:pt>
                 <c:pt idx="43">
-                  <c:v>-3.9616992</c:v>
+                  <c:v>-491.48</c:v>
                 </c:pt>
                 <c:pt idx="44">
-                  <c:v>-5.24419229</c:v>
+                  <c:v>-525.17</c:v>
                 </c:pt>
                 <c:pt idx="45">
-                  <c:v>-6.4943532</c:v>
+                  <c:v>-554.21</c:v>
                 </c:pt>
                 <c:pt idx="46">
-                  <c:v>-7.70447426</c:v>
+                  <c:v>-578.32</c:v>
                 </c:pt>
                 <c:pt idx="47">
-                  <c:v>-8.86709468</c:v>
+                  <c:v>-597.3</c:v>
                 </c:pt>
                 <c:pt idx="48">
-                  <c:v>-9.97504651</c:v>
+                  <c:v>-610.98</c:v>
                 </c:pt>
                 <c:pt idx="49">
-                  <c:v>-11.02149886</c:v>
+                  <c:v>-619.24</c:v>
                 </c:pt>
                 <c:pt idx="50">
-                  <c:v>-12</c:v>
+                  <c:v>-622.0</c:v>
                 </c:pt>
                 <c:pt idx="51">
-                  <c:v>-12.90451715</c:v>
+                  <c:v>-619.24</c:v>
                 </c:pt>
                 <c:pt idx="52">
-                  <c:v>-13.72947367</c:v>
+                  <c:v>-610.98</c:v>
                 </c:pt>
                 <c:pt idx="53">
-                  <c:v>-14.46978341</c:v>
+                  <c:v>-597.3</c:v>
                 </c:pt>
                 <c:pt idx="54">
-                  <c:v>-15.12088213</c:v>
+                  <c:v>-578.32</c:v>
                 </c:pt>
                 <c:pt idx="55">
-                  <c:v>-15.67875558</c:v>
+                  <c:v>-554.21</c:v>
                 </c:pt>
                 <c:pt idx="56">
-                  <c:v>-16.13996429</c:v>
+                  <c:v>-525.17</c:v>
                 </c:pt>
                 <c:pt idx="57">
-                  <c:v>-16.50166475</c:v>
+                  <c:v>-491.48</c:v>
                 </c:pt>
                 <c:pt idx="58">
-                  <c:v>-16.76162696</c:v>
+                  <c:v>-453.42</c:v>
                 </c:pt>
                 <c:pt idx="59">
-                  <c:v>-16.91824817</c:v>
+                  <c:v>-411.34</c:v>
                 </c:pt>
                 <c:pt idx="60">
-                  <c:v>-16.97056275</c:v>
+                  <c:v>-365.6</c:v>
                 </c:pt>
                 <c:pt idx="61">
-                  <c:v>-16.91824817</c:v>
+                  <c:v>-316.62</c:v>
                 </c:pt>
                 <c:pt idx="62">
-                  <c:v>-16.76162696</c:v>
+                  <c:v>-264.83</c:v>
                 </c:pt>
                 <c:pt idx="63">
-                  <c:v>-16.50166475</c:v>
+                  <c:v>-210.69</c:v>
                 </c:pt>
                 <c:pt idx="64">
-                  <c:v>-16.13996429</c:v>
+                  <c:v>-154.69</c:v>
                 </c:pt>
                 <c:pt idx="65">
-                  <c:v>-15.67875558</c:v>
+                  <c:v>-97.3</c:v>
                 </c:pt>
                 <c:pt idx="66">
-                  <c:v>-15.12088213</c:v>
+                  <c:v>-39.06</c:v>
                 </c:pt>
                 <c:pt idx="67">
-                  <c:v>-14.46978341</c:v>
+                  <c:v>19.54</c:v>
                 </c:pt>
                 <c:pt idx="68">
-                  <c:v>-13.72947367</c:v>
+                  <c:v>77.96</c:v>
                 </c:pt>
                 <c:pt idx="69">
-                  <c:v>-12.90451715</c:v>
+                  <c:v>135.69</c:v>
                 </c:pt>
                 <c:pt idx="70">
-                  <c:v>-12</c:v>
+                  <c:v>192.21</c:v>
                 </c:pt>
                 <c:pt idx="71">
-                  <c:v>-11.02149886</c:v>
+                  <c:v>247.03</c:v>
                 </c:pt>
                 <c:pt idx="72">
-                  <c:v>-9.97504651</c:v>
+                  <c:v>299.65</c:v>
                 </c:pt>
                 <c:pt idx="73">
-                  <c:v>-8.86709468</c:v>
+                  <c:v>349.62</c:v>
                 </c:pt>
                 <c:pt idx="74">
-                  <c:v>-7.70447426</c:v>
+                  <c:v>396.48</c:v>
                 </c:pt>
                 <c:pt idx="75">
-                  <c:v>-6.4943532</c:v>
+                  <c:v>439.82</c:v>
                 </c:pt>
                 <c:pt idx="76">
-                  <c:v>-5.24419229</c:v>
+                  <c:v>479.26</c:v>
                 </c:pt>
                 <c:pt idx="77">
-                  <c:v>-3.9616992</c:v>
+                  <c:v>514.44</c:v>
                 </c:pt>
                 <c:pt idx="78">
-                  <c:v>-2.6547809</c:v>
+                  <c:v>545.06</c:v>
                 </c:pt>
                 <c:pt idx="79">
-                  <c:v>-1.33149501</c:v>
+                  <c:v>570.84</c:v>
                 </c:pt>
                 <c:pt idx="80">
-                  <c:v>-0</c:v>
+                  <c:v>591.56</c:v>
                 </c:pt>
                 <c:pt idx="81">
-                  <c:v>1.33149501</c:v>
+                  <c:v>607.02</c:v>
                 </c:pt>
                 <c:pt idx="82">
-                  <c:v>2.6547809</c:v>
+                  <c:v>617.1</c:v>
                 </c:pt>
                 <c:pt idx="83">
-                  <c:v>3.9616992</c:v>
+                  <c:v>621.69</c:v>
                 </c:pt>
                 <c:pt idx="84">
-                  <c:v>5.24419229</c:v>
+                  <c:v>620.77</c:v>
                 </c:pt>
                 <c:pt idx="85">
-                  <c:v>6.4943532</c:v>
+                  <c:v>614.34</c:v>
                 </c:pt>
                 <c:pt idx="86">
-                  <c:v>7.70447426</c:v>
+                  <c:v>602.46</c:v>
                 </c:pt>
                 <c:pt idx="87">
-                  <c:v>8.86709468</c:v>
+                  <c:v>585.23</c:v>
                 </c:pt>
                 <c:pt idx="88">
-                  <c:v>9.97504651</c:v>
+                  <c:v>562.8</c:v>
                 </c:pt>
                 <c:pt idx="89">
-                  <c:v>11.02149886</c:v>
+                  <c:v>535.38</c:v>
                 </c:pt>
                 <c:pt idx="90">
-                  <c:v>12</c:v>
+                  <c:v>503.21</c:v>
                 </c:pt>
                 <c:pt idx="91">
-                  <c:v>12.90451715</c:v>
+                  <c:v>466.57</c:v>
                 </c:pt>
                 <c:pt idx="92">
-                  <c:v>13.72947367</c:v>
+                  <c:v>425.79</c:v>
                 </c:pt>
                 <c:pt idx="93">
-                  <c:v>14.46978341</c:v>
+                  <c:v>381.23</c:v>
                 </c:pt>
                 <c:pt idx="94">
-                  <c:v>15.12088213</c:v>
+                  <c:v>333.28</c:v>
                 </c:pt>
                 <c:pt idx="95">
-                  <c:v>15.67875558</c:v>
+                  <c:v>282.38</c:v>
                 </c:pt>
                 <c:pt idx="96">
-                  <c:v>16.13996429</c:v>
+                  <c:v>228.97</c:v>
                 </c:pt>
                 <c:pt idx="97">
-                  <c:v>16.50166475</c:v>
+                  <c:v>173.53</c:v>
                 </c:pt>
                 <c:pt idx="98">
-                  <c:v>16.76162696</c:v>
+                  <c:v>116.55</c:v>
                 </c:pt>
                 <c:pt idx="99">
-                  <c:v>16.91824817</c:v>
+                  <c:v>58.54</c:v>
                 </c:pt>
                 <c:pt idx="100">
-                  <c:v>16.97056275</c:v>
+                  <c:v>0.0</c:v>
                 </c:pt>
                 <c:pt idx="101">
-                  <c:v>16.91824817</c:v>
+                  <c:v>-58.54</c:v>
                 </c:pt>
                 <c:pt idx="102">
-                  <c:v>16.76162696</c:v>
+                  <c:v>-116.55</c:v>
                 </c:pt>
                 <c:pt idx="103">
-                  <c:v>16.50166475</c:v>
+                  <c:v>-173.53</c:v>
                 </c:pt>
                 <c:pt idx="104">
-                  <c:v>16.13996429</c:v>
+                  <c:v>-228.97</c:v>
                 </c:pt>
                 <c:pt idx="105">
-                  <c:v>15.67875558</c:v>
+                  <c:v>-282.38</c:v>
                 </c:pt>
                 <c:pt idx="106">
-                  <c:v>15.12088213</c:v>
+                  <c:v>-333.28</c:v>
                 </c:pt>
                 <c:pt idx="107">
-                  <c:v>14.46978341</c:v>
+                  <c:v>-381.23</c:v>
                 </c:pt>
                 <c:pt idx="108">
-                  <c:v>13.72947367</c:v>
+                  <c:v>-425.79</c:v>
                 </c:pt>
                 <c:pt idx="109">
-                  <c:v>12.90451715</c:v>
+                  <c:v>-466.57</c:v>
                 </c:pt>
                 <c:pt idx="110">
-                  <c:v>12</c:v>
+                  <c:v>-503.21</c:v>
                 </c:pt>
                 <c:pt idx="111">
-                  <c:v>11.02149886</c:v>
+                  <c:v>-535.38</c:v>
                 </c:pt>
                 <c:pt idx="112">
-                  <c:v>9.97504651</c:v>
+                  <c:v>-562.8</c:v>
                 </c:pt>
                 <c:pt idx="113">
-                  <c:v>8.86709468</c:v>
+                  <c:v>-585.23</c:v>
                 </c:pt>
                 <c:pt idx="114">
-                  <c:v>7.70447426</c:v>
+                  <c:v>-602.46</c:v>
                 </c:pt>
                 <c:pt idx="115">
-                  <c:v>6.4943532</c:v>
+                  <c:v>-614.34</c:v>
                 </c:pt>
                 <c:pt idx="116">
-                  <c:v>5.24419229</c:v>
+                  <c:v>-620.77</c:v>
                 </c:pt>
                 <c:pt idx="117">
-                  <c:v>3.9616992</c:v>
+                  <c:v>-621.69</c:v>
                 </c:pt>
                 <c:pt idx="118">
-                  <c:v>2.6547809</c:v>
+                  <c:v>-617.1</c:v>
                 </c:pt>
                 <c:pt idx="119">
-                  <c:v>1.33149501</c:v>
+                  <c:v>-607.02</c:v>
                 </c:pt>
                 <c:pt idx="120">
-                  <c:v>0</c:v>
+                  <c:v>-591.56</c:v>
                 </c:pt>
                 <c:pt idx="121">
-                  <c:v>-1.33149501</c:v>
+                  <c:v>-570.84</c:v>
                 </c:pt>
                 <c:pt idx="122">
-                  <c:v>-2.6547809</c:v>
+                  <c:v>-545.06</c:v>
                 </c:pt>
                 <c:pt idx="123">
-                  <c:v>-3.9616992</c:v>
+                  <c:v>-514.44</c:v>
                 </c:pt>
                 <c:pt idx="124">
-                  <c:v>-5.24419229</c:v>
+                  <c:v>-479.26</c:v>
                 </c:pt>
                 <c:pt idx="125">
-                  <c:v>-6.4943532</c:v>
+                  <c:v>-439.82</c:v>
                 </c:pt>
                 <c:pt idx="126">
-                  <c:v>-7.70447426</c:v>
+                  <c:v>-396.48</c:v>
                 </c:pt>
                 <c:pt idx="127">
-                  <c:v>-8.86709468</c:v>
+                  <c:v>-349.62</c:v>
                 </c:pt>
                 <c:pt idx="128">
-                  <c:v>-9.97504651</c:v>
+                  <c:v>-299.65</c:v>
                 </c:pt>
                 <c:pt idx="129">
-                  <c:v>-11.02149886</c:v>
+                  <c:v>-247.03</c:v>
                 </c:pt>
                 <c:pt idx="130">
-                  <c:v>-12</c:v>
+                  <c:v>-192.21</c:v>
                 </c:pt>
                 <c:pt idx="131">
-                  <c:v>-12.90451715</c:v>
+                  <c:v>-135.69</c:v>
                 </c:pt>
                 <c:pt idx="132">
-                  <c:v>-13.72947367</c:v>
+                  <c:v>-77.96</c:v>
                 </c:pt>
                 <c:pt idx="133">
-                  <c:v>-14.46978341</c:v>
+                  <c:v>-19.54</c:v>
                 </c:pt>
                 <c:pt idx="134">
-                  <c:v>-15.12088213</c:v>
+                  <c:v>39.06</c:v>
                 </c:pt>
                 <c:pt idx="135">
-                  <c:v>-15.67875558</c:v>
+                  <c:v>97.3</c:v>
                 </c:pt>
                 <c:pt idx="136">
-                  <c:v>-16.13996429</c:v>
+                  <c:v>154.69</c:v>
                 </c:pt>
                 <c:pt idx="137">
-                  <c:v>-16.50166475</c:v>
+                  <c:v>210.69</c:v>
                 </c:pt>
                 <c:pt idx="138">
-                  <c:v>-16.76162696</c:v>
+                  <c:v>264.83</c:v>
                 </c:pt>
                 <c:pt idx="139">
-                  <c:v>-16.91824817</c:v>
+                  <c:v>316.62</c:v>
                 </c:pt>
                 <c:pt idx="140">
-                  <c:v>-16.97056275</c:v>
+                  <c:v>365.6</c:v>
                 </c:pt>
                 <c:pt idx="141">
-                  <c:v>-16.91824817</c:v>
+                  <c:v>411.34</c:v>
                 </c:pt>
                 <c:pt idx="142">
-                  <c:v>-16.76162696</c:v>
+                  <c:v>453.42</c:v>
                 </c:pt>
                 <c:pt idx="143">
-                  <c:v>-16.50166475</c:v>
+                  <c:v>491.48</c:v>
                 </c:pt>
                 <c:pt idx="144">
-                  <c:v>-16.13996429</c:v>
+                  <c:v>525.17</c:v>
                 </c:pt>
                 <c:pt idx="145">
-                  <c:v>-15.67875558</c:v>
+                  <c:v>554.21</c:v>
                 </c:pt>
                 <c:pt idx="146">
-                  <c:v>-15.12088213</c:v>
+                  <c:v>578.32</c:v>
                 </c:pt>
                 <c:pt idx="147">
-                  <c:v>-14.46978341</c:v>
+                  <c:v>597.3</c:v>
                 </c:pt>
                 <c:pt idx="148">
-                  <c:v>-13.72947367</c:v>
+                  <c:v>610.98</c:v>
                 </c:pt>
                 <c:pt idx="149">
-                  <c:v>-12.90451715</c:v>
+                  <c:v>619.24</c:v>
                 </c:pt>
                 <c:pt idx="150">
-                  <c:v>-12</c:v>
+                  <c:v>622.0</c:v>
                 </c:pt>
                 <c:pt idx="151">
-                  <c:v>-11.02149886</c:v>
+                  <c:v>619.24</c:v>
                 </c:pt>
                 <c:pt idx="152">
-                  <c:v>-9.97504651</c:v>
+                  <c:v>610.98</c:v>
                 </c:pt>
                 <c:pt idx="153">
-                  <c:v>-8.86709468</c:v>
+                  <c:v>597.3</c:v>
                 </c:pt>
                 <c:pt idx="154">
-                  <c:v>-7.70447426</c:v>
+                  <c:v>578.32</c:v>
                 </c:pt>
                 <c:pt idx="155">
-                  <c:v>-6.4943532</c:v>
+                  <c:v>554.21</c:v>
                 </c:pt>
                 <c:pt idx="156">
-                  <c:v>-5.24419229</c:v>
+                  <c:v>525.17</c:v>
                 </c:pt>
                 <c:pt idx="157">
-                  <c:v>-3.9616992</c:v>
+                  <c:v>491.48</c:v>
                 </c:pt>
                 <c:pt idx="158">
-                  <c:v>-2.6547809</c:v>
+                  <c:v>453.42</c:v>
                 </c:pt>
                 <c:pt idx="159">
-                  <c:v>-1.33149501</c:v>
+                  <c:v>411.34</c:v>
                 </c:pt>
                 <c:pt idx="160">
-                  <c:v>-0</c:v>
+                  <c:v>365.6</c:v>
                 </c:pt>
               </c:numCache>
             </c:numRef>
@@ -6400,8 +6408,8 @@
         <c:axId val="48672768"/>
         <c:scaling>
           <c:orientation val="minMax"/>
-          <c:max val="20"/>
-          <c:min val="-20"/>
+          <c:max val="700"/>
+          <c:min val="-700"/>
         </c:scaling>
         <c:delete val="0"/>
         <c:axPos val="l"/>
@@ -6474,7 +6482,7 @@
           </a:p>
         </c:txPr>
         <c:crossAx val="48650112"/>
-        <c:majorUnit val="10"/>
+        <c:majorUnit val="350"/>
       </c:valAx>
       <c:valAx>
         <c:axId val="48650112"/>
@@ -6577,7 +6585,15 @@
           <c:idx val="0"/>
           <c:order val="0"/>
           <c:tx>
-            <c:v>Spänning (V)</c:v>
+            <c:strRef>
+              <c:f>Sheet1!$B$1</c:f>
+              <c:strCache>
+                <c:ptCount val="1"/>
+                <c:pt idx="0">
+                  <c:v>u</c:v>
+                </c:pt>
+              </c:strCache>
+            </c:strRef>
           </c:tx>
           <c:spPr>
             <a:ln xmlns:a="http://schemas.openxmlformats.org/drawingml/2006/main" w="23813">
@@ -6591,12 +6607,12 @@
           </c:marker>
           <c:xVal>
             <c:numRef>
-              <c:f>'Chart Data'!$A$2:$A$162</c:f>
+              <c:f>Sheet1!$A$2:$A$162</c:f>
               <c:numCache>
                 <c:formatCode>General</c:formatCode>
                 <c:ptCount val="161"/>
                 <c:pt idx="0">
-                  <c:v>0</c:v>
+                  <c:v>0.0</c:v>
                 </c:pt>
                 <c:pt idx="1">
                   <c:v>0.25</c:v>
@@ -6608,7 +6624,7 @@
                   <c:v>0.75</c:v>
                 </c:pt>
                 <c:pt idx="4">
-                  <c:v>1</c:v>
+                  <c:v>1.0</c:v>
                 </c:pt>
                 <c:pt idx="5">
                   <c:v>1.25</c:v>
@@ -6620,7 +6636,7 @@
                   <c:v>1.75</c:v>
                 </c:pt>
                 <c:pt idx="8">
-                  <c:v>2</c:v>
+                  <c:v>2.0</c:v>
                 </c:pt>
                 <c:pt idx="9">
                   <c:v>2.25</c:v>
@@ -6632,7 +6648,7 @@
                   <c:v>2.75</c:v>
                 </c:pt>
                 <c:pt idx="12">
-                  <c:v>3</c:v>
+                  <c:v>3.0</c:v>
                 </c:pt>
                 <c:pt idx="13">
                   <c:v>3.25</c:v>
@@ -6644,7 +6660,7 @@
                   <c:v>3.75</c:v>
                 </c:pt>
                 <c:pt idx="16">
-                  <c:v>4</c:v>
+                  <c:v>4.0</c:v>
                 </c:pt>
                 <c:pt idx="17">
                   <c:v>4.25</c:v>
@@ -6656,7 +6672,7 @@
                   <c:v>4.75</c:v>
                 </c:pt>
                 <c:pt idx="20">
-                  <c:v>5</c:v>
+                  <c:v>5.0</c:v>
                 </c:pt>
                 <c:pt idx="21">
                   <c:v>5.25</c:v>
@@ -6668,7 +6684,7 @@
                   <c:v>5.75</c:v>
                 </c:pt>
                 <c:pt idx="24">
-                  <c:v>6</c:v>
+                  <c:v>6.0</c:v>
                 </c:pt>
                 <c:pt idx="25">
                   <c:v>6.25</c:v>
@@ -6680,7 +6696,7 @@
                   <c:v>6.75</c:v>
                 </c:pt>
                 <c:pt idx="28">
-                  <c:v>7</c:v>
+                  <c:v>7.0</c:v>
                 </c:pt>
                 <c:pt idx="29">
                   <c:v>7.25</c:v>
@@ -6692,7 +6708,7 @@
                   <c:v>7.75</c:v>
                 </c:pt>
                 <c:pt idx="32">
-                  <c:v>8</c:v>
+                  <c:v>8.0</c:v>
                 </c:pt>
                 <c:pt idx="33">
                   <c:v>8.25</c:v>
@@ -6704,7 +6720,7 @@
                   <c:v>8.75</c:v>
                 </c:pt>
                 <c:pt idx="36">
-                  <c:v>9</c:v>
+                  <c:v>9.0</c:v>
                 </c:pt>
                 <c:pt idx="37">
                   <c:v>9.25</c:v>
@@ -6716,7 +6732,7 @@
                   <c:v>9.75</c:v>
                 </c:pt>
                 <c:pt idx="40">
-                  <c:v>10</c:v>
+                  <c:v>10.0</c:v>
                 </c:pt>
                 <c:pt idx="41">
                   <c:v>10.25</c:v>
@@ -6728,7 +6744,7 @@
                   <c:v>10.75</c:v>
                 </c:pt>
                 <c:pt idx="44">
-                  <c:v>11</c:v>
+                  <c:v>11.0</c:v>
                 </c:pt>
                 <c:pt idx="45">
                   <c:v>11.25</c:v>
@@ -6740,7 +6756,7 @@
                   <c:v>11.75</c:v>
                 </c:pt>
                 <c:pt idx="48">
-                  <c:v>12</c:v>
+                  <c:v>12.0</c:v>
                 </c:pt>
                 <c:pt idx="49">
                   <c:v>12.25</c:v>
@@ -6752,7 +6768,7 @@
                   <c:v>12.75</c:v>
                 </c:pt>
                 <c:pt idx="52">
-                  <c:v>13</c:v>
+                  <c:v>13.0</c:v>
                 </c:pt>
                 <c:pt idx="53">
                   <c:v>13.25</c:v>
@@ -6764,7 +6780,7 @@
                   <c:v>13.75</c:v>
                 </c:pt>
                 <c:pt idx="56">
-                  <c:v>14</c:v>
+                  <c:v>14.0</c:v>
                 </c:pt>
                 <c:pt idx="57">
                   <c:v>14.25</c:v>
@@ -6776,7 +6792,7 @@
                   <c:v>14.75</c:v>
                 </c:pt>
                 <c:pt idx="60">
-                  <c:v>15</c:v>
+                  <c:v>15.0</c:v>
                 </c:pt>
                 <c:pt idx="61">
                   <c:v>15.25</c:v>
@@ -6788,7 +6804,7 @@
                   <c:v>15.75</c:v>
                 </c:pt>
                 <c:pt idx="64">
-                  <c:v>16</c:v>
+                  <c:v>16.0</c:v>
                 </c:pt>
                 <c:pt idx="65">
                   <c:v>16.25</c:v>
@@ -6800,7 +6816,7 @@
                   <c:v>16.75</c:v>
                 </c:pt>
                 <c:pt idx="68">
-                  <c:v>17</c:v>
+                  <c:v>17.0</c:v>
                 </c:pt>
                 <c:pt idx="69">
                   <c:v>17.25</c:v>
@@ -6812,7 +6828,7 @@
                   <c:v>17.75</c:v>
                 </c:pt>
                 <c:pt idx="72">
-                  <c:v>18</c:v>
+                  <c:v>18.0</c:v>
                 </c:pt>
                 <c:pt idx="73">
                   <c:v>18.25</c:v>
@@ -6824,7 +6840,7 @@
                   <c:v>18.75</c:v>
                 </c:pt>
                 <c:pt idx="76">
-                  <c:v>19</c:v>
+                  <c:v>19.0</c:v>
                 </c:pt>
                 <c:pt idx="77">
                   <c:v>19.25</c:v>
@@ -6836,7 +6852,7 @@
                   <c:v>19.75</c:v>
                 </c:pt>
                 <c:pt idx="80">
-                  <c:v>20</c:v>
+                  <c:v>20.0</c:v>
                 </c:pt>
                 <c:pt idx="81">
                   <c:v>20.25</c:v>
@@ -6848,7 +6864,7 @@
                   <c:v>20.75</c:v>
                 </c:pt>
                 <c:pt idx="84">
-                  <c:v>21</c:v>
+                  <c:v>21.0</c:v>
                 </c:pt>
                 <c:pt idx="85">
                   <c:v>21.25</c:v>
@@ -6860,7 +6876,7 @@
                   <c:v>21.75</c:v>
                 </c:pt>
                 <c:pt idx="88">
-                  <c:v>22</c:v>
+                  <c:v>22.0</c:v>
                 </c:pt>
                 <c:pt idx="89">
                   <c:v>22.25</c:v>
@@ -6872,7 +6888,7 @@
                   <c:v>22.75</c:v>
                 </c:pt>
                 <c:pt idx="92">
-                  <c:v>23</c:v>
+                  <c:v>23.0</c:v>
                 </c:pt>
                 <c:pt idx="93">
                   <c:v>23.25</c:v>
@@ -6884,7 +6900,7 @@
                   <c:v>23.75</c:v>
                 </c:pt>
                 <c:pt idx="96">
-                  <c:v>24</c:v>
+                  <c:v>24.0</c:v>
                 </c:pt>
                 <c:pt idx="97">
                   <c:v>24.25</c:v>
@@ -6896,7 +6912,7 @@
                   <c:v>24.75</c:v>
                 </c:pt>
                 <c:pt idx="100">
-                  <c:v>25</c:v>
+                  <c:v>25.0</c:v>
                 </c:pt>
                 <c:pt idx="101">
                   <c:v>25.25</c:v>
@@ -6908,7 +6924,7 @@
                   <c:v>25.75</c:v>
                 </c:pt>
                 <c:pt idx="104">
-                  <c:v>26</c:v>
+                  <c:v>26.0</c:v>
                 </c:pt>
                 <c:pt idx="105">
                   <c:v>26.25</c:v>
@@ -6920,7 +6936,7 @@
                   <c:v>26.75</c:v>
                 </c:pt>
                 <c:pt idx="108">
-                  <c:v>27</c:v>
+                  <c:v>27.0</c:v>
                 </c:pt>
                 <c:pt idx="109">
                   <c:v>27.25</c:v>
@@ -6932,7 +6948,7 @@
                   <c:v>27.75</c:v>
                 </c:pt>
                 <c:pt idx="112">
-                  <c:v>28</c:v>
+                  <c:v>28.0</c:v>
                 </c:pt>
                 <c:pt idx="113">
                   <c:v>28.25</c:v>
@@ -6944,7 +6960,7 @@
                   <c:v>28.75</c:v>
                 </c:pt>
                 <c:pt idx="116">
-                  <c:v>29</c:v>
+                  <c:v>29.0</c:v>
                 </c:pt>
                 <c:pt idx="117">
                   <c:v>29.25</c:v>
@@ -6956,7 +6972,7 @@
                   <c:v>29.75</c:v>
                 </c:pt>
                 <c:pt idx="120">
-                  <c:v>30</c:v>
+                  <c:v>30.0</c:v>
                 </c:pt>
                 <c:pt idx="121">
                   <c:v>30.25</c:v>
@@ -6968,7 +6984,7 @@
                   <c:v>30.75</c:v>
                 </c:pt>
                 <c:pt idx="124">
-                  <c:v>31</c:v>
+                  <c:v>31.0</c:v>
                 </c:pt>
                 <c:pt idx="125">
                   <c:v>31.25</c:v>
@@ -6980,7 +6996,7 @@
                   <c:v>31.75</c:v>
                 </c:pt>
                 <c:pt idx="128">
-                  <c:v>32</c:v>
+                  <c:v>32.0</c:v>
                 </c:pt>
                 <c:pt idx="129">
                   <c:v>32.25</c:v>
@@ -6992,7 +7008,7 @@
                   <c:v>32.75</c:v>
                 </c:pt>
                 <c:pt idx="132">
-                  <c:v>33</c:v>
+                  <c:v>33.0</c:v>
                 </c:pt>
                 <c:pt idx="133">
                   <c:v>33.25</c:v>
@@ -7004,7 +7020,7 @@
                   <c:v>33.75</c:v>
                 </c:pt>
                 <c:pt idx="136">
-                  <c:v>34</c:v>
+                  <c:v>34.0</c:v>
                 </c:pt>
                 <c:pt idx="137">
                   <c:v>34.25</c:v>
@@ -7016,7 +7032,7 @@
                   <c:v>34.75</c:v>
                 </c:pt>
                 <c:pt idx="140">
-                  <c:v>35</c:v>
+                  <c:v>35.0</c:v>
                 </c:pt>
                 <c:pt idx="141">
                   <c:v>35.25</c:v>
@@ -7028,7 +7044,7 @@
                   <c:v>35.75</c:v>
                 </c:pt>
                 <c:pt idx="144">
-                  <c:v>36</c:v>
+                  <c:v>36.0</c:v>
                 </c:pt>
                 <c:pt idx="145">
                   <c:v>36.25</c:v>
@@ -7040,7 +7056,7 @@
                   <c:v>36.75</c:v>
                 </c:pt>
                 <c:pt idx="148">
-                  <c:v>37</c:v>
+                  <c:v>37.0</c:v>
                 </c:pt>
                 <c:pt idx="149">
                   <c:v>37.25</c:v>
@@ -7052,7 +7068,7 @@
                   <c:v>37.75</c:v>
                 </c:pt>
                 <c:pt idx="152">
-                  <c:v>38</c:v>
+                  <c:v>38.0</c:v>
                 </c:pt>
                 <c:pt idx="153">
                   <c:v>38.25</c:v>
@@ -7064,7 +7080,7 @@
                   <c:v>38.75</c:v>
                 </c:pt>
                 <c:pt idx="156">
-                  <c:v>39</c:v>
+                  <c:v>39.0</c:v>
                 </c:pt>
                 <c:pt idx="157">
                   <c:v>39.25</c:v>
@@ -7076,499 +7092,499 @@
                   <c:v>39.75</c:v>
                 </c:pt>
                 <c:pt idx="160">
-                  <c:v>40</c:v>
+                  <c:v>40.0</c:v>
                 </c:pt>
               </c:numCache>
             </c:numRef>
           </c:xVal>
           <c:yVal>
             <c:numRef>
-              <c:f>'Chart Data'!$B$2:$B$162</c:f>
+              <c:f>Sheet1!$B$2:$B$162</c:f>
               <c:numCache>
                 <c:formatCode>General</c:formatCode>
                 <c:ptCount val="161"/>
                 <c:pt idx="0">
-                  <c:v>0</c:v>
+                  <c:v>0.0</c:v>
                 </c:pt>
                 <c:pt idx="1">
-                  <c:v>1.33149501</c:v>
+                  <c:v>58.54</c:v>
                 </c:pt>
                 <c:pt idx="2">
-                  <c:v>2.6547809</c:v>
+                  <c:v>116.55</c:v>
                 </c:pt>
                 <c:pt idx="3">
-                  <c:v>3.9616992</c:v>
+                  <c:v>173.53</c:v>
                 </c:pt>
                 <c:pt idx="4">
-                  <c:v>5.24419229</c:v>
+                  <c:v>228.97</c:v>
                 </c:pt>
                 <c:pt idx="5">
-                  <c:v>6.4943532</c:v>
+                  <c:v>282.38</c:v>
                 </c:pt>
                 <c:pt idx="6">
-                  <c:v>7.70447426</c:v>
+                  <c:v>333.28</c:v>
                 </c:pt>
                 <c:pt idx="7">
-                  <c:v>8.86709468</c:v>
+                  <c:v>381.23</c:v>
                 </c:pt>
                 <c:pt idx="8">
-                  <c:v>9.97504651</c:v>
+                  <c:v>425.79</c:v>
                 </c:pt>
                 <c:pt idx="9">
-                  <c:v>11.02149886</c:v>
+                  <c:v>466.57</c:v>
                 </c:pt>
                 <c:pt idx="10">
-                  <c:v>12</c:v>
+                  <c:v>503.21</c:v>
                 </c:pt>
                 <c:pt idx="11">
-                  <c:v>12.90451715</c:v>
+                  <c:v>535.38</c:v>
                 </c:pt>
                 <c:pt idx="12">
-                  <c:v>13.72947367</c:v>
+                  <c:v>562.8</c:v>
                 </c:pt>
                 <c:pt idx="13">
-                  <c:v>14.46978341</c:v>
+                  <c:v>585.23</c:v>
                 </c:pt>
                 <c:pt idx="14">
-                  <c:v>15.12088213</c:v>
+                  <c:v>602.46</c:v>
                 </c:pt>
                 <c:pt idx="15">
-                  <c:v>15.67875558</c:v>
+                  <c:v>614.34</c:v>
                 </c:pt>
                 <c:pt idx="16">
-                  <c:v>16.13996429</c:v>
+                  <c:v>620.77</c:v>
                 </c:pt>
                 <c:pt idx="17">
-                  <c:v>16.50166475</c:v>
+                  <c:v>621.69</c:v>
                 </c:pt>
                 <c:pt idx="18">
-                  <c:v>16.76162696</c:v>
+                  <c:v>617.1</c:v>
                 </c:pt>
                 <c:pt idx="19">
-                  <c:v>16.91824817</c:v>
+                  <c:v>607.02</c:v>
                 </c:pt>
                 <c:pt idx="20">
-                  <c:v>16.97056275</c:v>
+                  <c:v>591.56</c:v>
                 </c:pt>
                 <c:pt idx="21">
-                  <c:v>16.91824817</c:v>
+                  <c:v>570.84</c:v>
                 </c:pt>
                 <c:pt idx="22">
-                  <c:v>16.76162696</c:v>
+                  <c:v>545.06</c:v>
                 </c:pt>
                 <c:pt idx="23">
-                  <c:v>16.50166475</c:v>
+                  <c:v>514.44</c:v>
                 </c:pt>
                 <c:pt idx="24">
-                  <c:v>16.13996429</c:v>
+                  <c:v>479.26</c:v>
                 </c:pt>
                 <c:pt idx="25">
-                  <c:v>15.67875558</c:v>
+                  <c:v>439.82</c:v>
                 </c:pt>
                 <c:pt idx="26">
-                  <c:v>15.12088213</c:v>
+                  <c:v>396.48</c:v>
                 </c:pt>
                 <c:pt idx="27">
-                  <c:v>14.46978341</c:v>
+                  <c:v>349.62</c:v>
                 </c:pt>
                 <c:pt idx="28">
-                  <c:v>13.72947367</c:v>
+                  <c:v>299.65</c:v>
                 </c:pt>
                 <c:pt idx="29">
-                  <c:v>12.90451715</c:v>
+                  <c:v>247.03</c:v>
                 </c:pt>
                 <c:pt idx="30">
-                  <c:v>12</c:v>
+                  <c:v>192.21</c:v>
                 </c:pt>
                 <c:pt idx="31">
-                  <c:v>11.02149886</c:v>
+                  <c:v>135.69</c:v>
                 </c:pt>
                 <c:pt idx="32">
-                  <c:v>9.97504651</c:v>
+                  <c:v>77.96</c:v>
                 </c:pt>
                 <c:pt idx="33">
-                  <c:v>8.86709468</c:v>
+                  <c:v>19.54</c:v>
                 </c:pt>
                 <c:pt idx="34">
-                  <c:v>7.70447426</c:v>
+                  <c:v>-39.06</c:v>
                 </c:pt>
                 <c:pt idx="35">
-                  <c:v>6.4943532</c:v>
+                  <c:v>-97.3</c:v>
                 </c:pt>
                 <c:pt idx="36">
-                  <c:v>5.24419229</c:v>
+                  <c:v>-154.69</c:v>
                 </c:pt>
                 <c:pt idx="37">
-                  <c:v>3.9616992</c:v>
+                  <c:v>-210.69</c:v>
                 </c:pt>
                 <c:pt idx="38">
-                  <c:v>2.6547809</c:v>
+                  <c:v>-264.83</c:v>
                 </c:pt>
                 <c:pt idx="39">
-                  <c:v>1.33149501</c:v>
+                  <c:v>-316.62</c:v>
                 </c:pt>
                 <c:pt idx="40">
-                  <c:v>0</c:v>
+                  <c:v>-365.6</c:v>
                 </c:pt>
                 <c:pt idx="41">
-                  <c:v>-1.33149501</c:v>
+                  <c:v>-411.34</c:v>
                 </c:pt>
                 <c:pt idx="42">
-                  <c:v>-2.6547809</c:v>
+                  <c:v>-453.42</c:v>
                 </c:pt>
                 <c:pt idx="43">
-                  <c:v>-3.9616992</c:v>
+                  <c:v>-491.48</c:v>
                 </c:pt>
                 <c:pt idx="44">
-                  <c:v>-5.24419229</c:v>
+                  <c:v>-525.17</c:v>
                 </c:pt>
                 <c:pt idx="45">
-                  <c:v>-6.4943532</c:v>
+                  <c:v>-554.21</c:v>
                 </c:pt>
                 <c:pt idx="46">
-                  <c:v>-7.70447426</c:v>
+                  <c:v>-578.32</c:v>
                 </c:pt>
                 <c:pt idx="47">
-                  <c:v>-8.86709468</c:v>
+                  <c:v>-597.3</c:v>
                 </c:pt>
                 <c:pt idx="48">
-                  <c:v>-9.97504651</c:v>
+                  <c:v>-610.98</c:v>
                 </c:pt>
                 <c:pt idx="49">
-                  <c:v>-11.02149886</c:v>
+                  <c:v>-619.24</c:v>
                 </c:pt>
                 <c:pt idx="50">
-                  <c:v>-12</c:v>
+                  <c:v>-622.0</c:v>
                 </c:pt>
                 <c:pt idx="51">
-                  <c:v>-12.90451715</c:v>
+                  <c:v>-619.24</c:v>
                 </c:pt>
                 <c:pt idx="52">
-                  <c:v>-13.72947367</c:v>
+                  <c:v>-610.98</c:v>
                 </c:pt>
                 <c:pt idx="53">
-                  <c:v>-14.46978341</c:v>
+                  <c:v>-597.3</c:v>
                 </c:pt>
                 <c:pt idx="54">
-                  <c:v>-15.12088213</c:v>
+                  <c:v>-578.32</c:v>
                 </c:pt>
                 <c:pt idx="55">
-                  <c:v>-15.67875558</c:v>
+                  <c:v>-554.21</c:v>
                 </c:pt>
                 <c:pt idx="56">
-                  <c:v>-16.13996429</c:v>
+                  <c:v>-525.17</c:v>
                 </c:pt>
                 <c:pt idx="57">
-                  <c:v>-16.50166475</c:v>
+                  <c:v>-491.48</c:v>
                 </c:pt>
                 <c:pt idx="58">
-                  <c:v>-16.76162696</c:v>
+                  <c:v>-453.42</c:v>
                 </c:pt>
                 <c:pt idx="59">
-                  <c:v>-16.91824817</c:v>
+                  <c:v>-411.34</c:v>
                 </c:pt>
                 <c:pt idx="60">
-                  <c:v>-16.97056275</c:v>
+                  <c:v>-365.6</c:v>
                 </c:pt>
                 <c:pt idx="61">
-                  <c:v>-16.91824817</c:v>
+                  <c:v>-316.62</c:v>
                 </c:pt>
                 <c:pt idx="62">
-                  <c:v>-16.76162696</c:v>
+                  <c:v>-264.83</c:v>
                 </c:pt>
                 <c:pt idx="63">
-                  <c:v>-16.50166475</c:v>
+                  <c:v>-210.69</c:v>
                 </c:pt>
                 <c:pt idx="64">
-                  <c:v>-16.13996429</c:v>
+                  <c:v>-154.69</c:v>
                 </c:pt>
                 <c:pt idx="65">
-                  <c:v>-15.67875558</c:v>
+                  <c:v>-97.3</c:v>
                 </c:pt>
                 <c:pt idx="66">
-                  <c:v>-15.12088213</c:v>
+                  <c:v>-39.06</c:v>
                 </c:pt>
                 <c:pt idx="67">
-                  <c:v>-14.46978341</c:v>
+                  <c:v>19.54</c:v>
                 </c:pt>
                 <c:pt idx="68">
-                  <c:v>-13.72947367</c:v>
+                  <c:v>77.96</c:v>
                 </c:pt>
                 <c:pt idx="69">
-                  <c:v>-12.90451715</c:v>
+                  <c:v>135.69</c:v>
                 </c:pt>
                 <c:pt idx="70">
-                  <c:v>-12</c:v>
+                  <c:v>192.21</c:v>
                 </c:pt>
                 <c:pt idx="71">
-                  <c:v>-11.02149886</c:v>
+                  <c:v>247.03</c:v>
                 </c:pt>
                 <c:pt idx="72">
-                  <c:v>-9.97504651</c:v>
+                  <c:v>299.65</c:v>
                 </c:pt>
                 <c:pt idx="73">
-                  <c:v>-8.86709468</c:v>
+                  <c:v>349.62</c:v>
                 </c:pt>
                 <c:pt idx="74">
-                  <c:v>-7.70447426</c:v>
+                  <c:v>396.48</c:v>
                 </c:pt>
                 <c:pt idx="75">
-                  <c:v>-6.4943532</c:v>
+                  <c:v>439.82</c:v>
                 </c:pt>
                 <c:pt idx="76">
-                  <c:v>-5.24419229</c:v>
+                  <c:v>479.26</c:v>
                 </c:pt>
                 <c:pt idx="77">
-                  <c:v>-3.9616992</c:v>
+                  <c:v>514.44</c:v>
                 </c:pt>
                 <c:pt idx="78">
-                  <c:v>-2.6547809</c:v>
+                  <c:v>545.06</c:v>
                 </c:pt>
                 <c:pt idx="79">
-                  <c:v>-1.33149501</c:v>
+                  <c:v>570.84</c:v>
                 </c:pt>
                 <c:pt idx="80">
-                  <c:v>-0</c:v>
+                  <c:v>591.56</c:v>
                 </c:pt>
                 <c:pt idx="81">
-                  <c:v>1.33149501</c:v>
+                  <c:v>607.02</c:v>
                 </c:pt>
                 <c:pt idx="82">
-                  <c:v>2.6547809</c:v>
+                  <c:v>617.1</c:v>
                 </c:pt>
                 <c:pt idx="83">
-                  <c:v>3.9616992</c:v>
+                  <c:v>621.69</c:v>
                 </c:pt>
                 <c:pt idx="84">
-                  <c:v>5.24419229</c:v>
+                  <c:v>620.77</c:v>
                 </c:pt>
                 <c:pt idx="85">
-                  <c:v>6.4943532</c:v>
+                  <c:v>614.34</c:v>
                 </c:pt>
                 <c:pt idx="86">
-                  <c:v>7.70447426</c:v>
+                  <c:v>602.46</c:v>
                 </c:pt>
                 <c:pt idx="87">
-                  <c:v>8.86709468</c:v>
+                  <c:v>585.23</c:v>
                 </c:pt>
                 <c:pt idx="88">
-                  <c:v>9.97504651</c:v>
+                  <c:v>562.8</c:v>
                 </c:pt>
                 <c:pt idx="89">
-                  <c:v>11.02149886</c:v>
+                  <c:v>535.38</c:v>
                 </c:pt>
                 <c:pt idx="90">
-                  <c:v>12</c:v>
+                  <c:v>503.21</c:v>
                 </c:pt>
                 <c:pt idx="91">
-                  <c:v>12.90451715</c:v>
+                  <c:v>466.57</c:v>
                 </c:pt>
                 <c:pt idx="92">
-                  <c:v>13.72947367</c:v>
+                  <c:v>425.79</c:v>
                 </c:pt>
                 <c:pt idx="93">
-                  <c:v>14.46978341</c:v>
+                  <c:v>381.23</c:v>
                 </c:pt>
                 <c:pt idx="94">
-                  <c:v>15.12088213</c:v>
+                  <c:v>333.28</c:v>
                 </c:pt>
                 <c:pt idx="95">
-                  <c:v>15.67875558</c:v>
+                  <c:v>282.38</c:v>
                 </c:pt>
                 <c:pt idx="96">
-                  <c:v>16.13996429</c:v>
+                  <c:v>228.97</c:v>
                 </c:pt>
                 <c:pt idx="97">
-                  <c:v>16.50166475</c:v>
+                  <c:v>173.53</c:v>
                 </c:pt>
                 <c:pt idx="98">
-                  <c:v>16.76162696</c:v>
+                  <c:v>116.55</c:v>
                 </c:pt>
                 <c:pt idx="99">
-                  <c:v>16.91824817</c:v>
+                  <c:v>58.54</c:v>
                 </c:pt>
                 <c:pt idx="100">
-                  <c:v>16.97056275</c:v>
+                  <c:v>0.0</c:v>
                 </c:pt>
                 <c:pt idx="101">
-                  <c:v>16.91824817</c:v>
+                  <c:v>-58.54</c:v>
                 </c:pt>
                 <c:pt idx="102">
-                  <c:v>16.76162696</c:v>
+                  <c:v>-116.55</c:v>
                 </c:pt>
                 <c:pt idx="103">
-                  <c:v>16.50166475</c:v>
+                  <c:v>-173.53</c:v>
                 </c:pt>
                 <c:pt idx="104">
-                  <c:v>16.13996429</c:v>
+                  <c:v>-228.97</c:v>
                 </c:pt>
                 <c:pt idx="105">
-                  <c:v>15.67875558</c:v>
+                  <c:v>-282.38</c:v>
                 </c:pt>
                 <c:pt idx="106">
-                  <c:v>15.12088213</c:v>
+                  <c:v>-333.28</c:v>
                 </c:pt>
                 <c:pt idx="107">
-                  <c:v>14.46978341</c:v>
+                  <c:v>-381.23</c:v>
                 </c:pt>
                 <c:pt idx="108">
-                  <c:v>13.72947367</c:v>
+                  <c:v>-425.79</c:v>
                 </c:pt>
                 <c:pt idx="109">
-                  <c:v>12.90451715</c:v>
+                  <c:v>-466.57</c:v>
                 </c:pt>
                 <c:pt idx="110">
-                  <c:v>12</c:v>
+                  <c:v>-503.21</c:v>
                 </c:pt>
                 <c:pt idx="111">
-                  <c:v>11.02149886</c:v>
+                  <c:v>-535.38</c:v>
                 </c:pt>
                 <c:pt idx="112">
-                  <c:v>9.97504651</c:v>
+                  <c:v>-562.8</c:v>
                 </c:pt>
                 <c:pt idx="113">
-                  <c:v>8.86709468</c:v>
+                  <c:v>-585.23</c:v>
                 </c:pt>
                 <c:pt idx="114">
-                  <c:v>7.70447426</c:v>
+                  <c:v>-602.46</c:v>
                 </c:pt>
                 <c:pt idx="115">
-                  <c:v>6.4943532</c:v>
+                  <c:v>-614.34</c:v>
                 </c:pt>
                 <c:pt idx="116">
-                  <c:v>5.24419229</c:v>
+                  <c:v>-620.77</c:v>
                 </c:pt>
                 <c:pt idx="117">
-                  <c:v>3.9616992</c:v>
+                  <c:v>-621.69</c:v>
                 </c:pt>
                 <c:pt idx="118">
-                  <c:v>2.6547809</c:v>
+                  <c:v>-617.1</c:v>
                 </c:pt>
                 <c:pt idx="119">
-                  <c:v>1.33149501</c:v>
+                  <c:v>-607.02</c:v>
                 </c:pt>
                 <c:pt idx="120">
-                  <c:v>0</c:v>
+                  <c:v>-591.56</c:v>
                 </c:pt>
                 <c:pt idx="121">
-                  <c:v>-1.33149501</c:v>
+                  <c:v>-570.84</c:v>
                 </c:pt>
                 <c:pt idx="122">
-                  <c:v>-2.6547809</c:v>
+                  <c:v>-545.06</c:v>
                 </c:pt>
                 <c:pt idx="123">
-                  <c:v>-3.9616992</c:v>
+                  <c:v>-514.44</c:v>
                 </c:pt>
                 <c:pt idx="124">
-                  <c:v>-5.24419229</c:v>
+                  <c:v>-479.26</c:v>
                 </c:pt>
                 <c:pt idx="125">
-                  <c:v>-6.4943532</c:v>
+                  <c:v>-439.82</c:v>
                 </c:pt>
                 <c:pt idx="126">
-                  <c:v>-7.70447426</c:v>
+                  <c:v>-396.48</c:v>
                 </c:pt>
                 <c:pt idx="127">
-                  <c:v>-8.86709468</c:v>
+                  <c:v>-349.62</c:v>
                 </c:pt>
                 <c:pt idx="128">
-                  <c:v>-9.97504651</c:v>
+                  <c:v>-299.65</c:v>
                 </c:pt>
                 <c:pt idx="129">
-                  <c:v>-11.02149886</c:v>
+                  <c:v>-247.03</c:v>
                 </c:pt>
                 <c:pt idx="130">
-                  <c:v>-12</c:v>
+                  <c:v>-192.21</c:v>
                 </c:pt>
                 <c:pt idx="131">
-                  <c:v>-12.90451715</c:v>
+                  <c:v>-135.69</c:v>
                 </c:pt>
                 <c:pt idx="132">
-                  <c:v>-13.72947367</c:v>
+                  <c:v>-77.96</c:v>
                 </c:pt>
                 <c:pt idx="133">
-                  <c:v>-14.46978341</c:v>
+                  <c:v>-19.54</c:v>
                 </c:pt>
                 <c:pt idx="134">
-                  <c:v>-15.12088213</c:v>
+                  <c:v>39.06</c:v>
                 </c:pt>
                 <c:pt idx="135">
-                  <c:v>-15.67875558</c:v>
+                  <c:v>97.3</c:v>
                 </c:pt>
                 <c:pt idx="136">
-                  <c:v>-16.13996429</c:v>
+                  <c:v>154.69</c:v>
                 </c:pt>
                 <c:pt idx="137">
-                  <c:v>-16.50166475</c:v>
+                  <c:v>210.69</c:v>
                 </c:pt>
                 <c:pt idx="138">
-                  <c:v>-16.76162696</c:v>
+                  <c:v>264.83</c:v>
                 </c:pt>
                 <c:pt idx="139">
-                  <c:v>-16.91824817</c:v>
+                  <c:v>316.62</c:v>
                 </c:pt>
                 <c:pt idx="140">
-                  <c:v>-16.97056275</c:v>
+                  <c:v>365.6</c:v>
                 </c:pt>
                 <c:pt idx="141">
-                  <c:v>-16.91824817</c:v>
+                  <c:v>411.34</c:v>
                 </c:pt>
                 <c:pt idx="142">
-                  <c:v>-16.76162696</c:v>
+                  <c:v>453.42</c:v>
                 </c:pt>
                 <c:pt idx="143">
-                  <c:v>-16.50166475</c:v>
+                  <c:v>491.48</c:v>
                 </c:pt>
                 <c:pt idx="144">
-                  <c:v>-16.13996429</c:v>
+                  <c:v>525.17</c:v>
                 </c:pt>
                 <c:pt idx="145">
-                  <c:v>-15.67875558</c:v>
+                  <c:v>554.21</c:v>
                 </c:pt>
                 <c:pt idx="146">
-                  <c:v>-15.12088213</c:v>
+                  <c:v>578.32</c:v>
                 </c:pt>
                 <c:pt idx="147">
-                  <c:v>-14.46978341</c:v>
+                  <c:v>597.3</c:v>
                 </c:pt>
                 <c:pt idx="148">
-                  <c:v>-13.72947367</c:v>
+                  <c:v>610.98</c:v>
                 </c:pt>
                 <c:pt idx="149">
-                  <c:v>-12.90451715</c:v>
+                  <c:v>619.24</c:v>
                 </c:pt>
                 <c:pt idx="150">
-                  <c:v>-12</c:v>
+                  <c:v>622.0</c:v>
                 </c:pt>
                 <c:pt idx="151">
-                  <c:v>-11.02149886</c:v>
+                  <c:v>619.24</c:v>
                 </c:pt>
                 <c:pt idx="152">
-                  <c:v>-9.97504651</c:v>
+                  <c:v>610.98</c:v>
                 </c:pt>
                 <c:pt idx="153">
-                  <c:v>-8.86709468</c:v>
+                  <c:v>597.3</c:v>
                 </c:pt>
                 <c:pt idx="154">
-                  <c:v>-7.70447426</c:v>
+                  <c:v>578.32</c:v>
                 </c:pt>
                 <c:pt idx="155">
-                  <c:v>-6.4943532</c:v>
+                  <c:v>554.21</c:v>
                 </c:pt>
                 <c:pt idx="156">
-                  <c:v>-5.24419229</c:v>
+                  <c:v>525.17</c:v>
                 </c:pt>
                 <c:pt idx="157">
-                  <c:v>-3.9616992</c:v>
+                  <c:v>491.48</c:v>
                 </c:pt>
                 <c:pt idx="158">
-                  <c:v>-2.6547809</c:v>
+                  <c:v>453.42</c:v>
                 </c:pt>
                 <c:pt idx="159">
-                  <c:v>-1.33149501</c:v>
+                  <c:v>411.34</c:v>
                 </c:pt>
                 <c:pt idx="160">
-                  <c:v>-0</c:v>
+                  <c:v>365.6</c:v>
                 </c:pt>
               </c:numCache>
             </c:numRef>
@@ -7603,8 +7619,8 @@
         <c:axId val="48672768"/>
         <c:scaling>
           <c:orientation val="minMax"/>
-          <c:max val="20"/>
-          <c:min val="-20"/>
+          <c:max val="700"/>
+          <c:min val="-700"/>
         </c:scaling>
         <c:delete val="0"/>
         <c:axPos val="l"/>
@@ -7677,7 +7693,7 @@
           </a:p>
         </c:txPr>
         <c:crossAx val="48650112"/>
-        <c:majorUnit val="10"/>
+        <c:majorUnit val="350"/>
       </c:valAx>
       <c:valAx>
         <c:axId val="48650112"/>
@@ -7780,7 +7796,15 @@
           <c:idx val="0"/>
           <c:order val="0"/>
           <c:tx>
-            <c:v>Spänning (V)</c:v>
+            <c:strRef>
+              <c:f>Sheet1!$B$1</c:f>
+              <c:strCache>
+                <c:ptCount val="1"/>
+                <c:pt idx="0">
+                  <c:v>u</c:v>
+                </c:pt>
+              </c:strCache>
+            </c:strRef>
           </c:tx>
           <c:spPr>
             <a:ln xmlns:a="http://schemas.openxmlformats.org/drawingml/2006/main" w="23813">
@@ -7794,12 +7818,12 @@
           </c:marker>
           <c:xVal>
             <c:numRef>
-              <c:f>'Chart Data'!$A$2:$A$162</c:f>
+              <c:f>Sheet1!$A$2:$A$162</c:f>
               <c:numCache>
                 <c:formatCode>General</c:formatCode>
                 <c:ptCount val="161"/>
                 <c:pt idx="0">
-                  <c:v>0</c:v>
+                  <c:v>0.0</c:v>
                 </c:pt>
                 <c:pt idx="1">
                   <c:v>0.25</c:v>
@@ -7811,7 +7835,7 @@
                   <c:v>0.75</c:v>
                 </c:pt>
                 <c:pt idx="4">
-                  <c:v>1</c:v>
+                  <c:v>1.0</c:v>
                 </c:pt>
                 <c:pt idx="5">
                   <c:v>1.25</c:v>
@@ -7823,7 +7847,7 @@
                   <c:v>1.75</c:v>
                 </c:pt>
                 <c:pt idx="8">
-                  <c:v>2</c:v>
+                  <c:v>2.0</c:v>
                 </c:pt>
                 <c:pt idx="9">
                   <c:v>2.25</c:v>
@@ -7835,7 +7859,7 @@
                   <c:v>2.75</c:v>
                 </c:pt>
                 <c:pt idx="12">
-                  <c:v>3</c:v>
+                  <c:v>3.0</c:v>
                 </c:pt>
                 <c:pt idx="13">
                   <c:v>3.25</c:v>
@@ -7847,7 +7871,7 @@
                   <c:v>3.75</c:v>
                 </c:pt>
                 <c:pt idx="16">
-                  <c:v>4</c:v>
+                  <c:v>4.0</c:v>
                 </c:pt>
                 <c:pt idx="17">
                   <c:v>4.25</c:v>
@@ -7859,7 +7883,7 @@
                   <c:v>4.75</c:v>
                 </c:pt>
                 <c:pt idx="20">
-                  <c:v>5</c:v>
+                  <c:v>5.0</c:v>
                 </c:pt>
                 <c:pt idx="21">
                   <c:v>5.25</c:v>
@@ -7871,7 +7895,7 @@
                   <c:v>5.75</c:v>
                 </c:pt>
                 <c:pt idx="24">
-                  <c:v>6</c:v>
+                  <c:v>6.0</c:v>
                 </c:pt>
                 <c:pt idx="25">
                   <c:v>6.25</c:v>
@@ -7883,7 +7907,7 @@
                   <c:v>6.75</c:v>
                 </c:pt>
                 <c:pt idx="28">
-                  <c:v>7</c:v>
+                  <c:v>7.0</c:v>
                 </c:pt>
                 <c:pt idx="29">
                   <c:v>7.25</c:v>
@@ -7895,7 +7919,7 @@
                   <c:v>7.75</c:v>
                 </c:pt>
                 <c:pt idx="32">
-                  <c:v>8</c:v>
+                  <c:v>8.0</c:v>
                 </c:pt>
                 <c:pt idx="33">
                   <c:v>8.25</c:v>
@@ -7907,7 +7931,7 @@
                   <c:v>8.75</c:v>
                 </c:pt>
                 <c:pt idx="36">
-                  <c:v>9</c:v>
+                  <c:v>9.0</c:v>
                 </c:pt>
                 <c:pt idx="37">
                   <c:v>9.25</c:v>
@@ -7919,7 +7943,7 @@
                   <c:v>9.75</c:v>
                 </c:pt>
                 <c:pt idx="40">
-                  <c:v>10</c:v>
+                  <c:v>10.0</c:v>
                 </c:pt>
                 <c:pt idx="41">
                   <c:v>10.25</c:v>
@@ -7931,7 +7955,7 @@
                   <c:v>10.75</c:v>
                 </c:pt>
                 <c:pt idx="44">
-                  <c:v>11</c:v>
+                  <c:v>11.0</c:v>
                 </c:pt>
                 <c:pt idx="45">
                   <c:v>11.25</c:v>
@@ -7943,7 +7967,7 @@
                   <c:v>11.75</c:v>
                 </c:pt>
                 <c:pt idx="48">
-                  <c:v>12</c:v>
+                  <c:v>12.0</c:v>
                 </c:pt>
                 <c:pt idx="49">
                   <c:v>12.25</c:v>
@@ -7955,7 +7979,7 @@
                   <c:v>12.75</c:v>
                 </c:pt>
                 <c:pt idx="52">
-                  <c:v>13</c:v>
+                  <c:v>13.0</c:v>
                 </c:pt>
                 <c:pt idx="53">
                   <c:v>13.25</c:v>
@@ -7967,7 +7991,7 @@
                   <c:v>13.75</c:v>
                 </c:pt>
                 <c:pt idx="56">
-                  <c:v>14</c:v>
+                  <c:v>14.0</c:v>
                 </c:pt>
                 <c:pt idx="57">
                   <c:v>14.25</c:v>
@@ -7979,7 +8003,7 @@
                   <c:v>14.75</c:v>
                 </c:pt>
                 <c:pt idx="60">
-                  <c:v>15</c:v>
+                  <c:v>15.0</c:v>
                 </c:pt>
                 <c:pt idx="61">
                   <c:v>15.25</c:v>
@@ -7991,7 +8015,7 @@
                   <c:v>15.75</c:v>
                 </c:pt>
                 <c:pt idx="64">
-                  <c:v>16</c:v>
+                  <c:v>16.0</c:v>
                 </c:pt>
                 <c:pt idx="65">
                   <c:v>16.25</c:v>
@@ -8003,7 +8027,7 @@
                   <c:v>16.75</c:v>
                 </c:pt>
                 <c:pt idx="68">
-                  <c:v>17</c:v>
+                  <c:v>17.0</c:v>
                 </c:pt>
                 <c:pt idx="69">
                   <c:v>17.25</c:v>
@@ -8015,7 +8039,7 @@
                   <c:v>17.75</c:v>
                 </c:pt>
                 <c:pt idx="72">
-                  <c:v>18</c:v>
+                  <c:v>18.0</c:v>
                 </c:pt>
                 <c:pt idx="73">
                   <c:v>18.25</c:v>
@@ -8027,7 +8051,7 @@
                   <c:v>18.75</c:v>
                 </c:pt>
                 <c:pt idx="76">
-                  <c:v>19</c:v>
+                  <c:v>19.0</c:v>
                 </c:pt>
                 <c:pt idx="77">
                   <c:v>19.25</c:v>
@@ -8039,7 +8063,7 @@
                   <c:v>19.75</c:v>
                 </c:pt>
                 <c:pt idx="80">
-                  <c:v>20</c:v>
+                  <c:v>20.0</c:v>
                 </c:pt>
                 <c:pt idx="81">
                   <c:v>20.25</c:v>
@@ -8051,7 +8075,7 @@
                   <c:v>20.75</c:v>
                 </c:pt>
                 <c:pt idx="84">
-                  <c:v>21</c:v>
+                  <c:v>21.0</c:v>
                 </c:pt>
                 <c:pt idx="85">
                   <c:v>21.25</c:v>
@@ -8063,7 +8087,7 @@
                   <c:v>21.75</c:v>
                 </c:pt>
                 <c:pt idx="88">
-                  <c:v>22</c:v>
+                  <c:v>22.0</c:v>
                 </c:pt>
                 <c:pt idx="89">
                   <c:v>22.25</c:v>
@@ -8075,7 +8099,7 @@
                   <c:v>22.75</c:v>
                 </c:pt>
                 <c:pt idx="92">
-                  <c:v>23</c:v>
+                  <c:v>23.0</c:v>
                 </c:pt>
                 <c:pt idx="93">
                   <c:v>23.25</c:v>
@@ -8087,7 +8111,7 @@
                   <c:v>23.75</c:v>
                 </c:pt>
                 <c:pt idx="96">
-                  <c:v>24</c:v>
+                  <c:v>24.0</c:v>
                 </c:pt>
                 <c:pt idx="97">
                   <c:v>24.25</c:v>
@@ -8099,7 +8123,7 @@
                   <c:v>24.75</c:v>
                 </c:pt>
                 <c:pt idx="100">
-                  <c:v>25</c:v>
+                  <c:v>25.0</c:v>
                 </c:pt>
                 <c:pt idx="101">
                   <c:v>25.25</c:v>
@@ -8111,7 +8135,7 @@
                   <c:v>25.75</c:v>
                 </c:pt>
                 <c:pt idx="104">
-                  <c:v>26</c:v>
+                  <c:v>26.0</c:v>
                 </c:pt>
                 <c:pt idx="105">
                   <c:v>26.25</c:v>
@@ -8123,7 +8147,7 @@
                   <c:v>26.75</c:v>
                 </c:pt>
                 <c:pt idx="108">
-                  <c:v>27</c:v>
+                  <c:v>27.0</c:v>
                 </c:pt>
                 <c:pt idx="109">
                   <c:v>27.25</c:v>
@@ -8135,7 +8159,7 @@
                   <c:v>27.75</c:v>
                 </c:pt>
                 <c:pt idx="112">
-                  <c:v>28</c:v>
+                  <c:v>28.0</c:v>
                 </c:pt>
                 <c:pt idx="113">
                   <c:v>28.25</c:v>
@@ -8147,7 +8171,7 @@
                   <c:v>28.75</c:v>
                 </c:pt>
                 <c:pt idx="116">
-                  <c:v>29</c:v>
+                  <c:v>29.0</c:v>
                 </c:pt>
                 <c:pt idx="117">
                   <c:v>29.25</c:v>
@@ -8159,7 +8183,7 @@
                   <c:v>29.75</c:v>
                 </c:pt>
                 <c:pt idx="120">
-                  <c:v>30</c:v>
+                  <c:v>30.0</c:v>
                 </c:pt>
                 <c:pt idx="121">
                   <c:v>30.25</c:v>
@@ -8171,7 +8195,7 @@
                   <c:v>30.75</c:v>
                 </c:pt>
                 <c:pt idx="124">
-                  <c:v>31</c:v>
+                  <c:v>31.0</c:v>
                 </c:pt>
                 <c:pt idx="125">
                   <c:v>31.25</c:v>
@@ -8183,7 +8207,7 @@
                   <c:v>31.75</c:v>
                 </c:pt>
                 <c:pt idx="128">
-                  <c:v>32</c:v>
+                  <c:v>32.0</c:v>
                 </c:pt>
                 <c:pt idx="129">
                   <c:v>32.25</c:v>
@@ -8195,7 +8219,7 @@
                   <c:v>32.75</c:v>
                 </c:pt>
                 <c:pt idx="132">
-                  <c:v>33</c:v>
+                  <c:v>33.0</c:v>
                 </c:pt>
                 <c:pt idx="133">
                   <c:v>33.25</c:v>
@@ -8207,7 +8231,7 @@
                   <c:v>33.75</c:v>
                 </c:pt>
                 <c:pt idx="136">
-                  <c:v>34</c:v>
+                  <c:v>34.0</c:v>
                 </c:pt>
                 <c:pt idx="137">
                   <c:v>34.25</c:v>
@@ -8219,7 +8243,7 @@
                   <c:v>34.75</c:v>
                 </c:pt>
                 <c:pt idx="140">
-                  <c:v>35</c:v>
+                  <c:v>35.0</c:v>
                 </c:pt>
                 <c:pt idx="141">
                   <c:v>35.25</c:v>
@@ -8231,7 +8255,7 @@
                   <c:v>35.75</c:v>
                 </c:pt>
                 <c:pt idx="144">
-                  <c:v>36</c:v>
+                  <c:v>36.0</c:v>
                 </c:pt>
                 <c:pt idx="145">
                   <c:v>36.25</c:v>
@@ -8243,7 +8267,7 @@
                   <c:v>36.75</c:v>
                 </c:pt>
                 <c:pt idx="148">
-                  <c:v>37</c:v>
+                  <c:v>37.0</c:v>
                 </c:pt>
                 <c:pt idx="149">
                   <c:v>37.25</c:v>
@@ -8255,7 +8279,7 @@
                   <c:v>37.75</c:v>
                 </c:pt>
                 <c:pt idx="152">
-                  <c:v>38</c:v>
+                  <c:v>38.0</c:v>
                 </c:pt>
                 <c:pt idx="153">
                   <c:v>38.25</c:v>
@@ -8267,7 +8291,7 @@
                   <c:v>38.75</c:v>
                 </c:pt>
                 <c:pt idx="156">
-                  <c:v>39</c:v>
+                  <c:v>39.0</c:v>
                 </c:pt>
                 <c:pt idx="157">
                   <c:v>39.25</c:v>
@@ -8279,499 +8303,499 @@
                   <c:v>39.75</c:v>
                 </c:pt>
                 <c:pt idx="160">
-                  <c:v>40</c:v>
+                  <c:v>40.0</c:v>
                 </c:pt>
               </c:numCache>
             </c:numRef>
           </c:xVal>
           <c:yVal>
             <c:numRef>
-              <c:f>'Chart Data'!$B$2:$B$162</c:f>
+              <c:f>Sheet1!$B$2:$B$162</c:f>
               <c:numCache>
                 <c:formatCode>General</c:formatCode>
                 <c:ptCount val="161"/>
                 <c:pt idx="0">
-                  <c:v>0</c:v>
+                  <c:v>0.0</c:v>
                 </c:pt>
                 <c:pt idx="1">
-                  <c:v>1.33149501</c:v>
+                  <c:v>58.54</c:v>
                 </c:pt>
                 <c:pt idx="2">
-                  <c:v>2.6547809</c:v>
+                  <c:v>116.55</c:v>
                 </c:pt>
                 <c:pt idx="3">
-                  <c:v>3.9616992</c:v>
+                  <c:v>173.53</c:v>
                 </c:pt>
                 <c:pt idx="4">
-                  <c:v>5.24419229</c:v>
+                  <c:v>228.97</c:v>
                 </c:pt>
                 <c:pt idx="5">
-                  <c:v>6.4943532</c:v>
+                  <c:v>282.38</c:v>
                 </c:pt>
                 <c:pt idx="6">
-                  <c:v>7.70447426</c:v>
+                  <c:v>333.28</c:v>
                 </c:pt>
                 <c:pt idx="7">
-                  <c:v>8.86709468</c:v>
+                  <c:v>381.23</c:v>
                 </c:pt>
                 <c:pt idx="8">
-                  <c:v>9.97504651</c:v>
+                  <c:v>425.79</c:v>
                 </c:pt>
                 <c:pt idx="9">
-                  <c:v>11.02149886</c:v>
+                  <c:v>466.57</c:v>
                 </c:pt>
                 <c:pt idx="10">
-                  <c:v>12</c:v>
+                  <c:v>503.21</c:v>
                 </c:pt>
                 <c:pt idx="11">
-                  <c:v>12.90451715</c:v>
+                  <c:v>535.38</c:v>
                 </c:pt>
                 <c:pt idx="12">
-                  <c:v>13.72947367</c:v>
+                  <c:v>562.8</c:v>
                 </c:pt>
                 <c:pt idx="13">
-                  <c:v>14.46978341</c:v>
+                  <c:v>585.23</c:v>
                 </c:pt>
                 <c:pt idx="14">
-                  <c:v>15.12088213</c:v>
+                  <c:v>602.46</c:v>
                 </c:pt>
                 <c:pt idx="15">
-                  <c:v>15.67875558</c:v>
+                  <c:v>614.34</c:v>
                 </c:pt>
                 <c:pt idx="16">
-                  <c:v>16.13996429</c:v>
+                  <c:v>620.77</c:v>
                 </c:pt>
                 <c:pt idx="17">
-                  <c:v>16.50166475</c:v>
+                  <c:v>621.69</c:v>
                 </c:pt>
                 <c:pt idx="18">
-                  <c:v>16.76162696</c:v>
+                  <c:v>617.1</c:v>
                 </c:pt>
                 <c:pt idx="19">
-                  <c:v>16.91824817</c:v>
+                  <c:v>607.02</c:v>
                 </c:pt>
                 <c:pt idx="20">
-                  <c:v>16.97056275</c:v>
+                  <c:v>591.56</c:v>
                 </c:pt>
                 <c:pt idx="21">
-                  <c:v>16.91824817</c:v>
+                  <c:v>570.84</c:v>
                 </c:pt>
                 <c:pt idx="22">
-                  <c:v>16.76162696</c:v>
+                  <c:v>545.06</c:v>
                 </c:pt>
                 <c:pt idx="23">
-                  <c:v>16.50166475</c:v>
+                  <c:v>514.44</c:v>
                 </c:pt>
                 <c:pt idx="24">
-                  <c:v>16.13996429</c:v>
+                  <c:v>479.26</c:v>
                 </c:pt>
                 <c:pt idx="25">
-                  <c:v>15.67875558</c:v>
+                  <c:v>439.82</c:v>
                 </c:pt>
                 <c:pt idx="26">
-                  <c:v>15.12088213</c:v>
+                  <c:v>396.48</c:v>
                 </c:pt>
                 <c:pt idx="27">
-                  <c:v>14.46978341</c:v>
+                  <c:v>349.62</c:v>
                 </c:pt>
                 <c:pt idx="28">
-                  <c:v>13.72947367</c:v>
+                  <c:v>299.65</c:v>
                 </c:pt>
                 <c:pt idx="29">
-                  <c:v>12.90451715</c:v>
+                  <c:v>247.03</c:v>
                 </c:pt>
                 <c:pt idx="30">
-                  <c:v>12</c:v>
+                  <c:v>192.21</c:v>
                 </c:pt>
                 <c:pt idx="31">
-                  <c:v>11.02149886</c:v>
+                  <c:v>135.69</c:v>
                 </c:pt>
                 <c:pt idx="32">
-                  <c:v>9.97504651</c:v>
+                  <c:v>77.96</c:v>
                 </c:pt>
                 <c:pt idx="33">
-                  <c:v>8.86709468</c:v>
+                  <c:v>19.54</c:v>
                 </c:pt>
                 <c:pt idx="34">
-                  <c:v>7.70447426</c:v>
+                  <c:v>-39.06</c:v>
                 </c:pt>
                 <c:pt idx="35">
-                  <c:v>6.4943532</c:v>
+                  <c:v>-97.3</c:v>
                 </c:pt>
                 <c:pt idx="36">
-                  <c:v>5.24419229</c:v>
+                  <c:v>-154.69</c:v>
                 </c:pt>
                 <c:pt idx="37">
-                  <c:v>3.9616992</c:v>
+                  <c:v>-210.69</c:v>
                 </c:pt>
                 <c:pt idx="38">
-                  <c:v>2.6547809</c:v>
+                  <c:v>-264.83</c:v>
                 </c:pt>
                 <c:pt idx="39">
-                  <c:v>1.33149501</c:v>
+                  <c:v>-316.62</c:v>
                 </c:pt>
                 <c:pt idx="40">
-                  <c:v>0</c:v>
+                  <c:v>-365.6</c:v>
                 </c:pt>
                 <c:pt idx="41">
-                  <c:v>-1.33149501</c:v>
+                  <c:v>-411.34</c:v>
                 </c:pt>
                 <c:pt idx="42">
-                  <c:v>-2.6547809</c:v>
+                  <c:v>-453.42</c:v>
                 </c:pt>
                 <c:pt idx="43">
-                  <c:v>-3.9616992</c:v>
+                  <c:v>-491.48</c:v>
                 </c:pt>
                 <c:pt idx="44">
-                  <c:v>-5.24419229</c:v>
+                  <c:v>-525.17</c:v>
                 </c:pt>
                 <c:pt idx="45">
-                  <c:v>-6.4943532</c:v>
+                  <c:v>-554.21</c:v>
                 </c:pt>
                 <c:pt idx="46">
-                  <c:v>-7.70447426</c:v>
+                  <c:v>-578.32</c:v>
                 </c:pt>
                 <c:pt idx="47">
-                  <c:v>-8.86709468</c:v>
+                  <c:v>-597.3</c:v>
                 </c:pt>
                 <c:pt idx="48">
-                  <c:v>-9.97504651</c:v>
+                  <c:v>-610.98</c:v>
                 </c:pt>
                 <c:pt idx="49">
-                  <c:v>-11.02149886</c:v>
+                  <c:v>-619.24</c:v>
                 </c:pt>
                 <c:pt idx="50">
-                  <c:v>-12</c:v>
+                  <c:v>-622.0</c:v>
                 </c:pt>
                 <c:pt idx="51">
-                  <c:v>-12.90451715</c:v>
+                  <c:v>-619.24</c:v>
                 </c:pt>
                 <c:pt idx="52">
-                  <c:v>-13.72947367</c:v>
+                  <c:v>-610.98</c:v>
                 </c:pt>
                 <c:pt idx="53">
-                  <c:v>-14.46978341</c:v>
+                  <c:v>-597.3</c:v>
                 </c:pt>
                 <c:pt idx="54">
-                  <c:v>-15.12088213</c:v>
+                  <c:v>-578.32</c:v>
                 </c:pt>
                 <c:pt idx="55">
-                  <c:v>-15.67875558</c:v>
+                  <c:v>-554.21</c:v>
                 </c:pt>
                 <c:pt idx="56">
-                  <c:v>-16.13996429</c:v>
+                  <c:v>-525.17</c:v>
                 </c:pt>
                 <c:pt idx="57">
-                  <c:v>-16.50166475</c:v>
+                  <c:v>-491.48</c:v>
                 </c:pt>
                 <c:pt idx="58">
-                  <c:v>-16.76162696</c:v>
+                  <c:v>-453.42</c:v>
                 </c:pt>
                 <c:pt idx="59">
-                  <c:v>-16.91824817</c:v>
+                  <c:v>-411.34</c:v>
                 </c:pt>
                 <c:pt idx="60">
-                  <c:v>-16.97056275</c:v>
+                  <c:v>-365.6</c:v>
                 </c:pt>
                 <c:pt idx="61">
-                  <c:v>-16.91824817</c:v>
+                  <c:v>-316.62</c:v>
                 </c:pt>
                 <c:pt idx="62">
-                  <c:v>-16.76162696</c:v>
+                  <c:v>-264.83</c:v>
                 </c:pt>
                 <c:pt idx="63">
-                  <c:v>-16.50166475</c:v>
+                  <c:v>-210.69</c:v>
                 </c:pt>
                 <c:pt idx="64">
-                  <c:v>-16.13996429</c:v>
+                  <c:v>-154.69</c:v>
                 </c:pt>
                 <c:pt idx="65">
-                  <c:v>-15.67875558</c:v>
+                  <c:v>-97.3</c:v>
                 </c:pt>
                 <c:pt idx="66">
-                  <c:v>-15.12088213</c:v>
+                  <c:v>-39.06</c:v>
                 </c:pt>
                 <c:pt idx="67">
-                  <c:v>-14.46978341</c:v>
+                  <c:v>19.54</c:v>
                 </c:pt>
                 <c:pt idx="68">
-                  <c:v>-13.72947367</c:v>
+                  <c:v>77.96</c:v>
                 </c:pt>
                 <c:pt idx="69">
-                  <c:v>-12.90451715</c:v>
+                  <c:v>135.69</c:v>
                 </c:pt>
                 <c:pt idx="70">
-                  <c:v>-12</c:v>
+                  <c:v>192.21</c:v>
                 </c:pt>
                 <c:pt idx="71">
-                  <c:v>-11.02149886</c:v>
+                  <c:v>247.03</c:v>
                 </c:pt>
                 <c:pt idx="72">
-                  <c:v>-9.97504651</c:v>
+                  <c:v>299.65</c:v>
                 </c:pt>
                 <c:pt idx="73">
-                  <c:v>-8.86709468</c:v>
+                  <c:v>349.62</c:v>
                 </c:pt>
                 <c:pt idx="74">
-                  <c:v>-7.70447426</c:v>
+                  <c:v>396.48</c:v>
                 </c:pt>
                 <c:pt idx="75">
-                  <c:v>-6.4943532</c:v>
+                  <c:v>439.82</c:v>
                 </c:pt>
                 <c:pt idx="76">
-                  <c:v>-5.24419229</c:v>
+                  <c:v>479.26</c:v>
                 </c:pt>
                 <c:pt idx="77">
-                  <c:v>-3.9616992</c:v>
+                  <c:v>514.44</c:v>
                 </c:pt>
                 <c:pt idx="78">
-                  <c:v>-2.6547809</c:v>
+                  <c:v>545.06</c:v>
                 </c:pt>
                 <c:pt idx="79">
-                  <c:v>-1.33149501</c:v>
+                  <c:v>570.84</c:v>
                 </c:pt>
                 <c:pt idx="80">
-                  <c:v>-0</c:v>
+                  <c:v>591.56</c:v>
                 </c:pt>
                 <c:pt idx="81">
-                  <c:v>1.33149501</c:v>
+                  <c:v>607.02</c:v>
                 </c:pt>
                 <c:pt idx="82">
-                  <c:v>2.6547809</c:v>
+                  <c:v>617.1</c:v>
                 </c:pt>
                 <c:pt idx="83">
-                  <c:v>3.9616992</c:v>
+                  <c:v>621.69</c:v>
                 </c:pt>
                 <c:pt idx="84">
-                  <c:v>5.24419229</c:v>
+                  <c:v>620.77</c:v>
                 </c:pt>
                 <c:pt idx="85">
-                  <c:v>6.4943532</c:v>
+                  <c:v>614.34</c:v>
                 </c:pt>
                 <c:pt idx="86">
-                  <c:v>7.70447426</c:v>
+                  <c:v>602.46</c:v>
                 </c:pt>
                 <c:pt idx="87">
-                  <c:v>8.86709468</c:v>
+                  <c:v>585.23</c:v>
                 </c:pt>
                 <c:pt idx="88">
-                  <c:v>9.97504651</c:v>
+                  <c:v>562.8</c:v>
                 </c:pt>
                 <c:pt idx="89">
-                  <c:v>11.02149886</c:v>
+                  <c:v>535.38</c:v>
                 </c:pt>
                 <c:pt idx="90">
-                  <c:v>12</c:v>
+                  <c:v>503.21</c:v>
                 </c:pt>
                 <c:pt idx="91">
-                  <c:v>12.90451715</c:v>
+                  <c:v>466.57</c:v>
                 </c:pt>
                 <c:pt idx="92">
-                  <c:v>13.72947367</c:v>
+                  <c:v>425.79</c:v>
                 </c:pt>
                 <c:pt idx="93">
-                  <c:v>14.46978341</c:v>
+                  <c:v>381.23</c:v>
                 </c:pt>
                 <c:pt idx="94">
-                  <c:v>15.12088213</c:v>
+                  <c:v>333.28</c:v>
                 </c:pt>
                 <c:pt idx="95">
-                  <c:v>15.67875558</c:v>
+                  <c:v>282.38</c:v>
                 </c:pt>
                 <c:pt idx="96">
-                  <c:v>16.13996429</c:v>
+                  <c:v>228.97</c:v>
                 </c:pt>
                 <c:pt idx="97">
-                  <c:v>16.50166475</c:v>
+                  <c:v>173.53</c:v>
                 </c:pt>
                 <c:pt idx="98">
-                  <c:v>16.76162696</c:v>
+                  <c:v>116.55</c:v>
                 </c:pt>
                 <c:pt idx="99">
-                  <c:v>16.91824817</c:v>
+                  <c:v>58.54</c:v>
                 </c:pt>
                 <c:pt idx="100">
-                  <c:v>16.97056275</c:v>
+                  <c:v>0.0</c:v>
                 </c:pt>
                 <c:pt idx="101">
-                  <c:v>16.91824817</c:v>
+                  <c:v>-58.54</c:v>
                 </c:pt>
                 <c:pt idx="102">
-                  <c:v>16.76162696</c:v>
+                  <c:v>-116.55</c:v>
                 </c:pt>
                 <c:pt idx="103">
-                  <c:v>16.50166475</c:v>
+                  <c:v>-173.53</c:v>
                 </c:pt>
                 <c:pt idx="104">
-                  <c:v>16.13996429</c:v>
+                  <c:v>-228.97</c:v>
                 </c:pt>
                 <c:pt idx="105">
-                  <c:v>15.67875558</c:v>
+                  <c:v>-282.38</c:v>
                 </c:pt>
                 <c:pt idx="106">
-                  <c:v>15.12088213</c:v>
+                  <c:v>-333.28</c:v>
                 </c:pt>
                 <c:pt idx="107">
-                  <c:v>14.46978341</c:v>
+                  <c:v>-381.23</c:v>
                 </c:pt>
                 <c:pt idx="108">
-                  <c:v>13.72947367</c:v>
+                  <c:v>-425.79</c:v>
                 </c:pt>
                 <c:pt idx="109">
-                  <c:v>12.90451715</c:v>
+                  <c:v>-466.57</c:v>
                 </c:pt>
                 <c:pt idx="110">
-                  <c:v>12</c:v>
+                  <c:v>-503.21</c:v>
                 </c:pt>
                 <c:pt idx="111">
-                  <c:v>11.02149886</c:v>
+                  <c:v>-535.38</c:v>
                 </c:pt>
                 <c:pt idx="112">
-                  <c:v>9.97504651</c:v>
+                  <c:v>-562.8</c:v>
                 </c:pt>
                 <c:pt idx="113">
-                  <c:v>8.86709468</c:v>
+                  <c:v>-585.23</c:v>
                 </c:pt>
                 <c:pt idx="114">
-                  <c:v>7.70447426</c:v>
+                  <c:v>-602.46</c:v>
                 </c:pt>
                 <c:pt idx="115">
-                  <c:v>6.4943532</c:v>
+                  <c:v>-614.34</c:v>
                 </c:pt>
                 <c:pt idx="116">
-                  <c:v>5.24419229</c:v>
+                  <c:v>-620.77</c:v>
                 </c:pt>
                 <c:pt idx="117">
-                  <c:v>3.9616992</c:v>
+                  <c:v>-621.69</c:v>
                 </c:pt>
                 <c:pt idx="118">
-                  <c:v>2.6547809</c:v>
+                  <c:v>-617.1</c:v>
                 </c:pt>
                 <c:pt idx="119">
-                  <c:v>1.33149501</c:v>
+                  <c:v>-607.02</c:v>
                 </c:pt>
                 <c:pt idx="120">
-                  <c:v>0</c:v>
+                  <c:v>-591.56</c:v>
                 </c:pt>
                 <c:pt idx="121">
-                  <c:v>-1.33149501</c:v>
+                  <c:v>-570.84</c:v>
                 </c:pt>
                 <c:pt idx="122">
-                  <c:v>-2.6547809</c:v>
+                  <c:v>-545.06</c:v>
                 </c:pt>
                 <c:pt idx="123">
-                  <c:v>-3.9616992</c:v>
+                  <c:v>-514.44</c:v>
                 </c:pt>
                 <c:pt idx="124">
-                  <c:v>-5.24419229</c:v>
+                  <c:v>-479.26</c:v>
                 </c:pt>
                 <c:pt idx="125">
-                  <c:v>-6.4943532</c:v>
+                  <c:v>-439.82</c:v>
                 </c:pt>
                 <c:pt idx="126">
-                  <c:v>-7.70447426</c:v>
+                  <c:v>-396.48</c:v>
                 </c:pt>
                 <c:pt idx="127">
-                  <c:v>-8.86709468</c:v>
+                  <c:v>-349.62</c:v>
                 </c:pt>
                 <c:pt idx="128">
-                  <c:v>-9.97504651</c:v>
+                  <c:v>-299.65</c:v>
                 </c:pt>
                 <c:pt idx="129">
-                  <c:v>-11.02149886</c:v>
+                  <c:v>-247.03</c:v>
                 </c:pt>
                 <c:pt idx="130">
-                  <c:v>-12</c:v>
+                  <c:v>-192.21</c:v>
                 </c:pt>
                 <c:pt idx="131">
-                  <c:v>-12.90451715</c:v>
+                  <c:v>-135.69</c:v>
                 </c:pt>
                 <c:pt idx="132">
-                  <c:v>-13.72947367</c:v>
+                  <c:v>-77.96</c:v>
                 </c:pt>
                 <c:pt idx="133">
-                  <c:v>-14.46978341</c:v>
+                  <c:v>-19.54</c:v>
                 </c:pt>
                 <c:pt idx="134">
-                  <c:v>-15.12088213</c:v>
+                  <c:v>39.06</c:v>
                 </c:pt>
                 <c:pt idx="135">
-                  <c:v>-15.67875558</c:v>
+                  <c:v>97.3</c:v>
                 </c:pt>
                 <c:pt idx="136">
-                  <c:v>-16.13996429</c:v>
+                  <c:v>154.69</c:v>
                 </c:pt>
                 <c:pt idx="137">
-                  <c:v>-16.50166475</c:v>
+                  <c:v>210.69</c:v>
                 </c:pt>
                 <c:pt idx="138">
-                  <c:v>-16.76162696</c:v>
+                  <c:v>264.83</c:v>
                 </c:pt>
                 <c:pt idx="139">
-                  <c:v>-16.91824817</c:v>
+                  <c:v>316.62</c:v>
                 </c:pt>
                 <c:pt idx="140">
-                  <c:v>-16.97056275</c:v>
+                  <c:v>365.6</c:v>
                 </c:pt>
                 <c:pt idx="141">
-                  <c:v>-16.91824817</c:v>
+                  <c:v>411.34</c:v>
                 </c:pt>
                 <c:pt idx="142">
-                  <c:v>-16.76162696</c:v>
+                  <c:v>453.42</c:v>
                 </c:pt>
                 <c:pt idx="143">
-                  <c:v>-16.50166475</c:v>
+                  <c:v>491.48</c:v>
                 </c:pt>
                 <c:pt idx="144">
-                  <c:v>-16.13996429</c:v>
+                  <c:v>525.17</c:v>
                 </c:pt>
                 <c:pt idx="145">
-                  <c:v>-15.67875558</c:v>
+                  <c:v>554.21</c:v>
                 </c:pt>
                 <c:pt idx="146">
-                  <c:v>-15.12088213</c:v>
+                  <c:v>578.32</c:v>
                 </c:pt>
                 <c:pt idx="147">
-                  <c:v>-14.46978341</c:v>
+                  <c:v>597.3</c:v>
                 </c:pt>
                 <c:pt idx="148">
-                  <c:v>-13.72947367</c:v>
+                  <c:v>610.98</c:v>
                 </c:pt>
                 <c:pt idx="149">
-                  <c:v>-12.90451715</c:v>
+                  <c:v>619.24</c:v>
                 </c:pt>
                 <c:pt idx="150">
-                  <c:v>-12</c:v>
+                  <c:v>622.0</c:v>
                 </c:pt>
                 <c:pt idx="151">
-                  <c:v>-11.02149886</c:v>
+                  <c:v>619.24</c:v>
                 </c:pt>
                 <c:pt idx="152">
-                  <c:v>-9.97504651</c:v>
+                  <c:v>610.98</c:v>
                 </c:pt>
                 <c:pt idx="153">
-                  <c:v>-8.86709468</c:v>
+                  <c:v>597.3</c:v>
                 </c:pt>
                 <c:pt idx="154">
-                  <c:v>-7.70447426</c:v>
+                  <c:v>578.32</c:v>
                 </c:pt>
                 <c:pt idx="155">
-                  <c:v>-6.4943532</c:v>
+                  <c:v>554.21</c:v>
                 </c:pt>
                 <c:pt idx="156">
-                  <c:v>-5.24419229</c:v>
+                  <c:v>525.17</c:v>
                 </c:pt>
                 <c:pt idx="157">
-                  <c:v>-3.9616992</c:v>
+                  <c:v>491.48</c:v>
                 </c:pt>
                 <c:pt idx="158">
-                  <c:v>-2.6547809</c:v>
+                  <c:v>453.42</c:v>
                 </c:pt>
                 <c:pt idx="159">
-                  <c:v>-1.33149501</c:v>
+                  <c:v>411.34</c:v>
                 </c:pt>
                 <c:pt idx="160">
-                  <c:v>-0</c:v>
+                  <c:v>365.6</c:v>
                 </c:pt>
               </c:numCache>
             </c:numRef>
@@ -8806,8 +8830,8 @@
         <c:axId val="48672768"/>
         <c:scaling>
           <c:orientation val="minMax"/>
-          <c:max val="20"/>
-          <c:min val="-20"/>
+          <c:max val="700"/>
+          <c:min val="-700"/>
         </c:scaling>
         <c:delete val="0"/>
         <c:axPos val="l"/>
@@ -8880,7 +8904,7 @@
           </a:p>
         </c:txPr>
         <c:crossAx val="48650112"/>
-        <c:majorUnit val="10"/>
+        <c:majorUnit val="350"/>
       </c:valAx>
       <c:valAx>
         <c:axId val="48650112"/>
@@ -8983,7 +9007,15 @@
           <c:idx val="0"/>
           <c:order val="0"/>
           <c:tx>
-            <c:v>Spänning (V)</c:v>
+            <c:strRef>
+              <c:f>Sheet1!$B$1</c:f>
+              <c:strCache>
+                <c:ptCount val="1"/>
+                <c:pt idx="0">
+                  <c:v>u</c:v>
+                </c:pt>
+              </c:strCache>
+            </c:strRef>
           </c:tx>
           <c:spPr>
             <a:ln xmlns:a="http://schemas.openxmlformats.org/drawingml/2006/main" w="23813">
@@ -8997,12 +9029,12 @@
           </c:marker>
           <c:xVal>
             <c:numRef>
-              <c:f>'Chart Data'!$A$2:$A$162</c:f>
+              <c:f>Sheet1!$A$2:$A$162</c:f>
               <c:numCache>
                 <c:formatCode>General</c:formatCode>
                 <c:ptCount val="161"/>
                 <c:pt idx="0">
-                  <c:v>0</c:v>
+                  <c:v>0.0</c:v>
                 </c:pt>
                 <c:pt idx="1">
                   <c:v>0.25</c:v>
@@ -9014,7 +9046,7 @@
                   <c:v>0.75</c:v>
                 </c:pt>
                 <c:pt idx="4">
-                  <c:v>1</c:v>
+                  <c:v>1.0</c:v>
                 </c:pt>
                 <c:pt idx="5">
                   <c:v>1.25</c:v>
@@ -9026,7 +9058,7 @@
                   <c:v>1.75</c:v>
                 </c:pt>
                 <c:pt idx="8">
-                  <c:v>2</c:v>
+                  <c:v>2.0</c:v>
                 </c:pt>
                 <c:pt idx="9">
                   <c:v>2.25</c:v>
@@ -9038,7 +9070,7 @@
                   <c:v>2.75</c:v>
                 </c:pt>
                 <c:pt idx="12">
-                  <c:v>3</c:v>
+                  <c:v>3.0</c:v>
                 </c:pt>
                 <c:pt idx="13">
                   <c:v>3.25</c:v>
@@ -9050,7 +9082,7 @@
                   <c:v>3.75</c:v>
                 </c:pt>
                 <c:pt idx="16">
-                  <c:v>4</c:v>
+                  <c:v>4.0</c:v>
                 </c:pt>
                 <c:pt idx="17">
                   <c:v>4.25</c:v>
@@ -9062,7 +9094,7 @@
                   <c:v>4.75</c:v>
                 </c:pt>
                 <c:pt idx="20">
-                  <c:v>5</c:v>
+                  <c:v>5.0</c:v>
                 </c:pt>
                 <c:pt idx="21">
                   <c:v>5.25</c:v>
@@ -9074,7 +9106,7 @@
                   <c:v>5.75</c:v>
                 </c:pt>
                 <c:pt idx="24">
-                  <c:v>6</c:v>
+                  <c:v>6.0</c:v>
                 </c:pt>
                 <c:pt idx="25">
                   <c:v>6.25</c:v>
@@ -9086,7 +9118,7 @@
                   <c:v>6.75</c:v>
                 </c:pt>
                 <c:pt idx="28">
-                  <c:v>7</c:v>
+                  <c:v>7.0</c:v>
                 </c:pt>
                 <c:pt idx="29">
                   <c:v>7.25</c:v>
@@ -9098,7 +9130,7 @@
                   <c:v>7.75</c:v>
                 </c:pt>
                 <c:pt idx="32">
-                  <c:v>8</c:v>
+                  <c:v>8.0</c:v>
                 </c:pt>
                 <c:pt idx="33">
                   <c:v>8.25</c:v>
@@ -9110,7 +9142,7 @@
                   <c:v>8.75</c:v>
                 </c:pt>
                 <c:pt idx="36">
-                  <c:v>9</c:v>
+                  <c:v>9.0</c:v>
                 </c:pt>
                 <c:pt idx="37">
                   <c:v>9.25</c:v>
@@ -9122,7 +9154,7 @@
                   <c:v>9.75</c:v>
                 </c:pt>
                 <c:pt idx="40">
-                  <c:v>10</c:v>
+                  <c:v>10.0</c:v>
                 </c:pt>
                 <c:pt idx="41">
                   <c:v>10.25</c:v>
@@ -9134,7 +9166,7 @@
                   <c:v>10.75</c:v>
                 </c:pt>
                 <c:pt idx="44">
-                  <c:v>11</c:v>
+                  <c:v>11.0</c:v>
                 </c:pt>
                 <c:pt idx="45">
                   <c:v>11.25</c:v>
@@ -9146,7 +9178,7 @@
                   <c:v>11.75</c:v>
                 </c:pt>
                 <c:pt idx="48">
-                  <c:v>12</c:v>
+                  <c:v>12.0</c:v>
                 </c:pt>
                 <c:pt idx="49">
                   <c:v>12.25</c:v>
@@ -9158,7 +9190,7 @@
                   <c:v>12.75</c:v>
                 </c:pt>
                 <c:pt idx="52">
-                  <c:v>13</c:v>
+                  <c:v>13.0</c:v>
                 </c:pt>
                 <c:pt idx="53">
                   <c:v>13.25</c:v>
@@ -9170,7 +9202,7 @@
                   <c:v>13.75</c:v>
                 </c:pt>
                 <c:pt idx="56">
-                  <c:v>14</c:v>
+                  <c:v>14.0</c:v>
                 </c:pt>
                 <c:pt idx="57">
                   <c:v>14.25</c:v>
@@ -9182,7 +9214,7 @@
                   <c:v>14.75</c:v>
                 </c:pt>
                 <c:pt idx="60">
-                  <c:v>15</c:v>
+                  <c:v>15.0</c:v>
                 </c:pt>
                 <c:pt idx="61">
                   <c:v>15.25</c:v>
@@ -9194,7 +9226,7 @@
                   <c:v>15.75</c:v>
                 </c:pt>
                 <c:pt idx="64">
-                  <c:v>16</c:v>
+                  <c:v>16.0</c:v>
                 </c:pt>
                 <c:pt idx="65">
                   <c:v>16.25</c:v>
@@ -9206,7 +9238,7 @@
                   <c:v>16.75</c:v>
                 </c:pt>
                 <c:pt idx="68">
-                  <c:v>17</c:v>
+                  <c:v>17.0</c:v>
                 </c:pt>
                 <c:pt idx="69">
                   <c:v>17.25</c:v>
@@ -9218,7 +9250,7 @@
                   <c:v>17.75</c:v>
                 </c:pt>
                 <c:pt idx="72">
-                  <c:v>18</c:v>
+                  <c:v>18.0</c:v>
                 </c:pt>
                 <c:pt idx="73">
                   <c:v>18.25</c:v>
@@ -9230,7 +9262,7 @@
                   <c:v>18.75</c:v>
                 </c:pt>
                 <c:pt idx="76">
-                  <c:v>19</c:v>
+                  <c:v>19.0</c:v>
                 </c:pt>
                 <c:pt idx="77">
                   <c:v>19.25</c:v>
@@ -9242,7 +9274,7 @@
                   <c:v>19.75</c:v>
                 </c:pt>
                 <c:pt idx="80">
-                  <c:v>20</c:v>
+                  <c:v>20.0</c:v>
                 </c:pt>
                 <c:pt idx="81">
                   <c:v>20.25</c:v>
@@ -9254,7 +9286,7 @@
                   <c:v>20.75</c:v>
                 </c:pt>
                 <c:pt idx="84">
-                  <c:v>21</c:v>
+                  <c:v>21.0</c:v>
                 </c:pt>
                 <c:pt idx="85">
                   <c:v>21.25</c:v>
@@ -9266,7 +9298,7 @@
                   <c:v>21.75</c:v>
                 </c:pt>
                 <c:pt idx="88">
-                  <c:v>22</c:v>
+                  <c:v>22.0</c:v>
                 </c:pt>
                 <c:pt idx="89">
                   <c:v>22.25</c:v>
@@ -9278,7 +9310,7 @@
                   <c:v>22.75</c:v>
                 </c:pt>
                 <c:pt idx="92">
-                  <c:v>23</c:v>
+                  <c:v>23.0</c:v>
                 </c:pt>
                 <c:pt idx="93">
                   <c:v>23.25</c:v>
@@ -9290,7 +9322,7 @@
                   <c:v>23.75</c:v>
                 </c:pt>
                 <c:pt idx="96">
-                  <c:v>24</c:v>
+                  <c:v>24.0</c:v>
                 </c:pt>
                 <c:pt idx="97">
                   <c:v>24.25</c:v>
@@ -9302,7 +9334,7 @@
                   <c:v>24.75</c:v>
                 </c:pt>
                 <c:pt idx="100">
-                  <c:v>25</c:v>
+                  <c:v>25.0</c:v>
                 </c:pt>
                 <c:pt idx="101">
                   <c:v>25.25</c:v>
@@ -9314,7 +9346,7 @@
                   <c:v>25.75</c:v>
                 </c:pt>
                 <c:pt idx="104">
-                  <c:v>26</c:v>
+                  <c:v>26.0</c:v>
                 </c:pt>
                 <c:pt idx="105">
                   <c:v>26.25</c:v>
@@ -9326,7 +9358,7 @@
                   <c:v>26.75</c:v>
                 </c:pt>
                 <c:pt idx="108">
-                  <c:v>27</c:v>
+                  <c:v>27.0</c:v>
                 </c:pt>
                 <c:pt idx="109">
                   <c:v>27.25</c:v>
@@ -9338,7 +9370,7 @@
                   <c:v>27.75</c:v>
                 </c:pt>
                 <c:pt idx="112">
-                  <c:v>28</c:v>
+                  <c:v>28.0</c:v>
                 </c:pt>
                 <c:pt idx="113">
                   <c:v>28.25</c:v>
@@ -9350,7 +9382,7 @@
                   <c:v>28.75</c:v>
                 </c:pt>
                 <c:pt idx="116">
-                  <c:v>29</c:v>
+                  <c:v>29.0</c:v>
                 </c:pt>
                 <c:pt idx="117">
                   <c:v>29.25</c:v>
@@ -9362,7 +9394,7 @@
                   <c:v>29.75</c:v>
                 </c:pt>
                 <c:pt idx="120">
-                  <c:v>30</c:v>
+                  <c:v>30.0</c:v>
                 </c:pt>
                 <c:pt idx="121">
                   <c:v>30.25</c:v>
@@ -9374,7 +9406,7 @@
                   <c:v>30.75</c:v>
                 </c:pt>
                 <c:pt idx="124">
-                  <c:v>31</c:v>
+                  <c:v>31.0</c:v>
                 </c:pt>
                 <c:pt idx="125">
                   <c:v>31.25</c:v>
@@ -9386,7 +9418,7 @@
                   <c:v>31.75</c:v>
                 </c:pt>
                 <c:pt idx="128">
-                  <c:v>32</c:v>
+                  <c:v>32.0</c:v>
                 </c:pt>
                 <c:pt idx="129">
                   <c:v>32.25</c:v>
@@ -9398,7 +9430,7 @@
                   <c:v>32.75</c:v>
                 </c:pt>
                 <c:pt idx="132">
-                  <c:v>33</c:v>
+                  <c:v>33.0</c:v>
                 </c:pt>
                 <c:pt idx="133">
                   <c:v>33.25</c:v>
@@ -9410,7 +9442,7 @@
                   <c:v>33.75</c:v>
                 </c:pt>
                 <c:pt idx="136">
-                  <c:v>34</c:v>
+                  <c:v>34.0</c:v>
                 </c:pt>
                 <c:pt idx="137">
                   <c:v>34.25</c:v>
@@ -9422,7 +9454,7 @@
                   <c:v>34.75</c:v>
                 </c:pt>
                 <c:pt idx="140">
-                  <c:v>35</c:v>
+                  <c:v>35.0</c:v>
                 </c:pt>
                 <c:pt idx="141">
                   <c:v>35.25</c:v>
@@ -9434,7 +9466,7 @@
                   <c:v>35.75</c:v>
                 </c:pt>
                 <c:pt idx="144">
-                  <c:v>36</c:v>
+                  <c:v>36.0</c:v>
                 </c:pt>
                 <c:pt idx="145">
                   <c:v>36.25</c:v>
@@ -9446,7 +9478,7 @@
                   <c:v>36.75</c:v>
                 </c:pt>
                 <c:pt idx="148">
-                  <c:v>37</c:v>
+                  <c:v>37.0</c:v>
                 </c:pt>
                 <c:pt idx="149">
                   <c:v>37.25</c:v>
@@ -9458,7 +9490,7 @@
                   <c:v>37.75</c:v>
                 </c:pt>
                 <c:pt idx="152">
-                  <c:v>38</c:v>
+                  <c:v>38.0</c:v>
                 </c:pt>
                 <c:pt idx="153">
                   <c:v>38.25</c:v>
@@ -9470,7 +9502,7 @@
                   <c:v>38.75</c:v>
                 </c:pt>
                 <c:pt idx="156">
-                  <c:v>39</c:v>
+                  <c:v>39.0</c:v>
                 </c:pt>
                 <c:pt idx="157">
                   <c:v>39.25</c:v>
@@ -9482,499 +9514,499 @@
                   <c:v>39.75</c:v>
                 </c:pt>
                 <c:pt idx="160">
-                  <c:v>40</c:v>
+                  <c:v>40.0</c:v>
                 </c:pt>
               </c:numCache>
             </c:numRef>
           </c:xVal>
           <c:yVal>
             <c:numRef>
-              <c:f>'Chart Data'!$B$2:$B$162</c:f>
+              <c:f>Sheet1!$B$2:$B$162</c:f>
               <c:numCache>
                 <c:formatCode>General</c:formatCode>
                 <c:ptCount val="161"/>
                 <c:pt idx="0">
-                  <c:v>0</c:v>
+                  <c:v>0.0</c:v>
                 </c:pt>
                 <c:pt idx="1">
-                  <c:v>1.33149501</c:v>
+                  <c:v>58.54</c:v>
                 </c:pt>
                 <c:pt idx="2">
-                  <c:v>2.6547809</c:v>
+                  <c:v>116.55</c:v>
                 </c:pt>
                 <c:pt idx="3">
-                  <c:v>3.9616992</c:v>
+                  <c:v>173.53</c:v>
                 </c:pt>
                 <c:pt idx="4">
-                  <c:v>5.24419229</c:v>
+                  <c:v>228.97</c:v>
                 </c:pt>
                 <c:pt idx="5">
-                  <c:v>6.4943532</c:v>
+                  <c:v>282.38</c:v>
                 </c:pt>
                 <c:pt idx="6">
-                  <c:v>7.70447426</c:v>
+                  <c:v>333.28</c:v>
                 </c:pt>
                 <c:pt idx="7">
-                  <c:v>8.86709468</c:v>
+                  <c:v>381.23</c:v>
                 </c:pt>
                 <c:pt idx="8">
-                  <c:v>9.97504651</c:v>
+                  <c:v>425.79</c:v>
                 </c:pt>
                 <c:pt idx="9">
-                  <c:v>11.02149886</c:v>
+                  <c:v>466.57</c:v>
                 </c:pt>
                 <c:pt idx="10">
-                  <c:v>12</c:v>
+                  <c:v>503.21</c:v>
                 </c:pt>
                 <c:pt idx="11">
-                  <c:v>12.90451715</c:v>
+                  <c:v>535.38</c:v>
                 </c:pt>
                 <c:pt idx="12">
-                  <c:v>13.72947367</c:v>
+                  <c:v>562.8</c:v>
                 </c:pt>
                 <c:pt idx="13">
-                  <c:v>14.46978341</c:v>
+                  <c:v>585.23</c:v>
                 </c:pt>
                 <c:pt idx="14">
-                  <c:v>15.12088213</c:v>
+                  <c:v>602.46</c:v>
                 </c:pt>
                 <c:pt idx="15">
-                  <c:v>15.67875558</c:v>
+                  <c:v>614.34</c:v>
                 </c:pt>
                 <c:pt idx="16">
-                  <c:v>16.13996429</c:v>
+                  <c:v>620.77</c:v>
                 </c:pt>
                 <c:pt idx="17">
-                  <c:v>16.50166475</c:v>
+                  <c:v>621.69</c:v>
                 </c:pt>
                 <c:pt idx="18">
-                  <c:v>16.76162696</c:v>
+                  <c:v>617.1</c:v>
                 </c:pt>
                 <c:pt idx="19">
-                  <c:v>16.91824817</c:v>
+                  <c:v>607.02</c:v>
                 </c:pt>
                 <c:pt idx="20">
-                  <c:v>16.97056275</c:v>
+                  <c:v>591.56</c:v>
                 </c:pt>
                 <c:pt idx="21">
-                  <c:v>16.91824817</c:v>
+                  <c:v>570.84</c:v>
                 </c:pt>
                 <c:pt idx="22">
-                  <c:v>16.76162696</c:v>
+                  <c:v>545.06</c:v>
                 </c:pt>
                 <c:pt idx="23">
-                  <c:v>16.50166475</c:v>
+                  <c:v>514.44</c:v>
                 </c:pt>
                 <c:pt idx="24">
-                  <c:v>16.13996429</c:v>
+                  <c:v>479.26</c:v>
                 </c:pt>
                 <c:pt idx="25">
-                  <c:v>15.67875558</c:v>
+                  <c:v>439.82</c:v>
                 </c:pt>
                 <c:pt idx="26">
-                  <c:v>15.12088213</c:v>
+                  <c:v>396.48</c:v>
                 </c:pt>
                 <c:pt idx="27">
-                  <c:v>14.46978341</c:v>
+                  <c:v>349.62</c:v>
                 </c:pt>
                 <c:pt idx="28">
-                  <c:v>13.72947367</c:v>
+                  <c:v>299.65</c:v>
                 </c:pt>
                 <c:pt idx="29">
-                  <c:v>12.90451715</c:v>
+                  <c:v>247.03</c:v>
                 </c:pt>
                 <c:pt idx="30">
-                  <c:v>12</c:v>
+                  <c:v>192.21</c:v>
                 </c:pt>
                 <c:pt idx="31">
-                  <c:v>11.02149886</c:v>
+                  <c:v>135.69</c:v>
                 </c:pt>
                 <c:pt idx="32">
-                  <c:v>9.97504651</c:v>
+                  <c:v>77.96</c:v>
                 </c:pt>
                 <c:pt idx="33">
-                  <c:v>8.86709468</c:v>
+                  <c:v>19.54</c:v>
                 </c:pt>
                 <c:pt idx="34">
-                  <c:v>7.70447426</c:v>
+                  <c:v>-39.06</c:v>
                 </c:pt>
                 <c:pt idx="35">
-                  <c:v>6.4943532</c:v>
+                  <c:v>-97.3</c:v>
                 </c:pt>
                 <c:pt idx="36">
-                  <c:v>5.24419229</c:v>
+                  <c:v>-154.69</c:v>
                 </c:pt>
                 <c:pt idx="37">
-                  <c:v>3.9616992</c:v>
+                  <c:v>-210.69</c:v>
                 </c:pt>
                 <c:pt idx="38">
-                  <c:v>2.6547809</c:v>
+                  <c:v>-264.83</c:v>
                 </c:pt>
                 <c:pt idx="39">
-                  <c:v>1.33149501</c:v>
+                  <c:v>-316.62</c:v>
                 </c:pt>
                 <c:pt idx="40">
-                  <c:v>0</c:v>
+                  <c:v>-365.6</c:v>
                 </c:pt>
                 <c:pt idx="41">
-                  <c:v>-1.33149501</c:v>
+                  <c:v>-411.34</c:v>
                 </c:pt>
                 <c:pt idx="42">
-                  <c:v>-2.6547809</c:v>
+                  <c:v>-453.42</c:v>
                 </c:pt>
                 <c:pt idx="43">
-                  <c:v>-3.9616992</c:v>
+                  <c:v>-491.48</c:v>
                 </c:pt>
                 <c:pt idx="44">
-                  <c:v>-5.24419229</c:v>
+                  <c:v>-525.17</c:v>
                 </c:pt>
                 <c:pt idx="45">
-                  <c:v>-6.4943532</c:v>
+                  <c:v>-554.21</c:v>
                 </c:pt>
                 <c:pt idx="46">
-                  <c:v>-7.70447426</c:v>
+                  <c:v>-578.32</c:v>
                 </c:pt>
                 <c:pt idx="47">
-                  <c:v>-8.86709468</c:v>
+                  <c:v>-597.3</c:v>
                 </c:pt>
                 <c:pt idx="48">
-                  <c:v>-9.97504651</c:v>
+                  <c:v>-610.98</c:v>
                 </c:pt>
                 <c:pt idx="49">
-                  <c:v>-11.02149886</c:v>
+                  <c:v>-619.24</c:v>
                 </c:pt>
                 <c:pt idx="50">
-                  <c:v>-12</c:v>
+                  <c:v>-622.0</c:v>
                 </c:pt>
                 <c:pt idx="51">
-                  <c:v>-12.90451715</c:v>
+                  <c:v>-619.24</c:v>
                 </c:pt>
                 <c:pt idx="52">
-                  <c:v>-13.72947367</c:v>
+                  <c:v>-610.98</c:v>
                 </c:pt>
                 <c:pt idx="53">
-                  <c:v>-14.46978341</c:v>
+                  <c:v>-597.3</c:v>
                 </c:pt>
                 <c:pt idx="54">
-                  <c:v>-15.12088213</c:v>
+                  <c:v>-578.32</c:v>
                 </c:pt>
                 <c:pt idx="55">
-                  <c:v>-15.67875558</c:v>
+                  <c:v>-554.21</c:v>
                 </c:pt>
                 <c:pt idx="56">
-                  <c:v>-16.13996429</c:v>
+                  <c:v>-525.17</c:v>
                 </c:pt>
                 <c:pt idx="57">
-                  <c:v>-16.50166475</c:v>
+                  <c:v>-491.48</c:v>
                 </c:pt>
                 <c:pt idx="58">
-                  <c:v>-16.76162696</c:v>
+                  <c:v>-453.42</c:v>
                 </c:pt>
                 <c:pt idx="59">
-                  <c:v>-16.91824817</c:v>
+                  <c:v>-411.34</c:v>
                 </c:pt>
                 <c:pt idx="60">
-                  <c:v>-16.97056275</c:v>
+                  <c:v>-365.6</c:v>
                 </c:pt>
                 <c:pt idx="61">
-                  <c:v>-16.91824817</c:v>
+                  <c:v>-316.62</c:v>
                 </c:pt>
                 <c:pt idx="62">
-                  <c:v>-16.76162696</c:v>
+                  <c:v>-264.83</c:v>
                 </c:pt>
                 <c:pt idx="63">
-                  <c:v>-16.50166475</c:v>
+                  <c:v>-210.69</c:v>
                 </c:pt>
                 <c:pt idx="64">
-                  <c:v>-16.13996429</c:v>
+                  <c:v>-154.69</c:v>
                 </c:pt>
                 <c:pt idx="65">
-                  <c:v>-15.67875558</c:v>
+                  <c:v>-97.3</c:v>
                 </c:pt>
                 <c:pt idx="66">
-                  <c:v>-15.12088213</c:v>
+                  <c:v>-39.06</c:v>
                 </c:pt>
                 <c:pt idx="67">
-                  <c:v>-14.46978341</c:v>
+                  <c:v>19.54</c:v>
                 </c:pt>
                 <c:pt idx="68">
-                  <c:v>-13.72947367</c:v>
+                  <c:v>77.96</c:v>
                 </c:pt>
                 <c:pt idx="69">
-                  <c:v>-12.90451715</c:v>
+                  <c:v>135.69</c:v>
                 </c:pt>
                 <c:pt idx="70">
-                  <c:v>-12</c:v>
+                  <c:v>192.21</c:v>
                 </c:pt>
                 <c:pt idx="71">
-                  <c:v>-11.02149886</c:v>
+                  <c:v>247.03</c:v>
                 </c:pt>
                 <c:pt idx="72">
-                  <c:v>-9.97504651</c:v>
+                  <c:v>299.65</c:v>
                 </c:pt>
                 <c:pt idx="73">
-                  <c:v>-8.86709468</c:v>
+                  <c:v>349.62</c:v>
                 </c:pt>
                 <c:pt idx="74">
-                  <c:v>-7.70447426</c:v>
+                  <c:v>396.48</c:v>
                 </c:pt>
                 <c:pt idx="75">
-                  <c:v>-6.4943532</c:v>
+                  <c:v>439.82</c:v>
                 </c:pt>
                 <c:pt idx="76">
-                  <c:v>-5.24419229</c:v>
+                  <c:v>479.26</c:v>
                 </c:pt>
                 <c:pt idx="77">
-                  <c:v>-3.9616992</c:v>
+                  <c:v>514.44</c:v>
                 </c:pt>
                 <c:pt idx="78">
-                  <c:v>-2.6547809</c:v>
+                  <c:v>545.06</c:v>
                 </c:pt>
                 <c:pt idx="79">
-                  <c:v>-1.33149501</c:v>
+                  <c:v>570.84</c:v>
                 </c:pt>
                 <c:pt idx="80">
-                  <c:v>-0</c:v>
+                  <c:v>591.56</c:v>
                 </c:pt>
                 <c:pt idx="81">
-                  <c:v>1.33149501</c:v>
+                  <c:v>607.02</c:v>
                 </c:pt>
                 <c:pt idx="82">
-                  <c:v>2.6547809</c:v>
+                  <c:v>617.1</c:v>
                 </c:pt>
                 <c:pt idx="83">
-                  <c:v>3.9616992</c:v>
+                  <c:v>621.69</c:v>
                 </c:pt>
                 <c:pt idx="84">
-                  <c:v>5.24419229</c:v>
+                  <c:v>620.77</c:v>
                 </c:pt>
                 <c:pt idx="85">
-                  <c:v>6.4943532</c:v>
+                  <c:v>614.34</c:v>
                 </c:pt>
                 <c:pt idx="86">
-                  <c:v>7.70447426</c:v>
+                  <c:v>602.46</c:v>
                 </c:pt>
                 <c:pt idx="87">
-                  <c:v>8.86709468</c:v>
+                  <c:v>585.23</c:v>
                 </c:pt>
                 <c:pt idx="88">
-                  <c:v>9.97504651</c:v>
+                  <c:v>562.8</c:v>
                 </c:pt>
                 <c:pt idx="89">
-                  <c:v>11.02149886</c:v>
+                  <c:v>535.38</c:v>
                 </c:pt>
                 <c:pt idx="90">
-                  <c:v>12</c:v>
+                  <c:v>503.21</c:v>
                 </c:pt>
                 <c:pt idx="91">
-                  <c:v>12.90451715</c:v>
+                  <c:v>466.57</c:v>
                 </c:pt>
                 <c:pt idx="92">
-                  <c:v>13.72947367</c:v>
+                  <c:v>425.79</c:v>
                 </c:pt>
                 <c:pt idx="93">
-                  <c:v>14.46978341</c:v>
+                  <c:v>381.23</c:v>
                 </c:pt>
                 <c:pt idx="94">
-                  <c:v>15.12088213</c:v>
+                  <c:v>333.28</c:v>
                 </c:pt>
                 <c:pt idx="95">
-                  <c:v>15.67875558</c:v>
+                  <c:v>282.38</c:v>
                 </c:pt>
                 <c:pt idx="96">
-                  <c:v>16.13996429</c:v>
+                  <c:v>228.97</c:v>
                 </c:pt>
                 <c:pt idx="97">
-                  <c:v>16.50166475</c:v>
+                  <c:v>173.53</c:v>
                 </c:pt>
                 <c:pt idx="98">
-                  <c:v>16.76162696</c:v>
+                  <c:v>116.55</c:v>
                 </c:pt>
                 <c:pt idx="99">
-                  <c:v>16.91824817</c:v>
+                  <c:v>58.54</c:v>
                 </c:pt>
                 <c:pt idx="100">
-                  <c:v>16.97056275</c:v>
+                  <c:v>0.0</c:v>
                 </c:pt>
                 <c:pt idx="101">
-                  <c:v>16.91824817</c:v>
+                  <c:v>-58.54</c:v>
                 </c:pt>
                 <c:pt idx="102">
-                  <c:v>16.76162696</c:v>
+                  <c:v>-116.55</c:v>
                 </c:pt>
                 <c:pt idx="103">
-                  <c:v>16.50166475</c:v>
+                  <c:v>-173.53</c:v>
                 </c:pt>
                 <c:pt idx="104">
-                  <c:v>16.13996429</c:v>
+                  <c:v>-228.97</c:v>
                 </c:pt>
                 <c:pt idx="105">
-                  <c:v>15.67875558</c:v>
+                  <c:v>-282.38</c:v>
                 </c:pt>
                 <c:pt idx="106">
-                  <c:v>15.12088213</c:v>
+                  <c:v>-333.28</c:v>
                 </c:pt>
                 <c:pt idx="107">
-                  <c:v>14.46978341</c:v>
+                  <c:v>-381.23</c:v>
                 </c:pt>
                 <c:pt idx="108">
-                  <c:v>13.72947367</c:v>
+                  <c:v>-425.79</c:v>
                 </c:pt>
                 <c:pt idx="109">
-                  <c:v>12.90451715</c:v>
+                  <c:v>-466.57</c:v>
                 </c:pt>
                 <c:pt idx="110">
-                  <c:v>12</c:v>
+                  <c:v>-503.21</c:v>
                 </c:pt>
                 <c:pt idx="111">
-                  <c:v>11.02149886</c:v>
+                  <c:v>-535.38</c:v>
                 </c:pt>
                 <c:pt idx="112">
-                  <c:v>9.97504651</c:v>
+                  <c:v>-562.8</c:v>
                 </c:pt>
                 <c:pt idx="113">
-                  <c:v>8.86709468</c:v>
+                  <c:v>-585.23</c:v>
                 </c:pt>
                 <c:pt idx="114">
-                  <c:v>7.70447426</c:v>
+                  <c:v>-602.46</c:v>
                 </c:pt>
                 <c:pt idx="115">
-                  <c:v>6.4943532</c:v>
+                  <c:v>-614.34</c:v>
                 </c:pt>
                 <c:pt idx="116">
-                  <c:v>5.24419229</c:v>
+                  <c:v>-620.77</c:v>
                 </c:pt>
                 <c:pt idx="117">
-                  <c:v>3.9616992</c:v>
+                  <c:v>-621.69</c:v>
                 </c:pt>
                 <c:pt idx="118">
-                  <c:v>2.6547809</c:v>
+                  <c:v>-617.1</c:v>
                 </c:pt>
                 <c:pt idx="119">
-                  <c:v>1.33149501</c:v>
+                  <c:v>-607.02</c:v>
                 </c:pt>
                 <c:pt idx="120">
-                  <c:v>0</c:v>
+                  <c:v>-591.56</c:v>
                 </c:pt>
                 <c:pt idx="121">
-                  <c:v>-1.33149501</c:v>
+                  <c:v>-570.84</c:v>
                 </c:pt>
                 <c:pt idx="122">
-                  <c:v>-2.6547809</c:v>
+                  <c:v>-545.06</c:v>
                 </c:pt>
                 <c:pt idx="123">
-                  <c:v>-3.9616992</c:v>
+                  <c:v>-514.44</c:v>
                 </c:pt>
                 <c:pt idx="124">
-                  <c:v>-5.24419229</c:v>
+                  <c:v>-479.26</c:v>
                 </c:pt>
                 <c:pt idx="125">
-                  <c:v>-6.4943532</c:v>
+                  <c:v>-439.82</c:v>
                 </c:pt>
                 <c:pt idx="126">
-                  <c:v>-7.70447426</c:v>
+                  <c:v>-396.48</c:v>
                 </c:pt>
                 <c:pt idx="127">
-                  <c:v>-8.86709468</c:v>
+                  <c:v>-349.62</c:v>
                 </c:pt>
                 <c:pt idx="128">
-                  <c:v>-9.97504651</c:v>
+                  <c:v>-299.65</c:v>
                 </c:pt>
                 <c:pt idx="129">
-                  <c:v>-11.02149886</c:v>
+                  <c:v>-247.03</c:v>
                 </c:pt>
                 <c:pt idx="130">
-                  <c:v>-12</c:v>
+                  <c:v>-192.21</c:v>
                 </c:pt>
                 <c:pt idx="131">
-                  <c:v>-12.90451715</c:v>
+                  <c:v>-135.69</c:v>
                 </c:pt>
                 <c:pt idx="132">
-                  <c:v>-13.72947367</c:v>
+                  <c:v>-77.96</c:v>
                 </c:pt>
                 <c:pt idx="133">
-                  <c:v>-14.46978341</c:v>
+                  <c:v>-19.54</c:v>
                 </c:pt>
                 <c:pt idx="134">
-                  <c:v>-15.12088213</c:v>
+                  <c:v>39.06</c:v>
                 </c:pt>
                 <c:pt idx="135">
-                  <c:v>-15.67875558</c:v>
+                  <c:v>97.3</c:v>
                 </c:pt>
                 <c:pt idx="136">
-                  <c:v>-16.13996429</c:v>
+                  <c:v>154.69</c:v>
                 </c:pt>
                 <c:pt idx="137">
-                  <c:v>-16.50166475</c:v>
+                  <c:v>210.69</c:v>
                 </c:pt>
                 <c:pt idx="138">
-                  <c:v>-16.76162696</c:v>
+                  <c:v>264.83</c:v>
                 </c:pt>
                 <c:pt idx="139">
-                  <c:v>-16.91824817</c:v>
+                  <c:v>316.62</c:v>
                 </c:pt>
                 <c:pt idx="140">
-                  <c:v>-16.97056275</c:v>
+                  <c:v>365.6</c:v>
                 </c:pt>
                 <c:pt idx="141">
-                  <c:v>-16.91824817</c:v>
+                  <c:v>411.34</c:v>
                 </c:pt>
                 <c:pt idx="142">
-                  <c:v>-16.76162696</c:v>
+                  <c:v>453.42</c:v>
                 </c:pt>
                 <c:pt idx="143">
-                  <c:v>-16.50166475</c:v>
+                  <c:v>491.48</c:v>
                 </c:pt>
                 <c:pt idx="144">
-                  <c:v>-16.13996429</c:v>
+                  <c:v>525.17</c:v>
                 </c:pt>
                 <c:pt idx="145">
-                  <c:v>-15.67875558</c:v>
+                  <c:v>554.21</c:v>
                 </c:pt>
                 <c:pt idx="146">
-                  <c:v>-15.12088213</c:v>
+                  <c:v>578.32</c:v>
                 </c:pt>
                 <c:pt idx="147">
-                  <c:v>-14.46978341</c:v>
+                  <c:v>597.3</c:v>
                 </c:pt>
                 <c:pt idx="148">
-                  <c:v>-13.72947367</c:v>
+                  <c:v>610.98</c:v>
                 </c:pt>
                 <c:pt idx="149">
-                  <c:v>-12.90451715</c:v>
+                  <c:v>619.24</c:v>
                 </c:pt>
                 <c:pt idx="150">
-                  <c:v>-12</c:v>
+                  <c:v>622.0</c:v>
                 </c:pt>
                 <c:pt idx="151">
-                  <c:v>-11.02149886</c:v>
+                  <c:v>619.24</c:v>
                 </c:pt>
                 <c:pt idx="152">
-                  <c:v>-9.97504651</c:v>
+                  <c:v>610.98</c:v>
                 </c:pt>
                 <c:pt idx="153">
-                  <c:v>-8.86709468</c:v>
+                  <c:v>597.3</c:v>
                 </c:pt>
                 <c:pt idx="154">
-                  <c:v>-7.70447426</c:v>
+                  <c:v>578.32</c:v>
                 </c:pt>
                 <c:pt idx="155">
-                  <c:v>-6.4943532</c:v>
+                  <c:v>554.21</c:v>
                 </c:pt>
                 <c:pt idx="156">
-                  <c:v>-5.24419229</c:v>
+                  <c:v>525.17</c:v>
                 </c:pt>
                 <c:pt idx="157">
-                  <c:v>-3.9616992</c:v>
+                  <c:v>491.48</c:v>
                 </c:pt>
                 <c:pt idx="158">
-                  <c:v>-2.6547809</c:v>
+                  <c:v>453.42</c:v>
                 </c:pt>
                 <c:pt idx="159">
-                  <c:v>-1.33149501</c:v>
+                  <c:v>411.34</c:v>
                 </c:pt>
                 <c:pt idx="160">
-                  <c:v>-0</c:v>
+                  <c:v>365.6</c:v>
                 </c:pt>
               </c:numCache>
             </c:numRef>
@@ -10009,8 +10041,8 @@
         <c:axId val="48672768"/>
         <c:scaling>
           <c:orientation val="minMax"/>
-          <c:max val="20"/>
-          <c:min val="-20"/>
+          <c:max val="700"/>
+          <c:min val="-700"/>
         </c:scaling>
         <c:delete val="0"/>
         <c:axPos val="l"/>
@@ -10083,7 +10115,7 @@
           </a:p>
         </c:txPr>
         <c:crossAx val="48650112"/>
-        <c:majorUnit val="10"/>
+        <c:majorUnit val="350"/>
       </c:valAx>
       <c:valAx>
         <c:axId val="48650112"/>
@@ -10287,6 +10319,10 @@
             <a:noFill/>
           </a:ln>
         </p:spPr>
+        <p:txBody xmlns:a="http://schemas.openxmlformats.org/drawingml/2006/main">
+          <a:bodyPr/>
+          <a:p/>
+        </p:txBody>
       </p:sp>
       <p:sp>
         <p:nvSpPr>
@@ -10689,7 +10725,7 @@
                 <a:ea typeface="Calibri"/>
                 <a:cs typeface="Calibri"/>
               </a:rPr>
-              <a:t>För vår källa: vanligt medelvärde 0 V, RMS 12,00 V och topp 16,97 V.</a:t>
+              <a:t>För 440 V-nätet ombord: vanligt medelvärde 0 V, RMS 440 V och topp 622 V.</a:t>
             </a:r>
           </a:p>
         </p:txBody>
@@ -11385,7 +11421,7 @@
                 <a:ea typeface="Calibri"/>
                 <a:cs typeface="Calibri"/>
               </a:rPr>
-              <a:t>Exempel: U = 10 V RMS, f = 50 Hz, t = 3 ms = 0,003 s.</a:t>
+              <a:t>Exempel, fartygets 440 V-nät: U = 440 V RMS, f = 60 Hz, t = 2,0 ms = 0,002 s.</a:t>
             </a:r>
           </a:p>
           <a:p xmlns:a="http://schemas.openxmlformats.org/drawingml/2006/main">
@@ -11420,7 +11456,7 @@
                 <a:ea typeface="Calibri"/>
                 <a:cs typeface="Calibri"/>
               </a:rPr>
-              <a:t>û = 10√2 ≈ 14,14 V. Vinkeln 2πft ≈ 0,9425 rad (radianer; 2π radianer är ett helt varv, 360°).</a:t>
+              <a:t>û = 440√2 ≈ 622 V. Vinkeln 2πft ≈ 0,754 rad (radianer; 2π radianer är ett helt varv, 360°).</a:t>
             </a:r>
           </a:p>
           <a:p xmlns:a="http://schemas.openxmlformats.org/drawingml/2006/main">
@@ -11455,7 +11491,7 @@
                 <a:ea typeface="Calibri"/>
                 <a:cs typeface="Calibri"/>
               </a:rPr>
-              <a:t>u = 14,14 · sin(0,9425) ≈ 11,44 V. Räknaren ska stå i RAD (radianer), inte DEG (grader).</a:t>
+              <a:t>u = 622 · sin(0,754) ≈ 426 V. Räknaren ska stå i RAD (radianer), inte DEG (grader).</a:t>
             </a:r>
           </a:p>
         </p:txBody>
@@ -11821,7 +11857,7 @@
                 <a:ea typeface="Calibri"/>
                 <a:cs typeface="Calibri"/>
               </a:rPr>
-              <a:t>Vid 50 Hz är T = 20 ms. Ett tidsavstånd på 2,5 ms ger 360 · 2,5/20 = 45°.</a:t>
+              <a:t>Ombord, vid 60 Hz, är T ≈ 16,7 ms. Ett tidsavstånd på 2,5 ms ger 360 · 2,5/16,67 ≈ 54°.</a:t>
             </a:r>
           </a:p>
           <a:p xmlns:a="http://schemas.openxmlformats.org/drawingml/2006/main">
@@ -12645,7 +12681,7 @@
                 <a:ea typeface="Calibri"/>
                 <a:cs typeface="Calibri"/>
               </a:rPr>
-              <a:t>12,00 V</a:t>
+              <a:t>10,00 V</a:t>
             </a:r>
           </a:p>
         </p:txBody>
@@ -12759,7 +12795,7 @@
                 <a:ea typeface="Calibri"/>
                 <a:cs typeface="Calibri"/>
               </a:rPr>
-              <a:t>13,33 V</a:t>
+              <a:t>11,11 V</a:t>
             </a:r>
           </a:p>
         </p:txBody>
@@ -12873,7 +12909,7 @@
                 <a:ea typeface="Calibri"/>
                 <a:cs typeface="Calibri"/>
               </a:rPr>
-              <a:t>11,54 V</a:t>
+              <a:t>9,62 V</a:t>
             </a:r>
           </a:p>
         </p:txBody>
@@ -12930,7 +12966,7 @@
                 <a:ea typeface="Calibri"/>
                 <a:cs typeface="Calibri"/>
               </a:rPr>
-              <a:t>Alla tre signalerna har effektivvärdet 12,00 V och ingen likspänningsdel (DC-innehåll).</a:t>
+              <a:t>Alla tre signalerna har effektivvärdet 10,00 V och ingen likspänningsdel (DC-innehåll).</a:t>
             </a:r>
           </a:p>
           <a:p xmlns:a="http://schemas.openxmlformats.org/drawingml/2006/main">
@@ -12965,7 +13001,7 @@
                 <a:ea typeface="Calibri"/>
                 <a:cs typeface="Calibri"/>
               </a:rPr>
-              <a:t>Sinus: topp 16,97 V. Den sinuskalibrerade mätaren visar 12,00 V.</a:t>
+              <a:t>Sinus: topp 14,14 V. Den sinuskalibrerade mätaren visar 10,00 V.</a:t>
             </a:r>
           </a:p>
           <a:p xmlns:a="http://schemas.openxmlformats.org/drawingml/2006/main">
@@ -13000,7 +13036,7 @@
                 <a:ea typeface="Calibri"/>
                 <a:cs typeface="Calibri"/>
               </a:rPr>
-              <a:t>Fyrkant: topp 12,00 V. Medel(|u|) = 12,00 V. Visning ≈ 13,33 V.</a:t>
+              <a:t>Fyrkant: topp 10,00 V. Medel(|u|) = 10,00 V. Visning ≈ 11,11 V.</a:t>
             </a:r>
           </a:p>
           <a:p xmlns:a="http://schemas.openxmlformats.org/drawingml/2006/main">
@@ -13035,7 +13071,7 @@
                 <a:ea typeface="Calibri"/>
                 <a:cs typeface="Calibri"/>
               </a:rPr>
-              <a:t>Triangel: topp = √3 · 12 ≈ 20,78 V. Medel(|u|) = û/2. Visning ≈ 11,54 V.</a:t>
+              <a:t>Triangel: topp = √3 · 10 ≈ 17,32 V. Medel(|u|) = û/2. Visning ≈ 9,62 V.</a:t>
             </a:r>
           </a:p>
         </p:txBody>
@@ -14717,7 +14753,7 @@
                 <a:ea typeface="Calibri"/>
                 <a:cs typeface="Calibri"/>
               </a:rPr>
-              <a:t>En hel period: 0 till 20 ms</a:t>
+              <a:t>En hel period vid 60 Hz: 16,7 ms</a:t>
             </a:r>
           </a:p>
         </p:txBody>
@@ -14809,7 +14845,7 @@
                 <a:ea typeface="Calibri"/>
                 <a:cs typeface="Calibri"/>
               </a:rPr>
-              <a:t>Periodtiden T är tiden för en hel period. Vid 50 Hz: T = 1/50 = 0,020 s = 20,00 ms (millisekunder, tusendels sekunder).</a:t>
+              <a:t>Periodtiden T är tiden för en hel period. Ombord är frekvensen 60 Hz: T = 1/60 ≈ 0,0167 s = 16,7 ms (millisekunder, tusendels sekunder).</a:t>
             </a:r>
           </a:p>
           <a:p xmlns:a="http://schemas.openxmlformats.org/drawingml/2006/main">
@@ -14844,7 +14880,7 @@
                 <a:ea typeface="Calibri"/>
                 <a:cs typeface="Calibri"/>
               </a:rPr>
-              <a:t>På kurvan är avståndet mellan motsvarande punkter 20 ms.</a:t>
+              <a:t>På kurvan är avståndet mellan motsvarande punkter 16,7 ms.</a:t>
             </a:r>
           </a:p>
         </p:txBody>
@@ -15191,7 +15227,7 @@
                 <a:ea typeface="Calibri"/>
                 <a:cs typeface="Calibri"/>
               </a:rPr>
-              <a:t>Topp från noll: 16,97 V</a:t>
+              <a:t>Topp från noll: 622 V</a:t>
             </a:r>
           </a:p>
         </p:txBody>
@@ -15340,7 +15376,7 @@
                 <a:ea typeface="Calibri"/>
                 <a:cs typeface="Calibri"/>
               </a:rPr>
-              <a:t>För vår sinus: û ≈ 16,97 V och U</a:t>
+              <a:t>Exempel, 440 V-nätet ombord: û ≈ 622 V och U</a:t>
             </a:r>
             <a:r>
               <a:rPr sz="1650" b="0" baseline="-25000">
@@ -15362,7 +15398,7 @@
                 <a:ea typeface="Calibri"/>
                 <a:cs typeface="Calibri"/>
               </a:rPr>
-              <a:t> ≈ 33,94 V.</a:t>
+              <a:t> = 2 · û ≈ 1 245 V.</a:t>
             </a:r>
           </a:p>
         </p:txBody>
@@ -15772,7 +15808,7 @@
                 <a:ea typeface="Calibri"/>
                 <a:cs typeface="Calibri"/>
               </a:rPr>
-              <a:t>12,00 V</a:t>
+              <a:t>440 V</a:t>
             </a:r>
           </a:p>
         </p:txBody>
@@ -15886,7 +15922,7 @@
                 <a:ea typeface="Calibri"/>
                 <a:cs typeface="Calibri"/>
               </a:rPr>
-              <a:t>16,97 V</a:t>
+              <a:t>622 V</a:t>
             </a:r>
           </a:p>
         </p:txBody>
@@ -15943,7 +15979,7 @@
                 <a:ea typeface="Calibri"/>
                 <a:cs typeface="Calibri"/>
               </a:rPr>
-              <a:t>Effektivvärdet 12,00 V över en resistor ger samma medeleffekt (värme) som 12,00 V likspänning (DC) över samma resistor.</a:t>
+              <a:t>Effektivvärdet 230 V i vägguttaget värmer en vattenkokare lika mycket som 230 V likspänning (DC).</a:t>
             </a:r>
           </a:p>
           <a:p xmlns:a="http://schemas.openxmlformats.org/drawingml/2006/main">
@@ -15978,7 +16014,7 @@
                 <a:ea typeface="Calibri"/>
                 <a:cs typeface="Calibri"/>
               </a:rPr>
-              <a:t>Effektivvärdet förkortas RMS (root mean square, engelska för kvadratiskt medelvärde). U utan index betyder alltid effektivvärdet. Multimetern i växelspänningsläget (AC eller V~) visar här 12,00 V.</a:t>
+              <a:t>Effektivvärdet förkortas RMS (root mean square, engelska för kvadratiskt medelvärde). U utan index betyder alltid effektivvärdet. Multimetern i växelspänningsläget (AC eller V~) visar 230 V i vägguttaget och 440 V ombord.</a:t>
             </a:r>
           </a:p>
           <a:p xmlns:a="http://schemas.openxmlformats.org/drawingml/2006/main">
@@ -16013,7 +16049,7 @@
                 <a:ea typeface="Calibri"/>
                 <a:cs typeface="Calibri"/>
               </a:rPr>
-              <a:t>Sinusens topp är högre eftersom spänningen bara når toppen under en kort del av perioden.</a:t>
+              <a:t>Toppen är högre eftersom spänningen bara når toppen en kort stund.</a:t>
             </a:r>
           </a:p>
         </p:txBody>
@@ -16070,7 +16106,7 @@
                 <a:ea typeface="Calibri"/>
                 <a:cs typeface="Calibri"/>
               </a:rPr>
-              <a:t>û = √2 · U = √2 · 12,00 ≈ 16,97 V</a:t>
+              <a:t>û = √2 · U = √2 · 440 ≈ 622 V</a:t>
             </a:r>
           </a:p>
         </p:txBody>
@@ -16344,7 +16380,7 @@
                 <a:ea typeface="Calibri"/>
                 <a:cs typeface="Calibri"/>
               </a:rPr>
-              <a:t>Givet: sinus, U = 10,00 V RMS och f = 50 Hz.</a:t>
+              <a:t>Givet: fartygets huvudnät, U = 440 V RMS och f = 60 Hz.</a:t>
             </a:r>
           </a:p>
           <a:p xmlns:a="http://schemas.openxmlformats.org/drawingml/2006/main">
@@ -16372,7 +16408,7 @@
                 <a:ea typeface="Calibri"/>
                 <a:cs typeface="Calibri"/>
               </a:rPr>
-              <a:t>Period: T = 1 000/50 = 20,00 ms.</a:t>
+              <a:t>Period: T = 1 000/60 ≈ 16,7 ms.</a:t>
             </a:r>
           </a:p>
           <a:p xmlns:a="http://schemas.openxmlformats.org/drawingml/2006/main">
@@ -16400,7 +16436,7 @@
                 <a:ea typeface="Calibri"/>
                 <a:cs typeface="Calibri"/>
               </a:rPr>
-              <a:t>Topp: û = 10,00 · √2 ≈ 14,14 V. Topp till topp: 28,28 V.</a:t>
+              <a:t>Topp: û = 440 · √2 ≈ 622 V. Topp till topp: ≈ 1 245 V.</a:t>
             </a:r>
           </a:p>
           <a:p xmlns:a="http://schemas.openxmlformats.org/drawingml/2006/main">
@@ -16428,7 +16464,7 @@
                 <a:ea typeface="Calibri"/>
                 <a:cs typeface="Calibri"/>
               </a:rPr>
-              <a:t>Pröva sedan själv med 12,00 V RMS. Skriv förväntat värde före avläsningen.</a:t>
+              <a:t>Räkna sedan själv med labbens källa. Skriv förväntat värde före avläsningen.</a:t>
             </a:r>
           </a:p>
         </p:txBody>
@@ -16759,7 +16795,7 @@
                 <a:ea typeface="Calibri"/>
                 <a:cs typeface="Calibri"/>
               </a:rPr>
-              <a:t>10,00 V</a:t>
+              <a:t>= U</a:t>
             </a:r>
           </a:p>
         </p:txBody>
@@ -16873,7 +16909,7 @@
                 <a:ea typeface="Calibri"/>
                 <a:cs typeface="Calibri"/>
               </a:rPr>
-              <a:t>10,00 V</a:t>
+              <a:t>= U</a:t>
             </a:r>
           </a:p>
         </p:txBody>
@@ -17000,7 +17036,7 @@
                 <a:ea typeface="Calibri"/>
                 <a:cs typeface="Calibri"/>
               </a:rPr>
-              <a:t>Båda visar 10,00 V för denna ideala sinus. Kontrollen dokumenteras för båda instrumenten.</a:t>
+              <a:t>För en ren sinus visar båda mätartyperna kalibratorns effektivvärde. Skillnaden syns först vid andra kurvformer. Kontrollen dokumenteras för båda instrumenten.</a:t>
             </a:r>
           </a:p>
         </p:txBody>
@@ -17274,7 +17310,7 @@
                 <a:ea typeface="Calibri"/>
                 <a:cs typeface="Calibri"/>
               </a:rPr>
-              <a:t>Förutsäg periodtiden vid 50 Hz: 20,00 ms.</a:t>
+              <a:t>Exempel från fartyget, 60 Hz. Förutsäg: T = 1 000/60 ≈ 16,7 ms.</a:t>
             </a:r>
           </a:p>
           <a:p xmlns:a="http://schemas.openxmlformats.org/drawingml/2006/main">
@@ -17302,7 +17338,7 @@
                 <a:ea typeface="Calibri"/>
                 <a:cs typeface="Calibri"/>
               </a:rPr>
-              <a:t>Läs av simulatorn och registrera 20,00 ms.</a:t>
+              <a:t>Läs av och registrera 16,7 ms.</a:t>
             </a:r>
           </a:p>
           <a:p xmlns:a="http://schemas.openxmlformats.org/drawingml/2006/main">
@@ -17330,7 +17366,7 @@
                 <a:ea typeface="Calibri"/>
                 <a:cs typeface="Calibri"/>
               </a:rPr>
-              <a:t>Jämför: avläst − förväntat = 0,00 ms.</a:t>
+              <a:t>Jämför: avläst − förväntat = 0,0 ms.</a:t>
             </a:r>
           </a:p>
           <a:p xmlns:a="http://schemas.openxmlformats.org/drawingml/2006/main">
@@ -17358,7 +17394,7 @@
                 <a:ea typeface="Calibri"/>
                 <a:cs typeface="Calibri"/>
               </a:rPr>
-              <a:t>Förklara: en hel period tar 20 ms. Frekvensen är 50 perioder per sekund.</a:t>
+              <a:t>Förklara: en hel period tar 16,7 ms. Frekvensen är 60 perioder per sekund. I labben gör du samma sak vid 50 Hz.</a:t>
             </a:r>
           </a:p>
         </p:txBody>

</xml_diff>

<commit_message>
Sjöskolan v40: eget försök utan övningarnas svar, upplägg måndag–fredag, bildtexter i boken
- Genomgångens ”Eget försök” gav svaren på EL-000075, EL-000064 och EL-000319; nya värden.
- Lärarstöd och utbildningsguide: måndag, tisdag, fredag 2 × 45 min, labben sist.
- Boken: index i bildtexter nedsänkta (X_{L}, Z_{s}), alt-text uppläsbar.

Co-Authored-By: Claude Opus 5.5 <noreply@anthropic.com>
Claude-Session: https://claude.ai/code/session_011V9KjBb53XrDm23Dw58SH3
</commit_message>
<xml_diff>
--- a/sjoskolan/vecka-40/aktuell/v40_01_Sinusformad_vaxelspanning_elev.pptx
+++ b/sjoskolan/vecka-40/aktuell/v40_01_Sinusformad_vaxelspanning_elev.pptx
@@ -650,7 +650,7 @@
           </a:p>
           <a:p xmlns:a="http://schemas.openxmlformats.org/drawingml/2006/main">
             <a:r>
-              <a:t>Facit: T = 10,00 ms. û ≈ 33,94 V. Multimetern visar 24,00 V.</a:t>
+              <a:t>Facit: T ≈ 8,33 ms. û ≈ 67,88 V. Multimetern visar 48,00 V.</a:t>
             </a:r>
           </a:p>
           <a:p xmlns:a="http://schemas.openxmlformats.org/drawingml/2006/main">
@@ -10999,12 +10999,7 @@
                 <a:ea typeface="Calibri"/>
                 <a:cs typeface="Calibri"/>
               </a:rPr>
-              <a:t>En sinus har U = 24,00 V RMS och f = 100 Hz.</a:t>
-            </a:r>
-          </a:p>
-          <a:p xmlns:a="http://schemas.openxmlformats.org/drawingml/2006/main">
-            <a:r>
-              <a:t/>
+              <a:t>En sinus har U = 48,00 V RMS och f = 120 Hz.</a:t>
             </a:r>
           </a:p>
           <a:p xmlns:a="http://schemas.openxmlformats.org/drawingml/2006/main">
@@ -11018,6 +11013,18 @@
                 <a:cs typeface="Calibri"/>
               </a:defRPr>
             </a:pPr>
+          </a:p>
+          <a:p xmlns:a="http://schemas.openxmlformats.org/drawingml/2006/main">
+            <a:pPr>
+              <a:defRPr sz="2100" b="0">
+                <a:solidFill>
+                  <a:srgbClr val="172F43"/>
+                </a:solidFill>
+                <a:latin typeface="Calibri"/>
+                <a:ea typeface="Calibri"/>
+                <a:cs typeface="Calibri"/>
+              </a:defRPr>
+            </a:pPr>
             <a:r>
               <a:rPr sz="2100" b="0">
                 <a:solidFill>
@@ -11031,9 +11038,16 @@
             </a:r>
           </a:p>
           <a:p xmlns:a="http://schemas.openxmlformats.org/drawingml/2006/main">
-            <a:r>
-              <a:t/>
-            </a:r>
+            <a:pPr>
+              <a:defRPr sz="2100" b="0">
+                <a:solidFill>
+                  <a:srgbClr val="172F43"/>
+                </a:solidFill>
+                <a:latin typeface="Calibri"/>
+                <a:ea typeface="Calibri"/>
+                <a:cs typeface="Calibri"/>
+              </a:defRPr>
+            </a:pPr>
           </a:p>
           <a:p xmlns:a="http://schemas.openxmlformats.org/drawingml/2006/main">
             <a:pPr>

</xml_diff>

<commit_message>
Sjöskolan v40: tydlig väg för eleven och samma ord överallt
- Veckosidan: tre steg per del (genomgång, film, övningar), artikel under Mer,
  inlämning och sista dag överst, Börja-knappen öppnar genomgången del 1.
- Övningar: en del i taget, Markera som klar och framsteg per del (gemensamt/ovningsvy.mjs).
- Genomgången börjar med Det här ska du kunna; labbinfo flyttad till labbavsnitten;
  i telefonen bara rullistan; nästa steg till film och övningar.
- Film, artikel och labb pekar på nästa steg; Genomgång, Bildspel, Artikel, Film,
  Övningar, Labb och Inlämning som enda benämningar; labbets läshänvisning i avsnitt.

Co-Authored-By: Claude Opus 5.5 <noreply@anthropic.com>
Claude-Session: https://claude.ai/code/session_011V9KjBb53XrDm23Dw58SH3
</commit_message>
<xml_diff>
--- a/sjoskolan/vecka-40/aktuell/v40_01_Sinusformad_vaxelspanning_elev.pptx
+++ b/sjoskolan/vecka-40/aktuell/v40_01_Sinusformad_vaxelspanning_elev.pptx
@@ -14004,7 +14004,7 @@
                 <a:ea typeface="Calibri"/>
                 <a:cs typeface="Calibri"/>
               </a:rPr>
-              <a:t>Det här behövs i labben</a:t>
+              <a:t>Det här ska du kunna</a:t>
             </a:r>
           </a:p>
         </p:txBody>
@@ -14061,7 +14061,7 @@
                 <a:ea typeface="Calibri"/>
                 <a:cs typeface="Calibri"/>
               </a:rPr>
-              <a:t>Du ska kunna hitta en hel period och kurvans högsta värde.</a:t>
+              <a:t>Hitta en hel period på kurvan och räkna periodtiden T ur frekvensen.</a:t>
             </a:r>
           </a:p>
           <a:p xmlns:a="http://schemas.openxmlformats.org/drawingml/2006/main">
@@ -14096,7 +14096,7 @@
                 <a:ea typeface="Calibri"/>
                 <a:cs typeface="Calibri"/>
               </a:rPr>
-              <a:t>Du ska kunna förklara varför en multimeter och kurvans topp visar olika tal.</a:t>
+              <a:t>Skilja på toppvärde, effektivvärde (RMS) och medelvärde.</a:t>
             </a:r>
           </a:p>
           <a:p xmlns:a="http://schemas.openxmlformats.org/drawingml/2006/main">
@@ -14131,7 +14131,7 @@
                 <a:ea typeface="Calibri"/>
                 <a:cs typeface="Calibri"/>
               </a:rPr>
-              <a:t>I den guidade labben får du en egen sinusspänning mellan 13 och 23 V effektivvärde (skrivs till exempel 13 V RMS) och frekvensen 50 hertz (Hz). Värdet räknas fram ur ditt namn. Station B är ett senare, utökat försök.</a:t>
+              <a:t>Förklara varför en multimeter och kurvans topp visar olika tal.</a:t>
             </a:r>
           </a:p>
         </p:txBody>
@@ -17408,7 +17408,7 @@
                 <a:ea typeface="Calibri"/>
                 <a:cs typeface="Calibri"/>
               </a:rPr>
-              <a:t>Förklara: en hel period tar 16,7 ms. Frekvensen är 60 perioder per sekund. I labben gör du samma sak vid 50 Hz.</a:t>
+              <a:t>Förklara: en hel period tar 16,7 ms. Frekvensen är 60 perioder per sekund. I labben gör du samma sak vid 50 Hz med din egen spänning, som räknas fram ur ditt namn.</a:t>
             </a:r>
           </a:p>
         </p:txBody>

</xml_diff>

<commit_message>
Sjöskolan v40: elevens PowerPoint utan lärarens anteckningar, krypterad lärarkopia
- Talaranteckningar (lärarråd, kontrollfrågor, facit) borttagna ur v40_01–03_elev.pptx.
- Lärarkopior med anteckningar och nytt dagsupplägg (måndag, tisdag, fredag) krypterade
  i larare/filer/, nedladdning i utbildningsguiden för vecka 40 med lärarlösenordet.
- Veckosidan: genomgången för egen läsning, bildspel/PowerPoint/PDF till lektion och utskrift.
- QA: elevens PowerPoint får inte ha talaranteckningar.

Co-Authored-By: Claude Opus 5.5 <noreply@anthropic.com>
Claude-Session: https://claude.ai/code/session_011V9KjBb53XrDm23Dw58SH3
</commit_message>
<xml_diff>
--- a/sjoskolan/vecka-40/aktuell/v40_01_Sinusformad_vaxelspanning_elev.pptx
+++ b/sjoskolan/vecka-40/aktuell/v40_01_Sinusformad_vaxelspanning_elev.pptx
@@ -528,46 +528,7 @@
         <p:txBody>
           <a:bodyPr xmlns:a="http://schemas.openxmlformats.org/drawingml/2006/main"/>
           <a:lstStyle xmlns:a="http://schemas.openxmlformats.org/drawingml/2006/main"/>
-          <a:p xmlns:a="http://schemas.openxmlformats.org/drawingml/2006/main">
-            <a:r>
-              <a:t>Stanna här om eleven fortfarande blandar medelvärde och effektivvärde.</a:t>
-            </a:r>
-          </a:p>
-          <a:p xmlns:a="http://schemas.openxmlformats.org/drawingml/2006/main">
-            <a:r>
-              <a:t/>
-            </a:r>
-          </a:p>
-          <a:p xmlns:a="http://schemas.openxmlformats.org/drawingml/2006/main">
-            <a:r>
-              <a:t>Kontrollfråga: Betyder 0 V i medelvärde att källan inte kan ge effekt?</a:t>
-            </a:r>
-          </a:p>
-          <a:p xmlns:a="http://schemas.openxmlformats.org/drawingml/2006/main">
-            <a:r>
-              <a:t>Facit: Nej. Effekten i en resistor beror på spänningen i kvadrat.</a:t>
-            </a:r>
-          </a:p>
-          <a:p xmlns:a="http://schemas.openxmlformats.org/drawingml/2006/main">
-            <a:r>
-              <a:t/>
-            </a:r>
-          </a:p>
-          <a:p xmlns:a="http://schemas.openxmlformats.org/drawingml/2006/main">
-            <a:r>
-              <a:t>Webbgenomgång: https://nj22az.github.io/sjoskolan/vecka-40/aktuell/Genomgang.html?del=sinus&amp;avsnitt=medel</a:t>
-            </a:r>
-          </a:p>
-          <a:p xmlns:a="http://schemas.openxmlformats.org/drawingml/2006/main">
-            <a:r>
-              <a:t/>
-            </a:r>
-          </a:p>
-          <a:p xmlns:a="http://schemas.openxmlformats.org/drawingml/2006/main">
-            <a:r>
-              <a:t>Guidad labb: https://nj22az.github.io/sjoskolan/vaxelstromslabbet/?lage=guidad&amp;del=sinus</a:t>
-            </a:r>
-          </a:p>
+          <a:p xmlns:a="http://schemas.openxmlformats.org/drawingml/2006/main"/>
         </p:txBody>
       </p:sp>
       <p:sp>
@@ -633,46 +594,7 @@
         <p:txBody>
           <a:bodyPr xmlns:a="http://schemas.openxmlformats.org/drawingml/2006/main"/>
           <a:lstStyle xmlns:a="http://schemas.openxmlformats.org/drawingml/2006/main"/>
-          <a:p xmlns:a="http://schemas.openxmlformats.org/drawingml/2006/main">
-            <a:r>
-              <a:t>Detta kontrollerar överföring till nya värden. Godkänn inte endast att grundexemplet har kopierats.</a:t>
-            </a:r>
-          </a:p>
-          <a:p xmlns:a="http://schemas.openxmlformats.org/drawingml/2006/main">
-            <a:r>
-              <a:t/>
-            </a:r>
-          </a:p>
-          <a:p xmlns:a="http://schemas.openxmlformats.org/drawingml/2006/main">
-            <a:r>
-              <a:t>Kontrollfråga: Räkna innan facit visas.</a:t>
-            </a:r>
-          </a:p>
-          <a:p xmlns:a="http://schemas.openxmlformats.org/drawingml/2006/main">
-            <a:r>
-              <a:t>Facit: T ≈ 8,33 ms. û ≈ 67,88 V. Multimetern visar 48,00 V.</a:t>
-            </a:r>
-          </a:p>
-          <a:p xmlns:a="http://schemas.openxmlformats.org/drawingml/2006/main">
-            <a:r>
-              <a:t/>
-            </a:r>
-          </a:p>
-          <a:p xmlns:a="http://schemas.openxmlformats.org/drawingml/2006/main">
-            <a:r>
-              <a:t>Webbgenomgång: https://nj22az.github.io/sjoskolan/vecka-40/aktuell/Genomgang.html?del=sinus&amp;avsnitt=eget</a:t>
-            </a:r>
-          </a:p>
-          <a:p xmlns:a="http://schemas.openxmlformats.org/drawingml/2006/main">
-            <a:r>
-              <a:t/>
-            </a:r>
-          </a:p>
-          <a:p xmlns:a="http://schemas.openxmlformats.org/drawingml/2006/main">
-            <a:r>
-              <a:t>Guidad labb: https://nj22az.github.io/sjoskolan/vaxelstromslabbet/?lage=guidad&amp;del=sinus</a:t>
-            </a:r>
-          </a:p>
+          <a:p xmlns:a="http://schemas.openxmlformats.org/drawingml/2006/main"/>
         </p:txBody>
       </p:sp>
       <p:sp>
@@ -738,31 +660,7 @@
         <p:txBody>
           <a:bodyPr xmlns:a="http://schemas.openxmlformats.org/drawingml/2006/main"/>
           <a:lstStyle xmlns:a="http://schemas.openxmlformats.org/drawingml/2006/main"/>
-          <a:p xmlns:a="http://schemas.openxmlformats.org/drawingml/2006/main">
-            <a:r>
-              <a:t>Sinusformeln använder toppvärdet som amplitud. Momentanvärdet får ett negativt tecken under den negativa halvperioden.</a:t>
-            </a:r>
-          </a:p>
-          <a:p xmlns:a="http://schemas.openxmlformats.org/drawingml/2006/main">
-            <a:r>
-              <a:t/>
-            </a:r>
-          </a:p>
-          <a:p xmlns:a="http://schemas.openxmlformats.org/drawingml/2006/main">
-            <a:r>
-              <a:t>Webbgenomgång: https://nj22az.github.io/sjoskolan/vecka-40/aktuell/Genomgang.html?del=sinus&amp;avsnitt=moment</a:t>
-            </a:r>
-          </a:p>
-          <a:p xmlns:a="http://schemas.openxmlformats.org/drawingml/2006/main">
-            <a:r>
-              <a:t/>
-            </a:r>
-          </a:p>
-          <a:p xmlns:a="http://schemas.openxmlformats.org/drawingml/2006/main">
-            <a:r>
-              <a:t>Guidad labb: https://nj22az.github.io/sjoskolan/vaxelstromslabbet/?lage=guidad&amp;del=sinus</a:t>
-            </a:r>
-          </a:p>
+          <a:p xmlns:a="http://schemas.openxmlformats.org/drawingml/2006/main"/>
         </p:txBody>
       </p:sp>
       <p:sp>
@@ -828,31 +726,7 @@
         <p:txBody>
           <a:bodyPr xmlns:a="http://schemas.openxmlformats.org/drawingml/2006/main"/>
           <a:lstStyle xmlns:a="http://schemas.openxmlformats.org/drawingml/2006/main"/>
-          <a:p xmlns:a="http://schemas.openxmlformats.org/drawingml/2006/main">
-            <a:r>
-              <a:t>Beloppet räcker inte för att avgöra vem som leder. Eleven måste läsa kurvornas ordning.</a:t>
-            </a:r>
-          </a:p>
-          <a:p xmlns:a="http://schemas.openxmlformats.org/drawingml/2006/main">
-            <a:r>
-              <a:t/>
-            </a:r>
-          </a:p>
-          <a:p xmlns:a="http://schemas.openxmlformats.org/drawingml/2006/main">
-            <a:r>
-              <a:t>Webbgenomgång: https://nj22az.github.io/sjoskolan/vecka-40/aktuell/Genomgang.html?del=sinus&amp;avsnitt=fas</a:t>
-            </a:r>
-          </a:p>
-          <a:p xmlns:a="http://schemas.openxmlformats.org/drawingml/2006/main">
-            <a:r>
-              <a:t/>
-            </a:r>
-          </a:p>
-          <a:p xmlns:a="http://schemas.openxmlformats.org/drawingml/2006/main">
-            <a:r>
-              <a:t>Guidad labb: https://nj22az.github.io/sjoskolan/vaxelstromslabbet/?lage=guidad&amp;del=sinus</a:t>
-            </a:r>
-          </a:p>
+          <a:p xmlns:a="http://schemas.openxmlformats.org/drawingml/2006/main"/>
         </p:txBody>
       </p:sp>
       <p:sp>
@@ -918,41 +792,7 @@
         <p:txBody>
           <a:bodyPr xmlns:a="http://schemas.openxmlformats.org/drawingml/2006/main"/>
           <a:lstStyle xmlns:a="http://schemas.openxmlformats.org/drawingml/2006/main"/>
-          <a:p xmlns:a="http://schemas.openxmlformats.org/drawingml/2006/main">
-            <a:r>
-              <a:t>Källa: Fluke, True measurements of non-linear loads require a true-RMS measurement tool. Vanligt medelvärde, likriktat medelvärde och RMS måste hållas isär.</a:t>
-            </a:r>
-          </a:p>
-          <a:p xmlns:a="http://schemas.openxmlformats.org/drawingml/2006/main">
-            <a:r>
-              <a:t/>
-            </a:r>
-          </a:p>
-          <a:p xmlns:a="http://schemas.openxmlformats.org/drawingml/2006/main">
-            <a:r>
-              <a:t>Webbgenomgång: https://nj22az.github.io/sjoskolan/vecka-40/aktuell/Genomgang.html?del=sinus&amp;avsnitt=likriktat</a:t>
-            </a:r>
-          </a:p>
-          <a:p xmlns:a="http://schemas.openxmlformats.org/drawingml/2006/main">
-            <a:r>
-              <a:t/>
-            </a:r>
-          </a:p>
-          <a:p xmlns:a="http://schemas.openxmlformats.org/drawingml/2006/main">
-            <a:r>
-              <a:t>Guidad labb: https://nj22az.github.io/sjoskolan/vaxelstromslabbet/?lage=guidad&amp;del=sinus</a:t>
-            </a:r>
-          </a:p>
-          <a:p xmlns:a="http://schemas.openxmlformats.org/drawingml/2006/main">
-            <a:r>
-              <a:t/>
-            </a:r>
-          </a:p>
-          <a:p xmlns:a="http://schemas.openxmlformats.org/drawingml/2006/main">
-            <a:r>
-              <a:t>Källa: https://www.fluke.com/en-gb/learn/blog/electrical/true-measurements-of-non-linear-loads-require-a-true-rms-measurement-tool</a:t>
-            </a:r>
-          </a:p>
+          <a:p xmlns:a="http://schemas.openxmlformats.org/drawingml/2006/main"/>
         </p:txBody>
       </p:sp>
       <p:sp>
@@ -1018,41 +858,7 @@
         <p:txBody>
           <a:bodyPr xmlns:a="http://schemas.openxmlformats.org/drawingml/2006/main"/>
           <a:lstStyle xmlns:a="http://schemas.openxmlformats.org/drawingml/2006/main"/>
-          <a:p xmlns:a="http://schemas.openxmlformats.org/drawingml/2006/main">
-            <a:r>
-              <a:t>Här hålls RMS konstant. Vid jämförelse med samma toppvärde blir RMS i stället olika. True RMS visar 10,00 V för alla tre i idealmodellen. Verkliga instrument har frekvens-, bandbredds- och crestfaktorgränser.</a:t>
-            </a:r>
-          </a:p>
-          <a:p xmlns:a="http://schemas.openxmlformats.org/drawingml/2006/main">
-            <a:r>
-              <a:t/>
-            </a:r>
-          </a:p>
-          <a:p xmlns:a="http://schemas.openxmlformats.org/drawingml/2006/main">
-            <a:r>
-              <a:t>Webbgenomgång: https://nj22az.github.io/sjoskolan/vecka-40/aktuell/Genomgang.html?del=sinus&amp;avsnitt=kurvformer</a:t>
-            </a:r>
-          </a:p>
-          <a:p xmlns:a="http://schemas.openxmlformats.org/drawingml/2006/main">
-            <a:r>
-              <a:t/>
-            </a:r>
-          </a:p>
-          <a:p xmlns:a="http://schemas.openxmlformats.org/drawingml/2006/main">
-            <a:r>
-              <a:t>Guidad labb: https://nj22az.github.io/sjoskolan/vaxelstromslabbet/?lage=guidad&amp;del=sinus</a:t>
-            </a:r>
-          </a:p>
-          <a:p xmlns:a="http://schemas.openxmlformats.org/drawingml/2006/main">
-            <a:r>
-              <a:t/>
-            </a:r>
-          </a:p>
-          <a:p xmlns:a="http://schemas.openxmlformats.org/drawingml/2006/main">
-            <a:r>
-              <a:t>Källa: https://www.fluke.com/en-gb/learn/blog/electrical/true-measurements-of-non-linear-loads-require-a-true-rms-measurement-tool</a:t>
-            </a:r>
-          </a:p>
+          <a:p xmlns:a="http://schemas.openxmlformats.org/drawingml/2006/main"/>
         </p:txBody>
       </p:sp>
       <p:sp>
@@ -1118,31 +924,7 @@
         <p:txBody>
           <a:bodyPr xmlns:a="http://schemas.openxmlformats.org/drawingml/2006/main"/>
           <a:lstStyle xmlns:a="http://schemas.openxmlformats.org/drawingml/2006/main"/>
-          <a:p xmlns:a="http://schemas.openxmlformats.org/drawingml/2006/main">
-            <a:r>
-              <a:t>Skilj källans avvikelse från instrumentets visningsprincip. Stationsprotokollet har egna kontroller och används efter mätaravsnittet.</a:t>
-            </a:r>
-          </a:p>
-          <a:p xmlns:a="http://schemas.openxmlformats.org/drawingml/2006/main">
-            <a:r>
-              <a:t/>
-            </a:r>
-          </a:p>
-          <a:p xmlns:a="http://schemas.openxmlformats.org/drawingml/2006/main">
-            <a:r>
-              <a:t>Webbgenomgång: https://nj22az.github.io/sjoskolan/vecka-40/aktuell/Genomgang.html?del=sinus&amp;avsnitt=station</a:t>
-            </a:r>
-          </a:p>
-          <a:p xmlns:a="http://schemas.openxmlformats.org/drawingml/2006/main">
-            <a:r>
-              <a:t/>
-            </a:r>
-          </a:p>
-          <a:p xmlns:a="http://schemas.openxmlformats.org/drawingml/2006/main">
-            <a:r>
-              <a:t>Guidad labb: https://nj22az.github.io/sjoskolan/vaxelstromslabbet/?lage=guidad&amp;del=sinus</a:t>
-            </a:r>
-          </a:p>
+          <a:p xmlns:a="http://schemas.openxmlformats.org/drawingml/2006/main"/>
         </p:txBody>
       </p:sp>
       <p:sp>
@@ -1208,31 +990,7 @@
         <p:txBody>
           <a:bodyPr xmlns:a="http://schemas.openxmlformats.org/drawingml/2006/main"/>
           <a:lstStyle xmlns:a="http://schemas.openxmlformats.org/drawingml/2006/main"/>
-          <a:p xmlns:a="http://schemas.openxmlformats.org/drawingml/2006/main">
-            <a:r>
-              <a:t>Säkerheten i verklig mätning kan inte godkännas genom ett klick i simulatorn. Läraren behöver riggens dokumenterade mätpunkter och instrumentmanualer.</a:t>
-            </a:r>
-          </a:p>
-          <a:p xmlns:a="http://schemas.openxmlformats.org/drawingml/2006/main">
-            <a:r>
-              <a:t/>
-            </a:r>
-          </a:p>
-          <a:p xmlns:a="http://schemas.openxmlformats.org/drawingml/2006/main">
-            <a:r>
-              <a:t>Webbgenomgång: https://nj22az.github.io/sjoskolan/vecka-40/aktuell/Genomgang.html?del=sinus&amp;avsnitt=klart</a:t>
-            </a:r>
-          </a:p>
-          <a:p xmlns:a="http://schemas.openxmlformats.org/drawingml/2006/main">
-            <a:r>
-              <a:t/>
-            </a:r>
-          </a:p>
-          <a:p xmlns:a="http://schemas.openxmlformats.org/drawingml/2006/main">
-            <a:r>
-              <a:t>Guidad labb: https://nj22az.github.io/sjoskolan/vaxelstromslabbet/?lage=guidad&amp;del=sinus</a:t>
-            </a:r>
-          </a:p>
+          <a:p xmlns:a="http://schemas.openxmlformats.org/drawingml/2006/main"/>
         </p:txBody>
       </p:sp>
       <p:sp>
@@ -1298,31 +1056,7 @@
         <p:txBody>
           <a:bodyPr xmlns:a="http://schemas.openxmlformats.org/drawingml/2006/main"/>
           <a:lstStyle xmlns:a="http://schemas.openxmlformats.org/drawingml/2006/main"/>
-          <a:p xmlns:a="http://schemas.openxmlformats.org/drawingml/2006/main">
-            <a:r>
-              <a:t>Förslag: 30 min genomgång inklusive stegfilm, 15 min gemensam räkning, 30 min guidad labb, 15 min återkoppling. Delarna kan delas på två 45-minuterspass.</a:t>
-            </a:r>
-          </a:p>
-          <a:p xmlns:a="http://schemas.openxmlformats.org/drawingml/2006/main">
-            <a:r>
-              <a:t/>
-            </a:r>
-          </a:p>
-          <a:p xmlns:a="http://schemas.openxmlformats.org/drawingml/2006/main">
-            <a:r>
-              <a:t>Webbgenomgång: https://nj22az.github.io/sjoskolan/vecka-40/aktuell/Genomgang.html?del=sinus&amp;avsnitt=mal</a:t>
-            </a:r>
-          </a:p>
-          <a:p xmlns:a="http://schemas.openxmlformats.org/drawingml/2006/main">
-            <a:r>
-              <a:t/>
-            </a:r>
-          </a:p>
-          <a:p xmlns:a="http://schemas.openxmlformats.org/drawingml/2006/main">
-            <a:r>
-              <a:t>Guidad labb: https://nj22az.github.io/sjoskolan/vaxelstromslabbet/?lage=guidad&amp;del=sinus</a:t>
-            </a:r>
-          </a:p>
+          <a:p xmlns:a="http://schemas.openxmlformats.org/drawingml/2006/main"/>
         </p:txBody>
       </p:sp>
       <p:sp>
@@ -1388,31 +1122,7 @@
         <p:txBody>
           <a:bodyPr xmlns:a="http://schemas.openxmlformats.org/drawingml/2006/main"/>
           <a:lstStyle xmlns:a="http://schemas.openxmlformats.org/drawingml/2006/main"/>
-          <a:p xmlns:a="http://schemas.openxmlformats.org/drawingml/2006/main">
-            <a:r>
-              <a:t>Följ kurvan långsamt: noll, positiv topp, noll, negativ topp, noll. Kurvan visar spänningen vid olika tidpunkter, inte en partikels färd.</a:t>
-            </a:r>
-          </a:p>
-          <a:p xmlns:a="http://schemas.openxmlformats.org/drawingml/2006/main">
-            <a:r>
-              <a:t/>
-            </a:r>
-          </a:p>
-          <a:p xmlns:a="http://schemas.openxmlformats.org/drawingml/2006/main">
-            <a:r>
-              <a:t>Webbgenomgång: https://nj22az.github.io/sjoskolan/vecka-40/aktuell/Genomgang.html?del=sinus&amp;avsnitt=kurvan</a:t>
-            </a:r>
-          </a:p>
-          <a:p xmlns:a="http://schemas.openxmlformats.org/drawingml/2006/main">
-            <a:r>
-              <a:t/>
-            </a:r>
-          </a:p>
-          <a:p xmlns:a="http://schemas.openxmlformats.org/drawingml/2006/main">
-            <a:r>
-              <a:t>Guidad labb: https://nj22az.github.io/sjoskolan/vaxelstromslabbet/?lage=guidad&amp;del=sinus</a:t>
-            </a:r>
-          </a:p>
+          <a:p xmlns:a="http://schemas.openxmlformats.org/drawingml/2006/main"/>
         </p:txBody>
       </p:sp>
       <p:sp>
@@ -1478,46 +1188,7 @@
         <p:txBody>
           <a:bodyPr xmlns:a="http://schemas.openxmlformats.org/drawingml/2006/main"/>
           <a:lstStyle xmlns:a="http://schemas.openxmlformats.org/drawingml/2006/main"/>
-          <a:p xmlns:a="http://schemas.openxmlformats.org/drawingml/2006/main">
-            <a:r>
-              <a:t>Låt eleven peka på två stigande nollpassager innan formeln används. Vanligt fel: 0,0167 s skrivs som 0,0167 ms.</a:t>
-            </a:r>
-          </a:p>
-          <a:p xmlns:a="http://schemas.openxmlformats.org/drawingml/2006/main">
-            <a:r>
-              <a:t/>
-            </a:r>
-          </a:p>
-          <a:p xmlns:a="http://schemas.openxmlformats.org/drawingml/2006/main">
-            <a:r>
-              <a:t>Kontrollfråga: Vid 100 Hz: blir perioden längre eller kortare?</a:t>
-            </a:r>
-          </a:p>
-          <a:p xmlns:a="http://schemas.openxmlformats.org/drawingml/2006/main">
-            <a:r>
-              <a:t>Facit: Kortare. T = 1 000/100 = 10 ms.</a:t>
-            </a:r>
-          </a:p>
-          <a:p xmlns:a="http://schemas.openxmlformats.org/drawingml/2006/main">
-            <a:r>
-              <a:t/>
-            </a:r>
-          </a:p>
-          <a:p xmlns:a="http://schemas.openxmlformats.org/drawingml/2006/main">
-            <a:r>
-              <a:t>Webbgenomgång: https://nj22az.github.io/sjoskolan/vecka-40/aktuell/Genomgang.html?del=sinus&amp;avsnitt=period</a:t>
-            </a:r>
-          </a:p>
-          <a:p xmlns:a="http://schemas.openxmlformats.org/drawingml/2006/main">
-            <a:r>
-              <a:t/>
-            </a:r>
-          </a:p>
-          <a:p xmlns:a="http://schemas.openxmlformats.org/drawingml/2006/main">
-            <a:r>
-              <a:t>Guidad labb: https://nj22az.github.io/sjoskolan/vaxelstromslabbet/?lage=guidad&amp;del=sinus</a:t>
-            </a:r>
-          </a:p>
+          <a:p xmlns:a="http://schemas.openxmlformats.org/drawingml/2006/main"/>
         </p:txBody>
       </p:sp>
       <p:sp>
@@ -1583,46 +1254,7 @@
         <p:txBody>
           <a:bodyPr xmlns:a="http://schemas.openxmlformats.org/drawingml/2006/main"/>
           <a:lstStyle xmlns:a="http://schemas.openxmlformats.org/drawingml/2006/main"/>
-          <a:p xmlns:a="http://schemas.openxmlformats.org/drawingml/2006/main">
-            <a:r>
-              <a:t>Peka ut nollnivån. Eleven ska inte använda hela höjden när frågan gäller toppvärde.</a:t>
-            </a:r>
-          </a:p>
-          <a:p xmlns:a="http://schemas.openxmlformats.org/drawingml/2006/main">
-            <a:r>
-              <a:t/>
-            </a:r>
-          </a:p>
-          <a:p xmlns:a="http://schemas.openxmlformats.org/drawingml/2006/main">
-            <a:r>
-              <a:t>Kontrollfråga: Om Upp = 20 V, hur stort är û?</a:t>
-            </a:r>
-          </a:p>
-          <a:p xmlns:a="http://schemas.openxmlformats.org/drawingml/2006/main">
-            <a:r>
-              <a:t>Facit: û = 20/2 = 10 V.</a:t>
-            </a:r>
-          </a:p>
-          <a:p xmlns:a="http://schemas.openxmlformats.org/drawingml/2006/main">
-            <a:r>
-              <a:t/>
-            </a:r>
-          </a:p>
-          <a:p xmlns:a="http://schemas.openxmlformats.org/drawingml/2006/main">
-            <a:r>
-              <a:t>Webbgenomgång: https://nj22az.github.io/sjoskolan/vecka-40/aktuell/Genomgang.html?del=sinus&amp;avsnitt=topp</a:t>
-            </a:r>
-          </a:p>
-          <a:p xmlns:a="http://schemas.openxmlformats.org/drawingml/2006/main">
-            <a:r>
-              <a:t/>
-            </a:r>
-          </a:p>
-          <a:p xmlns:a="http://schemas.openxmlformats.org/drawingml/2006/main">
-            <a:r>
-              <a:t>Guidad labb: https://nj22az.github.io/sjoskolan/vaxelstromslabbet/?lage=guidad&amp;del=sinus</a:t>
-            </a:r>
-          </a:p>
+          <a:p xmlns:a="http://schemas.openxmlformats.org/drawingml/2006/main"/>
         </p:txBody>
       </p:sp>
       <p:sp>
@@ -1688,31 +1320,7 @@
         <p:txBody>
           <a:bodyPr xmlns:a="http://schemas.openxmlformats.org/drawingml/2006/main"/>
           <a:lstStyle xmlns:a="http://schemas.openxmlformats.org/drawingml/2006/main"/>
-          <a:p xmlns:a="http://schemas.openxmlformats.org/drawingml/2006/main">
-            <a:r>
-              <a:t>Förklara betydelsen innan förkortningen root mean square. Ett element på 23 Ω ger P = 230²/23 = 2 300 W med 230 V RMS och med 230 V DC.</a:t>
-            </a:r>
-          </a:p>
-          <a:p xmlns:a="http://schemas.openxmlformats.org/drawingml/2006/main">
-            <a:r>
-              <a:t/>
-            </a:r>
-          </a:p>
-          <a:p xmlns:a="http://schemas.openxmlformats.org/drawingml/2006/main">
-            <a:r>
-              <a:t>Webbgenomgång: https://nj22az.github.io/sjoskolan/vecka-40/aktuell/Genomgang.html?del=sinus&amp;avsnitt=rms</a:t>
-            </a:r>
-          </a:p>
-          <a:p xmlns:a="http://schemas.openxmlformats.org/drawingml/2006/main">
-            <a:r>
-              <a:t/>
-            </a:r>
-          </a:p>
-          <a:p xmlns:a="http://schemas.openxmlformats.org/drawingml/2006/main">
-            <a:r>
-              <a:t>Guidad labb: https://nj22az.github.io/sjoskolan/vaxelstromslabbet/?lage=guidad&amp;del=sinus</a:t>
-            </a:r>
-          </a:p>
+          <a:p xmlns:a="http://schemas.openxmlformats.org/drawingml/2006/main"/>
         </p:txBody>
       </p:sp>
       <p:sp>
@@ -1778,31 +1386,7 @@
         <p:txBody>
           <a:bodyPr xmlns:a="http://schemas.openxmlformats.org/drawingml/2006/main"/>
           <a:lstStyle xmlns:a="http://schemas.openxmlformats.org/drawingml/2006/main"/>
-          <a:p xmlns:a="http://schemas.openxmlformats.org/drawingml/2006/main">
-            <a:r>
-              <a:t>Exemplet har samma metod men andra värden än labbens källa, så att eleven själv räknar fram labbens svar.</a:t>
-            </a:r>
-          </a:p>
-          <a:p xmlns:a="http://schemas.openxmlformats.org/drawingml/2006/main">
-            <a:r>
-              <a:t/>
-            </a:r>
-          </a:p>
-          <a:p xmlns:a="http://schemas.openxmlformats.org/drawingml/2006/main">
-            <a:r>
-              <a:t>Webbgenomgång: https://nj22az.github.io/sjoskolan/vecka-40/aktuell/Genomgang.html?del=sinus&amp;avsnitt=exempel</a:t>
-            </a:r>
-          </a:p>
-          <a:p xmlns:a="http://schemas.openxmlformats.org/drawingml/2006/main">
-            <a:r>
-              <a:t/>
-            </a:r>
-          </a:p>
-          <a:p xmlns:a="http://schemas.openxmlformats.org/drawingml/2006/main">
-            <a:r>
-              <a:t>Guidad labb: https://nj22az.github.io/sjoskolan/vaxelstromslabbet/?lage=guidad&amp;del=sinus</a:t>
-            </a:r>
-          </a:p>
+          <a:p xmlns:a="http://schemas.openxmlformats.org/drawingml/2006/main"/>
         </p:txBody>
       </p:sp>
       <p:sp>
@@ -1868,31 +1452,7 @@
         <p:txBody>
           <a:bodyPr xmlns:a="http://schemas.openxmlformats.org/drawingml/2006/main"/>
           <a:lstStyle xmlns:a="http://schemas.openxmlformats.org/drawingml/2006/main"/>
-          <a:p xmlns:a="http://schemas.openxmlformats.org/drawingml/2006/main">
-            <a:r>
-              <a:t>Detta är en modell av instrumentkontroll, inte en utförd fysisk kalibrering. En verklig kontroll följer instrumentens och stationens instruktioner.</a:t>
-            </a:r>
-          </a:p>
-          <a:p xmlns:a="http://schemas.openxmlformats.org/drawingml/2006/main">
-            <a:r>
-              <a:t/>
-            </a:r>
-          </a:p>
-          <a:p xmlns:a="http://schemas.openxmlformats.org/drawingml/2006/main">
-            <a:r>
-              <a:t>Webbgenomgång: https://nj22az.github.io/sjoskolan/vecka-40/aktuell/Genomgang.html?del=sinus&amp;avsnitt=matarna</a:t>
-            </a:r>
-          </a:p>
-          <a:p xmlns:a="http://schemas.openxmlformats.org/drawingml/2006/main">
-            <a:r>
-              <a:t/>
-            </a:r>
-          </a:p>
-          <a:p xmlns:a="http://schemas.openxmlformats.org/drawingml/2006/main">
-            <a:r>
-              <a:t>Guidad labb: https://nj22az.github.io/sjoskolan/vaxelstromslabbet/?lage=guidad&amp;del=sinus</a:t>
-            </a:r>
-          </a:p>
+          <a:p xmlns:a="http://schemas.openxmlformats.org/drawingml/2006/main"/>
         </p:txBody>
       </p:sp>
       <p:sp>
@@ -1958,31 +1518,7 @@
         <p:txBody>
           <a:bodyPr xmlns:a="http://schemas.openxmlformats.org/drawingml/2006/main"/>
           <a:lstStyle xmlns:a="http://schemas.openxmlformats.org/drawingml/2006/main"/>
-          <a:p xmlns:a="http://schemas.openxmlformats.org/drawingml/2006/main">
-            <a:r>
-              <a:t>Öppna guidad labb och visa en rad. Eleven ska kunna säga vad som jämförs och vilken enhet som används.</a:t>
-            </a:r>
-          </a:p>
-          <a:p xmlns:a="http://schemas.openxmlformats.org/drawingml/2006/main">
-            <a:r>
-              <a:t/>
-            </a:r>
-          </a:p>
-          <a:p xmlns:a="http://schemas.openxmlformats.org/drawingml/2006/main">
-            <a:r>
-              <a:t>Webbgenomgång: https://nj22az.github.io/sjoskolan/vecka-40/aktuell/Genomgang.html?del=sinus&amp;avsnitt=protokoll</a:t>
-            </a:r>
-          </a:p>
-          <a:p xmlns:a="http://schemas.openxmlformats.org/drawingml/2006/main">
-            <a:r>
-              <a:t/>
-            </a:r>
-          </a:p>
-          <a:p xmlns:a="http://schemas.openxmlformats.org/drawingml/2006/main">
-            <a:r>
-              <a:t>Guidad labb: https://nj22az.github.io/sjoskolan/vaxelstromslabbet/?lage=guidad&amp;del=sinus</a:t>
-            </a:r>
-          </a:p>
+          <a:p xmlns:a="http://schemas.openxmlformats.org/drawingml/2006/main"/>
         </p:txBody>
       </p:sp>
       <p:sp>

</xml_diff>

<commit_message>
Sjöskolan v40: radianer och grader i presentationen, genomgången och en ny film
Ny bild 12 Radianer och grader i v40_01 (elev och lärare), hjulfigur i genomgången
och artikeln, filmen Radianer och grader med länkar från veckosidan och
räknarhjälpen. Måndagsplanen pekar på de nya bildnumren.

Co-Authored-By: Claude Opus 5.5 <noreply@anthropic.com>
Claude-Session: https://claude.ai/code/session_011V9KjBb53XrDm23Dw58SH3
</commit_message>
<xml_diff>
--- a/sjoskolan/vecka-40/aktuell/v40_01_Sinusformad_vaxelspanning_elev.pptx
+++ b/sjoskolan/vecka-40/aktuell/v40_01_Sinusformad_vaxelspanning_elev.pptx
@@ -19,6 +19,7 @@
     <p:sldId xmlns:r="http://schemas.openxmlformats.org/officeDocument/2006/relationships" id="264" r:id="Rf94a673741874e27"/>
     <p:sldId xmlns:r="http://schemas.openxmlformats.org/officeDocument/2006/relationships" id="265" r:id="Re494e029d18b4aa3"/>
     <p:sldId xmlns:r="http://schemas.openxmlformats.org/officeDocument/2006/relationships" id="266" r:id="R99e944cf199449e2"/>
+    <p:sldId xmlns:ns0="http://schemas.openxmlformats.org/officeDocument/2006/relationships" id="273" ns0:id="rId24"/>
     <p:sldId xmlns:r="http://schemas.openxmlformats.org/officeDocument/2006/relationships" id="267" r:id="Rded5d88f7ce64e01"/>
     <p:sldId xmlns:r="http://schemas.openxmlformats.org/officeDocument/2006/relationships" id="268" r:id="R593f3e47b5ab4e70"/>
     <p:sldId xmlns:r="http://schemas.openxmlformats.org/officeDocument/2006/relationships" id="269" r:id="Rb6f09006fb244792"/>
@@ -11212,7 +11213,7 @@
                 <a:ea typeface="Calibri"/>
                 <a:cs typeface="Calibri"/>
               </a:rPr>
-              <a:t>12</a:t>
+              <a:t>13</a:t>
             </a:r>
           </a:p>
         </p:txBody>
@@ -11613,7 +11614,7 @@
                 <a:ea typeface="Calibri"/>
                 <a:cs typeface="Calibri"/>
               </a:rPr>
-              <a:t>13</a:t>
+              <a:t>14</a:t>
             </a:r>
           </a:p>
         </p:txBody>
@@ -12014,7 +12015,7 @@
                 <a:ea typeface="Calibri"/>
                 <a:cs typeface="Calibri"/>
               </a:rPr>
-              <a:t>14</a:t>
+              <a:t>15</a:t>
             </a:r>
           </a:p>
         </p:txBody>
@@ -12735,7 +12736,7 @@
                 <a:ea typeface="Calibri"/>
                 <a:cs typeface="Calibri"/>
               </a:rPr>
-              <a:t>15</a:t>
+              <a:t>16</a:t>
             </a:r>
           </a:p>
         </p:txBody>
@@ -13093,7 +13094,7 @@
                 <a:ea typeface="Calibri"/>
                 <a:cs typeface="Calibri"/>
               </a:rPr>
-              <a:t>16</a:t>
+              <a:t>17</a:t>
             </a:r>
           </a:p>
         </p:txBody>
@@ -13437,7 +13438,7 @@
                 <a:ea typeface="Calibri"/>
                 <a:cs typeface="Calibri"/>
               </a:rPr>
-              <a:t>17</a:t>
+              <a:t>18</a:t>
             </a:r>
           </a:p>
         </p:txBody>
@@ -13449,6 +13450,438 @@
       </p:ext>
     </p:extLst>
   </p:cSld>
+</p:sld>
+</file>
+
+<file path=ppt/slides/slide18.xml><?xml version="1.0" encoding="utf-8"?>
+<p:sld xmlns:a="http://schemas.openxmlformats.org/drawingml/2006/main" xmlns:p="http://schemas.openxmlformats.org/presentationml/2006/main" xmlns:r="http://schemas.openxmlformats.org/officeDocument/2006/relationships">
+  <p:cSld>
+    <p:spTree>
+      <p:nvGrpSpPr>
+        <p:cNvPr id="1" name=""/>
+        <p:cNvGrpSpPr/>
+        <p:nvPr/>
+      </p:nvGrpSpPr>
+      <p:grpSpPr/>
+      <p:pic>
+        <p:nvPicPr>
+          <p:cNvPr id="2" name="Picture 1" descr="image.jpeg"/>
+          <p:cNvPicPr>
+            <a:picLocks noChangeAspect="1"/>
+          </p:cNvPicPr>
+          <p:nvPr/>
+        </p:nvPicPr>
+        <p:blipFill>
+          <a:blip r:embed="rId2"/>
+          <a:stretch>
+            <a:fillRect/>
+          </a:stretch>
+        </p:blipFill>
+        <p:spPr>
+          <a:xfrm>
+            <a:off x="0" y="6098791"/>
+            <a:ext cx="9144006" cy="763524"/>
+          </a:xfrm>
+          <a:prstGeom prst="rect">
+            <a:avLst/>
+          </a:prstGeom>
+        </p:spPr>
+      </p:pic>
+      <p:sp>
+        <p:nvSpPr>
+          <p:cNvPr id="9" name="title">
+            <a:extLst>
+              <a:ext uri="{FF2B5EF4-FFF2-40B4-BE49-F238E27FC236}">
+                <a16:creationId xmlns:a16="http://schemas.microsoft.com/office/drawing/2014/main" id="{768C19FF-3F32-4696-8C05-BA05833A4972}"/>
+              </a:ext>
+            </a:extLst>
+          </p:cNvPr>
+          <p:cNvSpPr>
+            <a:spLocks noGrp="1"/>
+          </p:cNvSpPr>
+          <p:nvPr/>
+        </p:nvSpPr>
+        <p:spPr>
+          <a:xfrm>
+            <a:off x="571500" y="428625"/>
+            <a:ext cx="8001000" cy="781050"/>
+          </a:xfrm>
+          <a:prstGeom prst="rect">
+            <a:avLst/>
+          </a:prstGeom>
+          <a:noFill/>
+          <a:ln w="0">
+            <a:noFill/>
+          </a:ln>
+        </p:spPr>
+        <p:txBody>
+          <a:bodyPr lIns="0" tIns="0" rIns="0" bIns="0" anchor="t">
+            <a:noAutofit/>
+          </a:bodyPr>
+          <a:lstStyle/>
+          <a:p>
+            <a:pPr>
+              <a:defRPr sz="3000" b="1">
+                <a:solidFill>
+                  <a:srgbClr val="111111"/>
+                </a:solidFill>
+                <a:latin typeface="Calibri"/>
+                <a:ea typeface="Calibri"/>
+                <a:cs typeface="Calibri"/>
+              </a:defRPr>
+            </a:pPr>
+            <a:r>
+              <a:rPr sz="3000" b="1">
+                <a:solidFill>
+                  <a:srgbClr val="111111"/>
+                </a:solidFill>
+                <a:latin typeface="Calibri"/>
+                <a:ea typeface="Calibri"/>
+                <a:cs typeface="Calibri"/>
+              </a:rPr>
+              <a:t>Radianer och grader</a:t>
+            </a:r>
+          </a:p>
+        </p:txBody>
+      </p:sp>
+      <p:sp>
+        <p:nvSpPr>
+          <p:cNvPr id="10" name="body">
+            <a:extLst>
+              <a:ext uri="{FF2B5EF4-FFF2-40B4-BE49-F238E27FC236}">
+                <a16:creationId xmlns:a16="http://schemas.microsoft.com/office/drawing/2014/main" id="{46CF4177-6412-4786-B0E5-13C9F10B86B1}"/>
+              </a:ext>
+            </a:extLst>
+          </p:cNvPr>
+          <p:cNvSpPr>
+            <a:spLocks noGrp="1"/>
+          </p:cNvSpPr>
+          <p:nvPr/>
+        </p:nvSpPr>
+        <p:spPr>
+          <a:xfrm>
+            <a:off x="762000" y="3680000"/>
+            <a:ext cx="7620000" cy="2650000"/>
+          </a:xfrm>
+          <a:prstGeom prst="rect">
+            <a:avLst/>
+          </a:prstGeom>
+          <a:noFill/>
+          <a:ln w="0">
+            <a:noFill/>
+          </a:ln>
+        </p:spPr>
+        <p:txBody>
+          <a:bodyPr lIns="0" tIns="0" rIns="0" bIns="0" anchor="t">
+            <a:noAutofit/>
+          </a:bodyPr>
+          <a:lstStyle/>
+          <a:p>
+            <a:pPr>
+              <a:spcAft>
+                <a:spcPts val="500"/>
+              </a:spcAft>
+              <a:defRPr sz="2100" b="0">
+                <a:solidFill>
+                  <a:srgbClr val="172F43"/>
+                </a:solidFill>
+                <a:latin typeface="Calibri"/>
+                <a:ea typeface="Calibri"/>
+                <a:cs typeface="Calibri"/>
+              </a:defRPr>
+            </a:pPr>
+            <a:r>
+              <a:rPr sz="1500" b="0">
+                <a:solidFill>
+                  <a:srgbClr val="172F43"/>
+                </a:solidFill>
+                <a:latin typeface="Calibri"/>
+                <a:ea typeface="Calibri"/>
+                <a:cs typeface="Calibri"/>
+              </a:rPr>
+              <a:t>En vinkel kan mätas i grader eller i radianer, som en längd i meter eller i fot. Ett helt varv är 360° eller 2π radianer (cirka 6,28). 1 radian är cirka 57°.</a:t>
+            </a:r>
+          </a:p>
+          <a:p>
+            <a:pPr>
+              <a:spcAft>
+                <a:spcPts val="500"/>
+              </a:spcAft>
+              <a:defRPr sz="2100" b="0">
+                <a:solidFill>
+                  <a:srgbClr val="172F43"/>
+                </a:solidFill>
+                <a:latin typeface="Calibri"/>
+                <a:ea typeface="Calibri"/>
+                <a:cs typeface="Calibri"/>
+              </a:defRPr>
+            </a:pPr>
+            <a:r>
+              <a:rPr sz="1500" b="0">
+                <a:solidFill>
+                  <a:srgbClr val="172F43"/>
+                </a:solidFill>
+                <a:latin typeface="Calibri"/>
+                <a:ea typeface="Calibri"/>
+                <a:cs typeface="Calibri"/>
+              </a:rPr>
+              <a:t>Radianer mäter sträckan som kanten på ett hjul med radien 1 har rullat. Ett halvt varv är π och ett kvarts varv π/2.</a:t>
+            </a:r>
+          </a:p>
+          <a:p>
+            <a:pPr>
+              <a:spcAft>
+                <a:spcPts val="500"/>
+              </a:spcAft>
+              <a:defRPr sz="2100" b="0">
+                <a:solidFill>
+                  <a:srgbClr val="172F43"/>
+                </a:solidFill>
+                <a:latin typeface="Calibri"/>
+                <a:ea typeface="Calibri"/>
+                <a:cs typeface="Calibri"/>
+              </a:defRPr>
+            </a:pPr>
+            <a:r>
+              <a:rPr sz="1500" b="0">
+                <a:solidFill>
+                  <a:srgbClr val="172F43"/>
+                </a:solidFill>
+                <a:latin typeface="Calibri"/>
+                <a:ea typeface="Calibri"/>
+                <a:cs typeface="Calibri"/>
+              </a:rPr>
+              <a:t>Generatorn vrids ett varv per period, alltså 2π · f · t radianer efter tiden t. Därför står räknaren i RAD när du räknar u(t) = û · sin(2π · f · t).</a:t>
+            </a:r>
+          </a:p>
+          <a:p>
+            <a:pPr>
+              <a:spcAft>
+                <a:spcPts val="500"/>
+              </a:spcAft>
+              <a:defRPr sz="2100" b="0">
+                <a:solidFill>
+                  <a:srgbClr val="172F43"/>
+                </a:solidFill>
+                <a:latin typeface="Calibri"/>
+                <a:ea typeface="Calibri"/>
+                <a:cs typeface="Calibri"/>
+              </a:defRPr>
+            </a:pPr>
+            <a:r>
+              <a:rPr sz="1500" b="0">
+                <a:solidFill>
+                  <a:srgbClr val="172F43"/>
+                </a:solidFill>
+                <a:latin typeface="Calibri"/>
+                <a:ea typeface="Calibri"/>
+                <a:cs typeface="Calibri"/>
+              </a:rPr>
+              <a:t>Fasvinklar i grader, som 90° eller φ = arctan(X/R), räknas i DEG. Snabbkoll: blir sin(90) = 1 står räknaren i DEG.</a:t>
+            </a:r>
+          </a:p>
+        </p:txBody>
+      </p:sp>
+      <p:sp>
+        <p:nvSpPr>
+          <p:cNvPr id="11" name="formula">
+            <a:extLst>
+              <a:ext uri="{FF2B5EF4-FFF2-40B4-BE49-F238E27FC236}">
+                <a16:creationId xmlns:a16="http://schemas.microsoft.com/office/drawing/2014/main" id="{A1C56A8B-AE69-44B9-B96A-9B246FD43181}"/>
+              </a:ext>
+            </a:extLst>
+          </p:cNvPr>
+          <p:cNvSpPr>
+            <a:spLocks noGrp="1"/>
+          </p:cNvSpPr>
+          <p:nvPr/>
+        </p:nvSpPr>
+        <p:spPr>
+          <a:xfrm>
+            <a:off x="762000" y="3250000"/>
+            <a:ext cx="7620000" cy="380000"/>
+          </a:xfrm>
+          <a:prstGeom prst="rect">
+            <a:avLst/>
+          </a:prstGeom>
+          <a:noFill/>
+          <a:ln w="0">
+            <a:noFill/>
+          </a:ln>
+        </p:spPr>
+        <p:txBody>
+          <a:bodyPr lIns="0" tIns="0" rIns="0" bIns="0" anchor="t">
+            <a:noAutofit/>
+          </a:bodyPr>
+          <a:lstStyle/>
+          <a:p>
+            <a:pPr>
+              <a:defRPr sz="2250" b="1">
+                <a:solidFill>
+                  <a:srgbClr val="064F91"/>
+                </a:solidFill>
+                <a:latin typeface="Calibri"/>
+                <a:ea typeface="Calibri"/>
+                <a:cs typeface="Calibri"/>
+              </a:defRPr>
+            </a:pPr>
+            <a:r>
+              <a:rPr sz="2250" b="1">
+                <a:solidFill>
+                  <a:srgbClr val="064F91"/>
+                </a:solidFill>
+                <a:latin typeface="Calibri"/>
+                <a:ea typeface="Calibri"/>
+                <a:cs typeface="Calibri"/>
+              </a:rPr>
+              <a:t>1 varv = 360° = 2π rad     1 rad ≈ 57°</a:t>
+            </a:r>
+          </a:p>
+        </p:txBody>
+      </p:sp>
+      <p:sp>
+        <p:nvSpPr>
+          <p:cNvPr id="12" name="section">
+            <a:extLst>
+              <a:ext uri="{FF2B5EF4-FFF2-40B4-BE49-F238E27FC236}">
+                <a16:creationId xmlns:a16="http://schemas.microsoft.com/office/drawing/2014/main" id="{77E6A15A-B27F-404F-A31E-CE18B0C88418}"/>
+              </a:ext>
+            </a:extLst>
+          </p:cNvPr>
+          <p:cNvSpPr>
+            <a:spLocks noGrp="1"/>
+          </p:cNvSpPr>
+          <p:nvPr/>
+        </p:nvSpPr>
+        <p:spPr>
+          <a:xfrm>
+            <a:off x="1809750" y="6419850"/>
+            <a:ext cx="4191000" cy="266700"/>
+          </a:xfrm>
+          <a:prstGeom prst="rect">
+            <a:avLst/>
+          </a:prstGeom>
+          <a:noFill/>
+          <a:ln w="0">
+            <a:noFill/>
+          </a:ln>
+        </p:spPr>
+        <p:txBody>
+          <a:bodyPr lIns="0" tIns="0" rIns="0" bIns="0" anchor="t">
+            <a:noAutofit/>
+          </a:bodyPr>
+          <a:lstStyle/>
+          <a:p>
+            <a:pPr>
+              <a:defRPr sz="1275" b="0">
+                <a:solidFill>
+                  <a:srgbClr val="FFFFFF"/>
+                </a:solidFill>
+                <a:latin typeface="Calibri"/>
+                <a:ea typeface="Calibri"/>
+                <a:cs typeface="Calibri"/>
+              </a:defRPr>
+            </a:pPr>
+            <a:r>
+              <a:rPr sz="1275" b="0">
+                <a:solidFill>
+                  <a:srgbClr val="FFFFFF"/>
+                </a:solidFill>
+                <a:latin typeface="Calibri"/>
+                <a:ea typeface="Calibri"/>
+                <a:cs typeface="Calibri"/>
+              </a:rPr>
+              <a:t>Grunddel</a:t>
+            </a:r>
+          </a:p>
+        </p:txBody>
+      </p:sp>
+      <p:sp>
+        <p:nvSpPr>
+          <p:cNvPr id="13" name="page">
+            <a:extLst>
+              <a:ext uri="{FF2B5EF4-FFF2-40B4-BE49-F238E27FC236}">
+                <a16:creationId xmlns:a16="http://schemas.microsoft.com/office/drawing/2014/main" id="{D18C590D-2246-402D-B65B-6D4082600B0A}"/>
+              </a:ext>
+            </a:extLst>
+          </p:cNvPr>
+          <p:cNvSpPr>
+            <a:spLocks noGrp="1"/>
+          </p:cNvSpPr>
+          <p:nvPr/>
+        </p:nvSpPr>
+        <p:spPr>
+          <a:xfrm>
+            <a:off x="8286750" y="6438900"/>
+            <a:ext cx="428625" cy="285750"/>
+          </a:xfrm>
+          <a:prstGeom prst="rect">
+            <a:avLst/>
+          </a:prstGeom>
+          <a:noFill/>
+          <a:ln w="0">
+            <a:noFill/>
+          </a:ln>
+        </p:spPr>
+        <p:txBody>
+          <a:bodyPr lIns="0" tIns="0" rIns="0" bIns="0" anchor="t">
+            <a:noAutofit/>
+          </a:bodyPr>
+          <a:lstStyle/>
+          <a:p>
+            <a:pPr>
+              <a:defRPr sz="1500" b="0">
+                <a:solidFill>
+                  <a:srgbClr val="FFFFFF"/>
+                </a:solidFill>
+                <a:latin typeface="Calibri"/>
+                <a:ea typeface="Calibri"/>
+                <a:cs typeface="Calibri"/>
+              </a:defRPr>
+            </a:pPr>
+            <a:r>
+              <a:rPr sz="1500" b="0">
+                <a:solidFill>
+                  <a:srgbClr val="FFFFFF"/>
+                </a:solidFill>
+                <a:latin typeface="Calibri"/>
+                <a:ea typeface="Calibri"/>
+                <a:cs typeface="Calibri"/>
+              </a:rPr>
+              <a:t>12</a:t>
+            </a:r>
+          </a:p>
+        </p:txBody>
+      </p:sp>
+      <p:pic>
+        <p:nvPicPr>
+          <p:cNvPr id="14" name="figur-radianer" descr="rad.png"/>
+          <p:cNvPicPr>
+            <a:picLocks noChangeAspect="1"/>
+          </p:cNvPicPr>
+          <p:nvPr/>
+        </p:nvPicPr>
+        <p:blipFill>
+          <a:blip r:embed="rId3"/>
+          <a:stretch>
+            <a:fillRect/>
+          </a:stretch>
+        </p:blipFill>
+        <p:spPr>
+          <a:xfrm>
+            <a:off x="2349778" y="1200000"/>
+            <a:ext cx="4444444" cy="2000000"/>
+          </a:xfrm>
+          <a:prstGeom prst="rect">
+            <a:avLst/>
+          </a:prstGeom>
+        </p:spPr>
+      </p:pic>
+    </p:spTree>
+  </p:cSld>
+  <p:clrMapOvr>
+    <a:masterClrMapping/>
+  </p:clrMapOvr>
 </p:sld>
 </file>
 

</xml_diff>

<commit_message>
Sjöskolan v40: resultat som QR-kod, namnet sist och slumpat D
Eleven får ett D som slumpas på enheten och skriver namnet först i slutet.
Svaren på inlämning uppgift 1-3, den guidade labbens protokoll och avbockade
övningar skickas som en QR-kod (Resultat.html). Lärarsidan Resultatkoder läser
koden med kamera, skärmbild eller länk och visar rätt och fel mot elevens D.
Måndagens pass 2 omplanerat med QR-koden sist.

Co-Authored-By: Claude Opus 5.5 <noreply@anthropic.com>
Claude-Session: https://claude.ai/code/session_011V9KjBb53XrDm23Dw58SH3
</commit_message>
<xml_diff>
--- a/sjoskolan/vecka-40/aktuell/v40_01_Sinusformad_vaxelspanning_elev.pptx
+++ b/sjoskolan/vecka-40/aktuell/v40_01_Sinusformad_vaxelspanning_elev.pptx
@@ -10793,6 +10793,438 @@
 </file>
 
 <file path=ppt/slides/slide12.xml><?xml version="1.0" encoding="utf-8"?>
+<p:sld xmlns:a="http://schemas.openxmlformats.org/drawingml/2006/main" xmlns:p="http://schemas.openxmlformats.org/presentationml/2006/main" xmlns:r="http://schemas.openxmlformats.org/officeDocument/2006/relationships">
+  <p:cSld>
+    <p:spTree>
+      <p:nvGrpSpPr>
+        <p:cNvPr id="1" name=""/>
+        <p:cNvGrpSpPr/>
+        <p:nvPr/>
+      </p:nvGrpSpPr>
+      <p:grpSpPr/>
+      <p:pic>
+        <p:nvPicPr>
+          <p:cNvPr id="2" name="Picture 1" descr="image.jpeg"/>
+          <p:cNvPicPr>
+            <a:picLocks noChangeAspect="1"/>
+          </p:cNvPicPr>
+          <p:nvPr/>
+        </p:nvPicPr>
+        <p:blipFill>
+          <a:blip r:embed="rId2"/>
+          <a:stretch>
+            <a:fillRect/>
+          </a:stretch>
+        </p:blipFill>
+        <p:spPr>
+          <a:xfrm>
+            <a:off x="0" y="6098791"/>
+            <a:ext cx="9144006" cy="763524"/>
+          </a:xfrm>
+          <a:prstGeom prst="rect">
+            <a:avLst/>
+          </a:prstGeom>
+        </p:spPr>
+      </p:pic>
+      <p:sp>
+        <p:nvSpPr>
+          <p:cNvPr id="9" name="title">
+            <a:extLst>
+              <a:ext uri="{FF2B5EF4-FFF2-40B4-BE49-F238E27FC236}">
+                <a16:creationId xmlns:a16="http://schemas.microsoft.com/office/drawing/2014/main" id="{768C19FF-3F32-4696-8C05-BA05833A4972}"/>
+              </a:ext>
+            </a:extLst>
+          </p:cNvPr>
+          <p:cNvSpPr>
+            <a:spLocks noGrp="1"/>
+          </p:cNvSpPr>
+          <p:nvPr/>
+        </p:nvSpPr>
+        <p:spPr>
+          <a:xfrm>
+            <a:off x="571500" y="428625"/>
+            <a:ext cx="8001000" cy="781050"/>
+          </a:xfrm>
+          <a:prstGeom prst="rect">
+            <a:avLst/>
+          </a:prstGeom>
+          <a:noFill/>
+          <a:ln w="0">
+            <a:noFill/>
+          </a:ln>
+        </p:spPr>
+        <p:txBody>
+          <a:bodyPr lIns="0" tIns="0" rIns="0" bIns="0" anchor="t">
+            <a:noAutofit/>
+          </a:bodyPr>
+          <a:lstStyle/>
+          <a:p>
+            <a:pPr>
+              <a:defRPr sz="3000" b="1">
+                <a:solidFill>
+                  <a:srgbClr val="111111"/>
+                </a:solidFill>
+                <a:latin typeface="Calibri"/>
+                <a:ea typeface="Calibri"/>
+                <a:cs typeface="Calibri"/>
+              </a:defRPr>
+            </a:pPr>
+            <a:r>
+              <a:rPr sz="3000" b="1">
+                <a:solidFill>
+                  <a:srgbClr val="111111"/>
+                </a:solidFill>
+                <a:latin typeface="Calibri"/>
+                <a:ea typeface="Calibri"/>
+                <a:cs typeface="Calibri"/>
+              </a:rPr>
+              <a:t>Radianer och grader</a:t>
+            </a:r>
+          </a:p>
+        </p:txBody>
+      </p:sp>
+      <p:sp>
+        <p:nvSpPr>
+          <p:cNvPr id="10" name="body">
+            <a:extLst>
+              <a:ext uri="{FF2B5EF4-FFF2-40B4-BE49-F238E27FC236}">
+                <a16:creationId xmlns:a16="http://schemas.microsoft.com/office/drawing/2014/main" id="{46CF4177-6412-4786-B0E5-13C9F10B86B1}"/>
+              </a:ext>
+            </a:extLst>
+          </p:cNvPr>
+          <p:cNvSpPr>
+            <a:spLocks noGrp="1"/>
+          </p:cNvSpPr>
+          <p:nvPr/>
+        </p:nvSpPr>
+        <p:spPr>
+          <a:xfrm>
+            <a:off x="762000" y="3680000"/>
+            <a:ext cx="7620000" cy="2650000"/>
+          </a:xfrm>
+          <a:prstGeom prst="rect">
+            <a:avLst/>
+          </a:prstGeom>
+          <a:noFill/>
+          <a:ln w="0">
+            <a:noFill/>
+          </a:ln>
+        </p:spPr>
+        <p:txBody>
+          <a:bodyPr lIns="0" tIns="0" rIns="0" bIns="0" anchor="t">
+            <a:noAutofit/>
+          </a:bodyPr>
+          <a:lstStyle/>
+          <a:p>
+            <a:pPr>
+              <a:spcAft>
+                <a:spcPts val="500"/>
+              </a:spcAft>
+              <a:defRPr sz="2100" b="0">
+                <a:solidFill>
+                  <a:srgbClr val="172F43"/>
+                </a:solidFill>
+                <a:latin typeface="Calibri"/>
+                <a:ea typeface="Calibri"/>
+                <a:cs typeface="Calibri"/>
+              </a:defRPr>
+            </a:pPr>
+            <a:r>
+              <a:rPr sz="1500" b="0">
+                <a:solidFill>
+                  <a:srgbClr val="172F43"/>
+                </a:solidFill>
+                <a:latin typeface="Calibri"/>
+                <a:ea typeface="Calibri"/>
+                <a:cs typeface="Calibri"/>
+              </a:rPr>
+              <a:t>En vinkel kan mätas i grader eller i radianer, som en längd i meter eller i fot. Ett helt varv är 360° eller 2π radianer (cirka 6,28). 1 radian är cirka 57°.</a:t>
+            </a:r>
+          </a:p>
+          <a:p>
+            <a:pPr>
+              <a:spcAft>
+                <a:spcPts val="500"/>
+              </a:spcAft>
+              <a:defRPr sz="2100" b="0">
+                <a:solidFill>
+                  <a:srgbClr val="172F43"/>
+                </a:solidFill>
+                <a:latin typeface="Calibri"/>
+                <a:ea typeface="Calibri"/>
+                <a:cs typeface="Calibri"/>
+              </a:defRPr>
+            </a:pPr>
+            <a:r>
+              <a:rPr sz="1500" b="0">
+                <a:solidFill>
+                  <a:srgbClr val="172F43"/>
+                </a:solidFill>
+                <a:latin typeface="Calibri"/>
+                <a:ea typeface="Calibri"/>
+                <a:cs typeface="Calibri"/>
+              </a:rPr>
+              <a:t>Radianer mäter sträckan som kanten på ett hjul med radien 1 har rullat. Ett halvt varv är π och ett kvarts varv π/2.</a:t>
+            </a:r>
+          </a:p>
+          <a:p>
+            <a:pPr>
+              <a:spcAft>
+                <a:spcPts val="500"/>
+              </a:spcAft>
+              <a:defRPr sz="2100" b="0">
+                <a:solidFill>
+                  <a:srgbClr val="172F43"/>
+                </a:solidFill>
+                <a:latin typeface="Calibri"/>
+                <a:ea typeface="Calibri"/>
+                <a:cs typeface="Calibri"/>
+              </a:defRPr>
+            </a:pPr>
+            <a:r>
+              <a:rPr sz="1500" b="0">
+                <a:solidFill>
+                  <a:srgbClr val="172F43"/>
+                </a:solidFill>
+                <a:latin typeface="Calibri"/>
+                <a:ea typeface="Calibri"/>
+                <a:cs typeface="Calibri"/>
+              </a:rPr>
+              <a:t>Generatorn vrids ett varv per period, alltså 2π · f · t radianer efter tiden t. Därför står räknaren i RAD när du räknar u(t) = û · sin(2π · f · t).</a:t>
+            </a:r>
+          </a:p>
+          <a:p>
+            <a:pPr>
+              <a:spcAft>
+                <a:spcPts val="500"/>
+              </a:spcAft>
+              <a:defRPr sz="2100" b="0">
+                <a:solidFill>
+                  <a:srgbClr val="172F43"/>
+                </a:solidFill>
+                <a:latin typeface="Calibri"/>
+                <a:ea typeface="Calibri"/>
+                <a:cs typeface="Calibri"/>
+              </a:defRPr>
+            </a:pPr>
+            <a:r>
+              <a:rPr sz="1500" b="0">
+                <a:solidFill>
+                  <a:srgbClr val="172F43"/>
+                </a:solidFill>
+                <a:latin typeface="Calibri"/>
+                <a:ea typeface="Calibri"/>
+                <a:cs typeface="Calibri"/>
+              </a:rPr>
+              <a:t>Fasvinklar i grader, som 90° eller φ = arctan(X/R), räknas i DEG. Snabbkoll: blir sin(90) = 1 står räknaren i DEG.</a:t>
+            </a:r>
+          </a:p>
+        </p:txBody>
+      </p:sp>
+      <p:sp>
+        <p:nvSpPr>
+          <p:cNvPr id="11" name="formula">
+            <a:extLst>
+              <a:ext uri="{FF2B5EF4-FFF2-40B4-BE49-F238E27FC236}">
+                <a16:creationId xmlns:a16="http://schemas.microsoft.com/office/drawing/2014/main" id="{A1C56A8B-AE69-44B9-B96A-9B246FD43181}"/>
+              </a:ext>
+            </a:extLst>
+          </p:cNvPr>
+          <p:cNvSpPr>
+            <a:spLocks noGrp="1"/>
+          </p:cNvSpPr>
+          <p:nvPr/>
+        </p:nvSpPr>
+        <p:spPr>
+          <a:xfrm>
+            <a:off x="762000" y="3250000"/>
+            <a:ext cx="7620000" cy="380000"/>
+          </a:xfrm>
+          <a:prstGeom prst="rect">
+            <a:avLst/>
+          </a:prstGeom>
+          <a:noFill/>
+          <a:ln w="0">
+            <a:noFill/>
+          </a:ln>
+        </p:spPr>
+        <p:txBody>
+          <a:bodyPr lIns="0" tIns="0" rIns="0" bIns="0" anchor="t">
+            <a:noAutofit/>
+          </a:bodyPr>
+          <a:lstStyle/>
+          <a:p>
+            <a:pPr>
+              <a:defRPr sz="2250" b="1">
+                <a:solidFill>
+                  <a:srgbClr val="064F91"/>
+                </a:solidFill>
+                <a:latin typeface="Calibri"/>
+                <a:ea typeface="Calibri"/>
+                <a:cs typeface="Calibri"/>
+              </a:defRPr>
+            </a:pPr>
+            <a:r>
+              <a:rPr sz="2250" b="1">
+                <a:solidFill>
+                  <a:srgbClr val="064F91"/>
+                </a:solidFill>
+                <a:latin typeface="Calibri"/>
+                <a:ea typeface="Calibri"/>
+                <a:cs typeface="Calibri"/>
+              </a:rPr>
+              <a:t>1 varv = 360° = 2π rad     1 rad ≈ 57°</a:t>
+            </a:r>
+          </a:p>
+        </p:txBody>
+      </p:sp>
+      <p:sp>
+        <p:nvSpPr>
+          <p:cNvPr id="12" name="section">
+            <a:extLst>
+              <a:ext uri="{FF2B5EF4-FFF2-40B4-BE49-F238E27FC236}">
+                <a16:creationId xmlns:a16="http://schemas.microsoft.com/office/drawing/2014/main" id="{77E6A15A-B27F-404F-A31E-CE18B0C88418}"/>
+              </a:ext>
+            </a:extLst>
+          </p:cNvPr>
+          <p:cNvSpPr>
+            <a:spLocks noGrp="1"/>
+          </p:cNvSpPr>
+          <p:nvPr/>
+        </p:nvSpPr>
+        <p:spPr>
+          <a:xfrm>
+            <a:off x="1809750" y="6419850"/>
+            <a:ext cx="4191000" cy="266700"/>
+          </a:xfrm>
+          <a:prstGeom prst="rect">
+            <a:avLst/>
+          </a:prstGeom>
+          <a:noFill/>
+          <a:ln w="0">
+            <a:noFill/>
+          </a:ln>
+        </p:spPr>
+        <p:txBody>
+          <a:bodyPr lIns="0" tIns="0" rIns="0" bIns="0" anchor="t">
+            <a:noAutofit/>
+          </a:bodyPr>
+          <a:lstStyle/>
+          <a:p>
+            <a:pPr>
+              <a:defRPr sz="1275" b="0">
+                <a:solidFill>
+                  <a:srgbClr val="FFFFFF"/>
+                </a:solidFill>
+                <a:latin typeface="Calibri"/>
+                <a:ea typeface="Calibri"/>
+                <a:cs typeface="Calibri"/>
+              </a:defRPr>
+            </a:pPr>
+            <a:r>
+              <a:rPr sz="1275" b="0">
+                <a:solidFill>
+                  <a:srgbClr val="FFFFFF"/>
+                </a:solidFill>
+                <a:latin typeface="Calibri"/>
+                <a:ea typeface="Calibri"/>
+                <a:cs typeface="Calibri"/>
+              </a:rPr>
+              <a:t>Grunddel</a:t>
+            </a:r>
+          </a:p>
+        </p:txBody>
+      </p:sp>
+      <p:sp>
+        <p:nvSpPr>
+          <p:cNvPr id="13" name="page">
+            <a:extLst>
+              <a:ext uri="{FF2B5EF4-FFF2-40B4-BE49-F238E27FC236}">
+                <a16:creationId xmlns:a16="http://schemas.microsoft.com/office/drawing/2014/main" id="{D18C590D-2246-402D-B65B-6D4082600B0A}"/>
+              </a:ext>
+            </a:extLst>
+          </p:cNvPr>
+          <p:cNvSpPr>
+            <a:spLocks noGrp="1"/>
+          </p:cNvSpPr>
+          <p:nvPr/>
+        </p:nvSpPr>
+        <p:spPr>
+          <a:xfrm>
+            <a:off x="8286750" y="6438900"/>
+            <a:ext cx="428625" cy="285750"/>
+          </a:xfrm>
+          <a:prstGeom prst="rect">
+            <a:avLst/>
+          </a:prstGeom>
+          <a:noFill/>
+          <a:ln w="0">
+            <a:noFill/>
+          </a:ln>
+        </p:spPr>
+        <p:txBody>
+          <a:bodyPr lIns="0" tIns="0" rIns="0" bIns="0" anchor="t">
+            <a:noAutofit/>
+          </a:bodyPr>
+          <a:lstStyle/>
+          <a:p>
+            <a:pPr>
+              <a:defRPr sz="1500" b="0">
+                <a:solidFill>
+                  <a:srgbClr val="FFFFFF"/>
+                </a:solidFill>
+                <a:latin typeface="Calibri"/>
+                <a:ea typeface="Calibri"/>
+                <a:cs typeface="Calibri"/>
+              </a:defRPr>
+            </a:pPr>
+            <a:r>
+              <a:rPr sz="1500" b="0">
+                <a:solidFill>
+                  <a:srgbClr val="FFFFFF"/>
+                </a:solidFill>
+                <a:latin typeface="Calibri"/>
+                <a:ea typeface="Calibri"/>
+                <a:cs typeface="Calibri"/>
+              </a:rPr>
+              <a:t>12</a:t>
+            </a:r>
+          </a:p>
+        </p:txBody>
+      </p:sp>
+      <p:pic>
+        <p:nvPicPr>
+          <p:cNvPr id="14" name="figur-radianer" descr="rad.png"/>
+          <p:cNvPicPr>
+            <a:picLocks noChangeAspect="1"/>
+          </p:cNvPicPr>
+          <p:nvPr/>
+        </p:nvPicPr>
+        <p:blipFill>
+          <a:blip r:embed="rId3"/>
+          <a:stretch>
+            <a:fillRect/>
+          </a:stretch>
+        </p:blipFill>
+        <p:spPr>
+          <a:xfrm>
+            <a:off x="2349778" y="1200000"/>
+            <a:ext cx="4444444" cy="2000000"/>
+          </a:xfrm>
+          <a:prstGeom prst="rect">
+            <a:avLst/>
+          </a:prstGeom>
+        </p:spPr>
+      </p:pic>
+    </p:spTree>
+  </p:cSld>
+  <p:clrMapOvr>
+    <a:masterClrMapping/>
+  </p:clrMapOvr>
+</p:sld>
+</file>
+
+<file path=ppt/slides/slide13.xml><?xml version="1.0" encoding="utf-8"?>
 <p:sld xmlns:p="http://schemas.openxmlformats.org/presentationml/2006/main">
   <p:cSld>
     <p:spTree>
@@ -11228,7 +11660,7 @@
 </p:sld>
 </file>
 
-<file path=ppt/slides/slide13.xml><?xml version="1.0" encoding="utf-8"?>
+<file path=ppt/slides/slide14.xml><?xml version="1.0" encoding="utf-8"?>
 <p:sld xmlns:p="http://schemas.openxmlformats.org/presentationml/2006/main">
   <p:cSld>
     <p:spTree>
@@ -11629,7 +12061,7 @@
 </p:sld>
 </file>
 
-<file path=ppt/slides/slide14.xml><?xml version="1.0" encoding="utf-8"?>
+<file path=ppt/slides/slide15.xml><?xml version="1.0" encoding="utf-8"?>
 <p:sld xmlns:p="http://schemas.openxmlformats.org/presentationml/2006/main">
   <p:cSld>
     <p:spTree>
@@ -12030,7 +12462,7 @@
 </p:sld>
 </file>
 
-<file path=ppt/slides/slide15.xml><?xml version="1.0" encoding="utf-8"?>
+<file path=ppt/slides/slide16.xml><?xml version="1.0" encoding="utf-8"?>
 <p:sld xmlns:p="http://schemas.openxmlformats.org/presentationml/2006/main">
   <p:cSld>
     <p:spTree>
@@ -12751,7 +13183,7 @@
 </p:sld>
 </file>
 
-<file path=ppt/slides/slide16.xml><?xml version="1.0" encoding="utf-8"?>
+<file path=ppt/slides/slide17.xml><?xml version="1.0" encoding="utf-8"?>
 <p:sld xmlns:p="http://schemas.openxmlformats.org/presentationml/2006/main">
   <p:cSld>
     <p:spTree>
@@ -13109,7 +13541,7 @@
 </p:sld>
 </file>
 
-<file path=ppt/slides/slide17.xml><?xml version="1.0" encoding="utf-8"?>
+<file path=ppt/slides/slide18.xml><?xml version="1.0" encoding="utf-8"?>
 <p:sld xmlns:p="http://schemas.openxmlformats.org/presentationml/2006/main">
   <p:cSld>
     <p:spTree>
@@ -13450,438 +13882,6 @@
       </p:ext>
     </p:extLst>
   </p:cSld>
-</p:sld>
-</file>
-
-<file path=ppt/slides/slide18.xml><?xml version="1.0" encoding="utf-8"?>
-<p:sld xmlns:a="http://schemas.openxmlformats.org/drawingml/2006/main" xmlns:p="http://schemas.openxmlformats.org/presentationml/2006/main" xmlns:r="http://schemas.openxmlformats.org/officeDocument/2006/relationships">
-  <p:cSld>
-    <p:spTree>
-      <p:nvGrpSpPr>
-        <p:cNvPr id="1" name=""/>
-        <p:cNvGrpSpPr/>
-        <p:nvPr/>
-      </p:nvGrpSpPr>
-      <p:grpSpPr/>
-      <p:pic>
-        <p:nvPicPr>
-          <p:cNvPr id="2" name="Picture 1" descr="image.jpeg"/>
-          <p:cNvPicPr>
-            <a:picLocks noChangeAspect="1"/>
-          </p:cNvPicPr>
-          <p:nvPr/>
-        </p:nvPicPr>
-        <p:blipFill>
-          <a:blip r:embed="rId2"/>
-          <a:stretch>
-            <a:fillRect/>
-          </a:stretch>
-        </p:blipFill>
-        <p:spPr>
-          <a:xfrm>
-            <a:off x="0" y="6098791"/>
-            <a:ext cx="9144006" cy="763524"/>
-          </a:xfrm>
-          <a:prstGeom prst="rect">
-            <a:avLst/>
-          </a:prstGeom>
-        </p:spPr>
-      </p:pic>
-      <p:sp>
-        <p:nvSpPr>
-          <p:cNvPr id="9" name="title">
-            <a:extLst>
-              <a:ext uri="{FF2B5EF4-FFF2-40B4-BE49-F238E27FC236}">
-                <a16:creationId xmlns:a16="http://schemas.microsoft.com/office/drawing/2014/main" id="{768C19FF-3F32-4696-8C05-BA05833A4972}"/>
-              </a:ext>
-            </a:extLst>
-          </p:cNvPr>
-          <p:cNvSpPr>
-            <a:spLocks noGrp="1"/>
-          </p:cNvSpPr>
-          <p:nvPr/>
-        </p:nvSpPr>
-        <p:spPr>
-          <a:xfrm>
-            <a:off x="571500" y="428625"/>
-            <a:ext cx="8001000" cy="781050"/>
-          </a:xfrm>
-          <a:prstGeom prst="rect">
-            <a:avLst/>
-          </a:prstGeom>
-          <a:noFill/>
-          <a:ln w="0">
-            <a:noFill/>
-          </a:ln>
-        </p:spPr>
-        <p:txBody>
-          <a:bodyPr lIns="0" tIns="0" rIns="0" bIns="0" anchor="t">
-            <a:noAutofit/>
-          </a:bodyPr>
-          <a:lstStyle/>
-          <a:p>
-            <a:pPr>
-              <a:defRPr sz="3000" b="1">
-                <a:solidFill>
-                  <a:srgbClr val="111111"/>
-                </a:solidFill>
-                <a:latin typeface="Calibri"/>
-                <a:ea typeface="Calibri"/>
-                <a:cs typeface="Calibri"/>
-              </a:defRPr>
-            </a:pPr>
-            <a:r>
-              <a:rPr sz="3000" b="1">
-                <a:solidFill>
-                  <a:srgbClr val="111111"/>
-                </a:solidFill>
-                <a:latin typeface="Calibri"/>
-                <a:ea typeface="Calibri"/>
-                <a:cs typeface="Calibri"/>
-              </a:rPr>
-              <a:t>Radianer och grader</a:t>
-            </a:r>
-          </a:p>
-        </p:txBody>
-      </p:sp>
-      <p:sp>
-        <p:nvSpPr>
-          <p:cNvPr id="10" name="body">
-            <a:extLst>
-              <a:ext uri="{FF2B5EF4-FFF2-40B4-BE49-F238E27FC236}">
-                <a16:creationId xmlns:a16="http://schemas.microsoft.com/office/drawing/2014/main" id="{46CF4177-6412-4786-B0E5-13C9F10B86B1}"/>
-              </a:ext>
-            </a:extLst>
-          </p:cNvPr>
-          <p:cNvSpPr>
-            <a:spLocks noGrp="1"/>
-          </p:cNvSpPr>
-          <p:nvPr/>
-        </p:nvSpPr>
-        <p:spPr>
-          <a:xfrm>
-            <a:off x="762000" y="3680000"/>
-            <a:ext cx="7620000" cy="2650000"/>
-          </a:xfrm>
-          <a:prstGeom prst="rect">
-            <a:avLst/>
-          </a:prstGeom>
-          <a:noFill/>
-          <a:ln w="0">
-            <a:noFill/>
-          </a:ln>
-        </p:spPr>
-        <p:txBody>
-          <a:bodyPr lIns="0" tIns="0" rIns="0" bIns="0" anchor="t">
-            <a:noAutofit/>
-          </a:bodyPr>
-          <a:lstStyle/>
-          <a:p>
-            <a:pPr>
-              <a:spcAft>
-                <a:spcPts val="500"/>
-              </a:spcAft>
-              <a:defRPr sz="2100" b="0">
-                <a:solidFill>
-                  <a:srgbClr val="172F43"/>
-                </a:solidFill>
-                <a:latin typeface="Calibri"/>
-                <a:ea typeface="Calibri"/>
-                <a:cs typeface="Calibri"/>
-              </a:defRPr>
-            </a:pPr>
-            <a:r>
-              <a:rPr sz="1500" b="0">
-                <a:solidFill>
-                  <a:srgbClr val="172F43"/>
-                </a:solidFill>
-                <a:latin typeface="Calibri"/>
-                <a:ea typeface="Calibri"/>
-                <a:cs typeface="Calibri"/>
-              </a:rPr>
-              <a:t>En vinkel kan mätas i grader eller i radianer, som en längd i meter eller i fot. Ett helt varv är 360° eller 2π radianer (cirka 6,28). 1 radian är cirka 57°.</a:t>
-            </a:r>
-          </a:p>
-          <a:p>
-            <a:pPr>
-              <a:spcAft>
-                <a:spcPts val="500"/>
-              </a:spcAft>
-              <a:defRPr sz="2100" b="0">
-                <a:solidFill>
-                  <a:srgbClr val="172F43"/>
-                </a:solidFill>
-                <a:latin typeface="Calibri"/>
-                <a:ea typeface="Calibri"/>
-                <a:cs typeface="Calibri"/>
-              </a:defRPr>
-            </a:pPr>
-            <a:r>
-              <a:rPr sz="1500" b="0">
-                <a:solidFill>
-                  <a:srgbClr val="172F43"/>
-                </a:solidFill>
-                <a:latin typeface="Calibri"/>
-                <a:ea typeface="Calibri"/>
-                <a:cs typeface="Calibri"/>
-              </a:rPr>
-              <a:t>Radianer mäter sträckan som kanten på ett hjul med radien 1 har rullat. Ett halvt varv är π och ett kvarts varv π/2.</a:t>
-            </a:r>
-          </a:p>
-          <a:p>
-            <a:pPr>
-              <a:spcAft>
-                <a:spcPts val="500"/>
-              </a:spcAft>
-              <a:defRPr sz="2100" b="0">
-                <a:solidFill>
-                  <a:srgbClr val="172F43"/>
-                </a:solidFill>
-                <a:latin typeface="Calibri"/>
-                <a:ea typeface="Calibri"/>
-                <a:cs typeface="Calibri"/>
-              </a:defRPr>
-            </a:pPr>
-            <a:r>
-              <a:rPr sz="1500" b="0">
-                <a:solidFill>
-                  <a:srgbClr val="172F43"/>
-                </a:solidFill>
-                <a:latin typeface="Calibri"/>
-                <a:ea typeface="Calibri"/>
-                <a:cs typeface="Calibri"/>
-              </a:rPr>
-              <a:t>Generatorn vrids ett varv per period, alltså 2π · f · t radianer efter tiden t. Därför står räknaren i RAD när du räknar u(t) = û · sin(2π · f · t).</a:t>
-            </a:r>
-          </a:p>
-          <a:p>
-            <a:pPr>
-              <a:spcAft>
-                <a:spcPts val="500"/>
-              </a:spcAft>
-              <a:defRPr sz="2100" b="0">
-                <a:solidFill>
-                  <a:srgbClr val="172F43"/>
-                </a:solidFill>
-                <a:latin typeface="Calibri"/>
-                <a:ea typeface="Calibri"/>
-                <a:cs typeface="Calibri"/>
-              </a:defRPr>
-            </a:pPr>
-            <a:r>
-              <a:rPr sz="1500" b="0">
-                <a:solidFill>
-                  <a:srgbClr val="172F43"/>
-                </a:solidFill>
-                <a:latin typeface="Calibri"/>
-                <a:ea typeface="Calibri"/>
-                <a:cs typeface="Calibri"/>
-              </a:rPr>
-              <a:t>Fasvinklar i grader, som 90° eller φ = arctan(X/R), räknas i DEG. Snabbkoll: blir sin(90) = 1 står räknaren i DEG.</a:t>
-            </a:r>
-          </a:p>
-        </p:txBody>
-      </p:sp>
-      <p:sp>
-        <p:nvSpPr>
-          <p:cNvPr id="11" name="formula">
-            <a:extLst>
-              <a:ext uri="{FF2B5EF4-FFF2-40B4-BE49-F238E27FC236}">
-                <a16:creationId xmlns:a16="http://schemas.microsoft.com/office/drawing/2014/main" id="{A1C56A8B-AE69-44B9-B96A-9B246FD43181}"/>
-              </a:ext>
-            </a:extLst>
-          </p:cNvPr>
-          <p:cNvSpPr>
-            <a:spLocks noGrp="1"/>
-          </p:cNvSpPr>
-          <p:nvPr/>
-        </p:nvSpPr>
-        <p:spPr>
-          <a:xfrm>
-            <a:off x="762000" y="3250000"/>
-            <a:ext cx="7620000" cy="380000"/>
-          </a:xfrm>
-          <a:prstGeom prst="rect">
-            <a:avLst/>
-          </a:prstGeom>
-          <a:noFill/>
-          <a:ln w="0">
-            <a:noFill/>
-          </a:ln>
-        </p:spPr>
-        <p:txBody>
-          <a:bodyPr lIns="0" tIns="0" rIns="0" bIns="0" anchor="t">
-            <a:noAutofit/>
-          </a:bodyPr>
-          <a:lstStyle/>
-          <a:p>
-            <a:pPr>
-              <a:defRPr sz="2250" b="1">
-                <a:solidFill>
-                  <a:srgbClr val="064F91"/>
-                </a:solidFill>
-                <a:latin typeface="Calibri"/>
-                <a:ea typeface="Calibri"/>
-                <a:cs typeface="Calibri"/>
-              </a:defRPr>
-            </a:pPr>
-            <a:r>
-              <a:rPr sz="2250" b="1">
-                <a:solidFill>
-                  <a:srgbClr val="064F91"/>
-                </a:solidFill>
-                <a:latin typeface="Calibri"/>
-                <a:ea typeface="Calibri"/>
-                <a:cs typeface="Calibri"/>
-              </a:rPr>
-              <a:t>1 varv = 360° = 2π rad     1 rad ≈ 57°</a:t>
-            </a:r>
-          </a:p>
-        </p:txBody>
-      </p:sp>
-      <p:sp>
-        <p:nvSpPr>
-          <p:cNvPr id="12" name="section">
-            <a:extLst>
-              <a:ext uri="{FF2B5EF4-FFF2-40B4-BE49-F238E27FC236}">
-                <a16:creationId xmlns:a16="http://schemas.microsoft.com/office/drawing/2014/main" id="{77E6A15A-B27F-404F-A31E-CE18B0C88418}"/>
-              </a:ext>
-            </a:extLst>
-          </p:cNvPr>
-          <p:cNvSpPr>
-            <a:spLocks noGrp="1"/>
-          </p:cNvSpPr>
-          <p:nvPr/>
-        </p:nvSpPr>
-        <p:spPr>
-          <a:xfrm>
-            <a:off x="1809750" y="6419850"/>
-            <a:ext cx="4191000" cy="266700"/>
-          </a:xfrm>
-          <a:prstGeom prst="rect">
-            <a:avLst/>
-          </a:prstGeom>
-          <a:noFill/>
-          <a:ln w="0">
-            <a:noFill/>
-          </a:ln>
-        </p:spPr>
-        <p:txBody>
-          <a:bodyPr lIns="0" tIns="0" rIns="0" bIns="0" anchor="t">
-            <a:noAutofit/>
-          </a:bodyPr>
-          <a:lstStyle/>
-          <a:p>
-            <a:pPr>
-              <a:defRPr sz="1275" b="0">
-                <a:solidFill>
-                  <a:srgbClr val="FFFFFF"/>
-                </a:solidFill>
-                <a:latin typeface="Calibri"/>
-                <a:ea typeface="Calibri"/>
-                <a:cs typeface="Calibri"/>
-              </a:defRPr>
-            </a:pPr>
-            <a:r>
-              <a:rPr sz="1275" b="0">
-                <a:solidFill>
-                  <a:srgbClr val="FFFFFF"/>
-                </a:solidFill>
-                <a:latin typeface="Calibri"/>
-                <a:ea typeface="Calibri"/>
-                <a:cs typeface="Calibri"/>
-              </a:rPr>
-              <a:t>Grunddel</a:t>
-            </a:r>
-          </a:p>
-        </p:txBody>
-      </p:sp>
-      <p:sp>
-        <p:nvSpPr>
-          <p:cNvPr id="13" name="page">
-            <a:extLst>
-              <a:ext uri="{FF2B5EF4-FFF2-40B4-BE49-F238E27FC236}">
-                <a16:creationId xmlns:a16="http://schemas.microsoft.com/office/drawing/2014/main" id="{D18C590D-2246-402D-B65B-6D4082600B0A}"/>
-              </a:ext>
-            </a:extLst>
-          </p:cNvPr>
-          <p:cNvSpPr>
-            <a:spLocks noGrp="1"/>
-          </p:cNvSpPr>
-          <p:nvPr/>
-        </p:nvSpPr>
-        <p:spPr>
-          <a:xfrm>
-            <a:off x="8286750" y="6438900"/>
-            <a:ext cx="428625" cy="285750"/>
-          </a:xfrm>
-          <a:prstGeom prst="rect">
-            <a:avLst/>
-          </a:prstGeom>
-          <a:noFill/>
-          <a:ln w="0">
-            <a:noFill/>
-          </a:ln>
-        </p:spPr>
-        <p:txBody>
-          <a:bodyPr lIns="0" tIns="0" rIns="0" bIns="0" anchor="t">
-            <a:noAutofit/>
-          </a:bodyPr>
-          <a:lstStyle/>
-          <a:p>
-            <a:pPr>
-              <a:defRPr sz="1500" b="0">
-                <a:solidFill>
-                  <a:srgbClr val="FFFFFF"/>
-                </a:solidFill>
-                <a:latin typeface="Calibri"/>
-                <a:ea typeface="Calibri"/>
-                <a:cs typeface="Calibri"/>
-              </a:defRPr>
-            </a:pPr>
-            <a:r>
-              <a:rPr sz="1500" b="0">
-                <a:solidFill>
-                  <a:srgbClr val="FFFFFF"/>
-                </a:solidFill>
-                <a:latin typeface="Calibri"/>
-                <a:ea typeface="Calibri"/>
-                <a:cs typeface="Calibri"/>
-              </a:rPr>
-              <a:t>12</a:t>
-            </a:r>
-          </a:p>
-        </p:txBody>
-      </p:sp>
-      <p:pic>
-        <p:nvPicPr>
-          <p:cNvPr id="14" name="figur-radianer" descr="rad.png"/>
-          <p:cNvPicPr>
-            <a:picLocks noChangeAspect="1"/>
-          </p:cNvPicPr>
-          <p:nvPr/>
-        </p:nvPicPr>
-        <p:blipFill>
-          <a:blip r:embed="rId3"/>
-          <a:stretch>
-            <a:fillRect/>
-          </a:stretch>
-        </p:blipFill>
-        <p:spPr>
-          <a:xfrm>
-            <a:off x="2349778" y="1200000"/>
-            <a:ext cx="4444444" cy="2000000"/>
-          </a:xfrm>
-          <a:prstGeom prst="rect">
-            <a:avLst/>
-          </a:prstGeom>
-        </p:spPr>
-      </p:pic>
-    </p:spTree>
-  </p:cSld>
-  <p:clrMapOvr>
-    <a:masterClrMapping/>
-  </p:clrMapOvr>
 </p:sld>
 </file>
 
@@ -17297,11 +17297,6 @@
             </a:r>
           </a:p>
           <a:p xmlns:a="http://schemas.openxmlformats.org/drawingml/2006/main">
-            <a:r>
-              <a:t/>
-            </a:r>
-          </a:p>
-          <a:p xmlns:a="http://schemas.openxmlformats.org/drawingml/2006/main">
             <a:pPr>
               <a:defRPr sz="2100" b="0">
                 <a:solidFill>
@@ -17312,6 +17307,18 @@
                 <a:cs typeface="Calibri"/>
               </a:defRPr>
             </a:pPr>
+          </a:p>
+          <a:p xmlns:a="http://schemas.openxmlformats.org/drawingml/2006/main">
+            <a:pPr>
+              <a:defRPr sz="2100" b="0">
+                <a:solidFill>
+                  <a:srgbClr val="172F43"/>
+                </a:solidFill>
+                <a:latin typeface="Calibri"/>
+                <a:ea typeface="Calibri"/>
+                <a:cs typeface="Calibri"/>
+              </a:defRPr>
+            </a:pPr>
             <a:r>
               <a:rPr sz="2100" b="0">
                 <a:solidFill>
@@ -17325,11 +17332,6 @@
             </a:r>
           </a:p>
           <a:p xmlns:a="http://schemas.openxmlformats.org/drawingml/2006/main">
-            <a:r>
-              <a:t/>
-            </a:r>
-          </a:p>
-          <a:p xmlns:a="http://schemas.openxmlformats.org/drawingml/2006/main">
             <a:pPr>
               <a:defRPr sz="2100" b="0">
                 <a:solidFill>
@@ -17340,6 +17342,18 @@
                 <a:cs typeface="Calibri"/>
               </a:defRPr>
             </a:pPr>
+          </a:p>
+          <a:p xmlns:a="http://schemas.openxmlformats.org/drawingml/2006/main">
+            <a:pPr>
+              <a:defRPr sz="2100" b="0">
+                <a:solidFill>
+                  <a:srgbClr val="172F43"/>
+                </a:solidFill>
+                <a:latin typeface="Calibri"/>
+                <a:ea typeface="Calibri"/>
+                <a:cs typeface="Calibri"/>
+              </a:defRPr>
+            </a:pPr>
             <a:r>
               <a:rPr sz="2100" b="0">
                 <a:solidFill>
@@ -17353,11 +17367,6 @@
             </a:r>
           </a:p>
           <a:p xmlns:a="http://schemas.openxmlformats.org/drawingml/2006/main">
-            <a:r>
-              <a:t/>
-            </a:r>
-          </a:p>
-          <a:p xmlns:a="http://schemas.openxmlformats.org/drawingml/2006/main">
             <a:pPr>
               <a:defRPr sz="2100" b="0">
                 <a:solidFill>
@@ -17368,6 +17377,18 @@
                 <a:cs typeface="Calibri"/>
               </a:defRPr>
             </a:pPr>
+          </a:p>
+          <a:p xmlns:a="http://schemas.openxmlformats.org/drawingml/2006/main">
+            <a:pPr>
+              <a:defRPr sz="2100" b="0">
+                <a:solidFill>
+                  <a:srgbClr val="172F43"/>
+                </a:solidFill>
+                <a:latin typeface="Calibri"/>
+                <a:ea typeface="Calibri"/>
+                <a:cs typeface="Calibri"/>
+              </a:defRPr>
+            </a:pPr>
             <a:r>
               <a:rPr sz="2100" b="0">
                 <a:solidFill>
@@ -17377,7 +17398,7 @@
                 <a:ea typeface="Calibri"/>
                 <a:cs typeface="Calibri"/>
               </a:rPr>
-              <a:t>Förklara: en hel period tar 16,7 ms. Frekvensen är 60 perioder per sekund. I labben gör du samma sak vid 50 Hz med din egen spänning, som räknas fram ur ditt namn.</a:t>
+              <a:t>Förklara: en hel period tar 16,7 ms. Frekvensen är 60 perioder per sekund. I labben gör du samma sak vid 50 Hz med din egen spänning, som räknas fram ur ditt D.</a:t>
             </a:r>
           </a:p>
         </p:txBody>

</xml_diff>

<commit_message>
Sjöskolan v40: Din tur-bilder och lärarmanus att läsa upp
Fem Din tur-bilder (poster EL-000863-867) i genomgången och presentationerna,
svaret visas vid klick. Manus med Säg, Fråga och Klicka till varje bild;
lärarkopiorna byggs med verktyg/larare/lararnoter.py. Bildnummer uppdaterade.

Co-Authored-By: Claude Opus 5.5 <noreply@anthropic.com>
Claude-Session: https://claude.ai/code/session_011V9KjBb53XrDm23Dw58SH3
</commit_message>
<xml_diff>
--- a/sjoskolan/vecka-40/aktuell/v40_01_Sinusformad_vaxelspanning_elev.pptx
+++ b/sjoskolan/vecka-40/aktuell/v40_01_Sinusformad_vaxelspanning_elev.pptx
@@ -15,12 +15,14 @@
     <p:sldId xmlns:r="http://schemas.openxmlformats.org/officeDocument/2006/relationships" id="260" r:id="R37196922c30d4f26"/>
     <p:sldId xmlns:r="http://schemas.openxmlformats.org/officeDocument/2006/relationships" id="261" r:id="Rc88fabc7885042b4"/>
     <p:sldId xmlns:r="http://schemas.openxmlformats.org/officeDocument/2006/relationships" id="262" r:id="R414c5a60960c4c3d"/>
+    <p:sldId xmlns:ns0="http://schemas.openxmlformats.org/officeDocument/2006/relationships" id="274" ns0:id="rId25"/>
     <p:sldId xmlns:r="http://schemas.openxmlformats.org/officeDocument/2006/relationships" id="263" r:id="Rff95a2faf0894a32"/>
     <p:sldId xmlns:r="http://schemas.openxmlformats.org/officeDocument/2006/relationships" id="264" r:id="Rf94a673741874e27"/>
     <p:sldId xmlns:r="http://schemas.openxmlformats.org/officeDocument/2006/relationships" id="265" r:id="Re494e029d18b4aa3"/>
     <p:sldId xmlns:r="http://schemas.openxmlformats.org/officeDocument/2006/relationships" id="266" r:id="R99e944cf199449e2"/>
     <p:sldId xmlns:ns0="http://schemas.openxmlformats.org/officeDocument/2006/relationships" id="273" ns0:id="rId24"/>
     <p:sldId xmlns:r="http://schemas.openxmlformats.org/officeDocument/2006/relationships" id="267" r:id="Rded5d88f7ce64e01"/>
+    <p:sldId xmlns:ns0="http://schemas.openxmlformats.org/officeDocument/2006/relationships" id="275" ns0:id="rId26"/>
     <p:sldId xmlns:r="http://schemas.openxmlformats.org/officeDocument/2006/relationships" id="268" r:id="R593f3e47b5ab4e70"/>
     <p:sldId xmlns:r="http://schemas.openxmlformats.org/officeDocument/2006/relationships" id="269" r:id="Rb6f09006fb244792"/>
     <p:sldId xmlns:r="http://schemas.openxmlformats.org/officeDocument/2006/relationships" id="270" r:id="Rbddf0e0b75874633"/>
@@ -10059,6 +10061,385 @@
       </p:grpSpPr>
       <p:pic>
         <p:nvPicPr>
+          <p:cNvPr id="13" name="Bildobjekt 2"/>
+          <p:cNvPicPr>
+            <a:picLocks xmlns:a="http://schemas.openxmlformats.org/drawingml/2006/main" noChangeAspect="1"/>
+          </p:cNvPicPr>
+          <p:nvPr/>
+        </p:nvPicPr>
+        <p:blipFill>
+          <a:blip xmlns:r="http://schemas.openxmlformats.org/officeDocument/2006/relationships" xmlns:a="http://schemas.openxmlformats.org/drawingml/2006/main" r:embed="R1d96d33ba7aa4bac"/>
+          <a:stretch xmlns:a="http://schemas.openxmlformats.org/drawingml/2006/main">
+            <a:fillRect l="0" t="0" r="0" b="0"/>
+          </a:stretch>
+        </p:blipFill>
+        <p:spPr>
+          <a:xfrm xmlns:a="http://schemas.openxmlformats.org/drawingml/2006/main">
+            <a:off x="0" y="6098791"/>
+            <a:ext cx="9144006" cy="763524"/>
+          </a:xfrm>
+          <a:prstGeom xmlns:a="http://schemas.openxmlformats.org/drawingml/2006/main" prst="rect">
+            <a:avLst/>
+          </a:prstGeom>
+        </p:spPr>
+      </p:pic>
+      <p:sp>
+        <p:nvSpPr>
+          <p:cNvPr id="9" name="title">
+            <a:extLst xmlns:a="http://schemas.openxmlformats.org/drawingml/2006/main">
+              <a:ext uri="{FF2B5EF4-FFF2-40B4-BE49-F238E27FC236}">
+                <a16:creationId xmlns:a16="http://schemas.microsoft.com/office/drawing/2014/main" id="{DABF7100-E82B-4D1C-B160-ABF3EC162748}"/>
+              </a:ext>
+            </a:extLst>
+          </p:cNvPr>
+          <p:cNvSpPr>
+            <a:spLocks xmlns:a="http://schemas.openxmlformats.org/drawingml/2006/main" noGrp="1"/>
+          </p:cNvSpPr>
+          <p:nvPr/>
+        </p:nvSpPr>
+        <p:spPr>
+          <a:xfrm xmlns:a="http://schemas.openxmlformats.org/drawingml/2006/main">
+            <a:off x="571500" y="428625"/>
+            <a:ext cx="8001000" cy="781050"/>
+          </a:xfrm>
+          <a:prstGeom xmlns:a="http://schemas.openxmlformats.org/drawingml/2006/main" prst="rect">
+            <a:avLst/>
+          </a:prstGeom>
+          <a:noFill xmlns:a="http://schemas.openxmlformats.org/drawingml/2006/main"/>
+          <a:ln xmlns:a="http://schemas.openxmlformats.org/drawingml/2006/main" w="0">
+            <a:noFill/>
+          </a:ln>
+        </p:spPr>
+        <p:txBody>
+          <a:bodyPr xmlns:a="http://schemas.openxmlformats.org/drawingml/2006/main" lIns="0" tIns="0" rIns="0" bIns="0" anchor="t">
+            <a:noAutofit/>
+          </a:bodyPr>
+          <a:lstStyle xmlns:a="http://schemas.openxmlformats.org/drawingml/2006/main"/>
+          <a:p xmlns:a="http://schemas.openxmlformats.org/drawingml/2006/main">
+            <a:pPr>
+              <a:defRPr sz="3000" b="1">
+                <a:solidFill>
+                  <a:srgbClr val="111111"/>
+                </a:solidFill>
+                <a:latin typeface="Calibri"/>
+                <a:ea typeface="Calibri"/>
+                <a:cs typeface="Calibri"/>
+              </a:defRPr>
+            </a:pPr>
+            <a:r>
+              <a:rPr sz="3000" b="1">
+                <a:solidFill>
+                  <a:srgbClr val="111111"/>
+                </a:solidFill>
+                <a:latin typeface="Calibri"/>
+                <a:ea typeface="Calibri"/>
+                <a:cs typeface="Calibri"/>
+              </a:rPr>
+              <a:t>En protokollrad</a:t>
+            </a:r>
+          </a:p>
+        </p:txBody>
+      </p:sp>
+      <p:sp>
+        <p:nvSpPr>
+          <p:cNvPr id="10" name="body">
+            <a:extLst xmlns:a="http://schemas.openxmlformats.org/drawingml/2006/main">
+              <a:ext uri="{FF2B5EF4-FFF2-40B4-BE49-F238E27FC236}">
+                <a16:creationId xmlns:a16="http://schemas.microsoft.com/office/drawing/2014/main" id="{FB38414D-923A-430C-90E5-1E98ADD2A321}"/>
+              </a:ext>
+            </a:extLst>
+          </p:cNvPr>
+          <p:cNvSpPr>
+            <a:spLocks xmlns:a="http://schemas.openxmlformats.org/drawingml/2006/main" noGrp="1"/>
+          </p:cNvSpPr>
+          <p:nvPr/>
+        </p:nvSpPr>
+        <p:spPr>
+          <a:xfrm xmlns:a="http://schemas.openxmlformats.org/drawingml/2006/main">
+            <a:off x="762000" y="1590675"/>
+            <a:ext cx="7620000" cy="3524250"/>
+          </a:xfrm>
+          <a:prstGeom xmlns:a="http://schemas.openxmlformats.org/drawingml/2006/main" prst="rect">
+            <a:avLst/>
+          </a:prstGeom>
+          <a:noFill xmlns:a="http://schemas.openxmlformats.org/drawingml/2006/main"/>
+          <a:ln xmlns:a="http://schemas.openxmlformats.org/drawingml/2006/main" w="0">
+            <a:noFill/>
+          </a:ln>
+        </p:spPr>
+        <p:txBody>
+          <a:bodyPr xmlns:a="http://schemas.openxmlformats.org/drawingml/2006/main" lIns="0" tIns="0" rIns="0" bIns="0" anchor="t">
+            <a:noAutofit/>
+          </a:bodyPr>
+          <a:lstStyle xmlns:a="http://schemas.openxmlformats.org/drawingml/2006/main"/>
+          <a:p xmlns:a="http://schemas.openxmlformats.org/drawingml/2006/main">
+            <a:pPr>
+              <a:defRPr sz="2100" b="0">
+                <a:solidFill>
+                  <a:srgbClr val="172F43"/>
+                </a:solidFill>
+                <a:latin typeface="Calibri"/>
+                <a:ea typeface="Calibri"/>
+                <a:cs typeface="Calibri"/>
+              </a:defRPr>
+            </a:pPr>
+            <a:r>
+              <a:rPr sz="2100" b="0">
+                <a:solidFill>
+                  <a:srgbClr val="172F43"/>
+                </a:solidFill>
+                <a:latin typeface="Calibri"/>
+                <a:ea typeface="Calibri"/>
+                <a:cs typeface="Calibri"/>
+              </a:rPr>
+              <a:t>Exempel från fartyget, 60 Hz. Förutsäg: T = 1 000/60 ≈ 16,7 ms.</a:t>
+            </a:r>
+          </a:p>
+          <a:p xmlns:a="http://schemas.openxmlformats.org/drawingml/2006/main">
+            <a:pPr>
+              <a:defRPr sz="2100" b="0">
+                <a:solidFill>
+                  <a:srgbClr val="172F43"/>
+                </a:solidFill>
+                <a:latin typeface="Calibri"/>
+                <a:ea typeface="Calibri"/>
+                <a:cs typeface="Calibri"/>
+              </a:defRPr>
+            </a:pPr>
+          </a:p>
+          <a:p xmlns:a="http://schemas.openxmlformats.org/drawingml/2006/main">
+            <a:pPr>
+              <a:defRPr sz="2100" b="0">
+                <a:solidFill>
+                  <a:srgbClr val="172F43"/>
+                </a:solidFill>
+                <a:latin typeface="Calibri"/>
+                <a:ea typeface="Calibri"/>
+                <a:cs typeface="Calibri"/>
+              </a:defRPr>
+            </a:pPr>
+            <a:r>
+              <a:rPr sz="2100" b="0">
+                <a:solidFill>
+                  <a:srgbClr val="172F43"/>
+                </a:solidFill>
+                <a:latin typeface="Calibri"/>
+                <a:ea typeface="Calibri"/>
+                <a:cs typeface="Calibri"/>
+              </a:rPr>
+              <a:t>Läs av och registrera 16,7 ms.</a:t>
+            </a:r>
+          </a:p>
+          <a:p xmlns:a="http://schemas.openxmlformats.org/drawingml/2006/main">
+            <a:pPr>
+              <a:defRPr sz="2100" b="0">
+                <a:solidFill>
+                  <a:srgbClr val="172F43"/>
+                </a:solidFill>
+                <a:latin typeface="Calibri"/>
+                <a:ea typeface="Calibri"/>
+                <a:cs typeface="Calibri"/>
+              </a:defRPr>
+            </a:pPr>
+          </a:p>
+          <a:p xmlns:a="http://schemas.openxmlformats.org/drawingml/2006/main">
+            <a:pPr>
+              <a:defRPr sz="2100" b="0">
+                <a:solidFill>
+                  <a:srgbClr val="172F43"/>
+                </a:solidFill>
+                <a:latin typeface="Calibri"/>
+                <a:ea typeface="Calibri"/>
+                <a:cs typeface="Calibri"/>
+              </a:defRPr>
+            </a:pPr>
+            <a:r>
+              <a:rPr sz="2100" b="0">
+                <a:solidFill>
+                  <a:srgbClr val="172F43"/>
+                </a:solidFill>
+                <a:latin typeface="Calibri"/>
+                <a:ea typeface="Calibri"/>
+                <a:cs typeface="Calibri"/>
+              </a:rPr>
+              <a:t>Jämför: avläst − förväntat = 0,0 ms.</a:t>
+            </a:r>
+          </a:p>
+          <a:p xmlns:a="http://schemas.openxmlformats.org/drawingml/2006/main">
+            <a:pPr>
+              <a:defRPr sz="2100" b="0">
+                <a:solidFill>
+                  <a:srgbClr val="172F43"/>
+                </a:solidFill>
+                <a:latin typeface="Calibri"/>
+                <a:ea typeface="Calibri"/>
+                <a:cs typeface="Calibri"/>
+              </a:defRPr>
+            </a:pPr>
+          </a:p>
+          <a:p xmlns:a="http://schemas.openxmlformats.org/drawingml/2006/main">
+            <a:pPr>
+              <a:defRPr sz="2100" b="0">
+                <a:solidFill>
+                  <a:srgbClr val="172F43"/>
+                </a:solidFill>
+                <a:latin typeface="Calibri"/>
+                <a:ea typeface="Calibri"/>
+                <a:cs typeface="Calibri"/>
+              </a:defRPr>
+            </a:pPr>
+            <a:r>
+              <a:rPr sz="2100" b="0">
+                <a:solidFill>
+                  <a:srgbClr val="172F43"/>
+                </a:solidFill>
+                <a:latin typeface="Calibri"/>
+                <a:ea typeface="Calibri"/>
+                <a:cs typeface="Calibri"/>
+              </a:rPr>
+              <a:t>Förklara: en hel period tar 16,7 ms. Frekvensen är 60 perioder per sekund. I labben gör du samma sak vid 50 Hz med din egen spänning, som räknas fram ur ditt D.</a:t>
+            </a:r>
+          </a:p>
+        </p:txBody>
+      </p:sp>
+      <p:sp>
+        <p:nvSpPr>
+          <p:cNvPr id="11" name="section">
+            <a:extLst xmlns:a="http://schemas.openxmlformats.org/drawingml/2006/main">
+              <a:ext uri="{FF2B5EF4-FFF2-40B4-BE49-F238E27FC236}">
+                <a16:creationId xmlns:a16="http://schemas.microsoft.com/office/drawing/2014/main" id="{7860C59D-1395-4123-B438-378564C342E8}"/>
+              </a:ext>
+            </a:extLst>
+          </p:cNvPr>
+          <p:cNvSpPr>
+            <a:spLocks xmlns:a="http://schemas.openxmlformats.org/drawingml/2006/main" noGrp="1"/>
+          </p:cNvSpPr>
+          <p:nvPr/>
+        </p:nvSpPr>
+        <p:spPr>
+          <a:xfrm xmlns:a="http://schemas.openxmlformats.org/drawingml/2006/main">
+            <a:off x="1809750" y="6419850"/>
+            <a:ext cx="4191000" cy="266700"/>
+          </a:xfrm>
+          <a:prstGeom xmlns:a="http://schemas.openxmlformats.org/drawingml/2006/main" prst="rect">
+            <a:avLst/>
+          </a:prstGeom>
+          <a:noFill xmlns:a="http://schemas.openxmlformats.org/drawingml/2006/main"/>
+          <a:ln xmlns:a="http://schemas.openxmlformats.org/drawingml/2006/main" w="0">
+            <a:noFill/>
+          </a:ln>
+        </p:spPr>
+        <p:txBody>
+          <a:bodyPr xmlns:a="http://schemas.openxmlformats.org/drawingml/2006/main" lIns="0" tIns="0" rIns="0" bIns="0" anchor="t">
+            <a:noAutofit/>
+          </a:bodyPr>
+          <a:lstStyle xmlns:a="http://schemas.openxmlformats.org/drawingml/2006/main"/>
+          <a:p xmlns:a="http://schemas.openxmlformats.org/drawingml/2006/main">
+            <a:pPr>
+              <a:defRPr sz="1275" b="0">
+                <a:solidFill>
+                  <a:srgbClr val="FFFFFF"/>
+                </a:solidFill>
+                <a:latin typeface="Calibri"/>
+                <a:ea typeface="Calibri"/>
+                <a:cs typeface="Calibri"/>
+              </a:defRPr>
+            </a:pPr>
+            <a:r>
+              <a:rPr sz="1275" b="0">
+                <a:solidFill>
+                  <a:srgbClr val="FFFFFF"/>
+                </a:solidFill>
+                <a:latin typeface="Calibri"/>
+                <a:ea typeface="Calibri"/>
+                <a:cs typeface="Calibri"/>
+              </a:rPr>
+              <a:t>Grunddel</a:t>
+            </a:r>
+          </a:p>
+        </p:txBody>
+      </p:sp>
+      <p:sp>
+        <p:nvSpPr>
+          <p:cNvPr id="12" name="page">
+            <a:extLst xmlns:a="http://schemas.openxmlformats.org/drawingml/2006/main">
+              <a:ext uri="{FF2B5EF4-FFF2-40B4-BE49-F238E27FC236}">
+                <a16:creationId xmlns:a16="http://schemas.microsoft.com/office/drawing/2014/main" id="{B016A708-78DC-4921-9CF0-4776568457B4}"/>
+              </a:ext>
+            </a:extLst>
+          </p:cNvPr>
+          <p:cNvSpPr>
+            <a:spLocks xmlns:a="http://schemas.openxmlformats.org/drawingml/2006/main" noGrp="1"/>
+          </p:cNvSpPr>
+          <p:nvPr/>
+        </p:nvSpPr>
+        <p:spPr>
+          <a:xfrm xmlns:a="http://schemas.openxmlformats.org/drawingml/2006/main">
+            <a:off x="8286750" y="6438900"/>
+            <a:ext cx="428625" cy="285750"/>
+          </a:xfrm>
+          <a:prstGeom xmlns:a="http://schemas.openxmlformats.org/drawingml/2006/main" prst="rect">
+            <a:avLst/>
+          </a:prstGeom>
+          <a:noFill xmlns:a="http://schemas.openxmlformats.org/drawingml/2006/main"/>
+          <a:ln xmlns:a="http://schemas.openxmlformats.org/drawingml/2006/main" w="0">
+            <a:noFill/>
+          </a:ln>
+        </p:spPr>
+        <p:txBody>
+          <a:bodyPr xmlns:a="http://schemas.openxmlformats.org/drawingml/2006/main" lIns="0" tIns="0" rIns="0" bIns="0" anchor="t">
+            <a:noAutofit/>
+          </a:bodyPr>
+          <a:lstStyle xmlns:a="http://schemas.openxmlformats.org/drawingml/2006/main"/>
+          <a:p xmlns:a="http://schemas.openxmlformats.org/drawingml/2006/main">
+            <a:pPr>
+              <a:defRPr sz="1500" b="0">
+                <a:solidFill>
+                  <a:srgbClr val="FFFFFF"/>
+                </a:solidFill>
+                <a:latin typeface="Calibri"/>
+                <a:ea typeface="Calibri"/>
+                <a:cs typeface="Calibri"/>
+              </a:defRPr>
+            </a:pPr>
+            <a:r>
+              <a:rPr sz="1500" b="0">
+                <a:solidFill>
+                  <a:srgbClr val="FFFFFF"/>
+                </a:solidFill>
+                <a:latin typeface="Calibri"/>
+                <a:ea typeface="Calibri"/>
+                <a:cs typeface="Calibri"/>
+              </a:rPr>
+              <a:t>10</a:t>
+            </a:r>
+          </a:p>
+        </p:txBody>
+      </p:sp>
+    </p:spTree>
+    <p:extLst>
+      <p:ext uri="{BB962C8B-B14F-4D97-AF65-F5344CB8AC3E}">
+        <p14:creationId xmlns:p14="http://schemas.microsoft.com/office/powerpoint/2010/main" val="2747996220"/>
+      </p:ext>
+    </p:extLst>
+  </p:cSld>
+</p:sld>
+</file>
+
+<file path=ppt/slides/slide11.xml><?xml version="1.0" encoding="utf-8"?>
+<p:sld xmlns:p="http://schemas.openxmlformats.org/presentationml/2006/main">
+  <p:cSld>
+    <p:spTree>
+      <p:nvGrpSpPr>
+        <p:cNvPr id="1" name=""/>
+        <p:cNvGrpSpPr/>
+        <p:nvPr/>
+      </p:nvGrpSpPr>
+      <p:grpSpPr>
+        <a:xfrm xmlns:a="http://schemas.openxmlformats.org/drawingml/2006/main"/>
+      </p:grpSpPr>
+      <p:pic>
+        <p:nvPicPr>
           <p:cNvPr id="14" name="Bildobjekt 2"/>
           <p:cNvPicPr>
             <a:picLocks xmlns:a="http://schemas.openxmlformats.org/drawingml/2006/main" noChangeAspect="1"/>
@@ -10376,7 +10757,7 @@
                 <a:ea typeface="Calibri"/>
                 <a:cs typeface="Calibri"/>
               </a:rPr>
-              <a:t>10</a:t>
+              <a:t>11</a:t>
             </a:r>
           </a:p>
         </p:txBody>
@@ -10391,7 +10772,7 @@
 </p:sld>
 </file>
 
-<file path=ppt/slides/slide11.xml><?xml version="1.0" encoding="utf-8"?>
+<file path=ppt/slides/slide12.xml><?xml version="1.0" encoding="utf-8"?>
 <p:sld xmlns:p="http://schemas.openxmlformats.org/presentationml/2006/main">
   <p:cSld>
     <p:spTree>
@@ -10777,7 +11158,7 @@
                 <a:ea typeface="Calibri"/>
                 <a:cs typeface="Calibri"/>
               </a:rPr>
-              <a:t>11</a:t>
+              <a:t>12</a:t>
             </a:r>
           </a:p>
         </p:txBody>
@@ -10792,7 +11173,7 @@
 </p:sld>
 </file>
 
-<file path=ppt/slides/slide12.xml><?xml version="1.0" encoding="utf-8"?>
+<file path=ppt/slides/slide13.xml><?xml version="1.0" encoding="utf-8"?>
 <p:sld xmlns:a="http://schemas.openxmlformats.org/drawingml/2006/main" xmlns:p="http://schemas.openxmlformats.org/presentationml/2006/main" xmlns:r="http://schemas.openxmlformats.org/officeDocument/2006/relationships">
   <p:cSld>
     <p:spTree>
@@ -11187,7 +11568,7 @@
                 <a:ea typeface="Calibri"/>
                 <a:cs typeface="Calibri"/>
               </a:rPr>
-              <a:t>12</a:t>
+              <a:t>13</a:t>
             </a:r>
           </a:p>
         </p:txBody>
@@ -11224,7 +11605,7 @@
 </p:sld>
 </file>
 
-<file path=ppt/slides/slide13.xml><?xml version="1.0" encoding="utf-8"?>
+<file path=ppt/slides/slide14.xml><?xml version="1.0" encoding="utf-8"?>
 <p:sld xmlns:p="http://schemas.openxmlformats.org/presentationml/2006/main">
   <p:cSld>
     <p:spTree>
@@ -11645,7 +12026,7 @@
                 <a:ea typeface="Calibri"/>
                 <a:cs typeface="Calibri"/>
               </a:rPr>
-              <a:t>13</a:t>
+              <a:t>14</a:t>
             </a:r>
           </a:p>
         </p:txBody>
@@ -11660,7 +12041,473 @@
 </p:sld>
 </file>
 
-<file path=ppt/slides/slide14.xml><?xml version="1.0" encoding="utf-8"?>
+<file path=ppt/slides/slide15.xml><?xml version="1.0" encoding="utf-8"?>
+<p:sld xmlns:a="http://schemas.openxmlformats.org/drawingml/2006/main" xmlns:p="http://schemas.openxmlformats.org/presentationml/2006/main" xmlns:r="http://schemas.openxmlformats.org/officeDocument/2006/relationships">
+  <p:cSld>
+    <p:spTree>
+      <p:nvGrpSpPr>
+        <p:cNvPr id="1" name=""/>
+        <p:cNvGrpSpPr/>
+        <p:nvPr/>
+      </p:nvGrpSpPr>
+      <p:grpSpPr/>
+      <p:pic>
+        <p:nvPicPr>
+          <p:cNvPr id="2" name="Picture 1" descr="image.jpeg"/>
+          <p:cNvPicPr>
+            <a:picLocks noChangeAspect="1"/>
+          </p:cNvPicPr>
+          <p:nvPr/>
+        </p:nvPicPr>
+        <p:blipFill>
+          <a:blip r:embed="rId2"/>
+          <a:stretch>
+            <a:fillRect/>
+          </a:stretch>
+        </p:blipFill>
+        <p:spPr>
+          <a:xfrm>
+            <a:off x="0" y="6098791"/>
+            <a:ext cx="9144006" cy="763524"/>
+          </a:xfrm>
+          <a:prstGeom prst="rect">
+            <a:avLst/>
+          </a:prstGeom>
+        </p:spPr>
+      </p:pic>
+      <p:sp>
+        <p:nvSpPr>
+          <p:cNvPr id="9" name="title">
+            <a:extLst>
+              <a:ext uri="{FF2B5EF4-FFF2-40B4-BE49-F238E27FC236}">
+                <a16:creationId xmlns:a16="http://schemas.microsoft.com/office/drawing/2014/main" id="{7962C62C-109D-441A-9E4A-67632189D64C}"/>
+              </a:ext>
+            </a:extLst>
+          </p:cNvPr>
+          <p:cNvSpPr>
+            <a:spLocks noGrp="1"/>
+          </p:cNvSpPr>
+          <p:nvPr/>
+        </p:nvSpPr>
+        <p:spPr>
+          <a:xfrm>
+            <a:off x="571500" y="428625"/>
+            <a:ext cx="8001000" cy="781050"/>
+          </a:xfrm>
+          <a:prstGeom prst="rect">
+            <a:avLst/>
+          </a:prstGeom>
+          <a:noFill/>
+          <a:ln w="0">
+            <a:noFill/>
+          </a:ln>
+        </p:spPr>
+        <p:txBody>
+          <a:bodyPr lIns="0" tIns="0" rIns="0" bIns="0" anchor="t">
+            <a:noAutofit/>
+          </a:bodyPr>
+          <a:lstStyle/>
+          <a:p>
+            <a:pPr>
+              <a:defRPr sz="3000" b="1">
+                <a:solidFill>
+                  <a:srgbClr val="111111"/>
+                </a:solidFill>
+                <a:latin typeface="Calibri"/>
+                <a:ea typeface="Calibri"/>
+                <a:cs typeface="Calibri"/>
+              </a:defRPr>
+            </a:pPr>
+            <a:r>
+              <a:rPr sz="3000" b="1">
+                <a:solidFill>
+                  <a:srgbClr val="111111"/>
+                </a:solidFill>
+                <a:latin typeface="Calibri"/>
+                <a:ea typeface="Calibri"/>
+                <a:cs typeface="Calibri"/>
+              </a:rPr>
+              <a:t>Din tur: momentanvärde i vägguttaget</a:t>
+            </a:r>
+          </a:p>
+        </p:txBody>
+      </p:sp>
+      <p:sp>
+        <p:nvSpPr>
+          <p:cNvPr id="10" name="body">
+            <a:extLst>
+              <a:ext uri="{FF2B5EF4-FFF2-40B4-BE49-F238E27FC236}">
+                <a16:creationId xmlns:a16="http://schemas.microsoft.com/office/drawing/2014/main" id="{8BAD7154-9510-4220-A4BE-FE50A6F6BFC1}"/>
+              </a:ext>
+            </a:extLst>
+          </p:cNvPr>
+          <p:cNvSpPr>
+            <a:spLocks noGrp="1"/>
+          </p:cNvSpPr>
+          <p:nvPr/>
+        </p:nvSpPr>
+        <p:spPr>
+          <a:xfrm>
+            <a:off x="762000" y="1330000"/>
+            <a:ext cx="7620000" cy="560000"/>
+          </a:xfrm>
+          <a:prstGeom prst="rect">
+            <a:avLst/>
+          </a:prstGeom>
+          <a:noFill/>
+          <a:ln w="0">
+            <a:noFill/>
+          </a:ln>
+        </p:spPr>
+        <p:txBody>
+          <a:bodyPr lIns="0" tIns="0" rIns="0" bIns="0" anchor="t">
+            <a:noAutofit/>
+          </a:bodyPr>
+          <a:lstStyle/>
+          <a:p>
+            <a:pPr>
+              <a:defRPr sz="2100" b="0">
+                <a:solidFill>
+                  <a:srgbClr val="172F43"/>
+                </a:solidFill>
+                <a:latin typeface="Calibri"/>
+                <a:ea typeface="Calibri"/>
+                <a:cs typeface="Calibri"/>
+              </a:defRPr>
+            </a:pPr>
+            <a:r>
+              <a:rPr sz="1600" b="0">
+                <a:solidFill>
+                  <a:srgbClr val="4D6579"/>
+                </a:solidFill>
+                <a:latin typeface="Calibri"/>
+                <a:ea typeface="Calibri"/>
+                <a:cs typeface="Calibri"/>
+              </a:rPr>
+              <a:t>Räkna på papper eller miniwhiteboard. Titta på svaret först när du har ett eget.</a:t>
+            </a:r>
+          </a:p>
+        </p:txBody>
+      </p:sp>
+      <p:sp>
+        <p:nvSpPr>
+          <p:cNvPr id="11" name="check">
+            <a:extLst>
+              <a:ext uri="{FF2B5EF4-FFF2-40B4-BE49-F238E27FC236}">
+                <a16:creationId xmlns:a16="http://schemas.microsoft.com/office/drawing/2014/main" id="{B70753C7-C3B8-4F47-B62B-24102E19EEBC}"/>
+              </a:ext>
+            </a:extLst>
+          </p:cNvPr>
+          <p:cNvSpPr>
+            <a:spLocks noGrp="1"/>
+          </p:cNvSpPr>
+          <p:nvPr/>
+        </p:nvSpPr>
+        <p:spPr>
+          <a:xfrm>
+            <a:off x="762000" y="1950000"/>
+            <a:ext cx="7620000" cy="1900000"/>
+          </a:xfrm>
+          <a:prstGeom prst="rect">
+            <a:avLst/>
+          </a:prstGeom>
+          <a:noFill/>
+          <a:ln w="0">
+            <a:noFill/>
+          </a:ln>
+        </p:spPr>
+        <p:txBody>
+          <a:bodyPr lIns="0" tIns="0" rIns="0" bIns="0" anchor="t" wrap="square">
+            <a:noAutofit/>
+          </a:bodyPr>
+          <a:lstStyle/>
+          <a:p>
+            <a:pPr>
+              <a:defRPr sz="1725" b="1">
+                <a:solidFill>
+                  <a:srgbClr val="064F91"/>
+                </a:solidFill>
+                <a:latin typeface="Calibri"/>
+                <a:ea typeface="Calibri"/>
+                <a:cs typeface="Calibri"/>
+              </a:defRPr>
+            </a:pPr>
+            <a:r>
+              <a:rPr sz="2600" b="1">
+                <a:solidFill>
+                  <a:srgbClr val="163248"/>
+                </a:solidFill>
+                <a:latin typeface="Calibri"/>
+                <a:ea typeface="Calibri"/>
+                <a:cs typeface="Calibri"/>
+              </a:rPr>
+              <a:t>Vägguttaget hemma: U = 230 V RMS och f = 50 Hz. Hur stor är spänningen u efter t = 3,0 ms? Räknaren ska stå i RAD.</a:t>
+            </a:r>
+          </a:p>
+        </p:txBody>
+      </p:sp>
+      <p:sp>
+        <p:nvSpPr>
+          <p:cNvPr id="12" name="section">
+            <a:extLst>
+              <a:ext uri="{FF2B5EF4-FFF2-40B4-BE49-F238E27FC236}">
+                <a16:creationId xmlns:a16="http://schemas.microsoft.com/office/drawing/2014/main" id="{9B1C64DD-2273-42DB-B85F-C12446C1D3B3}"/>
+              </a:ext>
+            </a:extLst>
+          </p:cNvPr>
+          <p:cNvSpPr>
+            <a:spLocks noGrp="1"/>
+          </p:cNvSpPr>
+          <p:nvPr/>
+        </p:nvSpPr>
+        <p:spPr>
+          <a:xfrm>
+            <a:off x="1809750" y="6419850"/>
+            <a:ext cx="4191000" cy="266700"/>
+          </a:xfrm>
+          <a:prstGeom prst="rect">
+            <a:avLst/>
+          </a:prstGeom>
+          <a:noFill/>
+          <a:ln w="0">
+            <a:noFill/>
+          </a:ln>
+        </p:spPr>
+        <p:txBody>
+          <a:bodyPr lIns="0" tIns="0" rIns="0" bIns="0" anchor="t">
+            <a:noAutofit/>
+          </a:bodyPr>
+          <a:lstStyle/>
+          <a:p>
+            <a:pPr>
+              <a:defRPr sz="1275" b="0">
+                <a:solidFill>
+                  <a:srgbClr val="FFFFFF"/>
+                </a:solidFill>
+                <a:latin typeface="Calibri"/>
+                <a:ea typeface="Calibri"/>
+                <a:cs typeface="Calibri"/>
+              </a:defRPr>
+            </a:pPr>
+            <a:r>
+              <a:rPr sz="1275" b="0">
+                <a:solidFill>
+                  <a:srgbClr val="FFFFFF"/>
+                </a:solidFill>
+                <a:latin typeface="Calibri"/>
+                <a:ea typeface="Calibri"/>
+                <a:cs typeface="Calibri"/>
+              </a:rPr>
+              <a:t>Fördjupning</a:t>
+            </a:r>
+          </a:p>
+        </p:txBody>
+      </p:sp>
+      <p:sp>
+        <p:nvSpPr>
+          <p:cNvPr id="13" name="page">
+            <a:extLst>
+              <a:ext uri="{FF2B5EF4-FFF2-40B4-BE49-F238E27FC236}">
+                <a16:creationId xmlns:a16="http://schemas.microsoft.com/office/drawing/2014/main" id="{56C39C5B-E2A3-490F-AB9A-BF7FF13842D6}"/>
+              </a:ext>
+            </a:extLst>
+          </p:cNvPr>
+          <p:cNvSpPr>
+            <a:spLocks noGrp="1"/>
+          </p:cNvSpPr>
+          <p:nvPr/>
+        </p:nvSpPr>
+        <p:spPr>
+          <a:xfrm>
+            <a:off x="8286750" y="6438900"/>
+            <a:ext cx="428625" cy="285750"/>
+          </a:xfrm>
+          <a:prstGeom prst="rect">
+            <a:avLst/>
+          </a:prstGeom>
+          <a:noFill/>
+          <a:ln w="0">
+            <a:noFill/>
+          </a:ln>
+        </p:spPr>
+        <p:txBody>
+          <a:bodyPr lIns="0" tIns="0" rIns="0" bIns="0" anchor="t">
+            <a:noAutofit/>
+          </a:bodyPr>
+          <a:lstStyle/>
+          <a:p>
+            <a:pPr>
+              <a:defRPr sz="1500" b="0">
+                <a:solidFill>
+                  <a:srgbClr val="FFFFFF"/>
+                </a:solidFill>
+                <a:latin typeface="Calibri"/>
+                <a:ea typeface="Calibri"/>
+                <a:cs typeface="Calibri"/>
+              </a:defRPr>
+            </a:pPr>
+            <a:r>
+              <a:rPr sz="1500" b="0">
+                <a:solidFill>
+                  <a:srgbClr val="FFFFFF"/>
+                </a:solidFill>
+                <a:latin typeface="Calibri"/>
+                <a:ea typeface="Calibri"/>
+                <a:cs typeface="Calibri"/>
+              </a:rPr>
+              <a:t>15</a:t>
+            </a:r>
+          </a:p>
+        </p:txBody>
+      </p:sp>
+      <p:sp>
+        <p:nvSpPr>
+          <p:cNvPr id="14" name="svar">
+            <a:extLst>
+              <a:ext uri="{FF2B5EF4-FFF2-40B4-BE49-F238E27FC236}">
+                <a16:creationId xmlns:a16="http://schemas.microsoft.com/office/drawing/2014/main" id="{B70753C7-C3B8-4F47-B62B-24102E19EEBC}"/>
+              </a:ext>
+            </a:extLst>
+          </p:cNvPr>
+          <p:cNvSpPr>
+            <a:spLocks noGrp="1"/>
+          </p:cNvSpPr>
+          <p:nvPr/>
+        </p:nvSpPr>
+        <p:spPr>
+          <a:xfrm>
+            <a:off x="762000" y="3950000"/>
+            <a:ext cx="7620000" cy="1250000"/>
+          </a:xfrm>
+          <a:prstGeom prst="rect">
+            <a:avLst/>
+          </a:prstGeom>
+          <a:solidFill>
+            <a:srgbClr val="E9F5EE"/>
+          </a:solidFill>
+          <a:ln w="19050">
+            <a:solidFill>
+              <a:srgbClr val="176844"/>
+            </a:solidFill>
+          </a:ln>
+        </p:spPr>
+        <p:txBody>
+          <a:bodyPr lIns="160000" tIns="110000" rIns="160000" bIns="110000" anchor="t" wrap="square">
+            <a:noAutofit/>
+          </a:bodyPr>
+          <a:lstStyle/>
+          <a:p>
+            <a:pPr>
+              <a:defRPr sz="1725" b="1">
+                <a:solidFill>
+                  <a:srgbClr val="064F91"/>
+                </a:solidFill>
+                <a:latin typeface="Calibri"/>
+                <a:ea typeface="Calibri"/>
+                <a:cs typeface="Calibri"/>
+              </a:defRPr>
+            </a:pPr>
+            <a:r>
+              <a:rPr sz="2000" b="1">
+                <a:solidFill>
+                  <a:srgbClr val="176844"/>
+                </a:solidFill>
+                <a:latin typeface="Calibri"/>
+                <a:ea typeface="Calibri"/>
+                <a:cs typeface="Calibri"/>
+              </a:rPr>
+              <a:t>û = √2 · 230 ≈ 325 V. Vinkeln 2π · 50 · 0,003 ≈ 0,942 rad. u ≈ 325 · sin(0,942) ≈ 263 V. Står räknaren i DEG blir svaret fel, cirka 5,3 V.</a:t>
+            </a:r>
+          </a:p>
+        </p:txBody>
+      </p:sp>
+    </p:spTree>
+  </p:cSld>
+  <p:clrMapOvr>
+    <a:masterClrMapping/>
+  </p:clrMapOvr>
+  <p:timing>
+    <p:tnLst>
+      <p:par>
+        <p:cTn id="1" dur="indefinite" restart="never" nodeType="tmRoot">
+          <p:childTnLst>
+            <p:seq concurrent="1" nextAc="seek">
+              <p:cTn id="2" dur="indefinite" nodeType="mainSeq">
+                <p:childTnLst>
+                  <p:par>
+                    <p:cTn id="3" fill="hold">
+                      <p:stCondLst>
+                        <p:cond delay="indefinite"/>
+                      </p:stCondLst>
+                      <p:childTnLst>
+                        <p:par>
+                          <p:cTn id="4" fill="hold">
+                            <p:stCondLst>
+                              <p:cond delay="0"/>
+                            </p:stCondLst>
+                            <p:childTnLst>
+                              <p:par>
+                                <p:cTn id="5" presetID="1" presetClass="entr" presetSubtype="0" fill="hold" grpId="0" nodeType="clickEffect">
+                                  <p:stCondLst>
+                                    <p:cond delay="0"/>
+                                  </p:stCondLst>
+                                  <p:childTnLst>
+                                    <p:set>
+                                      <p:cBhvr>
+                                        <p:cTn id="6" dur="1" fill="hold">
+                                          <p:stCondLst>
+                                            <p:cond delay="0"/>
+                                          </p:stCondLst>
+                                        </p:cTn>
+                                        <p:tgtEl>
+                                          <p:spTgt spid="14"/>
+                                        </p:tgtEl>
+                                        <p:attrNameLst>
+                                          <p:attrName>style.visibility</p:attrName>
+                                        </p:attrNameLst>
+                                      </p:cBhvr>
+                                      <p:to>
+                                        <p:strVal val="visible"/>
+                                      </p:to>
+                                    </p:set>
+                                  </p:childTnLst>
+                                </p:cTn>
+                              </p:par>
+                            </p:childTnLst>
+                          </p:cTn>
+                        </p:par>
+                      </p:childTnLst>
+                    </p:cTn>
+                  </p:par>
+                </p:childTnLst>
+              </p:cTn>
+              <p:prevCondLst>
+                <p:cond evt="onPrev" delay="0">
+                  <p:tgtEl>
+                    <p:sldTgt/>
+                  </p:tgtEl>
+                </p:cond>
+              </p:prevCondLst>
+              <p:nextCondLst>
+                <p:cond evt="onNext" delay="0">
+                  <p:tgtEl>
+                    <p:sldTgt/>
+                  </p:tgtEl>
+                </p:cond>
+              </p:nextCondLst>
+            </p:seq>
+          </p:childTnLst>
+        </p:cTn>
+      </p:par>
+    </p:tnLst>
+    <p:bldLst>
+      <p:bldP spid="14" grpId="0" animBg="1"/>
+    </p:bldLst>
+  </p:timing>
+</p:sld>
+</file>
+
+<file path=ppt/slides/slide16.xml><?xml version="1.0" encoding="utf-8"?>
 <p:sld xmlns:p="http://schemas.openxmlformats.org/presentationml/2006/main">
   <p:cSld>
     <p:spTree>
@@ -12046,7 +12893,7 @@
                 <a:ea typeface="Calibri"/>
                 <a:cs typeface="Calibri"/>
               </a:rPr>
-              <a:t>14</a:t>
+              <a:t>16</a:t>
             </a:r>
           </a:p>
         </p:txBody>
@@ -12061,7 +12908,7 @@
 </p:sld>
 </file>
 
-<file path=ppt/slides/slide15.xml><?xml version="1.0" encoding="utf-8"?>
+<file path=ppt/slides/slide17.xml><?xml version="1.0" encoding="utf-8"?>
 <p:sld xmlns:p="http://schemas.openxmlformats.org/presentationml/2006/main">
   <p:cSld>
     <p:spTree>
@@ -12447,7 +13294,7 @@
                 <a:ea typeface="Calibri"/>
                 <a:cs typeface="Calibri"/>
               </a:rPr>
-              <a:t>15</a:t>
+              <a:t>17</a:t>
             </a:r>
           </a:p>
         </p:txBody>
@@ -12462,7 +13309,7 @@
 </p:sld>
 </file>
 
-<file path=ppt/slides/slide16.xml><?xml version="1.0" encoding="utf-8"?>
+<file path=ppt/slides/slide18.xml><?xml version="1.0" encoding="utf-8"?>
 <p:sld xmlns:p="http://schemas.openxmlformats.org/presentationml/2006/main">
   <p:cSld>
     <p:spTree>
@@ -13168,7 +14015,7 @@
                 <a:ea typeface="Calibri"/>
                 <a:cs typeface="Calibri"/>
               </a:rPr>
-              <a:t>16</a:t>
+              <a:t>18</a:t>
             </a:r>
           </a:p>
         </p:txBody>
@@ -13183,7 +14030,7 @@
 </p:sld>
 </file>
 
-<file path=ppt/slides/slide17.xml><?xml version="1.0" encoding="utf-8"?>
+<file path=ppt/slides/slide19.xml><?xml version="1.0" encoding="utf-8"?>
 <p:sld xmlns:p="http://schemas.openxmlformats.org/presentationml/2006/main">
   <p:cSld>
     <p:spTree>
@@ -13526,351 +14373,7 @@
                 <a:ea typeface="Calibri"/>
                 <a:cs typeface="Calibri"/>
               </a:rPr>
-              <a:t>17</a:t>
-            </a:r>
-          </a:p>
-        </p:txBody>
-      </p:sp>
-    </p:spTree>
-    <p:extLst>
-      <p:ext uri="{BB962C8B-B14F-4D97-AF65-F5344CB8AC3E}">
-        <p14:creationId xmlns:p14="http://schemas.microsoft.com/office/powerpoint/2010/main" val="2747996220"/>
-      </p:ext>
-    </p:extLst>
-  </p:cSld>
-</p:sld>
-</file>
-
-<file path=ppt/slides/slide18.xml><?xml version="1.0" encoding="utf-8"?>
-<p:sld xmlns:p="http://schemas.openxmlformats.org/presentationml/2006/main">
-  <p:cSld>
-    <p:spTree>
-      <p:nvGrpSpPr>
-        <p:cNvPr id="1" name=""/>
-        <p:cNvGrpSpPr/>
-        <p:nvPr/>
-      </p:nvGrpSpPr>
-      <p:grpSpPr>
-        <a:xfrm xmlns:a="http://schemas.openxmlformats.org/drawingml/2006/main"/>
-      </p:grpSpPr>
-      <p:pic>
-        <p:nvPicPr>
-          <p:cNvPr id="13" name="Bildobjekt 2"/>
-          <p:cNvPicPr>
-            <a:picLocks xmlns:a="http://schemas.openxmlformats.org/drawingml/2006/main" noChangeAspect="1"/>
-          </p:cNvPicPr>
-          <p:nvPr/>
-        </p:nvPicPr>
-        <p:blipFill>
-          <a:blip xmlns:r="http://schemas.openxmlformats.org/officeDocument/2006/relationships" xmlns:a="http://schemas.openxmlformats.org/drawingml/2006/main" r:embed="R980bf77cdbb64fa2"/>
-          <a:stretch xmlns:a="http://schemas.openxmlformats.org/drawingml/2006/main">
-            <a:fillRect l="0" t="0" r="0" b="0"/>
-          </a:stretch>
-        </p:blipFill>
-        <p:spPr>
-          <a:xfrm xmlns:a="http://schemas.openxmlformats.org/drawingml/2006/main">
-            <a:off x="0" y="6098791"/>
-            <a:ext cx="9144006" cy="763524"/>
-          </a:xfrm>
-          <a:prstGeom xmlns:a="http://schemas.openxmlformats.org/drawingml/2006/main" prst="rect">
-            <a:avLst/>
-          </a:prstGeom>
-        </p:spPr>
-      </p:pic>
-      <p:sp>
-        <p:nvSpPr>
-          <p:cNvPr id="9" name="title">
-            <a:extLst xmlns:a="http://schemas.openxmlformats.org/drawingml/2006/main">
-              <a:ext uri="{FF2B5EF4-FFF2-40B4-BE49-F238E27FC236}">
-                <a16:creationId xmlns:a16="http://schemas.microsoft.com/office/drawing/2014/main" id="{4F3A706E-8A75-4E8E-BA66-BDD3D02EAA11}"/>
-              </a:ext>
-            </a:extLst>
-          </p:cNvPr>
-          <p:cNvSpPr>
-            <a:spLocks xmlns:a="http://schemas.openxmlformats.org/drawingml/2006/main" noGrp="1"/>
-          </p:cNvSpPr>
-          <p:nvPr/>
-        </p:nvSpPr>
-        <p:spPr>
-          <a:xfrm xmlns:a="http://schemas.openxmlformats.org/drawingml/2006/main">
-            <a:off x="571500" y="428625"/>
-            <a:ext cx="8001000" cy="781050"/>
-          </a:xfrm>
-          <a:prstGeom xmlns:a="http://schemas.openxmlformats.org/drawingml/2006/main" prst="rect">
-            <a:avLst/>
-          </a:prstGeom>
-          <a:noFill xmlns:a="http://schemas.openxmlformats.org/drawingml/2006/main"/>
-          <a:ln xmlns:a="http://schemas.openxmlformats.org/drawingml/2006/main" w="0">
-            <a:noFill/>
-          </a:ln>
-        </p:spPr>
-        <p:txBody>
-          <a:bodyPr xmlns:a="http://schemas.openxmlformats.org/drawingml/2006/main" lIns="0" tIns="0" rIns="0" bIns="0" anchor="t">
-            <a:noAutofit/>
-          </a:bodyPr>
-          <a:lstStyle xmlns:a="http://schemas.openxmlformats.org/drawingml/2006/main"/>
-          <a:p xmlns:a="http://schemas.openxmlformats.org/drawingml/2006/main">
-            <a:pPr>
-              <a:defRPr sz="3000" b="1">
-                <a:solidFill>
-                  <a:srgbClr val="111111"/>
-                </a:solidFill>
-                <a:latin typeface="Calibri"/>
-                <a:ea typeface="Calibri"/>
-                <a:cs typeface="Calibri"/>
-              </a:defRPr>
-            </a:pPr>
-            <a:r>
-              <a:rPr sz="3000" b="1">
-                <a:solidFill>
-                  <a:srgbClr val="111111"/>
-                </a:solidFill>
-                <a:latin typeface="Calibri"/>
-                <a:ea typeface="Calibri"/>
-                <a:cs typeface="Calibri"/>
-              </a:rPr>
-              <a:t>Inför nästa del</a:t>
-            </a:r>
-          </a:p>
-        </p:txBody>
-      </p:sp>
-      <p:sp>
-        <p:nvSpPr>
-          <p:cNvPr id="10" name="body">
-            <a:extLst xmlns:a="http://schemas.openxmlformats.org/drawingml/2006/main">
-              <a:ext uri="{FF2B5EF4-FFF2-40B4-BE49-F238E27FC236}">
-                <a16:creationId xmlns:a16="http://schemas.microsoft.com/office/drawing/2014/main" id="{EA480D0F-7E52-40C4-B778-625E7178E7DB}"/>
-              </a:ext>
-            </a:extLst>
-          </p:cNvPr>
-          <p:cNvSpPr>
-            <a:spLocks xmlns:a="http://schemas.openxmlformats.org/drawingml/2006/main" noGrp="1"/>
-          </p:cNvSpPr>
-          <p:nvPr/>
-        </p:nvSpPr>
-        <p:spPr>
-          <a:xfrm xmlns:a="http://schemas.openxmlformats.org/drawingml/2006/main">
-            <a:off x="762000" y="1590675"/>
-            <a:ext cx="7620000" cy="3524250"/>
-          </a:xfrm>
-          <a:prstGeom xmlns:a="http://schemas.openxmlformats.org/drawingml/2006/main" prst="rect">
-            <a:avLst/>
-          </a:prstGeom>
-          <a:noFill xmlns:a="http://schemas.openxmlformats.org/drawingml/2006/main"/>
-          <a:ln xmlns:a="http://schemas.openxmlformats.org/drawingml/2006/main" w="0">
-            <a:noFill/>
-          </a:ln>
-        </p:spPr>
-        <p:txBody>
-          <a:bodyPr xmlns:a="http://schemas.openxmlformats.org/drawingml/2006/main" lIns="0" tIns="0" rIns="0" bIns="0" anchor="t">
-            <a:noAutofit/>
-          </a:bodyPr>
-          <a:lstStyle xmlns:a="http://schemas.openxmlformats.org/drawingml/2006/main"/>
-          <a:p xmlns:a="http://schemas.openxmlformats.org/drawingml/2006/main">
-            <a:pPr>
-              <a:defRPr sz="2100" b="0">
-                <a:solidFill>
-                  <a:srgbClr val="172F43"/>
-                </a:solidFill>
-                <a:latin typeface="Calibri"/>
-                <a:ea typeface="Calibri"/>
-                <a:cs typeface="Calibri"/>
-              </a:defRPr>
-            </a:pPr>
-            <a:r>
-              <a:rPr sz="2100" b="0">
-                <a:solidFill>
-                  <a:srgbClr val="172F43"/>
-                </a:solidFill>
-                <a:latin typeface="Calibri"/>
-                <a:ea typeface="Calibri"/>
-                <a:cs typeface="Calibri"/>
-              </a:rPr>
-              <a:t>Genomför grunduppgifterna och spara protokollet.</a:t>
-            </a:r>
-          </a:p>
-          <a:p xmlns:a="http://schemas.openxmlformats.org/drawingml/2006/main">
-            <a:pPr>
-              <a:defRPr sz="2100" b="0">
-                <a:solidFill>
-                  <a:srgbClr val="172F43"/>
-                </a:solidFill>
-                <a:latin typeface="Calibri"/>
-                <a:ea typeface="Calibri"/>
-                <a:cs typeface="Calibri"/>
-              </a:defRPr>
-            </a:pPr>
-          </a:p>
-          <a:p xmlns:a="http://schemas.openxmlformats.org/drawingml/2006/main">
-            <a:pPr>
-              <a:defRPr sz="2100" b="0">
-                <a:solidFill>
-                  <a:srgbClr val="172F43"/>
-                </a:solidFill>
-                <a:latin typeface="Calibri"/>
-                <a:ea typeface="Calibri"/>
-                <a:cs typeface="Calibri"/>
-              </a:defRPr>
-            </a:pPr>
-            <a:r>
-              <a:rPr sz="2100" b="0">
-                <a:solidFill>
-                  <a:srgbClr val="172F43"/>
-                </a:solidFill>
-                <a:latin typeface="Calibri"/>
-                <a:ea typeface="Calibri"/>
-                <a:cs typeface="Calibri"/>
-              </a:rPr>
-              <a:t>Förklara med egna ord skillnaden mellan effektivvärde (RMS), toppvärde och vanligt medelvärde.</a:t>
-            </a:r>
-          </a:p>
-          <a:p xmlns:a="http://schemas.openxmlformats.org/drawingml/2006/main">
-            <a:pPr>
-              <a:defRPr sz="2100" b="0">
-                <a:solidFill>
-                  <a:srgbClr val="172F43"/>
-                </a:solidFill>
-                <a:latin typeface="Calibri"/>
-                <a:ea typeface="Calibri"/>
-                <a:cs typeface="Calibri"/>
-              </a:defRPr>
-            </a:pPr>
-          </a:p>
-          <a:p xmlns:a="http://schemas.openxmlformats.org/drawingml/2006/main">
-            <a:pPr>
-              <a:defRPr sz="2100" b="0">
-                <a:solidFill>
-                  <a:srgbClr val="172F43"/>
-                </a:solidFill>
-                <a:latin typeface="Calibri"/>
-                <a:ea typeface="Calibri"/>
-                <a:cs typeface="Calibri"/>
-              </a:defRPr>
-            </a:pPr>
-            <a:r>
-              <a:rPr sz="2100" b="0">
-                <a:solidFill>
-                  <a:srgbClr val="172F43"/>
-                </a:solidFill>
-                <a:latin typeface="Calibri"/>
-                <a:ea typeface="Calibri"/>
-                <a:cs typeface="Calibri"/>
-              </a:rPr>
-              <a:t>Fysisk anslutning, oscilloskopets inställningar och godkända mätpunkter övas på den verkliga stationen.</a:t>
-            </a:r>
-          </a:p>
-        </p:txBody>
-      </p:sp>
-      <p:sp>
-        <p:nvSpPr>
-          <p:cNvPr id="11" name="section">
-            <a:extLst xmlns:a="http://schemas.openxmlformats.org/drawingml/2006/main">
-              <a:ext uri="{FF2B5EF4-FFF2-40B4-BE49-F238E27FC236}">
-                <a16:creationId xmlns:a16="http://schemas.microsoft.com/office/drawing/2014/main" id="{E4C4A516-CEE2-411B-8DF9-7A025726CECC}"/>
-              </a:ext>
-            </a:extLst>
-          </p:cNvPr>
-          <p:cNvSpPr>
-            <a:spLocks xmlns:a="http://schemas.openxmlformats.org/drawingml/2006/main" noGrp="1"/>
-          </p:cNvSpPr>
-          <p:nvPr/>
-        </p:nvSpPr>
-        <p:spPr>
-          <a:xfrm xmlns:a="http://schemas.openxmlformats.org/drawingml/2006/main">
-            <a:off x="1809750" y="6419850"/>
-            <a:ext cx="4191000" cy="266700"/>
-          </a:xfrm>
-          <a:prstGeom xmlns:a="http://schemas.openxmlformats.org/drawingml/2006/main" prst="rect">
-            <a:avLst/>
-          </a:prstGeom>
-          <a:noFill xmlns:a="http://schemas.openxmlformats.org/drawingml/2006/main"/>
-          <a:ln xmlns:a="http://schemas.openxmlformats.org/drawingml/2006/main" w="0">
-            <a:noFill/>
-          </a:ln>
-        </p:spPr>
-        <p:txBody>
-          <a:bodyPr xmlns:a="http://schemas.openxmlformats.org/drawingml/2006/main" lIns="0" tIns="0" rIns="0" bIns="0" anchor="t">
-            <a:noAutofit/>
-          </a:bodyPr>
-          <a:lstStyle xmlns:a="http://schemas.openxmlformats.org/drawingml/2006/main"/>
-          <a:p xmlns:a="http://schemas.openxmlformats.org/drawingml/2006/main">
-            <a:pPr>
-              <a:defRPr sz="1275" b="0">
-                <a:solidFill>
-                  <a:srgbClr val="FFFFFF"/>
-                </a:solidFill>
-                <a:latin typeface="Calibri"/>
-                <a:ea typeface="Calibri"/>
-                <a:cs typeface="Calibri"/>
-              </a:defRPr>
-            </a:pPr>
-            <a:r>
-              <a:rPr sz="1275" b="0">
-                <a:solidFill>
-                  <a:srgbClr val="FFFFFF"/>
-                </a:solidFill>
-                <a:latin typeface="Calibri"/>
-                <a:ea typeface="Calibri"/>
-                <a:cs typeface="Calibri"/>
-              </a:rPr>
-              <a:t>Grunddel</a:t>
-            </a:r>
-          </a:p>
-        </p:txBody>
-      </p:sp>
-      <p:sp>
-        <p:nvSpPr>
-          <p:cNvPr id="12" name="page">
-            <a:extLst xmlns:a="http://schemas.openxmlformats.org/drawingml/2006/main">
-              <a:ext uri="{FF2B5EF4-FFF2-40B4-BE49-F238E27FC236}">
-                <a16:creationId xmlns:a16="http://schemas.microsoft.com/office/drawing/2014/main" id="{23A670A8-23CE-446D-860E-D21DECB10F7F}"/>
-              </a:ext>
-            </a:extLst>
-          </p:cNvPr>
-          <p:cNvSpPr>
-            <a:spLocks xmlns:a="http://schemas.openxmlformats.org/drawingml/2006/main" noGrp="1"/>
-          </p:cNvSpPr>
-          <p:nvPr/>
-        </p:nvSpPr>
-        <p:spPr>
-          <a:xfrm xmlns:a="http://schemas.openxmlformats.org/drawingml/2006/main">
-            <a:off x="8286750" y="6438900"/>
-            <a:ext cx="428625" cy="285750"/>
-          </a:xfrm>
-          <a:prstGeom xmlns:a="http://schemas.openxmlformats.org/drawingml/2006/main" prst="rect">
-            <a:avLst/>
-          </a:prstGeom>
-          <a:noFill xmlns:a="http://schemas.openxmlformats.org/drawingml/2006/main"/>
-          <a:ln xmlns:a="http://schemas.openxmlformats.org/drawingml/2006/main" w="0">
-            <a:noFill/>
-          </a:ln>
-        </p:spPr>
-        <p:txBody>
-          <a:bodyPr xmlns:a="http://schemas.openxmlformats.org/drawingml/2006/main" lIns="0" tIns="0" rIns="0" bIns="0" anchor="t">
-            <a:noAutofit/>
-          </a:bodyPr>
-          <a:lstStyle xmlns:a="http://schemas.openxmlformats.org/drawingml/2006/main"/>
-          <a:p xmlns:a="http://schemas.openxmlformats.org/drawingml/2006/main">
-            <a:pPr>
-              <a:defRPr sz="1500" b="0">
-                <a:solidFill>
-                  <a:srgbClr val="FFFFFF"/>
-                </a:solidFill>
-                <a:latin typeface="Calibri"/>
-                <a:ea typeface="Calibri"/>
-                <a:cs typeface="Calibri"/>
-              </a:defRPr>
-            </a:pPr>
-            <a:r>
-              <a:rPr sz="1500" b="0">
-                <a:solidFill>
-                  <a:srgbClr val="FFFFFF"/>
-                </a:solidFill>
-                <a:latin typeface="Calibri"/>
-                <a:ea typeface="Calibri"/>
-                <a:cs typeface="Calibri"/>
-              </a:rPr>
-              <a:t>18</a:t>
+              <a:t>19</a:t>
             </a:r>
           </a:p>
         </p:txBody>
@@ -14229,6 +14732,350 @@
 </p:sld>
 </file>
 
+<file path=ppt/slides/slide20.xml><?xml version="1.0" encoding="utf-8"?>
+<p:sld xmlns:p="http://schemas.openxmlformats.org/presentationml/2006/main">
+  <p:cSld>
+    <p:spTree>
+      <p:nvGrpSpPr>
+        <p:cNvPr id="1" name=""/>
+        <p:cNvGrpSpPr/>
+        <p:nvPr/>
+      </p:nvGrpSpPr>
+      <p:grpSpPr>
+        <a:xfrm xmlns:a="http://schemas.openxmlformats.org/drawingml/2006/main"/>
+      </p:grpSpPr>
+      <p:pic>
+        <p:nvPicPr>
+          <p:cNvPr id="13" name="Bildobjekt 2"/>
+          <p:cNvPicPr>
+            <a:picLocks xmlns:a="http://schemas.openxmlformats.org/drawingml/2006/main" noChangeAspect="1"/>
+          </p:cNvPicPr>
+          <p:nvPr/>
+        </p:nvPicPr>
+        <p:blipFill>
+          <a:blip xmlns:r="http://schemas.openxmlformats.org/officeDocument/2006/relationships" xmlns:a="http://schemas.openxmlformats.org/drawingml/2006/main" r:embed="R980bf77cdbb64fa2"/>
+          <a:stretch xmlns:a="http://schemas.openxmlformats.org/drawingml/2006/main">
+            <a:fillRect l="0" t="0" r="0" b="0"/>
+          </a:stretch>
+        </p:blipFill>
+        <p:spPr>
+          <a:xfrm xmlns:a="http://schemas.openxmlformats.org/drawingml/2006/main">
+            <a:off x="0" y="6098791"/>
+            <a:ext cx="9144006" cy="763524"/>
+          </a:xfrm>
+          <a:prstGeom xmlns:a="http://schemas.openxmlformats.org/drawingml/2006/main" prst="rect">
+            <a:avLst/>
+          </a:prstGeom>
+        </p:spPr>
+      </p:pic>
+      <p:sp>
+        <p:nvSpPr>
+          <p:cNvPr id="9" name="title">
+            <a:extLst xmlns:a="http://schemas.openxmlformats.org/drawingml/2006/main">
+              <a:ext uri="{FF2B5EF4-FFF2-40B4-BE49-F238E27FC236}">
+                <a16:creationId xmlns:a16="http://schemas.microsoft.com/office/drawing/2014/main" id="{4F3A706E-8A75-4E8E-BA66-BDD3D02EAA11}"/>
+              </a:ext>
+            </a:extLst>
+          </p:cNvPr>
+          <p:cNvSpPr>
+            <a:spLocks xmlns:a="http://schemas.openxmlformats.org/drawingml/2006/main" noGrp="1"/>
+          </p:cNvSpPr>
+          <p:nvPr/>
+        </p:nvSpPr>
+        <p:spPr>
+          <a:xfrm xmlns:a="http://schemas.openxmlformats.org/drawingml/2006/main">
+            <a:off x="571500" y="428625"/>
+            <a:ext cx="8001000" cy="781050"/>
+          </a:xfrm>
+          <a:prstGeom xmlns:a="http://schemas.openxmlformats.org/drawingml/2006/main" prst="rect">
+            <a:avLst/>
+          </a:prstGeom>
+          <a:noFill xmlns:a="http://schemas.openxmlformats.org/drawingml/2006/main"/>
+          <a:ln xmlns:a="http://schemas.openxmlformats.org/drawingml/2006/main" w="0">
+            <a:noFill/>
+          </a:ln>
+        </p:spPr>
+        <p:txBody>
+          <a:bodyPr xmlns:a="http://schemas.openxmlformats.org/drawingml/2006/main" lIns="0" tIns="0" rIns="0" bIns="0" anchor="t">
+            <a:noAutofit/>
+          </a:bodyPr>
+          <a:lstStyle xmlns:a="http://schemas.openxmlformats.org/drawingml/2006/main"/>
+          <a:p xmlns:a="http://schemas.openxmlformats.org/drawingml/2006/main">
+            <a:pPr>
+              <a:defRPr sz="3000" b="1">
+                <a:solidFill>
+                  <a:srgbClr val="111111"/>
+                </a:solidFill>
+                <a:latin typeface="Calibri"/>
+                <a:ea typeface="Calibri"/>
+                <a:cs typeface="Calibri"/>
+              </a:defRPr>
+            </a:pPr>
+            <a:r>
+              <a:rPr sz="3000" b="1">
+                <a:solidFill>
+                  <a:srgbClr val="111111"/>
+                </a:solidFill>
+                <a:latin typeface="Calibri"/>
+                <a:ea typeface="Calibri"/>
+                <a:cs typeface="Calibri"/>
+              </a:rPr>
+              <a:t>Inför nästa del</a:t>
+            </a:r>
+          </a:p>
+        </p:txBody>
+      </p:sp>
+      <p:sp>
+        <p:nvSpPr>
+          <p:cNvPr id="10" name="body">
+            <a:extLst xmlns:a="http://schemas.openxmlformats.org/drawingml/2006/main">
+              <a:ext uri="{FF2B5EF4-FFF2-40B4-BE49-F238E27FC236}">
+                <a16:creationId xmlns:a16="http://schemas.microsoft.com/office/drawing/2014/main" id="{EA480D0F-7E52-40C4-B778-625E7178E7DB}"/>
+              </a:ext>
+            </a:extLst>
+          </p:cNvPr>
+          <p:cNvSpPr>
+            <a:spLocks xmlns:a="http://schemas.openxmlformats.org/drawingml/2006/main" noGrp="1"/>
+          </p:cNvSpPr>
+          <p:nvPr/>
+        </p:nvSpPr>
+        <p:spPr>
+          <a:xfrm xmlns:a="http://schemas.openxmlformats.org/drawingml/2006/main">
+            <a:off x="762000" y="1590675"/>
+            <a:ext cx="7620000" cy="3524250"/>
+          </a:xfrm>
+          <a:prstGeom xmlns:a="http://schemas.openxmlformats.org/drawingml/2006/main" prst="rect">
+            <a:avLst/>
+          </a:prstGeom>
+          <a:noFill xmlns:a="http://schemas.openxmlformats.org/drawingml/2006/main"/>
+          <a:ln xmlns:a="http://schemas.openxmlformats.org/drawingml/2006/main" w="0">
+            <a:noFill/>
+          </a:ln>
+        </p:spPr>
+        <p:txBody>
+          <a:bodyPr xmlns:a="http://schemas.openxmlformats.org/drawingml/2006/main" lIns="0" tIns="0" rIns="0" bIns="0" anchor="t">
+            <a:noAutofit/>
+          </a:bodyPr>
+          <a:lstStyle xmlns:a="http://schemas.openxmlformats.org/drawingml/2006/main"/>
+          <a:p xmlns:a="http://schemas.openxmlformats.org/drawingml/2006/main">
+            <a:pPr>
+              <a:defRPr sz="2100" b="0">
+                <a:solidFill>
+                  <a:srgbClr val="172F43"/>
+                </a:solidFill>
+                <a:latin typeface="Calibri"/>
+                <a:ea typeface="Calibri"/>
+                <a:cs typeface="Calibri"/>
+              </a:defRPr>
+            </a:pPr>
+            <a:r>
+              <a:rPr sz="2100" b="0">
+                <a:solidFill>
+                  <a:srgbClr val="172F43"/>
+                </a:solidFill>
+                <a:latin typeface="Calibri"/>
+                <a:ea typeface="Calibri"/>
+                <a:cs typeface="Calibri"/>
+              </a:rPr>
+              <a:t>Genomför grunduppgifterna och spara protokollet.</a:t>
+            </a:r>
+          </a:p>
+          <a:p xmlns:a="http://schemas.openxmlformats.org/drawingml/2006/main">
+            <a:pPr>
+              <a:defRPr sz="2100" b="0">
+                <a:solidFill>
+                  <a:srgbClr val="172F43"/>
+                </a:solidFill>
+                <a:latin typeface="Calibri"/>
+                <a:ea typeface="Calibri"/>
+                <a:cs typeface="Calibri"/>
+              </a:defRPr>
+            </a:pPr>
+          </a:p>
+          <a:p xmlns:a="http://schemas.openxmlformats.org/drawingml/2006/main">
+            <a:pPr>
+              <a:defRPr sz="2100" b="0">
+                <a:solidFill>
+                  <a:srgbClr val="172F43"/>
+                </a:solidFill>
+                <a:latin typeface="Calibri"/>
+                <a:ea typeface="Calibri"/>
+                <a:cs typeface="Calibri"/>
+              </a:defRPr>
+            </a:pPr>
+            <a:r>
+              <a:rPr sz="2100" b="0">
+                <a:solidFill>
+                  <a:srgbClr val="172F43"/>
+                </a:solidFill>
+                <a:latin typeface="Calibri"/>
+                <a:ea typeface="Calibri"/>
+                <a:cs typeface="Calibri"/>
+              </a:rPr>
+              <a:t>Förklara med egna ord skillnaden mellan effektivvärde (RMS), toppvärde och vanligt medelvärde.</a:t>
+            </a:r>
+          </a:p>
+          <a:p xmlns:a="http://schemas.openxmlformats.org/drawingml/2006/main">
+            <a:pPr>
+              <a:defRPr sz="2100" b="0">
+                <a:solidFill>
+                  <a:srgbClr val="172F43"/>
+                </a:solidFill>
+                <a:latin typeface="Calibri"/>
+                <a:ea typeface="Calibri"/>
+                <a:cs typeface="Calibri"/>
+              </a:defRPr>
+            </a:pPr>
+          </a:p>
+          <a:p xmlns:a="http://schemas.openxmlformats.org/drawingml/2006/main">
+            <a:pPr>
+              <a:defRPr sz="2100" b="0">
+                <a:solidFill>
+                  <a:srgbClr val="172F43"/>
+                </a:solidFill>
+                <a:latin typeface="Calibri"/>
+                <a:ea typeface="Calibri"/>
+                <a:cs typeface="Calibri"/>
+              </a:defRPr>
+            </a:pPr>
+            <a:r>
+              <a:rPr sz="2100" b="0">
+                <a:solidFill>
+                  <a:srgbClr val="172F43"/>
+                </a:solidFill>
+                <a:latin typeface="Calibri"/>
+                <a:ea typeface="Calibri"/>
+                <a:cs typeface="Calibri"/>
+              </a:rPr>
+              <a:t>Fysisk anslutning, oscilloskopets inställningar och godkända mätpunkter övas på den verkliga stationen.</a:t>
+            </a:r>
+          </a:p>
+        </p:txBody>
+      </p:sp>
+      <p:sp>
+        <p:nvSpPr>
+          <p:cNvPr id="11" name="section">
+            <a:extLst xmlns:a="http://schemas.openxmlformats.org/drawingml/2006/main">
+              <a:ext uri="{FF2B5EF4-FFF2-40B4-BE49-F238E27FC236}">
+                <a16:creationId xmlns:a16="http://schemas.microsoft.com/office/drawing/2014/main" id="{E4C4A516-CEE2-411B-8DF9-7A025726CECC}"/>
+              </a:ext>
+            </a:extLst>
+          </p:cNvPr>
+          <p:cNvSpPr>
+            <a:spLocks xmlns:a="http://schemas.openxmlformats.org/drawingml/2006/main" noGrp="1"/>
+          </p:cNvSpPr>
+          <p:nvPr/>
+        </p:nvSpPr>
+        <p:spPr>
+          <a:xfrm xmlns:a="http://schemas.openxmlformats.org/drawingml/2006/main">
+            <a:off x="1809750" y="6419850"/>
+            <a:ext cx="4191000" cy="266700"/>
+          </a:xfrm>
+          <a:prstGeom xmlns:a="http://schemas.openxmlformats.org/drawingml/2006/main" prst="rect">
+            <a:avLst/>
+          </a:prstGeom>
+          <a:noFill xmlns:a="http://schemas.openxmlformats.org/drawingml/2006/main"/>
+          <a:ln xmlns:a="http://schemas.openxmlformats.org/drawingml/2006/main" w="0">
+            <a:noFill/>
+          </a:ln>
+        </p:spPr>
+        <p:txBody>
+          <a:bodyPr xmlns:a="http://schemas.openxmlformats.org/drawingml/2006/main" lIns="0" tIns="0" rIns="0" bIns="0" anchor="t">
+            <a:noAutofit/>
+          </a:bodyPr>
+          <a:lstStyle xmlns:a="http://schemas.openxmlformats.org/drawingml/2006/main"/>
+          <a:p xmlns:a="http://schemas.openxmlformats.org/drawingml/2006/main">
+            <a:pPr>
+              <a:defRPr sz="1275" b="0">
+                <a:solidFill>
+                  <a:srgbClr val="FFFFFF"/>
+                </a:solidFill>
+                <a:latin typeface="Calibri"/>
+                <a:ea typeface="Calibri"/>
+                <a:cs typeface="Calibri"/>
+              </a:defRPr>
+            </a:pPr>
+            <a:r>
+              <a:rPr sz="1275" b="0">
+                <a:solidFill>
+                  <a:srgbClr val="FFFFFF"/>
+                </a:solidFill>
+                <a:latin typeface="Calibri"/>
+                <a:ea typeface="Calibri"/>
+                <a:cs typeface="Calibri"/>
+              </a:rPr>
+              <a:t>Grunddel</a:t>
+            </a:r>
+          </a:p>
+        </p:txBody>
+      </p:sp>
+      <p:sp>
+        <p:nvSpPr>
+          <p:cNvPr id="12" name="page">
+            <a:extLst xmlns:a="http://schemas.openxmlformats.org/drawingml/2006/main">
+              <a:ext uri="{FF2B5EF4-FFF2-40B4-BE49-F238E27FC236}">
+                <a16:creationId xmlns:a16="http://schemas.microsoft.com/office/drawing/2014/main" id="{23A670A8-23CE-446D-860E-D21DECB10F7F}"/>
+              </a:ext>
+            </a:extLst>
+          </p:cNvPr>
+          <p:cNvSpPr>
+            <a:spLocks xmlns:a="http://schemas.openxmlformats.org/drawingml/2006/main" noGrp="1"/>
+          </p:cNvSpPr>
+          <p:nvPr/>
+        </p:nvSpPr>
+        <p:spPr>
+          <a:xfrm xmlns:a="http://schemas.openxmlformats.org/drawingml/2006/main">
+            <a:off x="8286750" y="6438900"/>
+            <a:ext cx="428625" cy="285750"/>
+          </a:xfrm>
+          <a:prstGeom xmlns:a="http://schemas.openxmlformats.org/drawingml/2006/main" prst="rect">
+            <a:avLst/>
+          </a:prstGeom>
+          <a:noFill xmlns:a="http://schemas.openxmlformats.org/drawingml/2006/main"/>
+          <a:ln xmlns:a="http://schemas.openxmlformats.org/drawingml/2006/main" w="0">
+            <a:noFill/>
+          </a:ln>
+        </p:spPr>
+        <p:txBody>
+          <a:bodyPr xmlns:a="http://schemas.openxmlformats.org/drawingml/2006/main" lIns="0" tIns="0" rIns="0" bIns="0" anchor="t">
+            <a:noAutofit/>
+          </a:bodyPr>
+          <a:lstStyle xmlns:a="http://schemas.openxmlformats.org/drawingml/2006/main"/>
+          <a:p xmlns:a="http://schemas.openxmlformats.org/drawingml/2006/main">
+            <a:pPr>
+              <a:defRPr sz="1500" b="0">
+                <a:solidFill>
+                  <a:srgbClr val="FFFFFF"/>
+                </a:solidFill>
+                <a:latin typeface="Calibri"/>
+                <a:ea typeface="Calibri"/>
+                <a:cs typeface="Calibri"/>
+              </a:defRPr>
+            </a:pPr>
+            <a:r>
+              <a:rPr sz="1500" b="0">
+                <a:solidFill>
+                  <a:srgbClr val="FFFFFF"/>
+                </a:solidFill>
+                <a:latin typeface="Calibri"/>
+                <a:ea typeface="Calibri"/>
+                <a:cs typeface="Calibri"/>
+              </a:rPr>
+              <a:t>20</a:t>
+            </a:r>
+          </a:p>
+        </p:txBody>
+      </p:sp>
+    </p:spTree>
+    <p:extLst>
+      <p:ext uri="{BB962C8B-B14F-4D97-AF65-F5344CB8AC3E}">
+        <p14:creationId xmlns:p14="http://schemas.microsoft.com/office/powerpoint/2010/main" val="2747996220"/>
+      </p:ext>
+    </p:extLst>
+  </p:cSld>
+</p:sld>
+</file>
+
 <file path=ppt/slides/slide3.xml><?xml version="1.0" encoding="utf-8"?>
 <p:sld xmlns:p="http://schemas.openxmlformats.org/presentationml/2006/main">
   <p:cSld>
@@ -16577,6 +17424,516 @@
 </file>
 
 <file path=ppt/slides/slide8.xml><?xml version="1.0" encoding="utf-8"?>
+<p:sld xmlns:a="http://schemas.openxmlformats.org/drawingml/2006/main" xmlns:p="http://schemas.openxmlformats.org/presentationml/2006/main" xmlns:r="http://schemas.openxmlformats.org/officeDocument/2006/relationships">
+  <p:cSld>
+    <p:spTree>
+      <p:nvGrpSpPr>
+        <p:cNvPr id="1" name=""/>
+        <p:cNvGrpSpPr/>
+        <p:nvPr/>
+      </p:nvGrpSpPr>
+      <p:grpSpPr/>
+      <p:pic>
+        <p:nvPicPr>
+          <p:cNvPr id="2" name="Picture 1" descr="image.jpeg"/>
+          <p:cNvPicPr>
+            <a:picLocks noChangeAspect="1"/>
+          </p:cNvPicPr>
+          <p:nvPr/>
+        </p:nvPicPr>
+        <p:blipFill>
+          <a:blip r:embed="rId2"/>
+          <a:stretch>
+            <a:fillRect/>
+          </a:stretch>
+        </p:blipFill>
+        <p:spPr>
+          <a:xfrm>
+            <a:off x="0" y="6098791"/>
+            <a:ext cx="9144006" cy="763524"/>
+          </a:xfrm>
+          <a:prstGeom prst="rect">
+            <a:avLst/>
+          </a:prstGeom>
+        </p:spPr>
+      </p:pic>
+      <p:sp>
+        <p:nvSpPr>
+          <p:cNvPr id="9" name="title">
+            <a:extLst>
+              <a:ext uri="{FF2B5EF4-FFF2-40B4-BE49-F238E27FC236}">
+                <a16:creationId xmlns:a16="http://schemas.microsoft.com/office/drawing/2014/main" id="{7962C62C-109D-441A-9E4A-67632189D64C}"/>
+              </a:ext>
+            </a:extLst>
+          </p:cNvPr>
+          <p:cNvSpPr>
+            <a:spLocks noGrp="1"/>
+          </p:cNvSpPr>
+          <p:nvPr/>
+        </p:nvSpPr>
+        <p:spPr>
+          <a:xfrm>
+            <a:off x="571500" y="428625"/>
+            <a:ext cx="8001000" cy="781050"/>
+          </a:xfrm>
+          <a:prstGeom prst="rect">
+            <a:avLst/>
+          </a:prstGeom>
+          <a:noFill/>
+          <a:ln w="0">
+            <a:noFill/>
+          </a:ln>
+        </p:spPr>
+        <p:txBody>
+          <a:bodyPr lIns="0" tIns="0" rIns="0" bIns="0" anchor="t">
+            <a:noAutofit/>
+          </a:bodyPr>
+          <a:lstStyle/>
+          <a:p>
+            <a:pPr>
+              <a:defRPr sz="3000" b="1">
+                <a:solidFill>
+                  <a:srgbClr val="111111"/>
+                </a:solidFill>
+                <a:latin typeface="Calibri"/>
+                <a:ea typeface="Calibri"/>
+                <a:cs typeface="Calibri"/>
+              </a:defRPr>
+            </a:pPr>
+            <a:r>
+              <a:rPr sz="3000" b="1">
+                <a:solidFill>
+                  <a:srgbClr val="111111"/>
+                </a:solidFill>
+                <a:latin typeface="Calibri"/>
+                <a:ea typeface="Calibri"/>
+                <a:cs typeface="Calibri"/>
+              </a:rPr>
+              <a:t>Din tur: belysningsnätet ombord</a:t>
+            </a:r>
+          </a:p>
+        </p:txBody>
+      </p:sp>
+      <p:sp>
+        <p:nvSpPr>
+          <p:cNvPr id="10" name="body">
+            <a:extLst>
+              <a:ext uri="{FF2B5EF4-FFF2-40B4-BE49-F238E27FC236}">
+                <a16:creationId xmlns:a16="http://schemas.microsoft.com/office/drawing/2014/main" id="{8BAD7154-9510-4220-A4BE-FE50A6F6BFC1}"/>
+              </a:ext>
+            </a:extLst>
+          </p:cNvPr>
+          <p:cNvSpPr>
+            <a:spLocks noGrp="1"/>
+          </p:cNvSpPr>
+          <p:nvPr/>
+        </p:nvSpPr>
+        <p:spPr>
+          <a:xfrm>
+            <a:off x="762000" y="1330000"/>
+            <a:ext cx="7620000" cy="560000"/>
+          </a:xfrm>
+          <a:prstGeom prst="rect">
+            <a:avLst/>
+          </a:prstGeom>
+          <a:noFill/>
+          <a:ln w="0">
+            <a:noFill/>
+          </a:ln>
+        </p:spPr>
+        <p:txBody>
+          <a:bodyPr lIns="0" tIns="0" rIns="0" bIns="0" anchor="t">
+            <a:noAutofit/>
+          </a:bodyPr>
+          <a:lstStyle/>
+          <a:p>
+            <a:pPr>
+              <a:defRPr sz="2100" b="0">
+                <a:solidFill>
+                  <a:srgbClr val="172F43"/>
+                </a:solidFill>
+                <a:latin typeface="Calibri"/>
+                <a:ea typeface="Calibri"/>
+                <a:cs typeface="Calibri"/>
+              </a:defRPr>
+            </a:pPr>
+            <a:r>
+              <a:rPr sz="1600" b="0">
+                <a:solidFill>
+                  <a:srgbClr val="4D6579"/>
+                </a:solidFill>
+                <a:latin typeface="Calibri"/>
+                <a:ea typeface="Calibri"/>
+                <a:cs typeface="Calibri"/>
+              </a:rPr>
+              <a:t>Räkna på papper eller miniwhiteboard. Titta på svaret först när du har ett eget.</a:t>
+            </a:r>
+          </a:p>
+        </p:txBody>
+      </p:sp>
+      <p:sp>
+        <p:nvSpPr>
+          <p:cNvPr id="11" name="check">
+            <a:extLst>
+              <a:ext uri="{FF2B5EF4-FFF2-40B4-BE49-F238E27FC236}">
+                <a16:creationId xmlns:a16="http://schemas.microsoft.com/office/drawing/2014/main" id="{B70753C7-C3B8-4F47-B62B-24102E19EEBC}"/>
+              </a:ext>
+            </a:extLst>
+          </p:cNvPr>
+          <p:cNvSpPr>
+            <a:spLocks noGrp="1"/>
+          </p:cNvSpPr>
+          <p:nvPr/>
+        </p:nvSpPr>
+        <p:spPr>
+          <a:xfrm>
+            <a:off x="762000" y="1950000"/>
+            <a:ext cx="7620000" cy="1900000"/>
+          </a:xfrm>
+          <a:prstGeom prst="rect">
+            <a:avLst/>
+          </a:prstGeom>
+          <a:noFill/>
+          <a:ln w="0">
+            <a:noFill/>
+          </a:ln>
+        </p:spPr>
+        <p:txBody>
+          <a:bodyPr lIns="0" tIns="0" rIns="0" bIns="0" anchor="t" wrap="square">
+            <a:noAutofit/>
+          </a:bodyPr>
+          <a:lstStyle/>
+          <a:p>
+            <a:pPr>
+              <a:defRPr sz="1725" b="1">
+                <a:solidFill>
+                  <a:srgbClr val="064F91"/>
+                </a:solidFill>
+                <a:latin typeface="Calibri"/>
+                <a:ea typeface="Calibri"/>
+                <a:cs typeface="Calibri"/>
+              </a:defRPr>
+            </a:pPr>
+            <a:r>
+              <a:rPr sz="2600" b="1">
+                <a:solidFill>
+                  <a:srgbClr val="163248"/>
+                </a:solidFill>
+                <a:latin typeface="Calibri"/>
+                <a:ea typeface="Calibri"/>
+                <a:cs typeface="Calibri"/>
+              </a:rPr>
+              <a:t>Belysningsnätet ombord har U = 254 V RMS och f = 60 Hz. Räkna toppvärdet û och topp till topp U</a:t>
+            </a:r>
+            <a:r>
+              <a:rPr sz="2600" b="1" baseline="-25000">
+                <a:solidFill>
+                  <a:srgbClr val="163248"/>
+                </a:solidFill>
+                <a:latin typeface="Calibri"/>
+                <a:ea typeface="Calibri"/>
+                <a:cs typeface="Calibri"/>
+              </a:rPr>
+              <a:t>pp</a:t>
+            </a:r>
+            <a:r>
+              <a:rPr sz="2600" b="1">
+                <a:solidFill>
+                  <a:srgbClr val="163248"/>
+                </a:solidFill>
+                <a:latin typeface="Calibri"/>
+                <a:ea typeface="Calibri"/>
+                <a:cs typeface="Calibri"/>
+              </a:rPr>
+              <a:t>.</a:t>
+            </a:r>
+          </a:p>
+        </p:txBody>
+      </p:sp>
+      <p:sp>
+        <p:nvSpPr>
+          <p:cNvPr id="12" name="section">
+            <a:extLst>
+              <a:ext uri="{FF2B5EF4-FFF2-40B4-BE49-F238E27FC236}">
+                <a16:creationId xmlns:a16="http://schemas.microsoft.com/office/drawing/2014/main" id="{9B1C64DD-2273-42DB-B85F-C12446C1D3B3}"/>
+              </a:ext>
+            </a:extLst>
+          </p:cNvPr>
+          <p:cNvSpPr>
+            <a:spLocks noGrp="1"/>
+          </p:cNvSpPr>
+          <p:nvPr/>
+        </p:nvSpPr>
+        <p:spPr>
+          <a:xfrm>
+            <a:off x="1809750" y="6419850"/>
+            <a:ext cx="4191000" cy="266700"/>
+          </a:xfrm>
+          <a:prstGeom prst="rect">
+            <a:avLst/>
+          </a:prstGeom>
+          <a:noFill/>
+          <a:ln w="0">
+            <a:noFill/>
+          </a:ln>
+        </p:spPr>
+        <p:txBody>
+          <a:bodyPr lIns="0" tIns="0" rIns="0" bIns="0" anchor="t">
+            <a:noAutofit/>
+          </a:bodyPr>
+          <a:lstStyle/>
+          <a:p>
+            <a:pPr>
+              <a:defRPr sz="1275" b="0">
+                <a:solidFill>
+                  <a:srgbClr val="FFFFFF"/>
+                </a:solidFill>
+                <a:latin typeface="Calibri"/>
+                <a:ea typeface="Calibri"/>
+                <a:cs typeface="Calibri"/>
+              </a:defRPr>
+            </a:pPr>
+            <a:r>
+              <a:rPr sz="1275" b="0">
+                <a:solidFill>
+                  <a:srgbClr val="FFFFFF"/>
+                </a:solidFill>
+                <a:latin typeface="Calibri"/>
+                <a:ea typeface="Calibri"/>
+                <a:cs typeface="Calibri"/>
+              </a:rPr>
+              <a:t>Grunddel</a:t>
+            </a:r>
+          </a:p>
+        </p:txBody>
+      </p:sp>
+      <p:sp>
+        <p:nvSpPr>
+          <p:cNvPr id="13" name="page">
+            <a:extLst>
+              <a:ext uri="{FF2B5EF4-FFF2-40B4-BE49-F238E27FC236}">
+                <a16:creationId xmlns:a16="http://schemas.microsoft.com/office/drawing/2014/main" id="{56C39C5B-E2A3-490F-AB9A-BF7FF13842D6}"/>
+              </a:ext>
+            </a:extLst>
+          </p:cNvPr>
+          <p:cNvSpPr>
+            <a:spLocks noGrp="1"/>
+          </p:cNvSpPr>
+          <p:nvPr/>
+        </p:nvSpPr>
+        <p:spPr>
+          <a:xfrm>
+            <a:off x="8286750" y="6438900"/>
+            <a:ext cx="428625" cy="285750"/>
+          </a:xfrm>
+          <a:prstGeom prst="rect">
+            <a:avLst/>
+          </a:prstGeom>
+          <a:noFill/>
+          <a:ln w="0">
+            <a:noFill/>
+          </a:ln>
+        </p:spPr>
+        <p:txBody>
+          <a:bodyPr lIns="0" tIns="0" rIns="0" bIns="0" anchor="t">
+            <a:noAutofit/>
+          </a:bodyPr>
+          <a:lstStyle/>
+          <a:p>
+            <a:pPr>
+              <a:defRPr sz="1500" b="0">
+                <a:solidFill>
+                  <a:srgbClr val="FFFFFF"/>
+                </a:solidFill>
+                <a:latin typeface="Calibri"/>
+                <a:ea typeface="Calibri"/>
+                <a:cs typeface="Calibri"/>
+              </a:defRPr>
+            </a:pPr>
+            <a:r>
+              <a:rPr sz="1500" b="0">
+                <a:solidFill>
+                  <a:srgbClr val="FFFFFF"/>
+                </a:solidFill>
+                <a:latin typeface="Calibri"/>
+                <a:ea typeface="Calibri"/>
+                <a:cs typeface="Calibri"/>
+              </a:rPr>
+              <a:t>8</a:t>
+            </a:r>
+          </a:p>
+        </p:txBody>
+      </p:sp>
+      <p:sp>
+        <p:nvSpPr>
+          <p:cNvPr id="14" name="svar">
+            <a:extLst>
+              <a:ext uri="{FF2B5EF4-FFF2-40B4-BE49-F238E27FC236}">
+                <a16:creationId xmlns:a16="http://schemas.microsoft.com/office/drawing/2014/main" id="{B70753C7-C3B8-4F47-B62B-24102E19EEBC}"/>
+              </a:ext>
+            </a:extLst>
+          </p:cNvPr>
+          <p:cNvSpPr>
+            <a:spLocks noGrp="1"/>
+          </p:cNvSpPr>
+          <p:nvPr/>
+        </p:nvSpPr>
+        <p:spPr>
+          <a:xfrm>
+            <a:off x="762000" y="3950000"/>
+            <a:ext cx="7620000" cy="1250000"/>
+          </a:xfrm>
+          <a:prstGeom prst="rect">
+            <a:avLst/>
+          </a:prstGeom>
+          <a:solidFill>
+            <a:srgbClr val="E9F5EE"/>
+          </a:solidFill>
+          <a:ln w="19050">
+            <a:solidFill>
+              <a:srgbClr val="176844"/>
+            </a:solidFill>
+          </a:ln>
+        </p:spPr>
+        <p:txBody>
+          <a:bodyPr lIns="160000" tIns="110000" rIns="160000" bIns="110000" anchor="t" wrap="square">
+            <a:noAutofit/>
+          </a:bodyPr>
+          <a:lstStyle/>
+          <a:p>
+            <a:pPr>
+              <a:defRPr sz="1725" b="1">
+                <a:solidFill>
+                  <a:srgbClr val="064F91"/>
+                </a:solidFill>
+                <a:latin typeface="Calibri"/>
+                <a:ea typeface="Calibri"/>
+                <a:cs typeface="Calibri"/>
+              </a:defRPr>
+            </a:pPr>
+            <a:r>
+              <a:rPr sz="2000" b="1">
+                <a:solidFill>
+                  <a:srgbClr val="176844"/>
+                </a:solidFill>
+                <a:latin typeface="Calibri"/>
+                <a:ea typeface="Calibri"/>
+                <a:cs typeface="Calibri"/>
+              </a:rPr>
+              <a:t>û = √2 · 254 ≈ 359 V. U</a:t>
+            </a:r>
+            <a:r>
+              <a:rPr sz="2000" b="1" baseline="-25000">
+                <a:solidFill>
+                  <a:srgbClr val="176844"/>
+                </a:solidFill>
+                <a:latin typeface="Calibri"/>
+                <a:ea typeface="Calibri"/>
+                <a:cs typeface="Calibri"/>
+              </a:rPr>
+              <a:t>pp</a:t>
+            </a:r>
+            <a:r>
+              <a:rPr sz="2000" b="1">
+                <a:solidFill>
+                  <a:srgbClr val="176844"/>
+                </a:solidFill>
+                <a:latin typeface="Calibri"/>
+                <a:ea typeface="Calibri"/>
+                <a:cs typeface="Calibri"/>
+              </a:rPr>
+              <a:t> = 2 · û ≈ 718 V.</a:t>
+            </a:r>
+          </a:p>
+        </p:txBody>
+      </p:sp>
+    </p:spTree>
+  </p:cSld>
+  <p:clrMapOvr>
+    <a:masterClrMapping/>
+  </p:clrMapOvr>
+  <p:timing>
+    <p:tnLst>
+      <p:par>
+        <p:cTn id="1" dur="indefinite" restart="never" nodeType="tmRoot">
+          <p:childTnLst>
+            <p:seq concurrent="1" nextAc="seek">
+              <p:cTn id="2" dur="indefinite" nodeType="mainSeq">
+                <p:childTnLst>
+                  <p:par>
+                    <p:cTn id="3" fill="hold">
+                      <p:stCondLst>
+                        <p:cond delay="indefinite"/>
+                      </p:stCondLst>
+                      <p:childTnLst>
+                        <p:par>
+                          <p:cTn id="4" fill="hold">
+                            <p:stCondLst>
+                              <p:cond delay="0"/>
+                            </p:stCondLst>
+                            <p:childTnLst>
+                              <p:par>
+                                <p:cTn id="5" presetID="1" presetClass="entr" presetSubtype="0" fill="hold" grpId="0" nodeType="clickEffect">
+                                  <p:stCondLst>
+                                    <p:cond delay="0"/>
+                                  </p:stCondLst>
+                                  <p:childTnLst>
+                                    <p:set>
+                                      <p:cBhvr>
+                                        <p:cTn id="6" dur="1" fill="hold">
+                                          <p:stCondLst>
+                                            <p:cond delay="0"/>
+                                          </p:stCondLst>
+                                        </p:cTn>
+                                        <p:tgtEl>
+                                          <p:spTgt spid="14"/>
+                                        </p:tgtEl>
+                                        <p:attrNameLst>
+                                          <p:attrName>style.visibility</p:attrName>
+                                        </p:attrNameLst>
+                                      </p:cBhvr>
+                                      <p:to>
+                                        <p:strVal val="visible"/>
+                                      </p:to>
+                                    </p:set>
+                                  </p:childTnLst>
+                                </p:cTn>
+                              </p:par>
+                            </p:childTnLst>
+                          </p:cTn>
+                        </p:par>
+                      </p:childTnLst>
+                    </p:cTn>
+                  </p:par>
+                </p:childTnLst>
+              </p:cTn>
+              <p:prevCondLst>
+                <p:cond evt="onPrev" delay="0">
+                  <p:tgtEl>
+                    <p:sldTgt/>
+                  </p:tgtEl>
+                </p:cond>
+              </p:prevCondLst>
+              <p:nextCondLst>
+                <p:cond evt="onNext" delay="0">
+                  <p:tgtEl>
+                    <p:sldTgt/>
+                  </p:tgtEl>
+                </p:cond>
+              </p:nextCondLst>
+            </p:seq>
+          </p:childTnLst>
+        </p:cTn>
+      </p:par>
+    </p:tnLst>
+    <p:bldLst>
+      <p:bldP spid="14" grpId="0" animBg="1"/>
+    </p:bldLst>
+  </p:timing>
+</p:sld>
+</file>
+
+<file path=ppt/slides/slide9.xml><?xml version="1.0" encoding="utf-8"?>
 <p:sld xmlns:p="http://schemas.openxmlformats.org/presentationml/2006/main">
   <p:cSld>
     <p:spTree>
@@ -17087,385 +18444,6 @@
             <a:extLst xmlns:a="http://schemas.openxmlformats.org/drawingml/2006/main">
               <a:ext uri="{FF2B5EF4-FFF2-40B4-BE49-F238E27FC236}">
                 <a16:creationId xmlns:a16="http://schemas.microsoft.com/office/drawing/2014/main" id="{BC480966-7F56-495F-B28D-2C0C46A3A9AE}"/>
-              </a:ext>
-            </a:extLst>
-          </p:cNvPr>
-          <p:cNvSpPr>
-            <a:spLocks xmlns:a="http://schemas.openxmlformats.org/drawingml/2006/main" noGrp="1"/>
-          </p:cNvSpPr>
-          <p:nvPr/>
-        </p:nvSpPr>
-        <p:spPr>
-          <a:xfrm xmlns:a="http://schemas.openxmlformats.org/drawingml/2006/main">
-            <a:off x="8286750" y="6438900"/>
-            <a:ext cx="428625" cy="285750"/>
-          </a:xfrm>
-          <a:prstGeom xmlns:a="http://schemas.openxmlformats.org/drawingml/2006/main" prst="rect">
-            <a:avLst/>
-          </a:prstGeom>
-          <a:noFill xmlns:a="http://schemas.openxmlformats.org/drawingml/2006/main"/>
-          <a:ln xmlns:a="http://schemas.openxmlformats.org/drawingml/2006/main" w="0">
-            <a:noFill/>
-          </a:ln>
-        </p:spPr>
-        <p:txBody>
-          <a:bodyPr xmlns:a="http://schemas.openxmlformats.org/drawingml/2006/main" lIns="0" tIns="0" rIns="0" bIns="0" anchor="t">
-            <a:noAutofit/>
-          </a:bodyPr>
-          <a:lstStyle xmlns:a="http://schemas.openxmlformats.org/drawingml/2006/main"/>
-          <a:p xmlns:a="http://schemas.openxmlformats.org/drawingml/2006/main">
-            <a:pPr>
-              <a:defRPr sz="1500" b="0">
-                <a:solidFill>
-                  <a:srgbClr val="FFFFFF"/>
-                </a:solidFill>
-                <a:latin typeface="Calibri"/>
-                <a:ea typeface="Calibri"/>
-                <a:cs typeface="Calibri"/>
-              </a:defRPr>
-            </a:pPr>
-            <a:r>
-              <a:rPr sz="1500" b="0">
-                <a:solidFill>
-                  <a:srgbClr val="FFFFFF"/>
-                </a:solidFill>
-                <a:latin typeface="Calibri"/>
-                <a:ea typeface="Calibri"/>
-                <a:cs typeface="Calibri"/>
-              </a:rPr>
-              <a:t>8</a:t>
-            </a:r>
-          </a:p>
-        </p:txBody>
-      </p:sp>
-    </p:spTree>
-    <p:extLst>
-      <p:ext uri="{BB962C8B-B14F-4D97-AF65-F5344CB8AC3E}">
-        <p14:creationId xmlns:p14="http://schemas.microsoft.com/office/powerpoint/2010/main" val="2747996220"/>
-      </p:ext>
-    </p:extLst>
-  </p:cSld>
-</p:sld>
-</file>
-
-<file path=ppt/slides/slide9.xml><?xml version="1.0" encoding="utf-8"?>
-<p:sld xmlns:p="http://schemas.openxmlformats.org/presentationml/2006/main">
-  <p:cSld>
-    <p:spTree>
-      <p:nvGrpSpPr>
-        <p:cNvPr id="1" name=""/>
-        <p:cNvGrpSpPr/>
-        <p:nvPr/>
-      </p:nvGrpSpPr>
-      <p:grpSpPr>
-        <a:xfrm xmlns:a="http://schemas.openxmlformats.org/drawingml/2006/main"/>
-      </p:grpSpPr>
-      <p:pic>
-        <p:nvPicPr>
-          <p:cNvPr id="13" name="Bildobjekt 2"/>
-          <p:cNvPicPr>
-            <a:picLocks xmlns:a="http://schemas.openxmlformats.org/drawingml/2006/main" noChangeAspect="1"/>
-          </p:cNvPicPr>
-          <p:nvPr/>
-        </p:nvPicPr>
-        <p:blipFill>
-          <a:blip xmlns:r="http://schemas.openxmlformats.org/officeDocument/2006/relationships" xmlns:a="http://schemas.openxmlformats.org/drawingml/2006/main" r:embed="R1d96d33ba7aa4bac"/>
-          <a:stretch xmlns:a="http://schemas.openxmlformats.org/drawingml/2006/main">
-            <a:fillRect l="0" t="0" r="0" b="0"/>
-          </a:stretch>
-        </p:blipFill>
-        <p:spPr>
-          <a:xfrm xmlns:a="http://schemas.openxmlformats.org/drawingml/2006/main">
-            <a:off x="0" y="6098791"/>
-            <a:ext cx="9144006" cy="763524"/>
-          </a:xfrm>
-          <a:prstGeom xmlns:a="http://schemas.openxmlformats.org/drawingml/2006/main" prst="rect">
-            <a:avLst/>
-          </a:prstGeom>
-        </p:spPr>
-      </p:pic>
-      <p:sp>
-        <p:nvSpPr>
-          <p:cNvPr id="9" name="title">
-            <a:extLst xmlns:a="http://schemas.openxmlformats.org/drawingml/2006/main">
-              <a:ext uri="{FF2B5EF4-FFF2-40B4-BE49-F238E27FC236}">
-                <a16:creationId xmlns:a16="http://schemas.microsoft.com/office/drawing/2014/main" id="{DABF7100-E82B-4D1C-B160-ABF3EC162748}"/>
-              </a:ext>
-            </a:extLst>
-          </p:cNvPr>
-          <p:cNvSpPr>
-            <a:spLocks xmlns:a="http://schemas.openxmlformats.org/drawingml/2006/main" noGrp="1"/>
-          </p:cNvSpPr>
-          <p:nvPr/>
-        </p:nvSpPr>
-        <p:spPr>
-          <a:xfrm xmlns:a="http://schemas.openxmlformats.org/drawingml/2006/main">
-            <a:off x="571500" y="428625"/>
-            <a:ext cx="8001000" cy="781050"/>
-          </a:xfrm>
-          <a:prstGeom xmlns:a="http://schemas.openxmlformats.org/drawingml/2006/main" prst="rect">
-            <a:avLst/>
-          </a:prstGeom>
-          <a:noFill xmlns:a="http://schemas.openxmlformats.org/drawingml/2006/main"/>
-          <a:ln xmlns:a="http://schemas.openxmlformats.org/drawingml/2006/main" w="0">
-            <a:noFill/>
-          </a:ln>
-        </p:spPr>
-        <p:txBody>
-          <a:bodyPr xmlns:a="http://schemas.openxmlformats.org/drawingml/2006/main" lIns="0" tIns="0" rIns="0" bIns="0" anchor="t">
-            <a:noAutofit/>
-          </a:bodyPr>
-          <a:lstStyle xmlns:a="http://schemas.openxmlformats.org/drawingml/2006/main"/>
-          <a:p xmlns:a="http://schemas.openxmlformats.org/drawingml/2006/main">
-            <a:pPr>
-              <a:defRPr sz="3000" b="1">
-                <a:solidFill>
-                  <a:srgbClr val="111111"/>
-                </a:solidFill>
-                <a:latin typeface="Calibri"/>
-                <a:ea typeface="Calibri"/>
-                <a:cs typeface="Calibri"/>
-              </a:defRPr>
-            </a:pPr>
-            <a:r>
-              <a:rPr sz="3000" b="1">
-                <a:solidFill>
-                  <a:srgbClr val="111111"/>
-                </a:solidFill>
-                <a:latin typeface="Calibri"/>
-                <a:ea typeface="Calibri"/>
-                <a:cs typeface="Calibri"/>
-              </a:rPr>
-              <a:t>En protokollrad</a:t>
-            </a:r>
-          </a:p>
-        </p:txBody>
-      </p:sp>
-      <p:sp>
-        <p:nvSpPr>
-          <p:cNvPr id="10" name="body">
-            <a:extLst xmlns:a="http://schemas.openxmlformats.org/drawingml/2006/main">
-              <a:ext uri="{FF2B5EF4-FFF2-40B4-BE49-F238E27FC236}">
-                <a16:creationId xmlns:a16="http://schemas.microsoft.com/office/drawing/2014/main" id="{FB38414D-923A-430C-90E5-1E98ADD2A321}"/>
-              </a:ext>
-            </a:extLst>
-          </p:cNvPr>
-          <p:cNvSpPr>
-            <a:spLocks xmlns:a="http://schemas.openxmlformats.org/drawingml/2006/main" noGrp="1"/>
-          </p:cNvSpPr>
-          <p:nvPr/>
-        </p:nvSpPr>
-        <p:spPr>
-          <a:xfrm xmlns:a="http://schemas.openxmlformats.org/drawingml/2006/main">
-            <a:off x="762000" y="1590675"/>
-            <a:ext cx="7620000" cy="3524250"/>
-          </a:xfrm>
-          <a:prstGeom xmlns:a="http://schemas.openxmlformats.org/drawingml/2006/main" prst="rect">
-            <a:avLst/>
-          </a:prstGeom>
-          <a:noFill xmlns:a="http://schemas.openxmlformats.org/drawingml/2006/main"/>
-          <a:ln xmlns:a="http://schemas.openxmlformats.org/drawingml/2006/main" w="0">
-            <a:noFill/>
-          </a:ln>
-        </p:spPr>
-        <p:txBody>
-          <a:bodyPr xmlns:a="http://schemas.openxmlformats.org/drawingml/2006/main" lIns="0" tIns="0" rIns="0" bIns="0" anchor="t">
-            <a:noAutofit/>
-          </a:bodyPr>
-          <a:lstStyle xmlns:a="http://schemas.openxmlformats.org/drawingml/2006/main"/>
-          <a:p xmlns:a="http://schemas.openxmlformats.org/drawingml/2006/main">
-            <a:pPr>
-              <a:defRPr sz="2100" b="0">
-                <a:solidFill>
-                  <a:srgbClr val="172F43"/>
-                </a:solidFill>
-                <a:latin typeface="Calibri"/>
-                <a:ea typeface="Calibri"/>
-                <a:cs typeface="Calibri"/>
-              </a:defRPr>
-            </a:pPr>
-            <a:r>
-              <a:rPr sz="2100" b="0">
-                <a:solidFill>
-                  <a:srgbClr val="172F43"/>
-                </a:solidFill>
-                <a:latin typeface="Calibri"/>
-                <a:ea typeface="Calibri"/>
-                <a:cs typeface="Calibri"/>
-              </a:rPr>
-              <a:t>Exempel från fartyget, 60 Hz. Förutsäg: T = 1 000/60 ≈ 16,7 ms.</a:t>
-            </a:r>
-          </a:p>
-          <a:p xmlns:a="http://schemas.openxmlformats.org/drawingml/2006/main">
-            <a:pPr>
-              <a:defRPr sz="2100" b="0">
-                <a:solidFill>
-                  <a:srgbClr val="172F43"/>
-                </a:solidFill>
-                <a:latin typeface="Calibri"/>
-                <a:ea typeface="Calibri"/>
-                <a:cs typeface="Calibri"/>
-              </a:defRPr>
-            </a:pPr>
-          </a:p>
-          <a:p xmlns:a="http://schemas.openxmlformats.org/drawingml/2006/main">
-            <a:pPr>
-              <a:defRPr sz="2100" b="0">
-                <a:solidFill>
-                  <a:srgbClr val="172F43"/>
-                </a:solidFill>
-                <a:latin typeface="Calibri"/>
-                <a:ea typeface="Calibri"/>
-                <a:cs typeface="Calibri"/>
-              </a:defRPr>
-            </a:pPr>
-            <a:r>
-              <a:rPr sz="2100" b="0">
-                <a:solidFill>
-                  <a:srgbClr val="172F43"/>
-                </a:solidFill>
-                <a:latin typeface="Calibri"/>
-                <a:ea typeface="Calibri"/>
-                <a:cs typeface="Calibri"/>
-              </a:rPr>
-              <a:t>Läs av och registrera 16,7 ms.</a:t>
-            </a:r>
-          </a:p>
-          <a:p xmlns:a="http://schemas.openxmlformats.org/drawingml/2006/main">
-            <a:pPr>
-              <a:defRPr sz="2100" b="0">
-                <a:solidFill>
-                  <a:srgbClr val="172F43"/>
-                </a:solidFill>
-                <a:latin typeface="Calibri"/>
-                <a:ea typeface="Calibri"/>
-                <a:cs typeface="Calibri"/>
-              </a:defRPr>
-            </a:pPr>
-          </a:p>
-          <a:p xmlns:a="http://schemas.openxmlformats.org/drawingml/2006/main">
-            <a:pPr>
-              <a:defRPr sz="2100" b="0">
-                <a:solidFill>
-                  <a:srgbClr val="172F43"/>
-                </a:solidFill>
-                <a:latin typeface="Calibri"/>
-                <a:ea typeface="Calibri"/>
-                <a:cs typeface="Calibri"/>
-              </a:defRPr>
-            </a:pPr>
-            <a:r>
-              <a:rPr sz="2100" b="0">
-                <a:solidFill>
-                  <a:srgbClr val="172F43"/>
-                </a:solidFill>
-                <a:latin typeface="Calibri"/>
-                <a:ea typeface="Calibri"/>
-                <a:cs typeface="Calibri"/>
-              </a:rPr>
-              <a:t>Jämför: avläst − förväntat = 0,0 ms.</a:t>
-            </a:r>
-          </a:p>
-          <a:p xmlns:a="http://schemas.openxmlformats.org/drawingml/2006/main">
-            <a:pPr>
-              <a:defRPr sz="2100" b="0">
-                <a:solidFill>
-                  <a:srgbClr val="172F43"/>
-                </a:solidFill>
-                <a:latin typeface="Calibri"/>
-                <a:ea typeface="Calibri"/>
-                <a:cs typeface="Calibri"/>
-              </a:defRPr>
-            </a:pPr>
-          </a:p>
-          <a:p xmlns:a="http://schemas.openxmlformats.org/drawingml/2006/main">
-            <a:pPr>
-              <a:defRPr sz="2100" b="0">
-                <a:solidFill>
-                  <a:srgbClr val="172F43"/>
-                </a:solidFill>
-                <a:latin typeface="Calibri"/>
-                <a:ea typeface="Calibri"/>
-                <a:cs typeface="Calibri"/>
-              </a:defRPr>
-            </a:pPr>
-            <a:r>
-              <a:rPr sz="2100" b="0">
-                <a:solidFill>
-                  <a:srgbClr val="172F43"/>
-                </a:solidFill>
-                <a:latin typeface="Calibri"/>
-                <a:ea typeface="Calibri"/>
-                <a:cs typeface="Calibri"/>
-              </a:rPr>
-              <a:t>Förklara: en hel period tar 16,7 ms. Frekvensen är 60 perioder per sekund. I labben gör du samma sak vid 50 Hz med din egen spänning, som räknas fram ur ditt D.</a:t>
-            </a:r>
-          </a:p>
-        </p:txBody>
-      </p:sp>
-      <p:sp>
-        <p:nvSpPr>
-          <p:cNvPr id="11" name="section">
-            <a:extLst xmlns:a="http://schemas.openxmlformats.org/drawingml/2006/main">
-              <a:ext uri="{FF2B5EF4-FFF2-40B4-BE49-F238E27FC236}">
-                <a16:creationId xmlns:a16="http://schemas.microsoft.com/office/drawing/2014/main" id="{7860C59D-1395-4123-B438-378564C342E8}"/>
-              </a:ext>
-            </a:extLst>
-          </p:cNvPr>
-          <p:cNvSpPr>
-            <a:spLocks xmlns:a="http://schemas.openxmlformats.org/drawingml/2006/main" noGrp="1"/>
-          </p:cNvSpPr>
-          <p:nvPr/>
-        </p:nvSpPr>
-        <p:spPr>
-          <a:xfrm xmlns:a="http://schemas.openxmlformats.org/drawingml/2006/main">
-            <a:off x="1809750" y="6419850"/>
-            <a:ext cx="4191000" cy="266700"/>
-          </a:xfrm>
-          <a:prstGeom xmlns:a="http://schemas.openxmlformats.org/drawingml/2006/main" prst="rect">
-            <a:avLst/>
-          </a:prstGeom>
-          <a:noFill xmlns:a="http://schemas.openxmlformats.org/drawingml/2006/main"/>
-          <a:ln xmlns:a="http://schemas.openxmlformats.org/drawingml/2006/main" w="0">
-            <a:noFill/>
-          </a:ln>
-        </p:spPr>
-        <p:txBody>
-          <a:bodyPr xmlns:a="http://schemas.openxmlformats.org/drawingml/2006/main" lIns="0" tIns="0" rIns="0" bIns="0" anchor="t">
-            <a:noAutofit/>
-          </a:bodyPr>
-          <a:lstStyle xmlns:a="http://schemas.openxmlformats.org/drawingml/2006/main"/>
-          <a:p xmlns:a="http://schemas.openxmlformats.org/drawingml/2006/main">
-            <a:pPr>
-              <a:defRPr sz="1275" b="0">
-                <a:solidFill>
-                  <a:srgbClr val="FFFFFF"/>
-                </a:solidFill>
-                <a:latin typeface="Calibri"/>
-                <a:ea typeface="Calibri"/>
-                <a:cs typeface="Calibri"/>
-              </a:defRPr>
-            </a:pPr>
-            <a:r>
-              <a:rPr sz="1275" b="0">
-                <a:solidFill>
-                  <a:srgbClr val="FFFFFF"/>
-                </a:solidFill>
-                <a:latin typeface="Calibri"/>
-                <a:ea typeface="Calibri"/>
-                <a:cs typeface="Calibri"/>
-              </a:rPr>
-              <a:t>Grunddel</a:t>
-            </a:r>
-          </a:p>
-        </p:txBody>
-      </p:sp>
-      <p:sp>
-        <p:nvSpPr>
-          <p:cNvPr id="12" name="page">
-            <a:extLst xmlns:a="http://schemas.openxmlformats.org/drawingml/2006/main">
-              <a:ext uri="{FF2B5EF4-FFF2-40B4-BE49-F238E27FC236}">
-                <a16:creationId xmlns:a16="http://schemas.microsoft.com/office/drawing/2014/main" id="{B016A708-78DC-4921-9CF0-4776568457B4}"/>
               </a:ext>
             </a:extLst>
           </p:cNvPr>

</xml_diff>